<commit_message>
Expand DSH features, control responsibilities and acceptance story
</commit_message>
<xml_diff>
--- a/docs/presentations/guarding-the-value-stream/Guarding_the_Value_Stream.pptx
+++ b/docs/presentations/guarding-the-value-stream/Guarding_the_Value_Stream.pptx
@@ -26,6 +26,7 @@
     <p:sldId xmlns:ns0="http://schemas.openxmlformats.org/officeDocument/2006/relationships" id="294" ns0:id="rId23"/>
     <p:sldId xmlns:ns0="http://schemas.openxmlformats.org/officeDocument/2006/relationships" id="295" ns0:id="rId24"/>
     <p:sldId xmlns:ns0="http://schemas.openxmlformats.org/officeDocument/2006/relationships" id="296" ns0:id="rId25"/>
+    <p:sldId xmlns:ns0="http://schemas.openxmlformats.org/officeDocument/2006/relationships" id="303" ns0:id="rId32"/>
     <p:sldId xmlns:ns0="http://schemas.openxmlformats.org/officeDocument/2006/relationships" id="297" ns0:id="rId26"/>
     <p:sldId xmlns:ns0="http://schemas.openxmlformats.org/officeDocument/2006/relationships" id="298" ns0:id="rId27"/>
     <p:sldId xmlns:ns0="http://schemas.openxmlformats.org/officeDocument/2006/relationships" id="299" ns0:id="rId28"/>
@@ -621,7 +622,7 @@
           </a:p>
           <a:p>
             <a:r>
-              <a:t>DETAILED EXPLANATION</a:t>
+              <a:t>DETAIL AND LIMITS</a:t>
             </a:r>
           </a:p>
           <a:p>
@@ -731,7 +732,7 @@
           </a:p>
           <a:p>
             <a:r>
-              <a:t>DETAILED EXPLANATION</a:t>
+              <a:t>DETAIL AND LIMITS</a:t>
             </a:r>
           </a:p>
           <a:p>
@@ -846,7 +847,7 @@
           </a:p>
           <a:p>
             <a:r>
-              <a:t>DETAILED EXPLANATION</a:t>
+              <a:t>DETAIL AND LIMITS</a:t>
             </a:r>
           </a:p>
           <a:p>
@@ -952,7 +953,7 @@
           </a:p>
           <a:p>
             <a:r>
-              <a:t>DETAILED EXPLANATION</a:t>
+              <a:t>DETAIL AND LIMITS</a:t>
             </a:r>
           </a:p>
           <a:p>
@@ -1058,7 +1059,7 @@
           </a:p>
           <a:p>
             <a:r>
-              <a:t>DETAILED EXPLANATION</a:t>
+              <a:t>DETAIL AND LIMITS</a:t>
             </a:r>
           </a:p>
           <a:p>
@@ -1164,7 +1165,7 @@
           </a:p>
           <a:p>
             <a:r>
-              <a:t>DETAILED EXPLANATION</a:t>
+              <a:t>DETAIL AND LIMITS</a:t>
             </a:r>
           </a:p>
           <a:p>
@@ -1270,7 +1271,7 @@
           </a:p>
           <a:p>
             <a:r>
-              <a:t>DETAILED EXPLANATION</a:t>
+              <a:t>DETAIL AND LIMITS</a:t>
             </a:r>
           </a:p>
           <a:p>
@@ -1361,7 +1362,7 @@
           <a:lstStyle/>
           <a:p>
             <a:r>
-              <a:t>SLIDE 17: Why DSH: keep useful work and review in one place</a:t>
+              <a:t>SLIDE 17: DSH brings the working tools into one reviewable project</a:t>
             </a:r>
           </a:p>
           <a:p>
@@ -1371,17 +1372,17 @@
           </a:p>
           <a:p>
             <a:r>
-              <a:t>The tasks need more than a chat window. People need source files, a way to inspect calculations, discussion and handover. DSH brings those working tools together and gives us defined integration points for control work. The selling point is a practical environment for useful, inspectable work, not a promise that custom software eliminates risk.</a:t>
-            </a:r>
-          </a:p>
-          <a:p>
-            <a:r>
-              <a:t>DETAILED EXPLANATION</a:t>
-            </a:r>
-          </a:p>
-          <a:p>
-            <a:r>
-              <a:t>These features come from the recorded DSH material in the existing deck. This presentation does not include a new live verification or any Production change. An authenticated route controls entry to that route; it does not certify every app behind it. HarnessWatch motivates testing the execution layer, while airmkit supports evidence discipline. Neither toolkit is claimed as installed in DSH.</a:t>
+              <a:t>After the banking and insurance examples, the question is where the work happens. DSH brings a project, files, an assistant, Jupyter, a terminal and application access together. A credit analyst can organise approved statements, ask for a calculation notebook, inspect the code and save a memo. The reviewer can examine the source and calculation rather than receiving only a polished paragraph.</a:t>
+            </a:r>
+          </a:p>
+          <a:p>
+            <a:r>
+              <a:t>DETAIL AND LIMITS</a:t>
+            </a:r>
+          </a:p>
+          <a:p>
+            <a:r>
+              <a:t>The credit-memo sequence is an illustrative use, not a claim that a complete lending application is deployed. The public repository is a portable reference. Recorded features in the existing deck include projects, assistant file and code tools, Jupyter, terminal and authenticated application routes. An assistant can generate incorrect code or follow hostile document text. Review both its output and the actions used to create it. No live deployment was tested for this presentation update.</a:t>
             </a:r>
           </a:p>
           <a:p>
@@ -1391,7 +1392,7 @@
           </a:p>
           <a:p>
             <a:r>
-              <a:t>Connect each feature to an ordinary working action.</a:t>
+              <a:t>The value comes from making the work easier to inspect and hand over.</a:t>
             </a:r>
           </a:p>
           <a:p>
@@ -1399,7 +1400,16 @@
               <a:t>SOURCES</a:t>
             </a:r>
           </a:p>
-          <a:p/>
+          <a:p>
+            <a:r>
+              <a:t>https://github.com/skunpoj/dsh_setup/blob/main/docs/SECURITY.md</a:t>
+            </a:r>
+          </a:p>
+          <a:p>
+            <a:r>
+              <a:t>https://github.com/skunpoj/dsh_setup</a:t>
+            </a:r>
+          </a:p>
         </p:txBody>
       </p:sp>
       <p:sp>
@@ -1467,7 +1477,7 @@
           <a:lstStyle/>
           <a:p>
             <a:r>
-              <a:t>SLIDE 18: How DSH supports the working day</a:t>
+              <a:t>SLIDE 18: Each DSH feature closes a specific working gap</a:t>
             </a:r>
           </a:p>
           <a:p>
@@ -1477,17 +1487,17 @@
           </a:p>
           <a:p>
             <a:r>
-              <a:t>The project keeps the case together. Jupyter explains how a number was calculated. Terminal tools support inspection, and authenticated application routes provide entry to services. Managed environments reduce setup friction. For handover, save the work and inputs rather than rely on a notebook kernel remaining alive forever.</a:t>
-            </a:r>
-          </a:p>
-          <a:p>
-            <a:r>
-              <a:t>DETAILED EXPLANATION</a:t>
-            </a:r>
-          </a:p>
-          <a:p>
-            <a:r>
-              <a:t>Reproduction needs dataset version, code, parameters and environment information. A durable file is different from an active process. A colleague should be able to restart from saved material. These are recorded feature descriptions, not proof of isolation for every integration. Do not claim time saved until representative tasks are measured through review and accepted completion.</a:t>
+              <a:t>These features solve ordinary working problems. Projects help us find the evidence. Notebooks help us reproduce the number. Managed environments reduce differences between colleagues. Saved work and guides make handover possible. For a claim total, the next reviewer should find the invoice rows, duplicate rule, code and output without guessing how the number was produced.</a:t>
+            </a:r>
+          </a:p>
+          <a:p>
+            <a:r>
+              <a:t>DETAIL AND LIMITS</a:t>
+            </a:r>
+          </a:p>
+          <a:p>
+            <a:r>
+              <a:t>Organisation is not data-access enforcement. Reproducibility is not proof that a rule is correct. Persistence means saved data, not a guarantee that every running process restarts. The reference security documentation separates workspace claims and runtime identities and describes operator-reviewed dependency promotion. Actual persistence and network enforcement depend on the installed version, storage and cluster policy. This is a feature-to-gap explanation, not a fresh operational certification.</a:t>
             </a:r>
           </a:p>
           <a:p>
@@ -1497,7 +1507,7 @@
           </a:p>
           <a:p>
             <a:r>
-              <a:t>A saved report may execute somewhere else. Follow it to that boundary.</a:t>
+              <a:t>Convenient tools also create power. The next question is how we limit that power.</a:t>
             </a:r>
           </a:p>
           <a:p>
@@ -1505,7 +1515,16 @@
               <a:t>SOURCES</a:t>
             </a:r>
           </a:p>
-          <a:p/>
+          <a:p>
+            <a:r>
+              <a:t>https://github.com/skunpoj/dsh_setup/blob/main/docs/SECURITY.md</a:t>
+            </a:r>
+          </a:p>
+          <a:p>
+            <a:r>
+              <a:t>https://github.com/skunpoj/dsh_setup</a:t>
+            </a:r>
+          </a:p>
         </p:txBody>
       </p:sp>
       <p:sp>
@@ -1573,7 +1592,7 @@
           <a:lstStyle/>
           <a:p>
             <a:r>
-              <a:t>SLIDE 19: Generated HTML creates a second execution boundary</a:t>
+              <a:t>SLIDE 20: Generated HTML creates a second execution boundary</a:t>
             </a:r>
           </a:p>
           <a:p>
@@ -1588,7 +1607,7 @@
           </a:p>
           <a:p>
             <a:r>
-              <a:t>DETAILED EXPLANATION</a:t>
+              <a:t>DETAIL AND LIMITS</a:t>
             </a:r>
           </a:p>
           <a:p>
@@ -1683,7 +1702,7 @@
           <a:lstStyle/>
           <a:p>
             <a:r>
-              <a:t>SLIDE 20: Test the whole path before expanding a workflow</a:t>
+              <a:t>SLIDE 21: Safety evidence comes from testing the actual workflow</a:t>
             </a:r>
           </a:p>
           <a:p>
@@ -1693,17 +1712,17 @@
           </a:p>
           <a:p>
             <a:r>
-              <a:t>A page opening does not prove an unapproved message is blocked. A stop button appearing does not prove queued work is cancelled. Use disposable inputs and inspect what actually happened. Test prohibited actions and legitimate work. That produces evidence for a particular version and workflow rather than a general safety claim.</a:t>
-            </a:r>
-          </a:p>
-          <a:p>
-            <a:r>
-              <a:t>DETAILED EXPLANATION</a:t>
-            </a:r>
-          </a:p>
-          <a:p>
-            <a:r>
-              <a:t>These are proposed test activities, not new completed tests. A gateway can block one route while another remains open; target services need their own permissions. Alerts require a recipient and response owner. No universal token lifetime prevents every compromise. Keep local tests, deployment checks and business acceptance distinct. Do not run unauthorised probes against real customer systems.</a:t>
+              <a:t>To say a workflow is safer, show what it actually prevented and what still worked. Use disposable users, harmless secrets and representative documents. Try a forbidden read, send and network request. Inspect the exported report in the browser where people will open it. Then check that alerts reach an owner and that stopping and recovering the work behave as expected. Keep the evidence tied to the exact version and configuration.</a:t>
+            </a:r>
+          </a:p>
+          <a:p>
+            <a:r>
+              <a:t>DETAIL AND LIMITS</a:t>
+            </a:r>
+          </a:p>
+          <a:p>
+            <a:r>
+              <a:t>An HTTP success or green build does not establish access isolation. A blocked route does not establish all egress is blocked. Confirm persisted results and target-side audit where authorised. Test recovery without touching real customer records. Acceptance should include ordinary legitimate work so excessive refusal does not hide poor usability. These tests are a proposed qualification plan; no new live runtime, customer system or Production was accessed or changed for this edit.</a:t>
             </a:r>
           </a:p>
           <a:p>
@@ -1713,7 +1732,7 @@
           </a:p>
           <a:p>
             <a:r>
-              <a:t>Keep the resulting evidence small enough to use and complete enough to explain decisions.</a:t>
+              <a:t>The resulting evidence pack explains what was tested, what it cost and what remains unknown.</a:t>
             </a:r>
           </a:p>
           <a:p>
@@ -1723,12 +1742,12 @@
           </a:p>
           <a:p>
             <a:r>
-              <a:t>https://thanatchon36.github.io/harnesswatch/paper/</a:t>
-            </a:r>
-          </a:p>
-          <a:p>
-            <a:r>
-              <a:t>https://airc.nist.gov/airmf-resources/airmf/5-sec-core/</a:t>
+              <a:t>https://github.com/skunpoj/dsh_setup/blob/main/docs/SECURITY.md</a:t>
+            </a:r>
+          </a:p>
+          <a:p>
+            <a:r>
+              <a:t>https://github.com/skunpoj/dsh_setup</a:t>
             </a:r>
           </a:p>
         </p:txBody>
@@ -1813,7 +1832,7 @@
           </a:p>
           <a:p>
             <a:r>
-              <a:t>DETAILED EXPLANATION</a:t>
+              <a:t>DETAIL AND LIMITS</a:t>
             </a:r>
           </a:p>
           <a:p>
@@ -1908,7 +1927,7 @@
           <a:lstStyle/>
           <a:p>
             <a:r>
-              <a:t>SLIDE 21: Keep an evidence pack people can actually use</a:t>
+              <a:t>SLIDE 22: Keep an evidence pack people can actually use</a:t>
             </a:r>
           </a:p>
           <a:p>
@@ -1923,7 +1942,7 @@
           </a:p>
           <a:p>
             <a:r>
-              <a:t>DETAILED EXPLANATION</a:t>
+              <a:t>DETAIL AND LIMITS</a:t>
             </a:r>
           </a:p>
           <a:p>
@@ -2014,7 +2033,7 @@
           <a:lstStyle/>
           <a:p>
             <a:r>
-              <a:t>SLIDE 22: Measure a better completed task, not just a faster draft</a:t>
+              <a:t>SLIDE 23: Measure a better completed task, not just a faster draft</a:t>
             </a:r>
           </a:p>
           <a:p>
@@ -2029,7 +2048,7 @@
           </a:p>
           <a:p>
             <a:r>
-              <a:t>DETAILED EXPLANATION</a:t>
+              <a:t>DETAIL AND LIMITS</a:t>
             </a:r>
           </a:p>
           <a:p>
@@ -2124,7 +2143,7 @@
           <a:lstStyle/>
           <a:p>
             <a:r>
-              <a:t>SLIDE 23: Useful AI work needs clear authority and visible evidence</a:t>
+              <a:t>SLIDE 24: Useful AI work needs clear authority and visible evidence</a:t>
             </a:r>
           </a:p>
           <a:p>
@@ -2139,7 +2158,7 @@
           </a:p>
           <a:p>
             <a:r>
-              <a:t>DETAILED EXPLANATION</a:t>
+              <a:t>DETAIL AND LIMITS</a:t>
             </a:r>
           </a:p>
           <a:p>
@@ -2160,17 +2179,6 @@
           <a:p>
             <a:r>
               <a:t>SOURCES</a:t>
-            </a:r>
-          </a:p>
-          <a:p/>
-          <a:p>
-            <a:r>
-              <a:t>PUBLIC RESOURCE</a:t>
-            </a:r>
-          </a:p>
-          <a:p>
-            <a:r>
-              <a:t>Scan the QR code or open https://github.com/skunpoj/dsh_setup . Public material provides a configurable reference; site-specific credentials, endpoints and operating data must remain outside the repository. The QR code was decoded independently to verify the destination.</a:t>
             </a:r>
           </a:p>
           <a:p/>
@@ -2256,7 +2264,7 @@
           </a:p>
           <a:p>
             <a:r>
-              <a:t>DETAILED EXPLANATION</a:t>
+              <a:t>DETAIL AND LIMITS</a:t>
             </a:r>
           </a:p>
           <a:p>
@@ -2287,6 +2295,116 @@
           <a:p>
             <a:r>
               <a:t>https://openai.com/index/hugging-face-incident-and-the-road-ahead/</a:t>
+            </a:r>
+          </a:p>
+        </p:txBody>
+      </p:sp>
+      <p:sp>
+        <p:nvSpPr>
+          <p:cNvPr id="4" name="Slide Number Placeholder 3"/>
+          <p:cNvSpPr>
+            <a:spLocks noGrp="1"/>
+          </p:cNvSpPr>
+          <p:nvPr>
+            <p:ph type="sldNum" idx="5" sz="quarter"/>
+          </p:nvPr>
+        </p:nvSpPr>
+        <p:spPr/>
+      </p:sp>
+    </p:spTree>
+  </p:cSld>
+  <p:clrMapOvr>
+    <a:masterClrMapping/>
+  </p:clrMapOvr>
+</p:notes>
+</file>
+
+<file path=ppt/notesSlides/notesSlide24.xml><?xml version="1.0" encoding="utf-8"?>
+<p:notes xmlns:a="http://schemas.openxmlformats.org/drawingml/2006/main" xmlns:p="http://schemas.openxmlformats.org/presentationml/2006/main" xmlns:r="http://schemas.openxmlformats.org/officeDocument/2006/relationships">
+  <p:cSld>
+    <p:spTree>
+      <p:nvGrpSpPr>
+        <p:cNvPr id="1" name=""/>
+        <p:cNvGrpSpPr/>
+        <p:nvPr/>
+      </p:nvGrpSpPr>
+      <p:grpSpPr>
+        <a:xfrm>
+          <a:off x="0" y="0"/>
+          <a:ext cx="0" cy="0"/>
+          <a:chOff x="0" y="0"/>
+          <a:chExt cx="0" cy="0"/>
+        </a:xfrm>
+      </p:grpSpPr>
+      <p:sp>
+        <p:nvSpPr>
+          <p:cNvPr id="2" name="Slide Image Placeholder 1"/>
+          <p:cNvSpPr>
+            <a:spLocks noGrp="1"/>
+          </p:cNvSpPr>
+          <p:nvPr>
+            <p:ph type="sldImg" idx="2"/>
+          </p:nvPr>
+        </p:nvSpPr>
+        <p:spPr/>
+      </p:sp>
+      <p:sp>
+        <p:nvSpPr>
+          <p:cNvPr id="3" name="Notes Placeholder 2"/>
+          <p:cNvSpPr>
+            <a:spLocks noGrp="1"/>
+          </p:cNvSpPr>
+          <p:nvPr>
+            <p:ph type="body" idx="3" sz="quarter"/>
+          </p:nvPr>
+        </p:nvSpPr>
+        <p:spPr/>
+        <p:txBody>
+          <a:bodyPr/>
+          <a:lstStyle/>
+          <a:p>
+            <a:r>
+              <a:t>SLIDE 19: DSH provides control points that operators must configure and test</a:t>
+            </a:r>
+          </a:p>
+          <a:p>
+            <a:r>
+              <a:t>STORY TO TELL</a:t>
+            </a:r>
+          </a:p>
+          <a:p>
+            <a:r>
+              <a:t>The Hugging Face case showed why a permitted supporting service can become another route out. DSH gives us places to control identity, execution, network access and packages. The public reference defines several of those mechanisms. But the operator must configure and test them in the actual installation. A new business integration needs scoped credentials and explicit authority for sends or writes. A log is useful only if it captures the relevant event and someone acts on it.</a:t>
+            </a:r>
+          </a:p>
+          <a:p>
+            <a:r>
+              <a:t>DETAIL AND LIMITS</a:t>
+            </a:r>
+          </a:p>
+          <a:p>
+            <a:r>
+              <a:t>Status matters. The reference source documents identity-bound routing, separate claims, non-root execution, dropped capabilities, no execution-worker API token, network policies and reviewed package promotion. These are reference mechanisms, not a claim of current Production enforcement. CNI and DNS enforcement, browser routes and recovery require installation acceptance. Integration-specific approvals, complete tool-event capture and incident response are requirements to implement and verify where applicable. Trusted administrators and storage operators retain power. No universal sandbox, blanket approval gate, immutable command ledger or zero-risk guarantee is asserted.</a:t>
+            </a:r>
+          </a:p>
+          <a:p>
+            <a:r>
+              <a:t>TRANSITION</a:t>
+            </a:r>
+          </a:p>
+          <a:p>
+            <a:r>
+              <a:t>The output can also execute outside the workspace, especially when it is HTML.</a:t>
+            </a:r>
+          </a:p>
+          <a:p>
+            <a:r>
+              <a:t>SOURCES</a:t>
+            </a:r>
+          </a:p>
+          <a:p>
+            <a:r>
+              <a:t>https://github.com/skunpoj/dsh_setup/blob/main/docs/SECURITY.md</a:t>
             </a:r>
           </a:p>
         </p:txBody>
@@ -2366,7 +2484,7 @@
           </a:p>
           <a:p xmlns:a="http://schemas.openxmlformats.org/drawingml/2006/main">
             <a:r>
-              <a:t>DETAILED EXPLANATION</a:t>
+              <a:t>DETAIL AND LIMITS</a:t>
             </a:r>
           </a:p>
           <a:p xmlns:a="http://schemas.openxmlformats.org/drawingml/2006/main">
@@ -2496,7 +2614,7 @@
           </a:p>
           <a:p>
             <a:r>
-              <a:t>DETAILED EXPLANATION</a:t>
+              <a:t>DETAIL AND LIMITS</a:t>
             </a:r>
           </a:p>
           <a:p>
@@ -2606,7 +2724,7 @@
           </a:p>
           <a:p>
             <a:r>
-              <a:t>DETAILED EXPLANATION</a:t>
+              <a:t>DETAIL AND LIMITS</a:t>
             </a:r>
           </a:p>
           <a:p>
@@ -2712,7 +2830,7 @@
           </a:p>
           <a:p>
             <a:r>
-              <a:t>DETAILED EXPLANATION</a:t>
+              <a:t>DETAIL AND LIMITS</a:t>
             </a:r>
           </a:p>
           <a:p>
@@ -2822,7 +2940,7 @@
           </a:p>
           <a:p xmlns:a="http://schemas.openxmlformats.org/drawingml/2006/main">
             <a:r>
-              <a:t>DETAILED EXPLANATION</a:t>
+              <a:t>DETAIL AND LIMITS</a:t>
             </a:r>
           </a:p>
           <a:p xmlns:a="http://schemas.openxmlformats.org/drawingml/2006/main">
@@ -2932,7 +3050,7 @@
           </a:p>
           <a:p xmlns:a="http://schemas.openxmlformats.org/drawingml/2006/main">
             <a:r>
-              <a:t>DETAILED EXPLANATION</a:t>
+              <a:t>DETAIL AND LIMITS</a:t>
             </a:r>
           </a:p>
           <a:p xmlns:a="http://schemas.openxmlformats.org/drawingml/2006/main">
@@ -3047,7 +3165,7 @@
           </a:p>
           <a:p>
             <a:r>
-              <a:t>DETAILED EXPLANATION</a:t>
+              <a:t>DETAIL AND LIMITS</a:t>
             </a:r>
           </a:p>
           <a:p>
@@ -6995,13 +7113,13 @@
           <a:noFill/>
         </p:spPr>
         <p:txBody>
-          <a:bodyPr wrap="none">
-            <a:spAutoFit/>
-          </a:bodyPr>
-          <a:lstStyle/>
-          <a:p>
-            <a:pPr>
-              <a:defRPr sz="900">
+          <a:bodyPr wrap="square" lIns="0" rIns="0" tIns="0" bIns="0">
+            <a:spAutoFit/>
+          </a:bodyPr>
+          <a:lstStyle/>
+          <a:p>
+            <a:pPr>
+              <a:defRPr sz="900" b="0">
                 <a:solidFill>
                   <a:srgbClr val="66758A"/>
                 </a:solidFill>
@@ -7009,7 +7127,7 @@
               </a:defRPr>
             </a:pPr>
             <a:r>
-              <a:t>1 / 23     00:00–00:30 planned     Sources and explanation in notes</a:t>
+              <a:t>1 / 24    00:00–00:30 planned    Sources and explanation in notes</a:t>
             </a:r>
           </a:p>
         </p:txBody>
@@ -7478,13 +7596,13 @@
           <a:noFill/>
         </p:spPr>
         <p:txBody>
-          <a:bodyPr wrap="none">
-            <a:spAutoFit/>
-          </a:bodyPr>
-          <a:lstStyle/>
-          <a:p>
-            <a:pPr>
-              <a:defRPr sz="900">
+          <a:bodyPr wrap="square" lIns="0" rIns="0" tIns="0" bIns="0">
+            <a:spAutoFit/>
+          </a:bodyPr>
+          <a:lstStyle/>
+          <a:p>
+            <a:pPr>
+              <a:defRPr sz="900" b="0">
                 <a:solidFill>
                   <a:srgbClr val="66758A"/>
                 </a:solidFill>
@@ -7492,7 +7610,7 @@
               </a:defRPr>
             </a:pPr>
             <a:r>
-              <a:t>10 / 23     07:05–07:50 planned     Sources and explanation in notes</a:t>
+              <a:t>10 / 24    07:05–07:50 planned    Sources and explanation in notes</a:t>
             </a:r>
           </a:p>
         </p:txBody>
@@ -7922,13 +8040,13 @@
           <a:noFill/>
         </p:spPr>
         <p:txBody>
-          <a:bodyPr wrap="none">
-            <a:spAutoFit/>
-          </a:bodyPr>
-          <a:lstStyle/>
-          <a:p>
-            <a:pPr>
-              <a:defRPr sz="900">
+          <a:bodyPr wrap="square" lIns="0" rIns="0" tIns="0" bIns="0">
+            <a:spAutoFit/>
+          </a:bodyPr>
+          <a:lstStyle/>
+          <a:p>
+            <a:pPr>
+              <a:defRPr sz="900" b="0">
                 <a:solidFill>
                   <a:srgbClr val="66758A"/>
                 </a:solidFill>
@@ -7936,7 +8054,7 @@
               </a:defRPr>
             </a:pPr>
             <a:r>
-              <a:t>11 / 23     07:50–08:30 planned     Sources and explanation in notes</a:t>
+              <a:t>11 / 24    07:50–08:30 planned    Sources and explanation in notes</a:t>
             </a:r>
           </a:p>
         </p:txBody>
@@ -8405,13 +8523,13 @@
           <a:noFill/>
         </p:spPr>
         <p:txBody>
-          <a:bodyPr wrap="none">
-            <a:spAutoFit/>
-          </a:bodyPr>
-          <a:lstStyle/>
-          <a:p>
-            <a:pPr>
-              <a:defRPr sz="900">
+          <a:bodyPr wrap="square" lIns="0" rIns="0" tIns="0" bIns="0">
+            <a:spAutoFit/>
+          </a:bodyPr>
+          <a:lstStyle/>
+          <a:p>
+            <a:pPr>
+              <a:defRPr sz="900" b="0">
                 <a:solidFill>
                   <a:srgbClr val="66758A"/>
                 </a:solidFill>
@@ -8419,7 +8537,7 @@
               </a:defRPr>
             </a:pPr>
             <a:r>
-              <a:t>12 / 23     08:30–09:35 planned     Sources and explanation in notes</a:t>
+              <a:t>12 / 24    08:30–09:35 planned    Sources and explanation in notes</a:t>
             </a:r>
           </a:p>
         </p:txBody>
@@ -8888,13 +9006,13 @@
           <a:noFill/>
         </p:spPr>
         <p:txBody>
-          <a:bodyPr wrap="none">
-            <a:spAutoFit/>
-          </a:bodyPr>
-          <a:lstStyle/>
-          <a:p>
-            <a:pPr>
-              <a:defRPr sz="900">
+          <a:bodyPr wrap="square" lIns="0" rIns="0" tIns="0" bIns="0">
+            <a:spAutoFit/>
+          </a:bodyPr>
+          <a:lstStyle/>
+          <a:p>
+            <a:pPr>
+              <a:defRPr sz="900" b="0">
                 <a:solidFill>
                   <a:srgbClr val="66758A"/>
                 </a:solidFill>
@@ -8902,7 +9020,7 @@
               </a:defRPr>
             </a:pPr>
             <a:r>
-              <a:t>13 / 23     09:35–10:35 planned     Sources and explanation in notes</a:t>
+              <a:t>13 / 24    09:35–10:35 planned    Sources and explanation in notes</a:t>
             </a:r>
           </a:p>
         </p:txBody>
@@ -9371,13 +9489,13 @@
           <a:noFill/>
         </p:spPr>
         <p:txBody>
-          <a:bodyPr wrap="none">
-            <a:spAutoFit/>
-          </a:bodyPr>
-          <a:lstStyle/>
-          <a:p>
-            <a:pPr>
-              <a:defRPr sz="900">
+          <a:bodyPr wrap="square" lIns="0" rIns="0" tIns="0" bIns="0">
+            <a:spAutoFit/>
+          </a:bodyPr>
+          <a:lstStyle/>
+          <a:p>
+            <a:pPr>
+              <a:defRPr sz="900" b="0">
                 <a:solidFill>
                   <a:srgbClr val="66758A"/>
                 </a:solidFill>
@@ -9385,7 +9503,7 @@
               </a:defRPr>
             </a:pPr>
             <a:r>
-              <a:t>14 / 23     10:35–11:40 planned     Sources and explanation in notes</a:t>
+              <a:t>14 / 24    10:35–11:40 planned    Sources and explanation in notes</a:t>
             </a:r>
           </a:p>
         </p:txBody>
@@ -9854,13 +9972,13 @@
           <a:noFill/>
         </p:spPr>
         <p:txBody>
-          <a:bodyPr wrap="none">
-            <a:spAutoFit/>
-          </a:bodyPr>
-          <a:lstStyle/>
-          <a:p>
-            <a:pPr>
-              <a:defRPr sz="900">
+          <a:bodyPr wrap="square" lIns="0" rIns="0" tIns="0" bIns="0">
+            <a:spAutoFit/>
+          </a:bodyPr>
+          <a:lstStyle/>
+          <a:p>
+            <a:pPr>
+              <a:defRPr sz="900" b="0">
                 <a:solidFill>
                   <a:srgbClr val="66758A"/>
                 </a:solidFill>
@@ -9868,7 +9986,7 @@
               </a:defRPr>
             </a:pPr>
             <a:r>
-              <a:t>15 / 23     11:40–12:35 planned     Sources and explanation in notes</a:t>
+              <a:t>15 / 24    11:40–12:35 planned    Sources and explanation in notes</a:t>
             </a:r>
           </a:p>
         </p:txBody>
@@ -10337,13 +10455,13 @@
           <a:noFill/>
         </p:spPr>
         <p:txBody>
-          <a:bodyPr wrap="none">
-            <a:spAutoFit/>
-          </a:bodyPr>
-          <a:lstStyle/>
-          <a:p>
-            <a:pPr>
-              <a:defRPr sz="900">
+          <a:bodyPr wrap="square" lIns="0" rIns="0" tIns="0" bIns="0">
+            <a:spAutoFit/>
+          </a:bodyPr>
+          <a:lstStyle/>
+          <a:p>
+            <a:pPr>
+              <a:defRPr sz="900" b="0">
                 <a:solidFill>
                   <a:srgbClr val="66758A"/>
                 </a:solidFill>
@@ -10351,7 +10469,7 @@
               </a:defRPr>
             </a:pPr>
             <a:r>
-              <a:t>16 / 23     12:35–13:25 planned     Sources and explanation in notes</a:t>
+              <a:t>16 / 24    12:35–13:25 planned    Sources and explanation in notes</a:t>
             </a:r>
           </a:p>
         </p:txBody>
@@ -10383,23 +10501,20 @@
         <p:spPr>
           <a:xfrm>
             <a:off x="640080" y="411480"/>
-            <a:ext cx="10972800" cy="256032"/>
-          </a:xfrm>
-          <a:prstGeom prst="rect">
-            <a:avLst/>
-          </a:prstGeom>
-          <a:noFill/>
-        </p:spPr>
-        <p:txBody>
-          <a:bodyPr wrap="square" lIns="0" rIns="0" tIns="0" bIns="0">
-            <a:spAutoFit/>
-          </a:bodyPr>
-          <a:lstStyle/>
-          <a:p>
-            <a:pPr>
-              <a:spcAft>
-                <a:spcPts val="600"/>
-              </a:spcAft>
+            <a:ext cx="10972800" cy="274320"/>
+          </a:xfrm>
+          <a:prstGeom prst="rect">
+            <a:avLst/>
+          </a:prstGeom>
+          <a:noFill/>
+        </p:spPr>
+        <p:txBody>
+          <a:bodyPr wrap="square" lIns="0" rIns="0" tIns="0" bIns="0">
+            <a:spAutoFit/>
+          </a:bodyPr>
+          <a:lstStyle/>
+          <a:p>
+            <a:pPr>
               <a:defRPr sz="1100" b="1">
                 <a:solidFill>
                   <a:srgbClr val="0088BA"/>
@@ -10408,7 +10523,7 @@
               </a:defRPr>
             </a:pPr>
             <a:r>
-              <a:t>4 / WHAT DSH CONTRIBUTES</a:t>
+              <a:t>PART 3 / WHAT DSH PROVIDES AND HOW WE QUALIFY IT</a:t>
             </a:r>
           </a:p>
         </p:txBody>
@@ -10422,23 +10537,20 @@
         <p:spPr>
           <a:xfrm>
             <a:off x="640080" y="868680"/>
-            <a:ext cx="10972800" cy="731520"/>
-          </a:xfrm>
-          <a:prstGeom prst="rect">
-            <a:avLst/>
-          </a:prstGeom>
-          <a:noFill/>
-        </p:spPr>
-        <p:txBody>
-          <a:bodyPr wrap="square" lIns="0" rIns="0" tIns="0" bIns="0">
-            <a:spAutoFit/>
-          </a:bodyPr>
-          <a:lstStyle/>
-          <a:p>
-            <a:pPr>
-              <a:spcAft>
-                <a:spcPts val="600"/>
-              </a:spcAft>
+            <a:ext cx="10972800" cy="777240"/>
+          </a:xfrm>
+          <a:prstGeom prst="rect">
+            <a:avLst/>
+          </a:prstGeom>
+          <a:noFill/>
+        </p:spPr>
+        <p:txBody>
+          <a:bodyPr wrap="square" lIns="0" rIns="0" tIns="0" bIns="0">
+            <a:spAutoFit/>
+          </a:bodyPr>
+          <a:lstStyle/>
+          <a:p>
+            <a:pPr>
               <a:defRPr sz="2500" b="1">
                 <a:solidFill>
                   <a:srgbClr val="14243C"/>
@@ -10447,7 +10559,7 @@
               </a:defRPr>
             </a:pPr>
             <a:r>
-              <a:t>Why DSH: keep useful work and review in one place</a:t>
+              <a:t>DSH brings the working tools into one reviewable project</a:t>
             </a:r>
           </a:p>
         </p:txBody>
@@ -10460,24 +10572,21 @@
         </p:nvSpPr>
         <p:spPr>
           <a:xfrm>
-            <a:off x="685800" y="1901952"/>
-            <a:ext cx="3456432" cy="685800"/>
-          </a:xfrm>
-          <a:prstGeom prst="rect">
-            <a:avLst/>
-          </a:prstGeom>
-          <a:noFill/>
-        </p:spPr>
-        <p:txBody>
-          <a:bodyPr wrap="square" lIns="0" rIns="0" tIns="0" bIns="0">
-            <a:spAutoFit/>
-          </a:bodyPr>
-          <a:lstStyle/>
-          <a:p>
-            <a:pPr>
-              <a:spcAft>
-                <a:spcPts val="600"/>
-              </a:spcAft>
+            <a:off x="685800" y="1856231"/>
+            <a:ext cx="5212080" cy="393192"/>
+          </a:xfrm>
+          <a:prstGeom prst="rect">
+            <a:avLst/>
+          </a:prstGeom>
+          <a:noFill/>
+        </p:spPr>
+        <p:txBody>
+          <a:bodyPr wrap="square" lIns="0" rIns="0" tIns="0" bIns="0">
+            <a:spAutoFit/>
+          </a:bodyPr>
+          <a:lstStyle/>
+          <a:p>
+            <a:pPr>
               <a:defRPr sz="1800" b="1">
                 <a:solidFill>
                   <a:srgbClr val="007DA5"/>
@@ -10486,7 +10595,7 @@
               </a:defRPr>
             </a:pPr>
             <a:r>
-              <a:t>What the use cases need</a:t>
+              <a:t>Projects, files and assistant</a:t>
             </a:r>
           </a:p>
         </p:txBody>
@@ -10499,24 +10608,21 @@
         </p:nvSpPr>
         <p:spPr>
           <a:xfrm>
-            <a:off x="685800" y="2697480"/>
-            <a:ext cx="3456432" cy="2926080"/>
-          </a:xfrm>
-          <a:prstGeom prst="rect">
-            <a:avLst/>
-          </a:prstGeom>
-          <a:noFill/>
-        </p:spPr>
-        <p:txBody>
-          <a:bodyPr wrap="square" lIns="0" rIns="0" tIns="0" bIns="0">
-            <a:spAutoFit/>
-          </a:bodyPr>
-          <a:lstStyle/>
-          <a:p>
-            <a:pPr>
-              <a:spcAft>
-                <a:spcPts val="600"/>
-              </a:spcAft>
+            <a:off x="685800" y="2304287"/>
+            <a:ext cx="5212080" cy="1463040"/>
+          </a:xfrm>
+          <a:prstGeom prst="rect">
+            <a:avLst/>
+          </a:prstGeom>
+          <a:noFill/>
+        </p:spPr>
+        <p:txBody>
+          <a:bodyPr wrap="square" lIns="0" rIns="0" tIns="0" bIns="0">
+            <a:spAutoFit/>
+          </a:bodyPr>
+          <a:lstStyle/>
+          <a:p>
+            <a:pPr>
               <a:defRPr sz="1600" b="0">
                 <a:solidFill>
                   <a:srgbClr val="26354A"/>
@@ -10525,7 +10631,7 @@
               </a:defRPr>
             </a:pPr>
             <a:r>
-              <a:t>A place for approved files, conversations, calculations and saved results. Colleagues need to inspect the work, repeat the method and hand it over.</a:t>
+              <a:t>Organise approved inputs, questions and draft outputs together. Ask the assistant to explain a document or prepare code. Check its sources, assumptions and proposed actions.</a:t>
             </a:r>
           </a:p>
         </p:txBody>
@@ -10538,24 +10644,21 @@
         </p:nvSpPr>
         <p:spPr>
           <a:xfrm>
-            <a:off x="4434840" y="1901952"/>
-            <a:ext cx="3456432" cy="685800"/>
-          </a:xfrm>
-          <a:prstGeom prst="rect">
-            <a:avLst/>
-          </a:prstGeom>
-          <a:noFill/>
-        </p:spPr>
-        <p:txBody>
-          <a:bodyPr wrap="square" lIns="0" rIns="0" tIns="0" bIns="0">
-            <a:spAutoFit/>
-          </a:bodyPr>
-          <a:lstStyle/>
-          <a:p>
-            <a:pPr>
-              <a:spcAft>
-                <a:spcPts val="600"/>
-              </a:spcAft>
+            <a:off x="6309360" y="1856231"/>
+            <a:ext cx="5212080" cy="393192"/>
+          </a:xfrm>
+          <a:prstGeom prst="rect">
+            <a:avLst/>
+          </a:prstGeom>
+          <a:noFill/>
+        </p:spPr>
+        <p:txBody>
+          <a:bodyPr wrap="square" lIns="0" rIns="0" tIns="0" bIns="0">
+            <a:spAutoFit/>
+          </a:bodyPr>
+          <a:lstStyle/>
+          <a:p>
+            <a:pPr>
               <a:defRPr sz="1800" b="1">
                 <a:solidFill>
                   <a:srgbClr val="007DA5"/>
@@ -10564,7 +10667,7 @@
               </a:defRPr>
             </a:pPr>
             <a:r>
-              <a:t>Recorded DSH features</a:t>
+              <a:t>Jupyter and terminal</a:t>
             </a:r>
           </a:p>
         </p:txBody>
@@ -10577,24 +10680,21 @@
         </p:nvSpPr>
         <p:spPr>
           <a:xfrm>
-            <a:off x="4434840" y="2697480"/>
-            <a:ext cx="3456432" cy="2926080"/>
-          </a:xfrm>
-          <a:prstGeom prst="rect">
-            <a:avLst/>
-          </a:prstGeom>
-          <a:noFill/>
-        </p:spPr>
-        <p:txBody>
-          <a:bodyPr wrap="square" lIns="0" rIns="0" tIns="0" bIns="0">
-            <a:spAutoFit/>
-          </a:bodyPr>
-          <a:lstStyle/>
-          <a:p>
-            <a:pPr>
-              <a:spcAft>
-                <a:spcPts val="600"/>
-              </a:spcAft>
+            <a:off x="6309360" y="2304287"/>
+            <a:ext cx="5212080" cy="1463040"/>
+          </a:xfrm>
+          <a:prstGeom prst="rect">
+            <a:avLst/>
+          </a:prstGeom>
+          <a:noFill/>
+        </p:spPr>
+        <p:txBody>
+          <a:bodyPr wrap="square" lIns="0" rIns="0" tIns="0" bIns="0">
+            <a:spAutoFit/>
+          </a:bodyPr>
+          <a:lstStyle/>
+          <a:p>
+            <a:pPr>
               <a:defRPr sz="1600" b="0">
                 <a:solidFill>
                   <a:srgbClr val="26354A"/>
@@ -10603,7 +10703,7 @@
               </a:defRPr>
             </a:pPr>
             <a:r>
-              <a:t>Private projects, assistant tools for code and files, terminal, Jupyter and authenticated application routes. Managed environments and guides support repeatable work.</a:t>
+              <a:t>Inspect tables, run calculations and save the method. A reviewer can rerun a claim total or borrower ratio and see which records produced the result.</a:t>
             </a:r>
           </a:p>
         </p:txBody>
@@ -10616,24 +10716,21 @@
         </p:nvSpPr>
         <p:spPr>
           <a:xfrm>
-            <a:off x="8183879" y="1901952"/>
-            <a:ext cx="3456432" cy="685800"/>
-          </a:xfrm>
-          <a:prstGeom prst="rect">
-            <a:avLst/>
-          </a:prstGeom>
-          <a:noFill/>
-        </p:spPr>
-        <p:txBody>
-          <a:bodyPr wrap="square" lIns="0" rIns="0" tIns="0" bIns="0">
-            <a:spAutoFit/>
-          </a:bodyPr>
-          <a:lstStyle/>
-          <a:p>
-            <a:pPr>
-              <a:spcAft>
-                <a:spcPts val="600"/>
-              </a:spcAft>
+            <a:off x="685800" y="3858768"/>
+            <a:ext cx="5212080" cy="393192"/>
+          </a:xfrm>
+          <a:prstGeom prst="rect">
+            <a:avLst/>
+          </a:prstGeom>
+          <a:noFill/>
+        </p:spPr>
+        <p:txBody>
+          <a:bodyPr wrap="square" lIns="0" rIns="0" tIns="0" bIns="0">
+            <a:spAutoFit/>
+          </a:bodyPr>
+          <a:lstStyle/>
+          <a:p>
+            <a:pPr>
               <a:defRPr sz="1800" b="1">
                 <a:solidFill>
                   <a:srgbClr val="007DA5"/>
@@ -10642,7 +10739,7 @@
               </a:defRPr>
             </a:pPr>
             <a:r>
-              <a:t>What still needs qualification</a:t>
+              <a:t>Applications and environments</a:t>
             </a:r>
           </a:p>
         </p:txBody>
@@ -10655,24 +10752,21 @@
         </p:nvSpPr>
         <p:spPr>
           <a:xfrm>
-            <a:off x="8183879" y="2697480"/>
-            <a:ext cx="3456432" cy="2926080"/>
-          </a:xfrm>
-          <a:prstGeom prst="rect">
-            <a:avLst/>
-          </a:prstGeom>
-          <a:noFill/>
-        </p:spPr>
-        <p:txBody>
-          <a:bodyPr wrap="square" lIns="0" rIns="0" tIns="0" bIns="0">
-            <a:spAutoFit/>
-          </a:bodyPr>
-          <a:lstStyle/>
-          <a:p>
-            <a:pPr>
-              <a:spcAft>
-                <a:spcPts val="600"/>
-              </a:spcAft>
+            <a:off x="685800" y="4306824"/>
+            <a:ext cx="5212080" cy="1463040"/>
+          </a:xfrm>
+          <a:prstGeom prst="rect">
+            <a:avLst/>
+          </a:prstGeom>
+          <a:noFill/>
+        </p:spPr>
+        <p:txBody>
+          <a:bodyPr wrap="square" lIns="0" rIns="0" tIns="0" bIns="0">
+            <a:spAutoFit/>
+          </a:bodyPr>
+          <a:lstStyle/>
+          <a:p>
+            <a:pPr>
               <a:defRPr sz="1600" b="0">
                 <a:solidFill>
                   <a:srgbClr val="26354A"/>
@@ -10681,7 +10775,7 @@
               </a:defRPr>
             </a:pPr>
             <a:r>
-              <a:t>Workspace access, tools, routes and exports are places to configure and test controls. Owning those points creates responsibility. The examples do not mean all six business applications or complete enforcement already exist.</a:t>
+              <a:t>Authenticated application routes and managed environments help people use the same tools. Access and available applications depend on the installation and its policy.</a:t>
             </a:r>
           </a:p>
         </p:txBody>
@@ -10694,24 +10788,93 @@
         </p:nvSpPr>
         <p:spPr>
           <a:xfrm>
-            <a:off x="685800" y="6044184"/>
-            <a:ext cx="10789920" cy="237744"/>
-          </a:xfrm>
-          <a:prstGeom prst="rect">
-            <a:avLst/>
-          </a:prstGeom>
-          <a:noFill/>
-        </p:spPr>
-        <p:txBody>
-          <a:bodyPr wrap="square" lIns="0" rIns="0" tIns="0" bIns="0">
-            <a:spAutoFit/>
-          </a:bodyPr>
-          <a:lstStyle/>
-          <a:p>
-            <a:pPr>
-              <a:spcAft>
-                <a:spcPts val="600"/>
-              </a:spcAft>
+            <a:off x="6309360" y="3858768"/>
+            <a:ext cx="5212080" cy="393192"/>
+          </a:xfrm>
+          <a:prstGeom prst="rect">
+            <a:avLst/>
+          </a:prstGeom>
+          <a:noFill/>
+        </p:spPr>
+        <p:txBody>
+          <a:bodyPr wrap="square" lIns="0" rIns="0" tIns="0" bIns="0">
+            <a:spAutoFit/>
+          </a:bodyPr>
+          <a:lstStyle/>
+          <a:p>
+            <a:pPr>
+              <a:defRPr sz="1800" b="1">
+                <a:solidFill>
+                  <a:srgbClr val="007DA5"/>
+                </a:solidFill>
+                <a:latin typeface="Calibri"/>
+              </a:defRPr>
+            </a:pPr>
+            <a:r>
+              <a:t>A practical work sequence</a:t>
+            </a:r>
+          </a:p>
+        </p:txBody>
+      </p:sp>
+      <p:sp>
+        <p:nvSpPr>
+          <p:cNvPr id="11" name="TextBox 10"/>
+          <p:cNvSpPr txBox="1"/>
+          <p:nvPr/>
+        </p:nvSpPr>
+        <p:spPr>
+          <a:xfrm>
+            <a:off x="6309360" y="4306824"/>
+            <a:ext cx="5212080" cy="1463040"/>
+          </a:xfrm>
+          <a:prstGeom prst="rect">
+            <a:avLst/>
+          </a:prstGeom>
+          <a:noFill/>
+        </p:spPr>
+        <p:txBody>
+          <a:bodyPr wrap="square" lIns="0" rIns="0" tIns="0" bIns="0">
+            <a:spAutoFit/>
+          </a:bodyPr>
+          <a:lstStyle/>
+          <a:p>
+            <a:pPr>
+              <a:defRPr sz="1600" b="0">
+                <a:solidFill>
+                  <a:srgbClr val="26354A"/>
+                </a:solidFill>
+                <a:latin typeface="Calibri"/>
+              </a:defRPr>
+            </a:pPr>
+            <a:r>
+              <a:t>Upload approved statements, ask for a ratio notebook, inspect the calculation, then save a source-linked memo for review. Sending it or updating a business system needs separate authority.</a:t>
+            </a:r>
+          </a:p>
+        </p:txBody>
+      </p:sp>
+      <p:sp>
+        <p:nvSpPr>
+          <p:cNvPr id="12" name="TextBox 11"/>
+          <p:cNvSpPr txBox="1"/>
+          <p:nvPr/>
+        </p:nvSpPr>
+        <p:spPr>
+          <a:xfrm>
+            <a:off x="685800" y="6071616"/>
+            <a:ext cx="10789920" cy="274320"/>
+          </a:xfrm>
+          <a:prstGeom prst="rect">
+            <a:avLst/>
+          </a:prstGeom>
+          <a:noFill/>
+        </p:spPr>
+        <p:txBody>
+          <a:bodyPr wrap="square" lIns="0" rIns="0" tIns="0" bIns="0">
+            <a:spAutoFit/>
+          </a:bodyPr>
+          <a:lstStyle/>
+          <a:p>
+            <a:pPr>
               <a:defRPr sz="1000" b="0">
                 <a:solidFill>
                   <a:srgbClr val="66758A"/>
@@ -10720,53 +10883,14 @@
               </a:defRPr>
             </a:pPr>
             <a:r>
-              <a:t>Source links, explanation and limits are in the speaker guide and slide notes.</a:t>
-            </a:r>
-          </a:p>
-        </p:txBody>
-      </p:sp>
-      <p:sp>
-        <p:nvSpPr>
-          <p:cNvPr id="11" name="TextBox 10"/>
-          <p:cNvSpPr txBox="1"/>
-          <p:nvPr/>
-        </p:nvSpPr>
-        <p:spPr>
-          <a:xfrm>
-            <a:off x="685800" y="4892040"/>
-            <a:ext cx="10789920" cy="868680"/>
-          </a:xfrm>
-          <a:prstGeom prst="rect">
-            <a:avLst/>
-          </a:prstGeom>
-          <a:noFill/>
-        </p:spPr>
-        <p:txBody>
-          <a:bodyPr wrap="square" lIns="0" rIns="0" tIns="0" bIns="0">
-            <a:spAutoFit/>
-          </a:bodyPr>
-          <a:lstStyle/>
-          <a:p>
-            <a:pPr>
-              <a:spcAft>
-                <a:spcPts val="600"/>
-              </a:spcAft>
-              <a:defRPr sz="1600" b="0">
-                <a:solidFill>
-                  <a:srgbClr val="26354A"/>
-                </a:solidFill>
-                <a:latin typeface="Calibri"/>
-              </a:defRPr>
-            </a:pPr>
-            <a:r>
-              <a:t>Example in DSH: keep borrower files in a project, calculate ratios in Jupyter and save a source-linked memo. Review and any later write to the lending system remain separate steps.</a:t>
-            </a:r>
-          </a:p>
-        </p:txBody>
-      </p:sp>
-      <p:sp>
-        <p:nvSpPr>
-          <p:cNvPr id="12" name="TextBox 11"/>
+              <a:t>Reference features and proposed acceptance checks. No new live deployment verification.</a:t>
+            </a:r>
+          </a:p>
+        </p:txBody>
+      </p:sp>
+      <p:sp>
+        <p:nvSpPr>
+          <p:cNvPr id="13" name="TextBox 12"/>
           <p:cNvSpPr txBox="1"/>
           <p:nvPr/>
         </p:nvSpPr>
@@ -10781,13 +10905,13 @@
           <a:noFill/>
         </p:spPr>
         <p:txBody>
-          <a:bodyPr wrap="none">
-            <a:spAutoFit/>
-          </a:bodyPr>
-          <a:lstStyle/>
-          <a:p>
-            <a:pPr>
-              <a:defRPr sz="900">
+          <a:bodyPr wrap="square" lIns="0" rIns="0" tIns="0" bIns="0">
+            <a:spAutoFit/>
+          </a:bodyPr>
+          <a:lstStyle/>
+          <a:p>
+            <a:pPr>
+              <a:defRPr sz="900" b="0">
                 <a:solidFill>
                   <a:srgbClr val="66758A"/>
                 </a:solidFill>
@@ -10795,7 +10919,7 @@
               </a:defRPr>
             </a:pPr>
             <a:r>
-              <a:t>17 / 23     13:25–14:10 planned     Sources and explanation in notes</a:t>
+              <a:t>17 / 24    13:25–14:10 planned    Sources and explanation in notes</a:t>
             </a:r>
           </a:p>
         </p:txBody>
@@ -10827,23 +10951,20 @@
         <p:spPr>
           <a:xfrm>
             <a:off x="640080" y="411480"/>
-            <a:ext cx="10972800" cy="256032"/>
-          </a:xfrm>
-          <a:prstGeom prst="rect">
-            <a:avLst/>
-          </a:prstGeom>
-          <a:noFill/>
-        </p:spPr>
-        <p:txBody>
-          <a:bodyPr wrap="square" lIns="0" rIns="0" tIns="0" bIns="0">
-            <a:spAutoFit/>
-          </a:bodyPr>
-          <a:lstStyle/>
-          <a:p>
-            <a:pPr>
-              <a:spcAft>
-                <a:spcPts val="600"/>
-              </a:spcAft>
+            <a:ext cx="10972800" cy="274320"/>
+          </a:xfrm>
+          <a:prstGeom prst="rect">
+            <a:avLst/>
+          </a:prstGeom>
+          <a:noFill/>
+        </p:spPr>
+        <p:txBody>
+          <a:bodyPr wrap="square" lIns="0" rIns="0" tIns="0" bIns="0">
+            <a:spAutoFit/>
+          </a:bodyPr>
+          <a:lstStyle/>
+          <a:p>
+            <a:pPr>
               <a:defRPr sz="1100" b="1">
                 <a:solidFill>
                   <a:srgbClr val="0088BA"/>
@@ -10852,7 +10973,7 @@
               </a:defRPr>
             </a:pPr>
             <a:r>
-              <a:t>4 / FEATURES IN CONTEXT</a:t>
+              <a:t>PART 3 / WHAT DSH PROVIDES AND HOW WE QUALIFY IT</a:t>
             </a:r>
           </a:p>
         </p:txBody>
@@ -10866,23 +10987,20 @@
         <p:spPr>
           <a:xfrm>
             <a:off x="640080" y="868680"/>
-            <a:ext cx="10972800" cy="731520"/>
-          </a:xfrm>
-          <a:prstGeom prst="rect">
-            <a:avLst/>
-          </a:prstGeom>
-          <a:noFill/>
-        </p:spPr>
-        <p:txBody>
-          <a:bodyPr wrap="square" lIns="0" rIns="0" tIns="0" bIns="0">
-            <a:spAutoFit/>
-          </a:bodyPr>
-          <a:lstStyle/>
-          <a:p>
-            <a:pPr>
-              <a:spcAft>
-                <a:spcPts val="600"/>
-              </a:spcAft>
+            <a:ext cx="10972800" cy="777240"/>
+          </a:xfrm>
+          <a:prstGeom prst="rect">
+            <a:avLst/>
+          </a:prstGeom>
+          <a:noFill/>
+        </p:spPr>
+        <p:txBody>
+          <a:bodyPr wrap="square" lIns="0" rIns="0" tIns="0" bIns="0">
+            <a:spAutoFit/>
+          </a:bodyPr>
+          <a:lstStyle/>
+          <a:p>
+            <a:pPr>
               <a:defRPr sz="2500" b="1">
                 <a:solidFill>
                   <a:srgbClr val="14243C"/>
@@ -10891,7 +11009,7 @@
               </a:defRPr>
             </a:pPr>
             <a:r>
-              <a:t>How DSH supports the working day</a:t>
+              <a:t>Each DSH feature closes a specific working gap</a:t>
             </a:r>
           </a:p>
         </p:txBody>
@@ -10905,23 +11023,20 @@
         <p:spPr>
           <a:xfrm>
             <a:off x="685800" y="1856231"/>
-            <a:ext cx="5212080" cy="384048"/>
-          </a:xfrm>
-          <a:prstGeom prst="rect">
-            <a:avLst/>
-          </a:prstGeom>
-          <a:noFill/>
-        </p:spPr>
-        <p:txBody>
-          <a:bodyPr wrap="square" lIns="0" rIns="0" tIns="0" bIns="0">
-            <a:spAutoFit/>
-          </a:bodyPr>
-          <a:lstStyle/>
-          <a:p>
-            <a:pPr>
-              <a:spcAft>
-                <a:spcPts val="600"/>
-              </a:spcAft>
+            <a:ext cx="5212080" cy="393192"/>
+          </a:xfrm>
+          <a:prstGeom prst="rect">
+            <a:avLst/>
+          </a:prstGeom>
+          <a:noFill/>
+        </p:spPr>
+        <p:txBody>
+          <a:bodyPr wrap="square" lIns="0" rIns="0" tIns="0" bIns="0">
+            <a:spAutoFit/>
+          </a:bodyPr>
+          <a:lstStyle/>
+          <a:p>
+            <a:pPr>
               <a:defRPr sz="1800" b="1">
                 <a:solidFill>
                   <a:srgbClr val="007DA5"/>
@@ -10930,7 +11045,7 @@
               </a:defRPr>
             </a:pPr>
             <a:r>
-              <a:t>Files and conversation</a:t>
+              <a:t>Organisation: project and files</a:t>
             </a:r>
           </a:p>
         </p:txBody>
@@ -10943,24 +11058,21 @@
         </p:nvSpPr>
         <p:spPr>
           <a:xfrm>
-            <a:off x="685800" y="2295144"/>
-            <a:ext cx="5212080" cy="1435608"/>
-          </a:xfrm>
-          <a:prstGeom prst="rect">
-            <a:avLst/>
-          </a:prstGeom>
-          <a:noFill/>
-        </p:spPr>
-        <p:txBody>
-          <a:bodyPr wrap="square" lIns="0" rIns="0" tIns="0" bIns="0">
-            <a:spAutoFit/>
-          </a:bodyPr>
-          <a:lstStyle/>
-          <a:p>
-            <a:pPr>
-              <a:spcAft>
-                <a:spcPts val="600"/>
-              </a:spcAft>
+            <a:off x="685800" y="2304287"/>
+            <a:ext cx="5212080" cy="1463040"/>
+          </a:xfrm>
+          <a:prstGeom prst="rect">
+            <a:avLst/>
+          </a:prstGeom>
+          <a:noFill/>
+        </p:spPr>
+        <p:txBody>
+          <a:bodyPr wrap="square" lIns="0" rIns="0" tIns="0" bIns="0">
+            <a:spAutoFit/>
+          </a:bodyPr>
+          <a:lstStyle/>
+          <a:p>
+            <a:pPr>
               <a:defRPr sz="1600" b="0">
                 <a:solidFill>
                   <a:srgbClr val="26354A"/>
@@ -10969,7 +11081,7 @@
               </a:defRPr>
             </a:pPr>
             <a:r>
-              <a:t>Keep source material and discussion in a private project. Example: borrower statements, ratio assumptions and the draft memo remain together for review.</a:t>
+              <a:t>Keep inputs, discussion and outputs together so reviewers can find the evidence. Use approved copies, clear names and a recorded source date. A project alone does not authorise sensitive data.</a:t>
             </a:r>
           </a:p>
         </p:txBody>
@@ -10983,23 +11095,20 @@
         <p:spPr>
           <a:xfrm>
             <a:off x="6309360" y="1856231"/>
-            <a:ext cx="5212080" cy="384048"/>
-          </a:xfrm>
-          <a:prstGeom prst="rect">
-            <a:avLst/>
-          </a:prstGeom>
-          <a:noFill/>
-        </p:spPr>
-        <p:txBody>
-          <a:bodyPr wrap="square" lIns="0" rIns="0" tIns="0" bIns="0">
-            <a:spAutoFit/>
-          </a:bodyPr>
-          <a:lstStyle/>
-          <a:p>
-            <a:pPr>
-              <a:spcAft>
-                <a:spcPts val="600"/>
-              </a:spcAft>
+            <a:ext cx="5212080" cy="393192"/>
+          </a:xfrm>
+          <a:prstGeom prst="rect">
+            <a:avLst/>
+          </a:prstGeom>
+          <a:noFill/>
+        </p:spPr>
+        <p:txBody>
+          <a:bodyPr wrap="square" lIns="0" rIns="0" tIns="0" bIns="0">
+            <a:spAutoFit/>
+          </a:bodyPr>
+          <a:lstStyle/>
+          <a:p>
+            <a:pPr>
               <a:defRPr sz="1800" b="1">
                 <a:solidFill>
                   <a:srgbClr val="007DA5"/>
@@ -11008,7 +11117,7 @@
               </a:defRPr>
             </a:pPr>
             <a:r>
-              <a:t>Terminal and Jupyter</a:t>
+              <a:t>Inspection: code and notebooks</a:t>
             </a:r>
           </a:p>
         </p:txBody>
@@ -11021,24 +11130,21 @@
         </p:nvSpPr>
         <p:spPr>
           <a:xfrm>
-            <a:off x="6309360" y="2295144"/>
-            <a:ext cx="5212080" cy="1435608"/>
-          </a:xfrm>
-          <a:prstGeom prst="rect">
-            <a:avLst/>
-          </a:prstGeom>
-          <a:noFill/>
-        </p:spPr>
-        <p:txBody>
-          <a:bodyPr wrap="square" lIns="0" rIns="0" tIns="0" bIns="0">
-            <a:spAutoFit/>
-          </a:bodyPr>
-          <a:lstStyle/>
-          <a:p>
-            <a:pPr>
-              <a:spcAft>
-                <a:spcPts val="600"/>
-              </a:spcAft>
+            <a:off x="6309360" y="2304287"/>
+            <a:ext cx="5212080" cy="1463040"/>
+          </a:xfrm>
+          <a:prstGeom prst="rect">
+            <a:avLst/>
+          </a:prstGeom>
+          <a:noFill/>
+        </p:spPr>
+        <p:txBody>
+          <a:bodyPr wrap="square" lIns="0" rIns="0" tIns="0" bIns="0">
+            <a:spAutoFit/>
+          </a:bodyPr>
+          <a:lstStyle/>
+          <a:p>
+            <a:pPr>
               <a:defRPr sz="1600" b="0">
                 <a:solidFill>
                   <a:srgbClr val="26354A"/>
@@ -11047,7 +11153,7 @@
               </a:defRPr>
             </a:pPr>
             <a:r>
-              <a:t>Inspect data and rerun calculations. Example: a reviewer reproduces the invoice sum rather than trusting a number in a paragraph.</a:t>
+              <a:t>Save calculations with inputs and assumptions. For a claim, show the invoice rows and duplicate rule behind the total. Reproducible arithmetic still needs correct business rules.</a:t>
             </a:r>
           </a:p>
         </p:txBody>
@@ -11061,23 +11167,20 @@
         <p:spPr>
           <a:xfrm>
             <a:off x="685800" y="3858768"/>
-            <a:ext cx="5212080" cy="384048"/>
-          </a:xfrm>
-          <a:prstGeom prst="rect">
-            <a:avLst/>
-          </a:prstGeom>
-          <a:noFill/>
-        </p:spPr>
-        <p:txBody>
-          <a:bodyPr wrap="square" lIns="0" rIns="0" tIns="0" bIns="0">
-            <a:spAutoFit/>
-          </a:bodyPr>
-          <a:lstStyle/>
-          <a:p>
-            <a:pPr>
-              <a:spcAft>
-                <a:spcPts val="600"/>
-              </a:spcAft>
+            <a:ext cx="5212080" cy="393192"/>
+          </a:xfrm>
+          <a:prstGeom prst="rect">
+            <a:avLst/>
+          </a:prstGeom>
+          <a:noFill/>
+        </p:spPr>
+        <p:txBody>
+          <a:bodyPr wrap="square" lIns="0" rIns="0" tIns="0" bIns="0">
+            <a:spAutoFit/>
+          </a:bodyPr>
+          <a:lstStyle/>
+          <a:p>
+            <a:pPr>
               <a:defRPr sz="1800" b="1">
                 <a:solidFill>
                   <a:srgbClr val="007DA5"/>
@@ -11086,7 +11189,7 @@
               </a:defRPr>
             </a:pPr>
             <a:r>
-              <a:t>Apps and environments</a:t>
+              <a:t>Consistency: managed environments</a:t>
             </a:r>
           </a:p>
         </p:txBody>
@@ -11099,24 +11202,21 @@
         </p:nvSpPr>
         <p:spPr>
           <a:xfrm>
-            <a:off x="685800" y="4297679"/>
-            <a:ext cx="5212080" cy="1435608"/>
-          </a:xfrm>
-          <a:prstGeom prst="rect">
-            <a:avLst/>
-          </a:prstGeom>
-          <a:noFill/>
-        </p:spPr>
-        <p:txBody>
-          <a:bodyPr wrap="square" lIns="0" rIns="0" tIns="0" bIns="0">
-            <a:spAutoFit/>
-          </a:bodyPr>
-          <a:lstStyle/>
-          <a:p>
-            <a:pPr>
-              <a:spcAft>
-                <a:spcPts val="600"/>
-              </a:spcAft>
+            <a:off x="685800" y="4306824"/>
+            <a:ext cx="5212080" cy="1463040"/>
+          </a:xfrm>
+          <a:prstGeom prst="rect">
+            <a:avLst/>
+          </a:prstGeom>
+          <a:noFill/>
+        </p:spPr>
+        <p:txBody>
+          <a:bodyPr wrap="square" lIns="0" rIns="0" tIns="0" bIns="0">
+            <a:spAutoFit/>
+          </a:bodyPr>
+          <a:lstStyle/>
+          <a:p>
+            <a:pPr>
               <a:defRPr sz="1600" b="0">
                 <a:solidFill>
                   <a:srgbClr val="26354A"/>
@@ -11125,7 +11225,7 @@
               </a:defRPr>
             </a:pPr>
             <a:r>
-              <a:t>Authenticated routes connect users to services. Managed Python environments and versioned kernels support a consistent starting point. Guides aid adoption and handover.</a:t>
+              <a:t>Record dependencies and versions so colleagues can repeat the method. Review package source and hashes before approval. An approved package can still contain a vulnerability.</a:t>
             </a:r>
           </a:p>
         </p:txBody>
@@ -11139,23 +11239,20 @@
         <p:spPr>
           <a:xfrm>
             <a:off x="6309360" y="3858768"/>
-            <a:ext cx="5212080" cy="384048"/>
-          </a:xfrm>
-          <a:prstGeom prst="rect">
-            <a:avLst/>
-          </a:prstGeom>
-          <a:noFill/>
-        </p:spPr>
-        <p:txBody>
-          <a:bodyPr wrap="square" lIns="0" rIns="0" tIns="0" bIns="0">
-            <a:spAutoFit/>
-          </a:bodyPr>
-          <a:lstStyle/>
-          <a:p>
-            <a:pPr>
-              <a:spcAft>
-                <a:spcPts val="600"/>
-              </a:spcAft>
+            <a:ext cx="5212080" cy="393192"/>
+          </a:xfrm>
+          <a:prstGeom prst="rect">
+            <a:avLst/>
+          </a:prstGeom>
+          <a:noFill/>
+        </p:spPr>
+        <p:txBody>
+          <a:bodyPr wrap="square" lIns="0" rIns="0" tIns="0" bIns="0">
+            <a:spAutoFit/>
+          </a:bodyPr>
+          <a:lstStyle/>
+          <a:p>
+            <a:pPr>
               <a:defRPr sz="1800" b="1">
                 <a:solidFill>
                   <a:srgbClr val="007DA5"/>
@@ -11164,7 +11261,7 @@
               </a:defRPr>
             </a:pPr>
             <a:r>
-              <a:t>Persistence has limits</a:t>
+              <a:t>Handover: saved work and guides</a:t>
             </a:r>
           </a:p>
         </p:txBody>
@@ -11177,24 +11274,21 @@
         </p:nvSpPr>
         <p:spPr>
           <a:xfrm>
-            <a:off x="6309360" y="4297679"/>
-            <a:ext cx="5212080" cy="1435608"/>
-          </a:xfrm>
-          <a:prstGeom prst="rect">
-            <a:avLst/>
-          </a:prstGeom>
-          <a:noFill/>
-        </p:spPr>
-        <p:txBody>
-          <a:bodyPr wrap="square" lIns="0" rIns="0" tIns="0" bIns="0">
-            <a:spAutoFit/>
-          </a:bodyPr>
-          <a:lstStyle/>
-          <a:p>
-            <a:pPr>
-              <a:spcAft>
-                <a:spcPts val="600"/>
-              </a:spcAft>
+            <a:off x="6309360" y="4306824"/>
+            <a:ext cx="5212080" cy="1463040"/>
+          </a:xfrm>
+          <a:prstGeom prst="rect">
+            <a:avLst/>
+          </a:prstGeom>
+          <a:noFill/>
+        </p:spPr>
+        <p:txBody>
+          <a:bodyPr wrap="square" lIns="0" rIns="0" tIns="0" bIns="0">
+            <a:spAutoFit/>
+          </a:bodyPr>
+          <a:lstStyle/>
+          <a:p>
+            <a:pPr>
               <a:defRPr sz="1600" b="0">
                 <a:solidFill>
                   <a:srgbClr val="26354A"/>
@@ -11203,7 +11297,7 @@
               </a:defRPr>
             </a:pPr>
             <a:r>
-              <a:t>Saved files persist. Kernel memory and unmanaged running processes do not automatically return. Save inputs, code and results needed to recreate the work.</a:t>
+              <a:t>Save files, code, results and instructions for the next reviewer. Saved state can persist, but kernel memory and unmanaged processes may need restarting. Reopen and rerun to verify recovery.</a:t>
             </a:r>
           </a:p>
         </p:txBody>
@@ -11216,24 +11310,21 @@
         </p:nvSpPr>
         <p:spPr>
           <a:xfrm>
-            <a:off x="685800" y="6044184"/>
-            <a:ext cx="10789920" cy="237744"/>
-          </a:xfrm>
-          <a:prstGeom prst="rect">
-            <a:avLst/>
-          </a:prstGeom>
-          <a:noFill/>
-        </p:spPr>
-        <p:txBody>
-          <a:bodyPr wrap="square" lIns="0" rIns="0" tIns="0" bIns="0">
-            <a:spAutoFit/>
-          </a:bodyPr>
-          <a:lstStyle/>
-          <a:p>
-            <a:pPr>
-              <a:spcAft>
-                <a:spcPts val="600"/>
-              </a:spcAft>
+            <a:off x="685800" y="6071616"/>
+            <a:ext cx="10789920" cy="274320"/>
+          </a:xfrm>
+          <a:prstGeom prst="rect">
+            <a:avLst/>
+          </a:prstGeom>
+          <a:noFill/>
+        </p:spPr>
+        <p:txBody>
+          <a:bodyPr wrap="square" lIns="0" rIns="0" tIns="0" bIns="0">
+            <a:spAutoFit/>
+          </a:bodyPr>
+          <a:lstStyle/>
+          <a:p>
+            <a:pPr>
               <a:defRPr sz="1000" b="0">
                 <a:solidFill>
                   <a:srgbClr val="66758A"/>
@@ -11242,7 +11333,7 @@
               </a:defRPr>
             </a:pPr>
             <a:r>
-              <a:t>Source links, explanation and limits are in the speaker guide and slide notes.</a:t>
+              <a:t>Reference features and proposed acceptance checks. No new live deployment verification.</a:t>
             </a:r>
           </a:p>
         </p:txBody>
@@ -11264,13 +11355,13 @@
           <a:noFill/>
         </p:spPr>
         <p:txBody>
-          <a:bodyPr wrap="none">
-            <a:spAutoFit/>
-          </a:bodyPr>
-          <a:lstStyle/>
-          <a:p>
-            <a:pPr>
-              <a:defRPr sz="900">
+          <a:bodyPr wrap="square" lIns="0" rIns="0" tIns="0" bIns="0">
+            <a:spAutoFit/>
+          </a:bodyPr>
+          <a:lstStyle/>
+          <a:p>
+            <a:pPr>
+              <a:defRPr sz="900" b="0">
                 <a:solidFill>
                   <a:srgbClr val="66758A"/>
                 </a:solidFill>
@@ -11278,7 +11369,7 @@
               </a:defRPr>
             </a:pPr>
             <a:r>
-              <a:t>18 / 23     14:10–14:55 planned     Sources and explanation in notes</a:t>
+              <a:t>18 / 24    14:10–14:55 planned    Sources and explanation in notes</a:t>
             </a:r>
           </a:p>
         </p:txBody>
@@ -11747,13 +11838,13 @@
           <a:noFill/>
         </p:spPr>
         <p:txBody>
-          <a:bodyPr wrap="none">
-            <a:spAutoFit/>
-          </a:bodyPr>
-          <a:lstStyle/>
-          <a:p>
-            <a:pPr>
-              <a:defRPr sz="900">
+          <a:bodyPr wrap="square" lIns="0" rIns="0" tIns="0" bIns="0">
+            <a:spAutoFit/>
+          </a:bodyPr>
+          <a:lstStyle/>
+          <a:p>
+            <a:pPr>
+              <a:defRPr sz="900" b="0">
                 <a:solidFill>
                   <a:srgbClr val="66758A"/>
                 </a:solidFill>
@@ -11761,7 +11852,7 @@
               </a:defRPr>
             </a:pPr>
             <a:r>
-              <a:t>19 / 23     14:55–15:45 planned     Sources and explanation in notes</a:t>
+              <a:t>20 / 24    15:50–16:40 planned    Sources and explanation in notes</a:t>
             </a:r>
           </a:p>
         </p:txBody>
@@ -12191,13 +12282,13 @@
           <a:noFill/>
         </p:spPr>
         <p:txBody>
-          <a:bodyPr wrap="none">
-            <a:spAutoFit/>
-          </a:bodyPr>
-          <a:lstStyle/>
-          <a:p>
-            <a:pPr>
-              <a:defRPr sz="900">
+          <a:bodyPr wrap="square" lIns="0" rIns="0" tIns="0" bIns="0">
+            <a:spAutoFit/>
+          </a:bodyPr>
+          <a:lstStyle/>
+          <a:p>
+            <a:pPr>
+              <a:defRPr sz="900" b="0">
                 <a:solidFill>
                   <a:srgbClr val="66758A"/>
                 </a:solidFill>
@@ -12205,7 +12296,7 @@
               </a:defRPr>
             </a:pPr>
             <a:r>
-              <a:t>2 / 23     00:30–01:10 planned     Sources and explanation in notes</a:t>
+              <a:t>2 / 24    00:30–01:10 planned    Sources and explanation in notes</a:t>
             </a:r>
           </a:p>
         </p:txBody>
@@ -12237,23 +12328,20 @@
         <p:spPr>
           <a:xfrm>
             <a:off x="640080" y="411480"/>
-            <a:ext cx="10972800" cy="256032"/>
-          </a:xfrm>
-          <a:prstGeom prst="rect">
-            <a:avLst/>
-          </a:prstGeom>
-          <a:noFill/>
-        </p:spPr>
-        <p:txBody>
-          <a:bodyPr wrap="square" lIns="0" rIns="0" tIns="0" bIns="0">
-            <a:spAutoFit/>
-          </a:bodyPr>
-          <a:lstStyle/>
-          <a:p>
-            <a:pPr>
-              <a:spcAft>
-                <a:spcPts val="600"/>
-              </a:spcAft>
+            <a:ext cx="10972800" cy="274320"/>
+          </a:xfrm>
+          <a:prstGeom prst="rect">
+            <a:avLst/>
+          </a:prstGeom>
+          <a:noFill/>
+        </p:spPr>
+        <p:txBody>
+          <a:bodyPr wrap="square" lIns="0" rIns="0" tIns="0" bIns="0">
+            <a:spAutoFit/>
+          </a:bodyPr>
+          <a:lstStyle/>
+          <a:p>
+            <a:pPr>
               <a:defRPr sz="1100" b="1">
                 <a:solidFill>
                   <a:srgbClr val="0088BA"/>
@@ -12262,7 +12350,7 @@
               </a:defRPr>
             </a:pPr>
             <a:r>
-              <a:t>4 / ACCEPTANCE AND RECOVERY</a:t>
+              <a:t>PART 3 / WHAT DSH PROVIDES AND HOW WE QUALIFY IT</a:t>
             </a:r>
           </a:p>
         </p:txBody>
@@ -12276,23 +12364,20 @@
         <p:spPr>
           <a:xfrm>
             <a:off x="640080" y="868680"/>
-            <a:ext cx="10972800" cy="731520"/>
-          </a:xfrm>
-          <a:prstGeom prst="rect">
-            <a:avLst/>
-          </a:prstGeom>
-          <a:noFill/>
-        </p:spPr>
-        <p:txBody>
-          <a:bodyPr wrap="square" lIns="0" rIns="0" tIns="0" bIns="0">
-            <a:spAutoFit/>
-          </a:bodyPr>
-          <a:lstStyle/>
-          <a:p>
-            <a:pPr>
-              <a:spcAft>
-                <a:spcPts val="600"/>
-              </a:spcAft>
+            <a:ext cx="10972800" cy="777240"/>
+          </a:xfrm>
+          <a:prstGeom prst="rect">
+            <a:avLst/>
+          </a:prstGeom>
+          <a:noFill/>
+        </p:spPr>
+        <p:txBody>
+          <a:bodyPr wrap="square" lIns="0" rIns="0" tIns="0" bIns="0">
+            <a:spAutoFit/>
+          </a:bodyPr>
+          <a:lstStyle/>
+          <a:p>
+            <a:pPr>
               <a:defRPr sz="2500" b="1">
                 <a:solidFill>
                   <a:srgbClr val="14243C"/>
@@ -12301,7 +12386,7 @@
               </a:defRPr>
             </a:pPr>
             <a:r>
-              <a:t>Test the whole path before expanding a workflow</a:t>
+              <a:t>Safety evidence comes from testing the actual workflow</a:t>
             </a:r>
           </a:p>
         </p:txBody>
@@ -12315,23 +12400,20 @@
         <p:spPr>
           <a:xfrm>
             <a:off x="685800" y="1856231"/>
-            <a:ext cx="5212080" cy="384048"/>
-          </a:xfrm>
-          <a:prstGeom prst="rect">
-            <a:avLst/>
-          </a:prstGeom>
-          <a:noFill/>
-        </p:spPr>
-        <p:txBody>
-          <a:bodyPr wrap="square" lIns="0" rIns="0" tIns="0" bIns="0">
-            <a:spAutoFit/>
-          </a:bodyPr>
-          <a:lstStyle/>
-          <a:p>
-            <a:pPr>
-              <a:spcAft>
-                <a:spcPts val="600"/>
-              </a:spcAft>
+            <a:ext cx="5212080" cy="393192"/>
+          </a:xfrm>
+          <a:prstGeom prst="rect">
+            <a:avLst/>
+          </a:prstGeom>
+          <a:noFill/>
+        </p:spPr>
+        <p:txBody>
+          <a:bodyPr wrap="square" lIns="0" rIns="0" tIns="0" bIns="0">
+            <a:spAutoFit/>
+          </a:bodyPr>
+          <a:lstStyle/>
+          <a:p>
+            <a:pPr>
               <a:defRPr sz="1800" b="1">
                 <a:solidFill>
                   <a:srgbClr val="007DA5"/>
@@ -12340,7 +12422,7 @@
               </a:defRPr>
             </a:pPr>
             <a:r>
-              <a:t>Trust and access</a:t>
+              <a:t>Isolation and restricted routes</a:t>
             </a:r>
           </a:p>
         </p:txBody>
@@ -12353,24 +12435,21 @@
         </p:nvSpPr>
         <p:spPr>
           <a:xfrm>
-            <a:off x="685800" y="2295144"/>
-            <a:ext cx="5212080" cy="1435608"/>
-          </a:xfrm>
-          <a:prstGeom prst="rect">
-            <a:avLst/>
-          </a:prstGeom>
-          <a:noFill/>
-        </p:spPr>
-        <p:txBody>
-          <a:bodyPr wrap="square" lIns="0" rIns="0" tIns="0" bIns="0">
-            <a:spAutoFit/>
-          </a:bodyPr>
-          <a:lstStyle/>
-          <a:p>
-            <a:pPr>
-              <a:spcAft>
-                <a:spcPts val="600"/>
-              </a:spcAft>
+            <a:off x="685800" y="2304287"/>
+            <a:ext cx="5212080" cy="1463040"/>
+          </a:xfrm>
+          <a:prstGeom prst="rect">
+            <a:avLst/>
+          </a:prstGeom>
+          <a:noFill/>
+        </p:spPr>
+        <p:txBody>
+          <a:bodyPr wrap="square" lIns="0" rIns="0" tIns="0" bIns="0">
+            <a:spAutoFit/>
+          </a:bodyPr>
+          <a:lstStyle/>
+          <a:p>
+            <a:pPr>
               <a:defRPr sz="1600" b="0">
                 <a:solidFill>
                   <a:srgbClr val="26354A"/>
@@ -12379,7 +12458,7 @@
               </a:defRPr>
             </a:pPr>
             <a:r>
-              <a:t>Use harmless test secrets and untrusted sample documents. Check hooks and MCP settings before consent. Try alternative file and network paths, including supporting services.</a:t>
+              <a:t>With disposable users and test files, try reading a peer workspace and contacting an unapproved destination. Test DNS and package services too. Inspect denials and the receiving side where possible.</a:t>
             </a:r>
           </a:p>
         </p:txBody>
@@ -12393,23 +12472,20 @@
         <p:spPr>
           <a:xfrm>
             <a:off x="6309360" y="1856231"/>
-            <a:ext cx="5212080" cy="384048"/>
-          </a:xfrm>
-          <a:prstGeom prst="rect">
-            <a:avLst/>
-          </a:prstGeom>
-          <a:noFill/>
-        </p:spPr>
-        <p:txBody>
-          <a:bodyPr wrap="square" lIns="0" rIns="0" tIns="0" bIns="0">
-            <a:spAutoFit/>
-          </a:bodyPr>
-          <a:lstStyle/>
-          <a:p>
-            <a:pPr>
-              <a:spcAft>
-                <a:spcPts val="600"/>
-              </a:spcAft>
+            <a:ext cx="5212080" cy="393192"/>
+          </a:xfrm>
+          <a:prstGeom prst="rect">
+            <a:avLst/>
+          </a:prstGeom>
+          <a:noFill/>
+        </p:spPr>
+        <p:txBody>
+          <a:bodyPr wrap="square" lIns="0" rIns="0" tIns="0" bIns="0">
+            <a:spAutoFit/>
+          </a:bodyPr>
+          <a:lstStyle/>
+          <a:p>
+            <a:pPr>
               <a:defRPr sz="1800" b="1">
                 <a:solidFill>
                   <a:srgbClr val="007DA5"/>
@@ -12418,7 +12494,7 @@
               </a:defRPr>
             </a:pPr>
             <a:r>
-              <a:t>Actions and outputs</a:t>
+              <a:t>Unauthorised actions and exports</a:t>
             </a:r>
           </a:p>
         </p:txBody>
@@ -12431,24 +12507,21 @@
         </p:nvSpPr>
         <p:spPr>
           <a:xfrm>
-            <a:off x="6309360" y="2295144"/>
-            <a:ext cx="5212080" cy="1435608"/>
-          </a:xfrm>
-          <a:prstGeom prst="rect">
-            <a:avLst/>
-          </a:prstGeom>
-          <a:noFill/>
-        </p:spPr>
-        <p:txBody>
-          <a:bodyPr wrap="square" lIns="0" rIns="0" tIns="0" bIns="0">
-            <a:spAutoFit/>
-          </a:bodyPr>
-          <a:lstStyle/>
-          <a:p>
-            <a:pPr>
-              <a:spcAft>
-                <a:spcPts val="600"/>
-              </a:spcAft>
+            <a:off x="6309360" y="2304287"/>
+            <a:ext cx="5212080" cy="1463040"/>
+          </a:xfrm>
+          <a:prstGeom prst="rect">
+            <a:avLst/>
+          </a:prstGeom>
+          <a:noFill/>
+        </p:spPr>
+        <p:txBody>
+          <a:bodyPr wrap="square" lIns="0" rIns="0" tIns="0" bIns="0">
+            <a:spAutoFit/>
+          </a:bodyPr>
+          <a:lstStyle/>
+          <a:p>
+            <a:pPr>
               <a:defRPr sz="1600" b="0">
                 <a:solidFill>
                   <a:srgbClr val="26354A"/>
@@ -12457,7 +12530,7 @@
               </a:defRPr>
             </a:pPr>
             <a:r>
-              <a:t>Test tool names, arguments and limits. Check that an unapproved send or record change fails. Inspect HTML and saved context for unintended data or requests.</a:t>
+              <a:t>Use harmless canary data. Try an unapproved send or record change and inspect the target audit. Open exported HTML in its intended viewer and check scripts, remote requests and data exposure.</a:t>
             </a:r>
           </a:p>
         </p:txBody>
@@ -12471,23 +12544,20 @@
         <p:spPr>
           <a:xfrm>
             <a:off x="685800" y="3858768"/>
-            <a:ext cx="5212080" cy="384048"/>
-          </a:xfrm>
-          <a:prstGeom prst="rect">
-            <a:avLst/>
-          </a:prstGeom>
-          <a:noFill/>
-        </p:spPr>
-        <p:txBody>
-          <a:bodyPr wrap="square" lIns="0" rIns="0" tIns="0" bIns="0">
-            <a:spAutoFit/>
-          </a:bodyPr>
-          <a:lstStyle/>
-          <a:p>
-            <a:pPr>
-              <a:spcAft>
-                <a:spcPts val="600"/>
-              </a:spcAft>
+            <a:ext cx="5212080" cy="393192"/>
+          </a:xfrm>
+          <a:prstGeom prst="rect">
+            <a:avLst/>
+          </a:prstGeom>
+          <a:noFill/>
+        </p:spPr>
+        <p:txBody>
+          <a:bodyPr wrap="square" lIns="0" rIns="0" tIns="0" bIns="0">
+            <a:spAutoFit/>
+          </a:bodyPr>
+          <a:lstStyle/>
+          <a:p>
+            <a:pPr>
               <a:defRPr sz="1800" b="1">
                 <a:solidFill>
                   <a:srgbClr val="007DA5"/>
@@ -12496,7 +12566,7 @@
               </a:defRPr>
             </a:pPr>
             <a:r>
-              <a:t>Failure and recovery</a:t>
+              <a:t>Alerts, stop and recovery</a:t>
             </a:r>
           </a:p>
         </p:txBody>
@@ -12509,24 +12579,21 @@
         </p:nvSpPr>
         <p:spPr>
           <a:xfrm>
-            <a:off x="685800" y="4297679"/>
-            <a:ext cx="5212080" cy="1435608"/>
-          </a:xfrm>
-          <a:prstGeom prst="rect">
-            <a:avLst/>
-          </a:prstGeom>
-          <a:noFill/>
-        </p:spPr>
-        <p:txBody>
-          <a:bodyPr wrap="square" lIns="0" rIns="0" tIns="0" bIns="0">
-            <a:spAutoFit/>
-          </a:bodyPr>
-          <a:lstStyle/>
-          <a:p>
-            <a:pPr>
-              <a:spcAft>
-                <a:spcPts val="600"/>
-              </a:spcAft>
+            <a:off x="685800" y="4306824"/>
+            <a:ext cx="5212080" cy="1463040"/>
+          </a:xfrm>
+          <a:prstGeom prst="rect">
+            <a:avLst/>
+          </a:prstGeom>
+          <a:noFill/>
+        </p:spPr>
+        <p:txBody>
+          <a:bodyPr wrap="square" lIns="0" rIns="0" tIns="0" bIns="0">
+            <a:spAutoFit/>
+          </a:bodyPr>
+          <a:lstStyle/>
+          <a:p>
+            <a:pPr>
               <a:defRPr sz="1600" b="0">
                 <a:solidFill>
                   <a:srgbClr val="26354A"/>
@@ -12535,7 +12602,7 @@
               </a:defRPr>
             </a:pPr>
             <a:r>
-              <a:t>Check alerts and log access. Revoke a test credential, stop a test run and inspect queued work. Define which approved state can restart and who authorises it.</a:t>
+              <a:t>Trigger a controlled failure, confirm the right person receives the alert, then stop a disposable run. Check queued work, saved files and restart behaviour before approving recovery.</a:t>
             </a:r>
           </a:p>
         </p:txBody>
@@ -12549,23 +12616,20 @@
         <p:spPr>
           <a:xfrm>
             <a:off x="6309360" y="3858768"/>
-            <a:ext cx="5212080" cy="384048"/>
-          </a:xfrm>
-          <a:prstGeom prst="rect">
-            <a:avLst/>
-          </a:prstGeom>
-          <a:noFill/>
-        </p:spPr>
-        <p:txBody>
-          <a:bodyPr wrap="square" lIns="0" rIns="0" tIns="0" bIns="0">
-            <a:spAutoFit/>
-          </a:bodyPr>
-          <a:lstStyle/>
-          <a:p>
-            <a:pPr>
-              <a:spcAft>
-                <a:spcPts val="600"/>
-              </a:spcAft>
+            <a:ext cx="5212080" cy="393192"/>
+          </a:xfrm>
+          <a:prstGeom prst="rect">
+            <a:avLst/>
+          </a:prstGeom>
+          <a:noFill/>
+        </p:spPr>
+        <p:txBody>
+          <a:bodyPr wrap="square" lIns="0" rIns="0" tIns="0" bIns="0">
+            <a:spAutoFit/>
+          </a:bodyPr>
+          <a:lstStyle/>
+          <a:p>
+            <a:pPr>
               <a:defRPr sz="1800" b="1">
                 <a:solidFill>
                   <a:srgbClr val="007DA5"/>
@@ -12574,7 +12638,7 @@
               </a:defRPr>
             </a:pPr>
             <a:r>
-              <a:t>Pass evidence</a:t>
+              <a:t>A scoped acceptance record</a:t>
             </a:r>
           </a:p>
         </p:txBody>
@@ -12587,24 +12651,21 @@
         </p:nvSpPr>
         <p:spPr>
           <a:xfrm>
-            <a:off x="6309360" y="4297679"/>
-            <a:ext cx="5212080" cy="1435608"/>
-          </a:xfrm>
-          <a:prstGeom prst="rect">
-            <a:avLst/>
-          </a:prstGeom>
-          <a:noFill/>
-        </p:spPr>
-        <p:txBody>
-          <a:bodyPr wrap="square" lIns="0" rIns="0" tIns="0" bIns="0">
-            <a:spAutoFit/>
-          </a:bodyPr>
-          <a:lstStyle/>
-          <a:p>
-            <a:pPr>
-              <a:spcAft>
-                <a:spcPts val="600"/>
-              </a:spcAft>
+            <a:off x="6309360" y="4306824"/>
+            <a:ext cx="5212080" cy="1463040"/>
+          </a:xfrm>
+          <a:prstGeom prst="rect">
+            <a:avLst/>
+          </a:prstGeom>
+          <a:noFill/>
+        </p:spPr>
+        <p:txBody>
+          <a:bodyPr wrap="square" lIns="0" rIns="0" tIns="0" bIns="0">
+            <a:spAutoFit/>
+          </a:bodyPr>
+          <a:lstStyle/>
+          <a:p>
+            <a:pPr>
               <a:defRPr sz="1600" b="0">
                 <a:solidFill>
                   <a:srgbClr val="26354A"/>
@@ -12613,7 +12674,7 @@
               </a:defRPr>
             </a:pPr>
             <a:r>
-              <a:t>Keep exact versions, inputs, observed results and review decisions. Canaries cover selected paths. A green build, token expiry or visible stop control alone is insufficient.</a:t>
+              <a:t>Keep the exact version, configuration, inputs, expected result, observed result and owner decision. Test legitimate work too. These are proposed acceptance checks, not tests completed by this deck.</a:t>
             </a:r>
           </a:p>
         </p:txBody>
@@ -12626,24 +12687,21 @@
         </p:nvSpPr>
         <p:spPr>
           <a:xfrm>
-            <a:off x="685800" y="6044184"/>
-            <a:ext cx="10789920" cy="237744"/>
-          </a:xfrm>
-          <a:prstGeom prst="rect">
-            <a:avLst/>
-          </a:prstGeom>
-          <a:noFill/>
-        </p:spPr>
-        <p:txBody>
-          <a:bodyPr wrap="square" lIns="0" rIns="0" tIns="0" bIns="0">
-            <a:spAutoFit/>
-          </a:bodyPr>
-          <a:lstStyle/>
-          <a:p>
-            <a:pPr>
-              <a:spcAft>
-                <a:spcPts val="600"/>
-              </a:spcAft>
+            <a:off x="685800" y="6071616"/>
+            <a:ext cx="10789920" cy="274320"/>
+          </a:xfrm>
+          <a:prstGeom prst="rect">
+            <a:avLst/>
+          </a:prstGeom>
+          <a:noFill/>
+        </p:spPr>
+        <p:txBody>
+          <a:bodyPr wrap="square" lIns="0" rIns="0" tIns="0" bIns="0">
+            <a:spAutoFit/>
+          </a:bodyPr>
+          <a:lstStyle/>
+          <a:p>
+            <a:pPr>
               <a:defRPr sz="1000" b="0">
                 <a:solidFill>
                   <a:srgbClr val="66758A"/>
@@ -12652,7 +12710,7 @@
               </a:defRPr>
             </a:pPr>
             <a:r>
-              <a:t>Source links, explanation and limits are in the speaker guide and slide notes.</a:t>
+              <a:t>Reference features and proposed acceptance checks. No new live deployment verification.</a:t>
             </a:r>
           </a:p>
         </p:txBody>
@@ -12674,13 +12732,13 @@
           <a:noFill/>
         </p:spPr>
         <p:txBody>
-          <a:bodyPr wrap="none">
-            <a:spAutoFit/>
-          </a:bodyPr>
-          <a:lstStyle/>
-          <a:p>
-            <a:pPr>
-              <a:defRPr sz="900">
+          <a:bodyPr wrap="square" lIns="0" rIns="0" tIns="0" bIns="0">
+            <a:spAutoFit/>
+          </a:bodyPr>
+          <a:lstStyle/>
+          <a:p>
+            <a:pPr>
+              <a:defRPr sz="900" b="0">
                 <a:solidFill>
                   <a:srgbClr val="66758A"/>
                 </a:solidFill>
@@ -12688,7 +12746,7 @@
               </a:defRPr>
             </a:pPr>
             <a:r>
-              <a:t>20 / 23     15:45–16:35 planned     Sources and explanation in notes</a:t>
+              <a:t>21 / 24    16:40–17:30 planned    Sources and explanation in notes</a:t>
             </a:r>
           </a:p>
         </p:txBody>
@@ -13157,13 +13215,13 @@
           <a:noFill/>
         </p:spPr>
         <p:txBody>
-          <a:bodyPr wrap="none">
-            <a:spAutoFit/>
-          </a:bodyPr>
-          <a:lstStyle/>
-          <a:p>
-            <a:pPr>
-              <a:defRPr sz="900">
+          <a:bodyPr wrap="square" lIns="0" rIns="0" tIns="0" bIns="0">
+            <a:spAutoFit/>
+          </a:bodyPr>
+          <a:lstStyle/>
+          <a:p>
+            <a:pPr>
+              <a:defRPr sz="900" b="0">
                 <a:solidFill>
                   <a:srgbClr val="66758A"/>
                 </a:solidFill>
@@ -13171,7 +13229,7 @@
               </a:defRPr>
             </a:pPr>
             <a:r>
-              <a:t>21 / 23     16:35–17:20 planned     Sources and explanation in notes</a:t>
+              <a:t>22 / 24    17:30–18:15 planned    Sources and explanation in notes</a:t>
             </a:r>
           </a:p>
         </p:txBody>
@@ -13640,13 +13698,13 @@
           <a:noFill/>
         </p:spPr>
         <p:txBody>
-          <a:bodyPr wrap="none">
-            <a:spAutoFit/>
-          </a:bodyPr>
-          <a:lstStyle/>
-          <a:p>
-            <a:pPr>
-              <a:defRPr sz="900">
+          <a:bodyPr wrap="square" lIns="0" rIns="0" tIns="0" bIns="0">
+            <a:spAutoFit/>
+          </a:bodyPr>
+          <a:lstStyle/>
+          <a:p>
+            <a:pPr>
+              <a:defRPr sz="900" b="0">
                 <a:solidFill>
                   <a:srgbClr val="66758A"/>
                 </a:solidFill>
@@ -13654,7 +13712,7 @@
               </a:defRPr>
             </a:pPr>
             <a:r>
-              <a:t>22 / 23     17:20–18:05 planned     Sources and explanation in notes</a:t>
+              <a:t>23 / 24    18:15–19:00 planned    Sources and explanation in notes</a:t>
             </a:r>
           </a:p>
         </p:txBody>
@@ -13992,42 +14050,6 @@
       </p:sp>
       <p:sp>
         <p:nvSpPr>
-          <p:cNvPr id="12" name="TextBox 11"/>
-          <p:cNvSpPr txBox="1"/>
-          <p:nvPr/>
-        </p:nvSpPr>
-        <p:spPr>
-          <a:xfrm>
-            <a:off x="640080" y="6510528"/>
-            <a:ext cx="10972800" cy="182880"/>
-          </a:xfrm>
-          <a:prstGeom prst="rect">
-            <a:avLst/>
-          </a:prstGeom>
-          <a:noFill/>
-        </p:spPr>
-        <p:txBody>
-          <a:bodyPr wrap="none">
-            <a:spAutoFit/>
-          </a:bodyPr>
-          <a:lstStyle/>
-          <a:p>
-            <a:pPr>
-              <a:defRPr sz="900">
-                <a:solidFill>
-                  <a:srgbClr val="66758A"/>
-                </a:solidFill>
-                <a:latin typeface="Calibri"/>
-              </a:defRPr>
-            </a:pPr>
-            <a:r>
-              <a:t>23 / 23     18:05–18:35 planned     Sources and explanation in notes</a:t>
-            </a:r>
-          </a:p>
-        </p:txBody>
-      </p:sp>
-      <p:sp>
-        <p:nvSpPr>
           <p:cNvPr id="13" name="TextBox 12"/>
           <p:cNvSpPr txBox="1"/>
           <p:nvPr/>
@@ -14128,6 +14150,492 @@
                 <a:hlinkClick r:id="rId4"/>
               </a:rPr>
               <a:t>Source, setup and public presentation</a:t>
+            </a:r>
+          </a:p>
+        </p:txBody>
+      </p:sp>
+      <p:sp>
+        <p:nvSpPr>
+          <p:cNvPr id="16" name="TextBox 15"/>
+          <p:cNvSpPr txBox="1"/>
+          <p:nvPr/>
+        </p:nvSpPr>
+        <p:spPr>
+          <a:xfrm>
+            <a:off x="640080" y="6510528"/>
+            <a:ext cx="10972800" cy="182880"/>
+          </a:xfrm>
+          <a:prstGeom prst="rect">
+            <a:avLst/>
+          </a:prstGeom>
+          <a:noFill/>
+        </p:spPr>
+        <p:txBody>
+          <a:bodyPr wrap="square" lIns="0" rIns="0" tIns="0" bIns="0">
+            <a:spAutoFit/>
+          </a:bodyPr>
+          <a:lstStyle/>
+          <a:p>
+            <a:pPr>
+              <a:defRPr sz="900" b="0">
+                <a:solidFill>
+                  <a:srgbClr val="66758A"/>
+                </a:solidFill>
+                <a:latin typeface="Calibri"/>
+              </a:defRPr>
+            </a:pPr>
+            <a:r>
+              <a:t>24 / 24    19:00–19:30 planned    Sources and explanation in notes</a:t>
+            </a:r>
+          </a:p>
+        </p:txBody>
+      </p:sp>
+    </p:spTree>
+  </p:cSld>
+  <p:clrMapOvr>
+    <a:masterClrMapping/>
+  </p:clrMapOvr>
+</p:sld>
+</file>
+
+<file path=ppt/slides/slide24.xml><?xml version="1.0" encoding="utf-8"?>
+<p:sld xmlns:a="http://schemas.openxmlformats.org/drawingml/2006/main" xmlns:p="http://schemas.openxmlformats.org/presentationml/2006/main" xmlns:r="http://schemas.openxmlformats.org/officeDocument/2006/relationships">
+  <p:cSld>
+    <p:spTree>
+      <p:nvGrpSpPr>
+        <p:cNvPr id="1" name=""/>
+        <p:cNvGrpSpPr/>
+        <p:nvPr/>
+      </p:nvGrpSpPr>
+      <p:grpSpPr/>
+      <p:sp>
+        <p:nvSpPr>
+          <p:cNvPr id="2" name="TextBox 1"/>
+          <p:cNvSpPr txBox="1"/>
+          <p:nvPr/>
+        </p:nvSpPr>
+        <p:spPr>
+          <a:xfrm>
+            <a:off x="640080" y="411480"/>
+            <a:ext cx="10972800" cy="274320"/>
+          </a:xfrm>
+          <a:prstGeom prst="rect">
+            <a:avLst/>
+          </a:prstGeom>
+          <a:noFill/>
+        </p:spPr>
+        <p:txBody>
+          <a:bodyPr wrap="square" lIns="0" rIns="0" tIns="0" bIns="0">
+            <a:spAutoFit/>
+          </a:bodyPr>
+          <a:lstStyle/>
+          <a:p>
+            <a:pPr>
+              <a:defRPr sz="1100" b="1">
+                <a:solidFill>
+                  <a:srgbClr val="0088BA"/>
+                </a:solidFill>
+                <a:latin typeface="Calibri"/>
+              </a:defRPr>
+            </a:pPr>
+            <a:r>
+              <a:t>PART 3 / WHAT DSH PROVIDES AND HOW WE QUALIFY IT</a:t>
+            </a:r>
+          </a:p>
+        </p:txBody>
+      </p:sp>
+      <p:sp>
+        <p:nvSpPr>
+          <p:cNvPr id="3" name="TextBox 2"/>
+          <p:cNvSpPr txBox="1"/>
+          <p:nvPr/>
+        </p:nvSpPr>
+        <p:spPr>
+          <a:xfrm>
+            <a:off x="640080" y="868680"/>
+            <a:ext cx="10972800" cy="777240"/>
+          </a:xfrm>
+          <a:prstGeom prst="rect">
+            <a:avLst/>
+          </a:prstGeom>
+          <a:noFill/>
+        </p:spPr>
+        <p:txBody>
+          <a:bodyPr wrap="square" lIns="0" rIns="0" tIns="0" bIns="0">
+            <a:spAutoFit/>
+          </a:bodyPr>
+          <a:lstStyle/>
+          <a:p>
+            <a:pPr>
+              <a:defRPr sz="2500" b="1">
+                <a:solidFill>
+                  <a:srgbClr val="14243C"/>
+                </a:solidFill>
+                <a:latin typeface="Calibri"/>
+              </a:defRPr>
+            </a:pPr>
+            <a:r>
+              <a:t>DSH provides control points that operators must configure and test</a:t>
+            </a:r>
+          </a:p>
+        </p:txBody>
+      </p:sp>
+      <p:sp>
+        <p:nvSpPr>
+          <p:cNvPr id="4" name="TextBox 3"/>
+          <p:cNvSpPr txBox="1"/>
+          <p:nvPr/>
+        </p:nvSpPr>
+        <p:spPr>
+          <a:xfrm>
+            <a:off x="685800" y="1856231"/>
+            <a:ext cx="5212080" cy="393192"/>
+          </a:xfrm>
+          <a:prstGeom prst="rect">
+            <a:avLst/>
+          </a:prstGeom>
+          <a:noFill/>
+        </p:spPr>
+        <p:txBody>
+          <a:bodyPr wrap="square" lIns="0" rIns="0" tIns="0" bIns="0">
+            <a:spAutoFit/>
+          </a:bodyPr>
+          <a:lstStyle/>
+          <a:p>
+            <a:pPr>
+              <a:defRPr sz="1800" b="1">
+                <a:solidFill>
+                  <a:srgbClr val="007DA5"/>
+                </a:solidFill>
+                <a:latin typeface="Calibri"/>
+              </a:defRPr>
+            </a:pPr>
+            <a:r>
+              <a:t>Reference design: access and execution</a:t>
+            </a:r>
+          </a:p>
+        </p:txBody>
+      </p:sp>
+      <p:sp>
+        <p:nvSpPr>
+          <p:cNvPr id="5" name="TextBox 4"/>
+          <p:cNvSpPr txBox="1"/>
+          <p:nvPr/>
+        </p:nvSpPr>
+        <p:spPr>
+          <a:xfrm>
+            <a:off x="685800" y="2304287"/>
+            <a:ext cx="5212080" cy="1463040"/>
+          </a:xfrm>
+          <a:prstGeom prst="rect">
+            <a:avLst/>
+          </a:prstGeom>
+          <a:noFill/>
+        </p:spPr>
+        <p:txBody>
+          <a:bodyPr wrap="square" lIns="0" rIns="0" tIns="0" bIns="0">
+            <a:spAutoFit/>
+          </a:bodyPr>
+          <a:lstStyle/>
+          <a:p>
+            <a:pPr>
+              <a:defRPr sz="1600" b="0">
+                <a:solidFill>
+                  <a:srgbClr val="26354A"/>
+                </a:solidFill>
+                <a:latin typeface="Calibri"/>
+              </a:defRPr>
+            </a:pPr>
+            <a:r>
+              <a:t>The public reference defines authenticated routing, separate user workspaces, non-root workers, resource limits and no worker Kubernetes API token. Operators still hold privileged access.</a:t>
+            </a:r>
+          </a:p>
+        </p:txBody>
+      </p:sp>
+      <p:sp>
+        <p:nvSpPr>
+          <p:cNvPr id="6" name="TextBox 5"/>
+          <p:cNvSpPr txBox="1"/>
+          <p:nvPr/>
+        </p:nvSpPr>
+        <p:spPr>
+          <a:xfrm>
+            <a:off x="6309360" y="1856231"/>
+            <a:ext cx="5212080" cy="393192"/>
+          </a:xfrm>
+          <a:prstGeom prst="rect">
+            <a:avLst/>
+          </a:prstGeom>
+          <a:noFill/>
+        </p:spPr>
+        <p:txBody>
+          <a:bodyPr wrap="square" lIns="0" rIns="0" tIns="0" bIns="0">
+            <a:spAutoFit/>
+          </a:bodyPr>
+          <a:lstStyle/>
+          <a:p>
+            <a:pPr>
+              <a:defRPr sz="1800" b="1">
+                <a:solidFill>
+                  <a:srgbClr val="007DA5"/>
+                </a:solidFill>
+                <a:latin typeface="Calibri"/>
+              </a:defRPr>
+            </a:pPr>
+            <a:r>
+              <a:t>Reference design: network and packages</a:t>
+            </a:r>
+          </a:p>
+        </p:txBody>
+      </p:sp>
+      <p:sp>
+        <p:nvSpPr>
+          <p:cNvPr id="7" name="TextBox 6"/>
+          <p:cNvSpPr txBox="1"/>
+          <p:nvPr/>
+        </p:nvSpPr>
+        <p:spPr>
+          <a:xfrm>
+            <a:off x="6309360" y="2304287"/>
+            <a:ext cx="5212080" cy="1463040"/>
+          </a:xfrm>
+          <a:prstGeom prst="rect">
+            <a:avLst/>
+          </a:prstGeom>
+          <a:noFill/>
+        </p:spPr>
+        <p:txBody>
+          <a:bodyPr wrap="square" lIns="0" rIns="0" tIns="0" bIns="0">
+            <a:spAutoFit/>
+          </a:bodyPr>
+          <a:lstStyle/>
+          <a:p>
+            <a:pPr>
+              <a:defRPr sz="1600" b="0">
+                <a:solidFill>
+                  <a:srgbClr val="26354A"/>
+                </a:solidFill>
+                <a:latin typeface="Calibri"/>
+              </a:defRPr>
+            </a:pPr>
+            <a:r>
+              <a:t>Separate Internet and restricted runtimes. Apply network policy and reviewed package promotion. DNS, supporting services and cluster enforcement need tests on the installed version.</a:t>
+            </a:r>
+          </a:p>
+        </p:txBody>
+      </p:sp>
+      <p:sp>
+        <p:nvSpPr>
+          <p:cNvPr id="8" name="TextBox 7"/>
+          <p:cNvSpPr txBox="1"/>
+          <p:nvPr/>
+        </p:nvSpPr>
+        <p:spPr>
+          <a:xfrm>
+            <a:off x="685800" y="3858768"/>
+            <a:ext cx="5212080" cy="393192"/>
+          </a:xfrm>
+          <a:prstGeom prst="rect">
+            <a:avLst/>
+          </a:prstGeom>
+          <a:noFill/>
+        </p:spPr>
+        <p:txBody>
+          <a:bodyPr wrap="square" lIns="0" rIns="0" tIns="0" bIns="0">
+            <a:spAutoFit/>
+          </a:bodyPr>
+          <a:lstStyle/>
+          <a:p>
+            <a:pPr>
+              <a:defRPr sz="1800" b="1">
+                <a:solidFill>
+                  <a:srgbClr val="007DA5"/>
+                </a:solidFill>
+                <a:latin typeface="Calibri"/>
+              </a:defRPr>
+            </a:pPr>
+            <a:r>
+              <a:t>Integration requirement: authority</a:t>
+            </a:r>
+          </a:p>
+        </p:txBody>
+      </p:sp>
+      <p:sp>
+        <p:nvSpPr>
+          <p:cNvPr id="9" name="TextBox 8"/>
+          <p:cNvSpPr txBox="1"/>
+          <p:nvPr/>
+        </p:nvSpPr>
+        <p:spPr>
+          <a:xfrm>
+            <a:off x="685800" y="4306824"/>
+            <a:ext cx="5212080" cy="1463040"/>
+          </a:xfrm>
+          <a:prstGeom prst="rect">
+            <a:avLst/>
+          </a:prstGeom>
+          <a:noFill/>
+        </p:spPr>
+        <p:txBody>
+          <a:bodyPr wrap="square" lIns="0" rIns="0" tIns="0" bIns="0">
+            <a:spAutoFit/>
+          </a:bodyPr>
+          <a:lstStyle/>
+          <a:p>
+            <a:pPr>
+              <a:defRPr sz="1600" b="0">
+                <a:solidFill>
+                  <a:srgbClr val="26354A"/>
+                </a:solidFill>
+                <a:latin typeface="Calibri"/>
+              </a:defRPr>
+            </a:pPr>
+            <a:r>
+              <a:t>Give each connected workflow only the data and actions it needs. Configure scoped credentials and approval for consequential sends or writes. DSH does not imply universal approval enforcement.</a:t>
+            </a:r>
+          </a:p>
+        </p:txBody>
+      </p:sp>
+      <p:sp>
+        <p:nvSpPr>
+          <p:cNvPr id="10" name="TextBox 9"/>
+          <p:cNvSpPr txBox="1"/>
+          <p:nvPr/>
+        </p:nvSpPr>
+        <p:spPr>
+          <a:xfrm>
+            <a:off x="6309360" y="3858768"/>
+            <a:ext cx="5212080" cy="393192"/>
+          </a:xfrm>
+          <a:prstGeom prst="rect">
+            <a:avLst/>
+          </a:prstGeom>
+          <a:noFill/>
+        </p:spPr>
+        <p:txBody>
+          <a:bodyPr wrap="square" lIns="0" rIns="0" tIns="0" bIns="0">
+            <a:spAutoFit/>
+          </a:bodyPr>
+          <a:lstStyle/>
+          <a:p>
+            <a:pPr>
+              <a:defRPr sz="1800" b="1">
+                <a:solidFill>
+                  <a:srgbClr val="007DA5"/>
+                </a:solidFill>
+                <a:latin typeface="Calibri"/>
+              </a:defRPr>
+            </a:pPr>
+            <a:r>
+              <a:t>Operating requirement: monitoring</a:t>
+            </a:r>
+          </a:p>
+        </p:txBody>
+      </p:sp>
+      <p:sp>
+        <p:nvSpPr>
+          <p:cNvPr id="11" name="TextBox 10"/>
+          <p:cNvSpPr txBox="1"/>
+          <p:nvPr/>
+        </p:nvSpPr>
+        <p:spPr>
+          <a:xfrm>
+            <a:off x="6309360" y="4306824"/>
+            <a:ext cx="5212080" cy="1463040"/>
+          </a:xfrm>
+          <a:prstGeom prst="rect">
+            <a:avLst/>
+          </a:prstGeom>
+          <a:noFill/>
+        </p:spPr>
+        <p:txBody>
+          <a:bodyPr wrap="square" lIns="0" rIns="0" tIns="0" bIns="0">
+            <a:spAutoFit/>
+          </a:bodyPr>
+          <a:lstStyle/>
+          <a:p>
+            <a:pPr>
+              <a:defRPr sz="1600" b="0">
+                <a:solidFill>
+                  <a:srgbClr val="26354A"/>
+                </a:solidFill>
+                <a:latin typeface="Calibri"/>
+              </a:defRPr>
+            </a:pPr>
+            <a:r>
+              <a:t>Name an alert owner, define stop and restart decisions and protect relevant logs. Gateway access logs are not a complete tool-command ledger. Verify coverage before relying on it.</a:t>
+            </a:r>
+          </a:p>
+        </p:txBody>
+      </p:sp>
+      <p:sp>
+        <p:nvSpPr>
+          <p:cNvPr id="12" name="TextBox 11"/>
+          <p:cNvSpPr txBox="1"/>
+          <p:nvPr/>
+        </p:nvSpPr>
+        <p:spPr>
+          <a:xfrm>
+            <a:off x="685800" y="6071616"/>
+            <a:ext cx="10789920" cy="274320"/>
+          </a:xfrm>
+          <a:prstGeom prst="rect">
+            <a:avLst/>
+          </a:prstGeom>
+          <a:noFill/>
+        </p:spPr>
+        <p:txBody>
+          <a:bodyPr wrap="square" lIns="0" rIns="0" tIns="0" bIns="0">
+            <a:spAutoFit/>
+          </a:bodyPr>
+          <a:lstStyle/>
+          <a:p>
+            <a:pPr>
+              <a:defRPr sz="1000" b="0">
+                <a:solidFill>
+                  <a:srgbClr val="66758A"/>
+                </a:solidFill>
+                <a:latin typeface="Calibri"/>
+              </a:defRPr>
+            </a:pPr>
+            <a:r>
+              <a:t>Reference features and proposed acceptance checks. No new live deployment verification.</a:t>
+            </a:r>
+          </a:p>
+        </p:txBody>
+      </p:sp>
+      <p:sp>
+        <p:nvSpPr>
+          <p:cNvPr id="13" name="TextBox 12"/>
+          <p:cNvSpPr txBox="1"/>
+          <p:nvPr/>
+        </p:nvSpPr>
+        <p:spPr>
+          <a:xfrm>
+            <a:off x="640080" y="6510528"/>
+            <a:ext cx="10972800" cy="182880"/>
+          </a:xfrm>
+          <a:prstGeom prst="rect">
+            <a:avLst/>
+          </a:prstGeom>
+          <a:noFill/>
+        </p:spPr>
+        <p:txBody>
+          <a:bodyPr wrap="square" lIns="0" rIns="0" tIns="0" bIns="0">
+            <a:spAutoFit/>
+          </a:bodyPr>
+          <a:lstStyle/>
+          <a:p>
+            <a:pPr>
+              <a:defRPr sz="900" b="0">
+                <a:solidFill>
+                  <a:srgbClr val="66758A"/>
+                </a:solidFill>
+                <a:latin typeface="Calibri"/>
+              </a:defRPr>
+            </a:pPr>
+            <a:r>
+              <a:t>19 / 24    14:55–15:50 planned    Sources and explanation in notes</a:t>
             </a:r>
           </a:p>
         </p:txBody>
@@ -14563,13 +15071,13 @@
           <a:noFill/>
         </p:spPr>
         <p:txBody>
-          <a:bodyPr wrap="none">
-            <a:spAutoFit/>
-          </a:bodyPr>
-          <a:lstStyle/>
-          <a:p>
-            <a:pPr>
-              <a:defRPr sz="900">
+          <a:bodyPr wrap="square" lIns="0" rIns="0" tIns="0" bIns="0">
+            <a:spAutoFit/>
+          </a:bodyPr>
+          <a:lstStyle/>
+          <a:p>
+            <a:pPr>
+              <a:defRPr sz="900" b="0">
                 <a:solidFill>
                   <a:srgbClr val="66758A"/>
                 </a:solidFill>
@@ -14577,7 +15085,7 @@
               </a:defRPr>
             </a:pPr>
             <a:r>
-              <a:t>3 / 23     01:10–01:55 planned     Sources and explanation in notes</a:t>
+              <a:t>3 / 24    01:10–01:55 planned    Sources and explanation in notes</a:t>
             </a:r>
           </a:p>
         </p:txBody>
@@ -17360,13 +17868,13 @@
           <a:noFill/>
         </p:spPr>
         <p:txBody>
-          <a:bodyPr wrap="none">
-            <a:spAutoFit/>
-          </a:bodyPr>
-          <a:lstStyle/>
-          <a:p>
-            <a:pPr>
-              <a:defRPr sz="900">
+          <a:bodyPr wrap="square" lIns="0" rIns="0" tIns="0" bIns="0">
+            <a:spAutoFit/>
+          </a:bodyPr>
+          <a:lstStyle/>
+          <a:p>
+            <a:pPr>
+              <a:defRPr sz="900" b="0">
                 <a:solidFill>
                   <a:srgbClr val="66758A"/>
                 </a:solidFill>
@@ -17374,7 +17882,7 @@
               </a:defRPr>
             </a:pPr>
             <a:r>
-              <a:t>4 / 23     01:55–02:55 planned     Sources and explanation in notes</a:t>
+              <a:t>4 / 24    01:55–02:55 planned    Sources and explanation in notes</a:t>
             </a:r>
           </a:p>
         </p:txBody>
@@ -18188,13 +18696,13 @@
           <a:noFill/>
         </p:spPr>
         <p:txBody>
-          <a:bodyPr wrap="none">
-            <a:spAutoFit/>
-          </a:bodyPr>
-          <a:lstStyle/>
-          <a:p>
-            <a:pPr>
-              <a:defRPr sz="900">
+          <a:bodyPr wrap="square" lIns="0" rIns="0" tIns="0" bIns="0">
+            <a:spAutoFit/>
+          </a:bodyPr>
+          <a:lstStyle/>
+          <a:p>
+            <a:pPr>
+              <a:defRPr sz="900" b="0">
                 <a:solidFill>
                   <a:srgbClr val="66758A"/>
                 </a:solidFill>
@@ -18202,7 +18710,7 @@
               </a:defRPr>
             </a:pPr>
             <a:r>
-              <a:t>5 / 23     02:55–03:50 planned     Sources and explanation in notes</a:t>
+              <a:t>5 / 24    02:55–03:50 planned    Sources and explanation in notes</a:t>
             </a:r>
           </a:p>
         </p:txBody>
@@ -18632,13 +19140,13 @@
           <a:noFill/>
         </p:spPr>
         <p:txBody>
-          <a:bodyPr wrap="none">
-            <a:spAutoFit/>
-          </a:bodyPr>
-          <a:lstStyle/>
-          <a:p>
-            <a:pPr>
-              <a:defRPr sz="900">
+          <a:bodyPr wrap="square" lIns="0" rIns="0" tIns="0" bIns="0">
+            <a:spAutoFit/>
+          </a:bodyPr>
+          <a:lstStyle/>
+          <a:p>
+            <a:pPr>
+              <a:defRPr sz="900" b="0">
                 <a:solidFill>
                   <a:srgbClr val="66758A"/>
                 </a:solidFill>
@@ -18646,7 +19154,7 @@
               </a:defRPr>
             </a:pPr>
             <a:r>
-              <a:t>6 / 23     03:50–04:35 planned     Sources and explanation in notes</a:t>
+              <a:t>6 / 24    03:50–04:35 planned    Sources and explanation in notes</a:t>
             </a:r>
           </a:p>
         </p:txBody>
@@ -19323,13 +19831,13 @@
           <a:noFill/>
         </p:spPr>
         <p:txBody>
-          <a:bodyPr wrap="none">
-            <a:spAutoFit/>
-          </a:bodyPr>
-          <a:lstStyle/>
-          <a:p>
-            <a:pPr>
-              <a:defRPr sz="900">
+          <a:bodyPr wrap="square" lIns="0" rIns="0" tIns="0" bIns="0">
+            <a:spAutoFit/>
+          </a:bodyPr>
+          <a:lstStyle/>
+          <a:p>
+            <a:pPr>
+              <a:defRPr sz="900" b="0">
                 <a:solidFill>
                   <a:srgbClr val="66758A"/>
                 </a:solidFill>
@@ -19337,7 +19845,7 @@
               </a:defRPr>
             </a:pPr>
             <a:r>
-              <a:t>7 / 23     04:35–05:25 planned     Sources and explanation in notes</a:t>
+              <a:t>7 / 24    04:35–05:25 planned    Sources and explanation in notes</a:t>
             </a:r>
           </a:p>
         </p:txBody>
@@ -19914,13 +20422,13 @@
           <a:noFill/>
         </p:spPr>
         <p:txBody>
-          <a:bodyPr wrap="none">
-            <a:spAutoFit/>
-          </a:bodyPr>
-          <a:lstStyle/>
-          <a:p>
-            <a:pPr>
-              <a:defRPr sz="900">
+          <a:bodyPr wrap="square" lIns="0" rIns="0" tIns="0" bIns="0">
+            <a:spAutoFit/>
+          </a:bodyPr>
+          <a:lstStyle/>
+          <a:p>
+            <a:pPr>
+              <a:defRPr sz="900" b="0">
                 <a:solidFill>
                   <a:srgbClr val="66758A"/>
                 </a:solidFill>
@@ -19928,7 +20436,7 @@
               </a:defRPr>
             </a:pPr>
             <a:r>
-              <a:t>8 / 23     05:25–06:20 planned     Sources and explanation in notes</a:t>
+              <a:t>8 / 24    05:25–06:20 planned    Sources and explanation in notes</a:t>
             </a:r>
           </a:p>
         </p:txBody>
@@ -20345,13 +20853,13 @@
           <a:noFill/>
         </p:spPr>
         <p:txBody>
-          <a:bodyPr wrap="none">
-            <a:spAutoFit/>
-          </a:bodyPr>
-          <a:lstStyle/>
-          <a:p>
-            <a:pPr>
-              <a:defRPr sz="900">
+          <a:bodyPr wrap="square" lIns="0" rIns="0" tIns="0" bIns="0">
+            <a:spAutoFit/>
+          </a:bodyPr>
+          <a:lstStyle/>
+          <a:p>
+            <a:pPr>
+              <a:defRPr sz="900" b="0">
                 <a:solidFill>
                   <a:srgbClr val="66758A"/>
                 </a:solidFill>
@@ -20359,7 +20867,7 @@
               </a:defRPr>
             </a:pPr>
             <a:r>
-              <a:t>9 / 23     06:20–07:05 planned     Sources and explanation in notes</a:t>
+              <a:t>9 / 24    06:20–07:05 planned    Sources and explanation in notes</a:t>
             </a:r>
           </a:p>
         </p:txBody>

</xml_diff>

<commit_message>
Explain governance abbreviations and institution roles
</commit_message>
<xml_diff>
--- a/docs/presentations/guarding-the-value-stream/Guarding_the_Value_Stream.pptx
+++ b/docs/presentations/guarding-the-value-stream/Guarding_the_Value_Stream.pptx
@@ -717,7 +717,7 @@
           <a:lstStyle/>
           <a:p>
             <a:r>
-              <a:t>SLIDE 11: Governance should point to evidence people can use</a:t>
+              <a:t>SLIDE 11</a:t>
             </a:r>
           </a:p>
           <a:p>
@@ -727,17 +727,17 @@
           </a:p>
           <a:p>
             <a:r>
-              <a:t>A claims owner should be able to show what the system is for, which data it uses, how it was tested and who handles an exception. NIST gives us a way to organise the work. Insurance guidance reinforces responsibility for customer-impacting decisions. None turns a platform setting into a compliance certificate.</a:t>
-            </a:r>
-          </a:p>
-          <a:p>
-            <a:r>
-              <a:t>DETAIL AND LIMITS</a:t>
-            </a:r>
-          </a:p>
-          <a:p>
-            <a:r>
-              <a:t>NIST AI RMF is voluntary guidance. The NAIC model bulletin is a model for state insurance supervision, not a globally applicable law. DORA concerns relevant EU financial-sector ICT obligations. EU AI Act classification depends on role and use case; do not classify every AML or underwriting task identically. Keep legal applicability separate from technical test results and operational acceptance. Existing evidence can be reused when it genuinely supports each requirement.</a:t>
+              <a:t>These names play different roles. NIST is a US technical agency whose AI Risk Management Framework helps organise risk work. NAIC is the association of US state insurance regulators, and its model bulletin helps explain expectations for insurers. MAS is Singapore's central bank and financial regulator. DORA and the European Union AI Act are laws, rather than organisations. They cover different subjects and have different applicability. We can reuse evidence across reviews, but must assess each requirement separately.</a:t>
+            </a:r>
+          </a:p>
+          <a:p>
+            <a:r>
+              <a:t>DETAILED EXPLANATION</a:t>
+            </a:r>
+          </a:p>
+          <a:p>
+            <a:r>
+              <a:t>AI means artificial intelligence. RMF means Risk Management Framework. NIST stands for National Institute of Standards and Technology. Its framework is voluntary guidance, not a legal certification. GOVERN, MAP, MEASURE and MANAGE are named functions, not abbreviations: establish responsibility, understand context, evaluate risks, and prioritise responses. NAIC stands for National Association of Insurance Commissioners. Its model bulletin is not automatically one nationwide law; state adoption and local requirements matter. MAS stands for Monetary Authority of Singapore. DORA stands for Digital Operational Resilience Act, a European Union regulation addressing financial-sector information and communication technology resilience. The EU AI Act is a separate regulation on artificial intelligence. Do not treat DORA as an AI-specific framework or these sources as interchangeable. For a claims example, keep the policy and model version, approved data, validation results, reviewer sign-off and change history. These records can support different governance reviews, but do not by themselves establish compliance.</a:t>
             </a:r>
           </a:p>
           <a:p>
@@ -757,12 +757,27 @@
           </a:p>
           <a:p>
             <a:r>
-              <a:t>https://airc.nist.gov/airmf-resources/airmf/5-sec-core/</a:t>
+              <a:t>https://www.nist.gov/itl/ai-risk-management-framework/nist-ai-rmf-playbook</a:t>
             </a:r>
           </a:p>
           <a:p>
             <a:r>
               <a:t>https://content.naic.org/article/naic-members-approve-model-bulletin-use-ai-insurers</a:t>
+            </a:r>
+          </a:p>
+          <a:p>
+            <a:r>
+              <a:t>https://www.mas.gov.sg/</a:t>
+            </a:r>
+          </a:p>
+          <a:p>
+            <a:r>
+              <a:t>https://www.eiopa.europa.eu/digital-operational-resilience-act-dora_en</a:t>
+            </a:r>
+          </a:p>
+          <a:p>
+            <a:r>
+              <a:t>https://digital-strategy.ec.europa.eu/en/policies/regulatory-framework-ai</a:t>
             </a:r>
           </a:p>
         </p:txBody>
@@ -7635,30 +7650,63 @@
       <p:grpSpPr/>
       <p:sp>
         <p:nvSpPr>
-          <p:cNvPr id="2" name="TextBox 1"/>
+          <p:cNvPr id="12" name="TextBox 11"/>
+          <p:cNvSpPr txBox="1"/>
+          <p:nvPr/>
+        </p:nvSpPr>
+        <p:spPr>
+          <a:xfrm>
+            <a:off x="640080" y="6510528"/>
+            <a:ext cx="10972800" cy="182880"/>
+          </a:xfrm>
+          <a:prstGeom prst="rect">
+            <a:avLst/>
+          </a:prstGeom>
+          <a:noFill/>
+        </p:spPr>
+        <p:txBody>
+          <a:bodyPr wrap="square" lIns="0" rIns="0" tIns="0" bIns="0">
+            <a:spAutoFit/>
+          </a:bodyPr>
+          <a:lstStyle/>
+          <a:p>
+            <a:pPr>
+              <a:defRPr sz="900" b="0">
+                <a:solidFill>
+                  <a:srgbClr val="66758A"/>
+                </a:solidFill>
+                <a:latin typeface="Calibri"/>
+              </a:defRPr>
+            </a:pPr>
+            <a:r>
+              <a:t>11 / 24    07:50–08:30 planned    Sources and explanation in notes</a:t>
+            </a:r>
+          </a:p>
+        </p:txBody>
+      </p:sp>
+      <p:sp>
+        <p:nvSpPr>
+          <p:cNvPr id="13" name="TextBox 12"/>
           <p:cNvSpPr txBox="1"/>
           <p:nvPr/>
         </p:nvSpPr>
         <p:spPr>
           <a:xfrm>
             <a:off x="640080" y="411480"/>
-            <a:ext cx="10972800" cy="256032"/>
-          </a:xfrm>
-          <a:prstGeom prst="rect">
-            <a:avLst/>
-          </a:prstGeom>
-          <a:noFill/>
-        </p:spPr>
-        <p:txBody>
-          <a:bodyPr wrap="square" lIns="0" rIns="0" tIns="0" bIns="0">
-            <a:spAutoFit/>
-          </a:bodyPr>
-          <a:lstStyle/>
-          <a:p>
-            <a:pPr>
-              <a:spcAft>
-                <a:spcPts val="600"/>
-              </a:spcAft>
+            <a:ext cx="10972800" cy="274320"/>
+          </a:xfrm>
+          <a:prstGeom prst="rect">
+            <a:avLst/>
+          </a:prstGeom>
+          <a:noFill/>
+        </p:spPr>
+        <p:txBody>
+          <a:bodyPr wrap="square" lIns="0" rIns="0" tIns="0" bIns="0">
+            <a:spAutoFit/>
+          </a:bodyPr>
+          <a:lstStyle/>
+          <a:p>
+            <a:pPr>
               <a:defRPr sz="1100" b="1">
                 <a:solidFill>
                   <a:srgbClr val="0088BA"/>
@@ -7667,14 +7715,14 @@
               </a:defRPr>
             </a:pPr>
             <a:r>
-              <a:t>2 / PRACTICAL GOVERNANCE</a:t>
-            </a:r>
-          </a:p>
-        </p:txBody>
-      </p:sp>
-      <p:sp>
-        <p:nvSpPr>
-          <p:cNvPr id="3" name="TextBox 2"/>
+              <a:t>PART 2 / GOVERNANCE: WHO THE NAMES REFER TO</a:t>
+            </a:r>
+          </a:p>
+        </p:txBody>
+      </p:sp>
+      <p:sp>
+        <p:nvSpPr>
+          <p:cNvPr id="14" name="TextBox 13"/>
           <p:cNvSpPr txBox="1"/>
           <p:nvPr/>
         </p:nvSpPr>
@@ -7695,9 +7743,6 @@
           <a:lstStyle/>
           <a:p>
             <a:pPr>
-              <a:spcAft>
-                <a:spcPts val="600"/>
-              </a:spcAft>
               <a:defRPr sz="2500" b="1">
                 <a:solidFill>
                   <a:srgbClr val="14243C"/>
@@ -7706,37 +7751,34 @@
               </a:defRPr>
             </a:pPr>
             <a:r>
-              <a:t>Governance should point to evidence people can use</a:t>
-            </a:r>
-          </a:p>
-        </p:txBody>
-      </p:sp>
-      <p:sp>
-        <p:nvSpPr>
-          <p:cNvPr id="4" name="TextBox 3"/>
-          <p:cNvSpPr txBox="1"/>
-          <p:nvPr/>
-        </p:nvSpPr>
-        <p:spPr>
-          <a:xfrm>
-            <a:off x="685800" y="1901952"/>
-            <a:ext cx="3456432" cy="685800"/>
-          </a:xfrm>
-          <a:prstGeom prst="rect">
-            <a:avLst/>
-          </a:prstGeom>
-          <a:noFill/>
-        </p:spPr>
-        <p:txBody>
-          <a:bodyPr wrap="square" lIns="0" rIns="0" tIns="0" bIns="0">
-            <a:spAutoFit/>
-          </a:bodyPr>
-          <a:lstStyle/>
-          <a:p>
-            <a:pPr>
-              <a:spcAft>
-                <a:spcPts val="600"/>
-              </a:spcAft>
+              <a:t>Governance bodies and laws: what each name means</a:t>
+            </a:r>
+          </a:p>
+        </p:txBody>
+      </p:sp>
+      <p:sp>
+        <p:nvSpPr>
+          <p:cNvPr id="15" name="TextBox 14"/>
+          <p:cNvSpPr txBox="1"/>
+          <p:nvPr/>
+        </p:nvSpPr>
+        <p:spPr>
+          <a:xfrm>
+            <a:off x="685800" y="1856231"/>
+            <a:ext cx="5212080" cy="411480"/>
+          </a:xfrm>
+          <a:prstGeom prst="rect">
+            <a:avLst/>
+          </a:prstGeom>
+          <a:noFill/>
+        </p:spPr>
+        <p:txBody>
+          <a:bodyPr wrap="square" lIns="0" rIns="0" tIns="0" bIns="0">
+            <a:spAutoFit/>
+          </a:bodyPr>
+          <a:lstStyle/>
+          <a:p>
+            <a:pPr>
               <a:defRPr sz="1800" b="1">
                 <a:solidFill>
                   <a:srgbClr val="007DA5"/>
@@ -7745,37 +7787,34 @@
               </a:defRPr>
             </a:pPr>
             <a:r>
-              <a:t>NIST: organise the work</a:t>
-            </a:r>
-          </a:p>
-        </p:txBody>
-      </p:sp>
-      <p:sp>
-        <p:nvSpPr>
-          <p:cNvPr id="5" name="TextBox 4"/>
-          <p:cNvSpPr txBox="1"/>
-          <p:nvPr/>
-        </p:nvSpPr>
-        <p:spPr>
-          <a:xfrm>
-            <a:off x="685800" y="2697480"/>
-            <a:ext cx="3456432" cy="2926080"/>
-          </a:xfrm>
-          <a:prstGeom prst="rect">
-            <a:avLst/>
-          </a:prstGeom>
-          <a:noFill/>
-        </p:spPr>
-        <p:txBody>
-          <a:bodyPr wrap="square" lIns="0" rIns="0" tIns="0" bIns="0">
-            <a:spAutoFit/>
-          </a:bodyPr>
-          <a:lstStyle/>
-          <a:p>
-            <a:pPr>
-              <a:spcAft>
-                <a:spcPts val="600"/>
-              </a:spcAft>
+              <a:t>NIST: US technical guidance</a:t>
+            </a:r>
+          </a:p>
+        </p:txBody>
+      </p:sp>
+      <p:sp>
+        <p:nvSpPr>
+          <p:cNvPr id="16" name="TextBox 15"/>
+          <p:cNvSpPr txBox="1"/>
+          <p:nvPr/>
+        </p:nvSpPr>
+        <p:spPr>
+          <a:xfrm>
+            <a:off x="685800" y="2313432"/>
+            <a:ext cx="5212080" cy="1463040"/>
+          </a:xfrm>
+          <a:prstGeom prst="rect">
+            <a:avLst/>
+          </a:prstGeom>
+          <a:noFill/>
+        </p:spPr>
+        <p:txBody>
+          <a:bodyPr wrap="square" lIns="0" rIns="0" tIns="0" bIns="0">
+            <a:spAutoFit/>
+          </a:bodyPr>
+          <a:lstStyle/>
+          <a:p>
+            <a:pPr>
               <a:defRPr sz="1600" b="0">
                 <a:solidFill>
                   <a:srgbClr val="26354A"/>
@@ -7784,37 +7823,34 @@
               </a:defRPr>
             </a:pPr>
             <a:r>
-              <a:t>GOVERN names owners. MAP explains the use and dependencies. MEASURE tests quality and risk. MANAGE prioritises action and monitoring.</a:t>
-            </a:r>
-          </a:p>
-        </p:txBody>
-      </p:sp>
-      <p:sp>
-        <p:nvSpPr>
-          <p:cNvPr id="6" name="TextBox 5"/>
-          <p:cNvSpPr txBox="1"/>
-          <p:nvPr/>
-        </p:nvSpPr>
-        <p:spPr>
-          <a:xfrm>
-            <a:off x="4434840" y="1901952"/>
-            <a:ext cx="3456432" cy="685800"/>
-          </a:xfrm>
-          <a:prstGeom prst="rect">
-            <a:avLst/>
-          </a:prstGeom>
-          <a:noFill/>
-        </p:spPr>
-        <p:txBody>
-          <a:bodyPr wrap="square" lIns="0" rIns="0" tIns="0" bIns="0">
-            <a:spAutoFit/>
-          </a:bodyPr>
-          <a:lstStyle/>
-          <a:p>
-            <a:pPr>
-              <a:spcAft>
-                <a:spcPts val="600"/>
-              </a:spcAft>
+              <a:t>National Institute of Standards and Technology, a US federal agency. Its voluntary AI Risk Management Framework (AI RMF) organises work into GOVERN (owners), MAP (context), MEASURE (tests) and MANAGE (risk responses).</a:t>
+            </a:r>
+          </a:p>
+        </p:txBody>
+      </p:sp>
+      <p:sp>
+        <p:nvSpPr>
+          <p:cNvPr id="17" name="TextBox 16"/>
+          <p:cNvSpPr txBox="1"/>
+          <p:nvPr/>
+        </p:nvSpPr>
+        <p:spPr>
+          <a:xfrm>
+            <a:off x="6309360" y="1856231"/>
+            <a:ext cx="5212080" cy="411480"/>
+          </a:xfrm>
+          <a:prstGeom prst="rect">
+            <a:avLst/>
+          </a:prstGeom>
+          <a:noFill/>
+        </p:spPr>
+        <p:txBody>
+          <a:bodyPr wrap="square" lIns="0" rIns="0" tIns="0" bIns="0">
+            <a:spAutoFit/>
+          </a:bodyPr>
+          <a:lstStyle/>
+          <a:p>
+            <a:pPr>
               <a:defRPr sz="1800" b="1">
                 <a:solidFill>
                   <a:srgbClr val="007DA5"/>
@@ -7823,37 +7859,34 @@
               </a:defRPr>
             </a:pPr>
             <a:r>
-              <a:t>Insurance: protect customers</a:t>
-            </a:r>
-          </a:p>
-        </p:txBody>
-      </p:sp>
-      <p:sp>
-        <p:nvSpPr>
-          <p:cNvPr id="7" name="TextBox 6"/>
-          <p:cNvSpPr txBox="1"/>
-          <p:nvPr/>
-        </p:nvSpPr>
-        <p:spPr>
-          <a:xfrm>
-            <a:off x="4434840" y="2697480"/>
-            <a:ext cx="3456432" cy="2926080"/>
-          </a:xfrm>
-          <a:prstGeom prst="rect">
-            <a:avLst/>
-          </a:prstGeom>
-          <a:noFill/>
-        </p:spPr>
-        <p:txBody>
-          <a:bodyPr wrap="square" lIns="0" rIns="0" tIns="0" bIns="0">
-            <a:spAutoFit/>
-          </a:bodyPr>
-          <a:lstStyle/>
-          <a:p>
-            <a:pPr>
-              <a:spcAft>
-                <a:spcPts val="600"/>
-              </a:spcAft>
+              <a:t>NAIC: US insurance supervision</a:t>
+            </a:r>
+          </a:p>
+        </p:txBody>
+      </p:sp>
+      <p:sp>
+        <p:nvSpPr>
+          <p:cNvPr id="18" name="TextBox 17"/>
+          <p:cNvSpPr txBox="1"/>
+          <p:nvPr/>
+        </p:nvSpPr>
+        <p:spPr>
+          <a:xfrm>
+            <a:off x="6309360" y="2313432"/>
+            <a:ext cx="5212080" cy="1463040"/>
+          </a:xfrm>
+          <a:prstGeom prst="rect">
+            <a:avLst/>
+          </a:prstGeom>
+          <a:noFill/>
+        </p:spPr>
+        <p:txBody>
+          <a:bodyPr wrap="square" lIns="0" rIns="0" tIns="0" bIns="0">
+            <a:spAutoFit/>
+          </a:bodyPr>
+          <a:lstStyle/>
+          <a:p>
+            <a:pPr>
               <a:defRPr sz="1600" b="0">
                 <a:solidFill>
                   <a:srgbClr val="26354A"/>
@@ -7862,37 +7895,34 @@
               </a:defRPr>
             </a:pPr>
             <a:r>
-              <a:t>The NAIC model bulletin addresses governance, AI-supported decisions and a written AI Systems programme. Local adoption and requirements matter. Prepare data, validation and monitoring evidence.</a:t>
-            </a:r>
-          </a:p>
-        </p:txBody>
-      </p:sp>
-      <p:sp>
-        <p:nvSpPr>
-          <p:cNvPr id="8" name="TextBox 7"/>
-          <p:cNvSpPr txBox="1"/>
-          <p:nvPr/>
-        </p:nvSpPr>
-        <p:spPr>
-          <a:xfrm>
-            <a:off x="8183879" y="1901952"/>
-            <a:ext cx="3456432" cy="685800"/>
-          </a:xfrm>
-          <a:prstGeom prst="rect">
-            <a:avLst/>
-          </a:prstGeom>
-          <a:noFill/>
-        </p:spPr>
-        <p:txBody>
-          <a:bodyPr wrap="square" lIns="0" rIns="0" tIns="0" bIns="0">
-            <a:spAutoFit/>
-          </a:bodyPr>
-          <a:lstStyle/>
-          <a:p>
-            <a:pPr>
-              <a:spcAft>
-                <a:spcPts val="600"/>
-              </a:spcAft>
+              <a:t>National Association of Insurance Commissioners, the association of US state insurance regulators. Its model AI bulletin guides insurer governance and customer protection. Requirements depend on state adoption and applicable law.</a:t>
+            </a:r>
+          </a:p>
+        </p:txBody>
+      </p:sp>
+      <p:sp>
+        <p:nvSpPr>
+          <p:cNvPr id="19" name="TextBox 18"/>
+          <p:cNvSpPr txBox="1"/>
+          <p:nvPr/>
+        </p:nvSpPr>
+        <p:spPr>
+          <a:xfrm>
+            <a:off x="685800" y="3858768"/>
+            <a:ext cx="5212080" cy="411480"/>
+          </a:xfrm>
+          <a:prstGeom prst="rect">
+            <a:avLst/>
+          </a:prstGeom>
+          <a:noFill/>
+        </p:spPr>
+        <p:txBody>
+          <a:bodyPr wrap="square" lIns="0" rIns="0" tIns="0" bIns="0">
+            <a:spAutoFit/>
+          </a:bodyPr>
+          <a:lstStyle/>
+          <a:p>
+            <a:pPr>
               <a:defRPr sz="1800" b="1">
                 <a:solidFill>
                   <a:srgbClr val="007DA5"/>
@@ -7901,37 +7931,34 @@
               </a:defRPr>
             </a:pPr>
             <a:r>
-              <a:t>One evidence pack</a:t>
-            </a:r>
-          </a:p>
-        </p:txBody>
-      </p:sp>
-      <p:sp>
-        <p:nvSpPr>
-          <p:cNvPr id="9" name="TextBox 8"/>
-          <p:cNvSpPr txBox="1"/>
-          <p:nvPr/>
-        </p:nvSpPr>
-        <p:spPr>
-          <a:xfrm>
-            <a:off x="8183879" y="2697480"/>
-            <a:ext cx="3456432" cy="2926080"/>
-          </a:xfrm>
-          <a:prstGeom prst="rect">
-            <a:avLst/>
-          </a:prstGeom>
-          <a:noFill/>
-        </p:spPr>
-        <p:txBody>
-          <a:bodyPr wrap="square" lIns="0" rIns="0" tIns="0" bIns="0">
-            <a:spAutoFit/>
-          </a:bodyPr>
-          <a:lstStyle/>
-          <a:p>
-            <a:pPr>
-              <a:spcAft>
-                <a:spcPts val="600"/>
-              </a:spcAft>
+              <a:t>MAS: Singapore financial supervision</a:t>
+            </a:r>
+          </a:p>
+        </p:txBody>
+      </p:sp>
+      <p:sp>
+        <p:nvSpPr>
+          <p:cNvPr id="20" name="TextBox 19"/>
+          <p:cNvSpPr txBox="1"/>
+          <p:nvPr/>
+        </p:nvSpPr>
+        <p:spPr>
+          <a:xfrm>
+            <a:off x="685800" y="4315968"/>
+            <a:ext cx="5212080" cy="1463040"/>
+          </a:xfrm>
+          <a:prstGeom prst="rect">
+            <a:avLst/>
+          </a:prstGeom>
+          <a:noFill/>
+        </p:spPr>
+        <p:txBody>
+          <a:bodyPr wrap="square" lIns="0" rIns="0" tIns="0" bIns="0">
+            <a:spAutoFit/>
+          </a:bodyPr>
+          <a:lstStyle/>
+          <a:p>
+            <a:pPr>
               <a:defRPr sz="1600" b="0">
                 <a:solidFill>
                   <a:srgbClr val="26354A"/>
@@ -7940,37 +7967,106 @@
               </a:defRPr>
             </a:pPr>
             <a:r>
-              <a:t>Owner and purpose; approved data; provider and version; tests; approval points; monitoring; changes and incidents. MAS, DORA and EU AI Act applicability need separate jurisdiction and use-case review.</a:t>
-            </a:r>
-          </a:p>
-        </p:txBody>
-      </p:sp>
-      <p:sp>
-        <p:nvSpPr>
-          <p:cNvPr id="10" name="TextBox 9"/>
-          <p:cNvSpPr txBox="1"/>
-          <p:nvPr/>
-        </p:nvSpPr>
-        <p:spPr>
-          <a:xfrm>
-            <a:off x="685800" y="6044184"/>
-            <a:ext cx="10789920" cy="237744"/>
-          </a:xfrm>
-          <a:prstGeom prst="rect">
-            <a:avLst/>
-          </a:prstGeom>
-          <a:noFill/>
-        </p:spPr>
-        <p:txBody>
-          <a:bodyPr wrap="square" lIns="0" rIns="0" tIns="0" bIns="0">
-            <a:spAutoFit/>
-          </a:bodyPr>
-          <a:lstStyle/>
-          <a:p>
-            <a:pPr>
-              <a:spcAft>
-                <a:spcPts val="600"/>
-              </a:spcAft>
+              <a:t>Monetary Authority of Singapore, the central bank and integrated financial regulator. Its AI guidance addresses institutional accountability, inventories and proportionate controls. Assess applicability to the institution and use case.</a:t>
+            </a:r>
+          </a:p>
+        </p:txBody>
+      </p:sp>
+      <p:sp>
+        <p:nvSpPr>
+          <p:cNvPr id="21" name="TextBox 20"/>
+          <p:cNvSpPr txBox="1"/>
+          <p:nvPr/>
+        </p:nvSpPr>
+        <p:spPr>
+          <a:xfrm>
+            <a:off x="6309360" y="3858768"/>
+            <a:ext cx="5212080" cy="411480"/>
+          </a:xfrm>
+          <a:prstGeom prst="rect">
+            <a:avLst/>
+          </a:prstGeom>
+          <a:noFill/>
+        </p:spPr>
+        <p:txBody>
+          <a:bodyPr wrap="square" lIns="0" rIns="0" tIns="0" bIns="0">
+            <a:spAutoFit/>
+          </a:bodyPr>
+          <a:lstStyle/>
+          <a:p>
+            <a:pPr>
+              <a:defRPr sz="1800" b="1">
+                <a:solidFill>
+                  <a:srgbClr val="007DA5"/>
+                </a:solidFill>
+                <a:latin typeface="Calibri"/>
+              </a:defRPr>
+            </a:pPr>
+            <a:r>
+              <a:t>DORA and EU AI Act: European Union laws</a:t>
+            </a:r>
+          </a:p>
+        </p:txBody>
+      </p:sp>
+      <p:sp>
+        <p:nvSpPr>
+          <p:cNvPr id="22" name="TextBox 21"/>
+          <p:cNvSpPr txBox="1"/>
+          <p:nvPr/>
+        </p:nvSpPr>
+        <p:spPr>
+          <a:xfrm>
+            <a:off x="6309360" y="4315968"/>
+            <a:ext cx="5212080" cy="1463040"/>
+          </a:xfrm>
+          <a:prstGeom prst="rect">
+            <a:avLst/>
+          </a:prstGeom>
+          <a:noFill/>
+        </p:spPr>
+        <p:txBody>
+          <a:bodyPr wrap="square" lIns="0" rIns="0" tIns="0" bIns="0">
+            <a:spAutoFit/>
+          </a:bodyPr>
+          <a:lstStyle/>
+          <a:p>
+            <a:pPr>
+              <a:defRPr sz="1600" b="0">
+                <a:solidFill>
+                  <a:srgbClr val="26354A"/>
+                </a:solidFill>
+                <a:latin typeface="Calibri"/>
+              </a:defRPr>
+            </a:pPr>
+            <a:r>
+              <a:t>DORA means Digital Operational Resilience Act and addresses financial-sector technology resilience. EU means European Union. Its AI Act regulates AI by scope and risk. They are laws, not institutions; assess each separately.</a:t>
+            </a:r>
+          </a:p>
+        </p:txBody>
+      </p:sp>
+      <p:sp>
+        <p:nvSpPr>
+          <p:cNvPr id="23" name="TextBox 22"/>
+          <p:cNvSpPr txBox="1"/>
+          <p:nvPr/>
+        </p:nvSpPr>
+        <p:spPr>
+          <a:xfrm>
+            <a:off x="685800" y="6071616"/>
+            <a:ext cx="10789920" cy="274320"/>
+          </a:xfrm>
+          <a:prstGeom prst="rect">
+            <a:avLst/>
+          </a:prstGeom>
+          <a:noFill/>
+        </p:spPr>
+        <p:txBody>
+          <a:bodyPr wrap="square" lIns="0" rIns="0" tIns="0" bIns="0">
+            <a:spAutoFit/>
+          </a:bodyPr>
+          <a:lstStyle/>
+          <a:p>
+            <a:pPr>
               <a:defRPr sz="1000" b="0">
                 <a:solidFill>
                   <a:srgbClr val="66758A"/>
@@ -7979,82 +8075,7 @@
               </a:defRPr>
             </a:pPr>
             <a:r>
-              <a:t>Source links, explanation and limits are in the speaker guide and slide notes.</a:t>
-            </a:r>
-          </a:p>
-        </p:txBody>
-      </p:sp>
-      <p:sp>
-        <p:nvSpPr>
-          <p:cNvPr id="11" name="TextBox 10"/>
-          <p:cNvSpPr txBox="1"/>
-          <p:nvPr/>
-        </p:nvSpPr>
-        <p:spPr>
-          <a:xfrm>
-            <a:off x="685800" y="4892040"/>
-            <a:ext cx="10789920" cy="868680"/>
-          </a:xfrm>
-          <a:prstGeom prst="rect">
-            <a:avLst/>
-          </a:prstGeom>
-          <a:noFill/>
-        </p:spPr>
-        <p:txBody>
-          <a:bodyPr wrap="square" lIns="0" rIns="0" tIns="0" bIns="0">
-            <a:spAutoFit/>
-          </a:bodyPr>
-          <a:lstStyle/>
-          <a:p>
-            <a:pPr>
-              <a:spcAft>
-                <a:spcPts val="600"/>
-              </a:spcAft>
-              <a:defRPr sz="1600" b="0">
-                <a:solidFill>
-                  <a:srgbClr val="26354A"/>
-                </a:solidFill>
-                <a:latin typeface="Calibri"/>
-              </a:defRPr>
-            </a:pPr>
-            <a:r>
-              <a:t>Example evidence: the claims owner can show the policy version, validation cases, reviewer sign-off and change history. The same records can support risk review, audit and incident investigation.</a:t>
-            </a:r>
-          </a:p>
-        </p:txBody>
-      </p:sp>
-      <p:sp>
-        <p:nvSpPr>
-          <p:cNvPr id="12" name="TextBox 11"/>
-          <p:cNvSpPr txBox="1"/>
-          <p:nvPr/>
-        </p:nvSpPr>
-        <p:spPr>
-          <a:xfrm>
-            <a:off x="640080" y="6510528"/>
-            <a:ext cx="10972800" cy="182880"/>
-          </a:xfrm>
-          <a:prstGeom prst="rect">
-            <a:avLst/>
-          </a:prstGeom>
-          <a:noFill/>
-        </p:spPr>
-        <p:txBody>
-          <a:bodyPr wrap="square" lIns="0" rIns="0" tIns="0" bIns="0">
-            <a:spAutoFit/>
-          </a:bodyPr>
-          <a:lstStyle/>
-          <a:p>
-            <a:pPr>
-              <a:defRPr sz="900" b="0">
-                <a:solidFill>
-                  <a:srgbClr val="66758A"/>
-                </a:solidFill>
-                <a:latin typeface="Calibri"/>
-              </a:defRPr>
-            </a:pPr>
-            <a:r>
-              <a:t>11 / 24    07:50–08:30 planned    Sources and explanation in notes</a:t>
+              <a:t>AI = artificial intelligence. Reuse evidence, but assess each framework and law separately. Full sources in notes.</a:t>
             </a:r>
           </a:p>
         </p:txBody>
@@ -11401,23 +11422,20 @@
         <p:spPr>
           <a:xfrm>
             <a:off x="640080" y="411480"/>
-            <a:ext cx="10972800" cy="256032"/>
-          </a:xfrm>
-          <a:prstGeom prst="rect">
-            <a:avLst/>
-          </a:prstGeom>
-          <a:noFill/>
-        </p:spPr>
-        <p:txBody>
-          <a:bodyPr wrap="square" lIns="0" rIns="0" tIns="0" bIns="0">
-            <a:spAutoFit/>
-          </a:bodyPr>
-          <a:lstStyle/>
-          <a:p>
-            <a:pPr>
-              <a:spcAft>
-                <a:spcPts val="600"/>
-              </a:spcAft>
+            <a:ext cx="10972800" cy="274320"/>
+          </a:xfrm>
+          <a:prstGeom prst="rect">
+            <a:avLst/>
+          </a:prstGeom>
+          <a:noFill/>
+        </p:spPr>
+        <p:txBody>
+          <a:bodyPr wrap="square" lIns="0" rIns="0" tIns="0" bIns="0">
+            <a:spAutoFit/>
+          </a:bodyPr>
+          <a:lstStyle/>
+          <a:p>
+            <a:pPr>
               <a:defRPr sz="1100" b="1">
                 <a:solidFill>
                   <a:srgbClr val="0088BA"/>
@@ -11426,7 +11444,7 @@
               </a:defRPr>
             </a:pPr>
             <a:r>
-              <a:t>4 / FOLLOW THE OUTPUT</a:t>
+              <a:t>PART 3 / WHAT DSH PROVIDES AND HOW WE QUALIFY IT</a:t>
             </a:r>
           </a:p>
         </p:txBody>
@@ -11440,23 +11458,20 @@
         <p:spPr>
           <a:xfrm>
             <a:off x="640080" y="868680"/>
-            <a:ext cx="10972800" cy="731520"/>
-          </a:xfrm>
-          <a:prstGeom prst="rect">
-            <a:avLst/>
-          </a:prstGeom>
-          <a:noFill/>
-        </p:spPr>
-        <p:txBody>
-          <a:bodyPr wrap="square" lIns="0" rIns="0" tIns="0" bIns="0">
-            <a:spAutoFit/>
-          </a:bodyPr>
-          <a:lstStyle/>
-          <a:p>
-            <a:pPr>
-              <a:spcAft>
-                <a:spcPts val="600"/>
-              </a:spcAft>
+            <a:ext cx="10972800" cy="777240"/>
+          </a:xfrm>
+          <a:prstGeom prst="rect">
+            <a:avLst/>
+          </a:prstGeom>
+          <a:noFill/>
+        </p:spPr>
+        <p:txBody>
+          <a:bodyPr wrap="square" lIns="0" rIns="0" tIns="0" bIns="0">
+            <a:spAutoFit/>
+          </a:bodyPr>
+          <a:lstStyle/>
+          <a:p>
+            <a:pPr>
               <a:defRPr sz="2500" b="1">
                 <a:solidFill>
                   <a:srgbClr val="14243C"/>
@@ -11465,7 +11480,7 @@
               </a:defRPr>
             </a:pPr>
             <a:r>
-              <a:t>Generated HTML creates a second execution boundary</a:t>
+              <a:t>DSH provides control points that operators must configure and test</a:t>
             </a:r>
           </a:p>
         </p:txBody>
@@ -11479,23 +11494,20 @@
         <p:spPr>
           <a:xfrm>
             <a:off x="685800" y="1856231"/>
-            <a:ext cx="5212080" cy="384048"/>
-          </a:xfrm>
-          <a:prstGeom prst="rect">
-            <a:avLst/>
-          </a:prstGeom>
-          <a:noFill/>
-        </p:spPr>
-        <p:txBody>
-          <a:bodyPr wrap="square" lIns="0" rIns="0" tIns="0" bIns="0">
-            <a:spAutoFit/>
-          </a:bodyPr>
-          <a:lstStyle/>
-          <a:p>
-            <a:pPr>
-              <a:spcAft>
-                <a:spcPts val="600"/>
-              </a:spcAft>
+            <a:ext cx="5212080" cy="393192"/>
+          </a:xfrm>
+          <a:prstGeom prst="rect">
+            <a:avLst/>
+          </a:prstGeom>
+          <a:noFill/>
+        </p:spPr>
+        <p:txBody>
+          <a:bodyPr wrap="square" lIns="0" rIns="0" tIns="0" bIns="0">
+            <a:spAutoFit/>
+          </a:bodyPr>
+          <a:lstStyle/>
+          <a:p>
+            <a:pPr>
               <a:defRPr sz="1800" b="1">
                 <a:solidFill>
                   <a:srgbClr val="007DA5"/>
@@ -11504,7 +11516,7 @@
               </a:defRPr>
             </a:pPr>
             <a:r>
-              <a:t>Inside the workspace</a:t>
+              <a:t>Reference design: access and execution</a:t>
             </a:r>
           </a:p>
         </p:txBody>
@@ -11517,24 +11529,21 @@
         </p:nvSpPr>
         <p:spPr>
           <a:xfrm>
-            <a:off x="685800" y="2295144"/>
-            <a:ext cx="5212080" cy="1435608"/>
-          </a:xfrm>
-          <a:prstGeom prst="rect">
-            <a:avLst/>
-          </a:prstGeom>
-          <a:noFill/>
-        </p:spPr>
-        <p:txBody>
-          <a:bodyPr wrap="square" lIns="0" rIns="0" tIns="0" bIns="0">
-            <a:spAutoFit/>
-          </a:bodyPr>
-          <a:lstStyle/>
-          <a:p>
-            <a:pPr>
-              <a:spcAft>
-                <a:spcPts val="600"/>
-              </a:spcAft>
+            <a:off x="685800" y="2304287"/>
+            <a:ext cx="5212080" cy="1463040"/>
+          </a:xfrm>
+          <a:prstGeom prst="rect">
+            <a:avLst/>
+          </a:prstGeom>
+          <a:noFill/>
+        </p:spPr>
+        <p:txBody>
+          <a:bodyPr wrap="square" lIns="0" rIns="0" tIns="0" bIns="0">
+            <a:spAutoFit/>
+          </a:bodyPr>
+          <a:lstStyle/>
+          <a:p>
+            <a:pPr>
               <a:defRPr sz="1600" b="0">
                 <a:solidFill>
                   <a:srgbClr val="26354A"/>
@@ -11543,7 +11552,7 @@
               </a:defRPr>
             </a:pPr>
             <a:r>
-              <a:t>The assistant reads approved files and generates a report with the worker's identity and network permissions. Project inputs may still carry hostile instructions.</a:t>
+              <a:t>The public reference defines authenticated routing, separate user workspaces, non-root workers, resource limits and no worker Kubernetes API token. Operators still hold privileged access.</a:t>
             </a:r>
           </a:p>
         </p:txBody>
@@ -11557,23 +11566,20 @@
         <p:spPr>
           <a:xfrm>
             <a:off x="6309360" y="1856231"/>
-            <a:ext cx="5212080" cy="384048"/>
-          </a:xfrm>
-          <a:prstGeom prst="rect">
-            <a:avLst/>
-          </a:prstGeom>
-          <a:noFill/>
-        </p:spPr>
-        <p:txBody>
-          <a:bodyPr wrap="square" lIns="0" rIns="0" tIns="0" bIns="0">
-            <a:spAutoFit/>
-          </a:bodyPr>
-          <a:lstStyle/>
-          <a:p>
-            <a:pPr>
-              <a:spcAft>
-                <a:spcPts val="600"/>
-              </a:spcAft>
+            <a:ext cx="5212080" cy="393192"/>
+          </a:xfrm>
+          <a:prstGeom prst="rect">
+            <a:avLst/>
+          </a:prstGeom>
+          <a:noFill/>
+        </p:spPr>
+        <p:txBody>
+          <a:bodyPr wrap="square" lIns="0" rIns="0" tIns="0" bIns="0">
+            <a:spAutoFit/>
+          </a:bodyPr>
+          <a:lstStyle/>
+          <a:p>
+            <a:pPr>
               <a:defRPr sz="1800" b="1">
                 <a:solidFill>
                   <a:srgbClr val="007DA5"/>
@@ -11582,7 +11588,7 @@
               </a:defRPr>
             </a:pPr>
             <a:r>
-              <a:t>In the recipient's browser</a:t>
+              <a:t>Reference design: network and packages</a:t>
             </a:r>
           </a:p>
         </p:txBody>
@@ -11595,24 +11601,21 @@
         </p:nvSpPr>
         <p:spPr>
           <a:xfrm>
-            <a:off x="6309360" y="2295144"/>
-            <a:ext cx="5212080" cy="1435608"/>
-          </a:xfrm>
-          <a:prstGeom prst="rect">
-            <a:avLst/>
-          </a:prstGeom>
-          <a:noFill/>
-        </p:spPr>
-        <p:txBody>
-          <a:bodyPr wrap="square" lIns="0" rIns="0" tIns="0" bIns="0">
-            <a:spAutoFit/>
-          </a:bodyPr>
-          <a:lstStyle/>
-          <a:p>
-            <a:pPr>
-              <a:spcAft>
-                <a:spcPts val="600"/>
-              </a:spcAft>
+            <a:off x="6309360" y="2304287"/>
+            <a:ext cx="5212080" cy="1463040"/>
+          </a:xfrm>
+          <a:prstGeom prst="rect">
+            <a:avLst/>
+          </a:prstGeom>
+          <a:noFill/>
+        </p:spPr>
+        <p:txBody>
+          <a:bodyPr wrap="square" lIns="0" rIns="0" tIns="0" bIns="0">
+            <a:spAutoFit/>
+          </a:bodyPr>
+          <a:lstStyle/>
+          <a:p>
+            <a:pPr>
               <a:defRPr sz="1600" b="0">
                 <a:solidFill>
                   <a:srgbClr val="26354A"/>
@@ -11621,7 +11624,7 @@
               </a:defRPr>
             </a:pPr>
             <a:r>
-              <a:t>The report may load scripts, images or remote data. Browser permissions differ from the worker's. Relevant credentials may be sent where browser rules allow.</a:t>
+              <a:t>Separate Internet and restricted runtimes. Apply network policy and reviewed package promotion. DNS, supporting services and cluster enforcement need tests on the installed version.</a:t>
             </a:r>
           </a:p>
         </p:txBody>
@@ -11635,23 +11638,20 @@
         <p:spPr>
           <a:xfrm>
             <a:off x="685800" y="3858768"/>
-            <a:ext cx="5212080" cy="384048"/>
-          </a:xfrm>
-          <a:prstGeom prst="rect">
-            <a:avLst/>
-          </a:prstGeom>
-          <a:noFill/>
-        </p:spPr>
-        <p:txBody>
-          <a:bodyPr wrap="square" lIns="0" rIns="0" tIns="0" bIns="0">
-            <a:spAutoFit/>
-          </a:bodyPr>
-          <a:lstStyle/>
-          <a:p>
-            <a:pPr>
-              <a:spcAft>
-                <a:spcPts val="600"/>
-              </a:spcAft>
+            <a:ext cx="5212080" cy="393192"/>
+          </a:xfrm>
+          <a:prstGeom prst="rect">
+            <a:avLst/>
+          </a:prstGeom>
+          <a:noFill/>
+        </p:spPr>
+        <p:txBody>
+          <a:bodyPr wrap="square" lIns="0" rIns="0" tIns="0" bIns="0">
+            <a:spAutoFit/>
+          </a:bodyPr>
+          <a:lstStyle/>
+          <a:p>
+            <a:pPr>
               <a:defRPr sz="1800" b="1">
                 <a:solidFill>
                   <a:srgbClr val="007DA5"/>
@@ -11660,7 +11660,7 @@
               </a:defRPr>
             </a:pPr>
             <a:r>
-              <a:t>Practical example</a:t>
+              <a:t>Integration requirement: authority</a:t>
             </a:r>
           </a:p>
         </p:txBody>
@@ -11673,24 +11673,21 @@
         </p:nvSpPr>
         <p:spPr>
           <a:xfrm>
-            <a:off x="685800" y="4297679"/>
-            <a:ext cx="5212080" cy="1435608"/>
-          </a:xfrm>
-          <a:prstGeom prst="rect">
-            <a:avLst/>
-          </a:prstGeom>
-          <a:noFill/>
-        </p:spPr>
-        <p:txBody>
-          <a:bodyPr wrap="square" lIns="0" rIns="0" tIns="0" bIns="0">
-            <a:spAutoFit/>
-          </a:bodyPr>
-          <a:lstStyle/>
-          <a:p>
-            <a:pPr>
-              <a:spcAft>
-                <a:spcPts val="600"/>
-              </a:spcAft>
+            <a:off x="685800" y="4306824"/>
+            <a:ext cx="5212080" cy="1463040"/>
+          </a:xfrm>
+          <a:prstGeom prst="rect">
+            <a:avLst/>
+          </a:prstGeom>
+          <a:noFill/>
+        </p:spPr>
+        <p:txBody>
+          <a:bodyPr wrap="square" lIns="0" rIns="0" tIns="0" bIns="0">
+            <a:spAutoFit/>
+          </a:bodyPr>
+          <a:lstStyle/>
+          <a:p>
+            <a:pPr>
               <a:defRPr sz="1600" b="0">
                 <a:solidFill>
                   <a:srgbClr val="26354A"/>
@@ -11699,7 +11696,7 @@
               </a:defRPr>
             </a:pPr>
             <a:r>
-              <a:t>An external image URL in a claims report contains a case identifier. Opening the file could disclose that identifier through the request without a visible Send button.</a:t>
+              <a:t>Give each connected workflow only the data and actions it needs. Configure scoped credentials and approval for consequential sends or writes. DSH does not imply universal approval enforcement.</a:t>
             </a:r>
           </a:p>
         </p:txBody>
@@ -11713,23 +11710,20 @@
         <p:spPr>
           <a:xfrm>
             <a:off x="6309360" y="3858768"/>
-            <a:ext cx="5212080" cy="384048"/>
-          </a:xfrm>
-          <a:prstGeom prst="rect">
-            <a:avLst/>
-          </a:prstGeom>
-          <a:noFill/>
-        </p:spPr>
-        <p:txBody>
-          <a:bodyPr wrap="square" lIns="0" rIns="0" tIns="0" bIns="0">
-            <a:spAutoFit/>
-          </a:bodyPr>
-          <a:lstStyle/>
-          <a:p>
-            <a:pPr>
-              <a:spcAft>
-                <a:spcPts val="600"/>
-              </a:spcAft>
+            <a:ext cx="5212080" cy="393192"/>
+          </a:xfrm>
+          <a:prstGeom prst="rect">
+            <a:avLst/>
+          </a:prstGeom>
+          <a:noFill/>
+        </p:spPr>
+        <p:txBody>
+          <a:bodyPr wrap="square" lIns="0" rIns="0" tIns="0" bIns="0">
+            <a:spAutoFit/>
+          </a:bodyPr>
+          <a:lstStyle/>
+          <a:p>
+            <a:pPr>
               <a:defRPr sz="1800" b="1">
                 <a:solidFill>
                   <a:srgbClr val="007DA5"/>
@@ -11738,7 +11732,7 @@
               </a:defRPr>
             </a:pPr>
             <a:r>
-              <a:t>Controls to test</a:t>
+              <a:t>Operating requirement: monitoring</a:t>
             </a:r>
           </a:p>
         </p:txBody>
@@ -11751,24 +11745,21 @@
         </p:nvSpPr>
         <p:spPr>
           <a:xfrm>
-            <a:off x="6309360" y="4297679"/>
-            <a:ext cx="5212080" cy="1435608"/>
-          </a:xfrm>
-          <a:prstGeom prst="rect">
-            <a:avLst/>
-          </a:prstGeom>
-          <a:noFill/>
-        </p:spPr>
-        <p:txBody>
-          <a:bodyPr wrap="square" lIns="0" rIns="0" tIns="0" bIns="0">
-            <a:spAutoFit/>
-          </a:bodyPr>
-          <a:lstStyle/>
-          <a:p>
-            <a:pPr>
-              <a:spcAft>
-                <a:spcPts val="600"/>
-              </a:spcAft>
+            <a:off x="6309360" y="4306824"/>
+            <a:ext cx="5212080" cy="1463040"/>
+          </a:xfrm>
+          <a:prstGeom prst="rect">
+            <a:avLst/>
+          </a:prstGeom>
+          <a:noFill/>
+        </p:spPr>
+        <p:txBody>
+          <a:bodyPr wrap="square" lIns="0" rIns="0" tIns="0" bIns="0">
+            <a:spAutoFit/>
+          </a:bodyPr>
+          <a:lstStyle/>
+          <a:p>
+            <a:pPr>
               <a:defRPr sz="1600" b="0">
                 <a:solidFill>
                   <a:srgbClr val="26354A"/>
@@ -11777,7 +11768,7 @@
               </a:defRPr>
             </a:pPr>
             <a:r>
-              <a:t>Minimise sensitive exports. Review scripts and remote resources. Prefer self-contained output where appropriate. Test the final file in its real viewing environment.</a:t>
+              <a:t>Name an alert owner, define stop and restart decisions and protect relevant logs. Gateway access logs are not a complete tool-command ledger. Verify coverage before relying on it.</a:t>
             </a:r>
           </a:p>
         </p:txBody>
@@ -11790,24 +11781,21 @@
         </p:nvSpPr>
         <p:spPr>
           <a:xfrm>
-            <a:off x="685800" y="6044184"/>
-            <a:ext cx="10789920" cy="237744"/>
-          </a:xfrm>
-          <a:prstGeom prst="rect">
-            <a:avLst/>
-          </a:prstGeom>
-          <a:noFill/>
-        </p:spPr>
-        <p:txBody>
-          <a:bodyPr wrap="square" lIns="0" rIns="0" tIns="0" bIns="0">
-            <a:spAutoFit/>
-          </a:bodyPr>
-          <a:lstStyle/>
-          <a:p>
-            <a:pPr>
-              <a:spcAft>
-                <a:spcPts val="600"/>
-              </a:spcAft>
+            <a:off x="685800" y="6071616"/>
+            <a:ext cx="10789920" cy="274320"/>
+          </a:xfrm>
+          <a:prstGeom prst="rect">
+            <a:avLst/>
+          </a:prstGeom>
+          <a:noFill/>
+        </p:spPr>
+        <p:txBody>
+          <a:bodyPr wrap="square" lIns="0" rIns="0" tIns="0" bIns="0">
+            <a:spAutoFit/>
+          </a:bodyPr>
+          <a:lstStyle/>
+          <a:p>
+            <a:pPr>
               <a:defRPr sz="1000" b="0">
                 <a:solidFill>
                   <a:srgbClr val="66758A"/>
@@ -11816,7 +11804,7 @@
               </a:defRPr>
             </a:pPr>
             <a:r>
-              <a:t>Source links, explanation and limits are in the speaker guide and slide notes.</a:t>
+              <a:t>Reference features and proposed acceptance checks. No new live deployment verification.</a:t>
             </a:r>
           </a:p>
         </p:txBody>
@@ -11852,7 +11840,7 @@
               </a:defRPr>
             </a:pPr>
             <a:r>
-              <a:t>20 / 24    15:50–16:40 planned    Sources and explanation in notes</a:t>
+              <a:t>19 / 24    14:55–15:50 planned    Sources and explanation in notes</a:t>
             </a:r>
           </a:p>
         </p:txBody>
@@ -12328,20 +12316,23 @@
         <p:spPr>
           <a:xfrm>
             <a:off x="640080" y="411480"/>
-            <a:ext cx="10972800" cy="274320"/>
-          </a:xfrm>
-          <a:prstGeom prst="rect">
-            <a:avLst/>
-          </a:prstGeom>
-          <a:noFill/>
-        </p:spPr>
-        <p:txBody>
-          <a:bodyPr wrap="square" lIns="0" rIns="0" tIns="0" bIns="0">
-            <a:spAutoFit/>
-          </a:bodyPr>
-          <a:lstStyle/>
-          <a:p>
-            <a:pPr>
+            <a:ext cx="10972800" cy="256032"/>
+          </a:xfrm>
+          <a:prstGeom prst="rect">
+            <a:avLst/>
+          </a:prstGeom>
+          <a:noFill/>
+        </p:spPr>
+        <p:txBody>
+          <a:bodyPr wrap="square" lIns="0" rIns="0" tIns="0" bIns="0">
+            <a:spAutoFit/>
+          </a:bodyPr>
+          <a:lstStyle/>
+          <a:p>
+            <a:pPr>
+              <a:spcAft>
+                <a:spcPts val="600"/>
+              </a:spcAft>
               <a:defRPr sz="1100" b="1">
                 <a:solidFill>
                   <a:srgbClr val="0088BA"/>
@@ -12350,7 +12341,7 @@
               </a:defRPr>
             </a:pPr>
             <a:r>
-              <a:t>PART 3 / WHAT DSH PROVIDES AND HOW WE QUALIFY IT</a:t>
+              <a:t>4 / FOLLOW THE OUTPUT</a:t>
             </a:r>
           </a:p>
         </p:txBody>
@@ -12364,20 +12355,23 @@
         <p:spPr>
           <a:xfrm>
             <a:off x="640080" y="868680"/>
-            <a:ext cx="10972800" cy="777240"/>
-          </a:xfrm>
-          <a:prstGeom prst="rect">
-            <a:avLst/>
-          </a:prstGeom>
-          <a:noFill/>
-        </p:spPr>
-        <p:txBody>
-          <a:bodyPr wrap="square" lIns="0" rIns="0" tIns="0" bIns="0">
-            <a:spAutoFit/>
-          </a:bodyPr>
-          <a:lstStyle/>
-          <a:p>
-            <a:pPr>
+            <a:ext cx="10972800" cy="731520"/>
+          </a:xfrm>
+          <a:prstGeom prst="rect">
+            <a:avLst/>
+          </a:prstGeom>
+          <a:noFill/>
+        </p:spPr>
+        <p:txBody>
+          <a:bodyPr wrap="square" lIns="0" rIns="0" tIns="0" bIns="0">
+            <a:spAutoFit/>
+          </a:bodyPr>
+          <a:lstStyle/>
+          <a:p>
+            <a:pPr>
+              <a:spcAft>
+                <a:spcPts val="600"/>
+              </a:spcAft>
               <a:defRPr sz="2500" b="1">
                 <a:solidFill>
                   <a:srgbClr val="14243C"/>
@@ -12386,7 +12380,7 @@
               </a:defRPr>
             </a:pPr>
             <a:r>
-              <a:t>Safety evidence comes from testing the actual workflow</a:t>
+              <a:t>Generated HTML creates a second execution boundary</a:t>
             </a:r>
           </a:p>
         </p:txBody>
@@ -12400,20 +12394,23 @@
         <p:spPr>
           <a:xfrm>
             <a:off x="685800" y="1856231"/>
-            <a:ext cx="5212080" cy="393192"/>
-          </a:xfrm>
-          <a:prstGeom prst="rect">
-            <a:avLst/>
-          </a:prstGeom>
-          <a:noFill/>
-        </p:spPr>
-        <p:txBody>
-          <a:bodyPr wrap="square" lIns="0" rIns="0" tIns="0" bIns="0">
-            <a:spAutoFit/>
-          </a:bodyPr>
-          <a:lstStyle/>
-          <a:p>
-            <a:pPr>
+            <a:ext cx="5212080" cy="384048"/>
+          </a:xfrm>
+          <a:prstGeom prst="rect">
+            <a:avLst/>
+          </a:prstGeom>
+          <a:noFill/>
+        </p:spPr>
+        <p:txBody>
+          <a:bodyPr wrap="square" lIns="0" rIns="0" tIns="0" bIns="0">
+            <a:spAutoFit/>
+          </a:bodyPr>
+          <a:lstStyle/>
+          <a:p>
+            <a:pPr>
+              <a:spcAft>
+                <a:spcPts val="600"/>
+              </a:spcAft>
               <a:defRPr sz="1800" b="1">
                 <a:solidFill>
                   <a:srgbClr val="007DA5"/>
@@ -12422,7 +12419,7 @@
               </a:defRPr>
             </a:pPr>
             <a:r>
-              <a:t>Isolation and restricted routes</a:t>
+              <a:t>Inside the workspace</a:t>
             </a:r>
           </a:p>
         </p:txBody>
@@ -12435,21 +12432,24 @@
         </p:nvSpPr>
         <p:spPr>
           <a:xfrm>
-            <a:off x="685800" y="2304287"/>
-            <a:ext cx="5212080" cy="1463040"/>
-          </a:xfrm>
-          <a:prstGeom prst="rect">
-            <a:avLst/>
-          </a:prstGeom>
-          <a:noFill/>
-        </p:spPr>
-        <p:txBody>
-          <a:bodyPr wrap="square" lIns="0" rIns="0" tIns="0" bIns="0">
-            <a:spAutoFit/>
-          </a:bodyPr>
-          <a:lstStyle/>
-          <a:p>
-            <a:pPr>
+            <a:off x="685800" y="2295144"/>
+            <a:ext cx="5212080" cy="1435608"/>
+          </a:xfrm>
+          <a:prstGeom prst="rect">
+            <a:avLst/>
+          </a:prstGeom>
+          <a:noFill/>
+        </p:spPr>
+        <p:txBody>
+          <a:bodyPr wrap="square" lIns="0" rIns="0" tIns="0" bIns="0">
+            <a:spAutoFit/>
+          </a:bodyPr>
+          <a:lstStyle/>
+          <a:p>
+            <a:pPr>
+              <a:spcAft>
+                <a:spcPts val="600"/>
+              </a:spcAft>
               <a:defRPr sz="1600" b="0">
                 <a:solidFill>
                   <a:srgbClr val="26354A"/>
@@ -12458,7 +12458,7 @@
               </a:defRPr>
             </a:pPr>
             <a:r>
-              <a:t>With disposable users and test files, try reading a peer workspace and contacting an unapproved destination. Test DNS and package services too. Inspect denials and the receiving side where possible.</a:t>
+              <a:t>The assistant reads approved files and generates a report with the worker's identity and network permissions. Project inputs may still carry hostile instructions.</a:t>
             </a:r>
           </a:p>
         </p:txBody>
@@ -12472,20 +12472,23 @@
         <p:spPr>
           <a:xfrm>
             <a:off x="6309360" y="1856231"/>
-            <a:ext cx="5212080" cy="393192"/>
-          </a:xfrm>
-          <a:prstGeom prst="rect">
-            <a:avLst/>
-          </a:prstGeom>
-          <a:noFill/>
-        </p:spPr>
-        <p:txBody>
-          <a:bodyPr wrap="square" lIns="0" rIns="0" tIns="0" bIns="0">
-            <a:spAutoFit/>
-          </a:bodyPr>
-          <a:lstStyle/>
-          <a:p>
-            <a:pPr>
+            <a:ext cx="5212080" cy="384048"/>
+          </a:xfrm>
+          <a:prstGeom prst="rect">
+            <a:avLst/>
+          </a:prstGeom>
+          <a:noFill/>
+        </p:spPr>
+        <p:txBody>
+          <a:bodyPr wrap="square" lIns="0" rIns="0" tIns="0" bIns="0">
+            <a:spAutoFit/>
+          </a:bodyPr>
+          <a:lstStyle/>
+          <a:p>
+            <a:pPr>
+              <a:spcAft>
+                <a:spcPts val="600"/>
+              </a:spcAft>
               <a:defRPr sz="1800" b="1">
                 <a:solidFill>
                   <a:srgbClr val="007DA5"/>
@@ -12494,7 +12497,7 @@
               </a:defRPr>
             </a:pPr>
             <a:r>
-              <a:t>Unauthorised actions and exports</a:t>
+              <a:t>In the recipient's browser</a:t>
             </a:r>
           </a:p>
         </p:txBody>
@@ -12507,21 +12510,24 @@
         </p:nvSpPr>
         <p:spPr>
           <a:xfrm>
-            <a:off x="6309360" y="2304287"/>
-            <a:ext cx="5212080" cy="1463040"/>
-          </a:xfrm>
-          <a:prstGeom prst="rect">
-            <a:avLst/>
-          </a:prstGeom>
-          <a:noFill/>
-        </p:spPr>
-        <p:txBody>
-          <a:bodyPr wrap="square" lIns="0" rIns="0" tIns="0" bIns="0">
-            <a:spAutoFit/>
-          </a:bodyPr>
-          <a:lstStyle/>
-          <a:p>
-            <a:pPr>
+            <a:off x="6309360" y="2295144"/>
+            <a:ext cx="5212080" cy="1435608"/>
+          </a:xfrm>
+          <a:prstGeom prst="rect">
+            <a:avLst/>
+          </a:prstGeom>
+          <a:noFill/>
+        </p:spPr>
+        <p:txBody>
+          <a:bodyPr wrap="square" lIns="0" rIns="0" tIns="0" bIns="0">
+            <a:spAutoFit/>
+          </a:bodyPr>
+          <a:lstStyle/>
+          <a:p>
+            <a:pPr>
+              <a:spcAft>
+                <a:spcPts val="600"/>
+              </a:spcAft>
               <a:defRPr sz="1600" b="0">
                 <a:solidFill>
                   <a:srgbClr val="26354A"/>
@@ -12530,7 +12536,7 @@
               </a:defRPr>
             </a:pPr>
             <a:r>
-              <a:t>Use harmless canary data. Try an unapproved send or record change and inspect the target audit. Open exported HTML in its intended viewer and check scripts, remote requests and data exposure.</a:t>
+              <a:t>The report may load scripts, images or remote data. Browser permissions differ from the worker's. Relevant credentials may be sent where browser rules allow.</a:t>
             </a:r>
           </a:p>
         </p:txBody>
@@ -12544,20 +12550,23 @@
         <p:spPr>
           <a:xfrm>
             <a:off x="685800" y="3858768"/>
-            <a:ext cx="5212080" cy="393192"/>
-          </a:xfrm>
-          <a:prstGeom prst="rect">
-            <a:avLst/>
-          </a:prstGeom>
-          <a:noFill/>
-        </p:spPr>
-        <p:txBody>
-          <a:bodyPr wrap="square" lIns="0" rIns="0" tIns="0" bIns="0">
-            <a:spAutoFit/>
-          </a:bodyPr>
-          <a:lstStyle/>
-          <a:p>
-            <a:pPr>
+            <a:ext cx="5212080" cy="384048"/>
+          </a:xfrm>
+          <a:prstGeom prst="rect">
+            <a:avLst/>
+          </a:prstGeom>
+          <a:noFill/>
+        </p:spPr>
+        <p:txBody>
+          <a:bodyPr wrap="square" lIns="0" rIns="0" tIns="0" bIns="0">
+            <a:spAutoFit/>
+          </a:bodyPr>
+          <a:lstStyle/>
+          <a:p>
+            <a:pPr>
+              <a:spcAft>
+                <a:spcPts val="600"/>
+              </a:spcAft>
               <a:defRPr sz="1800" b="1">
                 <a:solidFill>
                   <a:srgbClr val="007DA5"/>
@@ -12566,7 +12575,7 @@
               </a:defRPr>
             </a:pPr>
             <a:r>
-              <a:t>Alerts, stop and recovery</a:t>
+              <a:t>Practical example</a:t>
             </a:r>
           </a:p>
         </p:txBody>
@@ -12579,21 +12588,24 @@
         </p:nvSpPr>
         <p:spPr>
           <a:xfrm>
-            <a:off x="685800" y="4306824"/>
-            <a:ext cx="5212080" cy="1463040"/>
-          </a:xfrm>
-          <a:prstGeom prst="rect">
-            <a:avLst/>
-          </a:prstGeom>
-          <a:noFill/>
-        </p:spPr>
-        <p:txBody>
-          <a:bodyPr wrap="square" lIns="0" rIns="0" tIns="0" bIns="0">
-            <a:spAutoFit/>
-          </a:bodyPr>
-          <a:lstStyle/>
-          <a:p>
-            <a:pPr>
+            <a:off x="685800" y="4297679"/>
+            <a:ext cx="5212080" cy="1435608"/>
+          </a:xfrm>
+          <a:prstGeom prst="rect">
+            <a:avLst/>
+          </a:prstGeom>
+          <a:noFill/>
+        </p:spPr>
+        <p:txBody>
+          <a:bodyPr wrap="square" lIns="0" rIns="0" tIns="0" bIns="0">
+            <a:spAutoFit/>
+          </a:bodyPr>
+          <a:lstStyle/>
+          <a:p>
+            <a:pPr>
+              <a:spcAft>
+                <a:spcPts val="600"/>
+              </a:spcAft>
               <a:defRPr sz="1600" b="0">
                 <a:solidFill>
                   <a:srgbClr val="26354A"/>
@@ -12602,7 +12614,7 @@
               </a:defRPr>
             </a:pPr>
             <a:r>
-              <a:t>Trigger a controlled failure, confirm the right person receives the alert, then stop a disposable run. Check queued work, saved files and restart behaviour before approving recovery.</a:t>
+              <a:t>An external image URL in a claims report contains a case identifier. Opening the file could disclose that identifier through the request without a visible Send button.</a:t>
             </a:r>
           </a:p>
         </p:txBody>
@@ -12616,20 +12628,23 @@
         <p:spPr>
           <a:xfrm>
             <a:off x="6309360" y="3858768"/>
-            <a:ext cx="5212080" cy="393192"/>
-          </a:xfrm>
-          <a:prstGeom prst="rect">
-            <a:avLst/>
-          </a:prstGeom>
-          <a:noFill/>
-        </p:spPr>
-        <p:txBody>
-          <a:bodyPr wrap="square" lIns="0" rIns="0" tIns="0" bIns="0">
-            <a:spAutoFit/>
-          </a:bodyPr>
-          <a:lstStyle/>
-          <a:p>
-            <a:pPr>
+            <a:ext cx="5212080" cy="384048"/>
+          </a:xfrm>
+          <a:prstGeom prst="rect">
+            <a:avLst/>
+          </a:prstGeom>
+          <a:noFill/>
+        </p:spPr>
+        <p:txBody>
+          <a:bodyPr wrap="square" lIns="0" rIns="0" tIns="0" bIns="0">
+            <a:spAutoFit/>
+          </a:bodyPr>
+          <a:lstStyle/>
+          <a:p>
+            <a:pPr>
+              <a:spcAft>
+                <a:spcPts val="600"/>
+              </a:spcAft>
               <a:defRPr sz="1800" b="1">
                 <a:solidFill>
                   <a:srgbClr val="007DA5"/>
@@ -12638,7 +12653,7 @@
               </a:defRPr>
             </a:pPr>
             <a:r>
-              <a:t>A scoped acceptance record</a:t>
+              <a:t>Controls to test</a:t>
             </a:r>
           </a:p>
         </p:txBody>
@@ -12651,21 +12666,24 @@
         </p:nvSpPr>
         <p:spPr>
           <a:xfrm>
-            <a:off x="6309360" y="4306824"/>
-            <a:ext cx="5212080" cy="1463040"/>
-          </a:xfrm>
-          <a:prstGeom prst="rect">
-            <a:avLst/>
-          </a:prstGeom>
-          <a:noFill/>
-        </p:spPr>
-        <p:txBody>
-          <a:bodyPr wrap="square" lIns="0" rIns="0" tIns="0" bIns="0">
-            <a:spAutoFit/>
-          </a:bodyPr>
-          <a:lstStyle/>
-          <a:p>
-            <a:pPr>
+            <a:off x="6309360" y="4297679"/>
+            <a:ext cx="5212080" cy="1435608"/>
+          </a:xfrm>
+          <a:prstGeom prst="rect">
+            <a:avLst/>
+          </a:prstGeom>
+          <a:noFill/>
+        </p:spPr>
+        <p:txBody>
+          <a:bodyPr wrap="square" lIns="0" rIns="0" tIns="0" bIns="0">
+            <a:spAutoFit/>
+          </a:bodyPr>
+          <a:lstStyle/>
+          <a:p>
+            <a:pPr>
+              <a:spcAft>
+                <a:spcPts val="600"/>
+              </a:spcAft>
               <a:defRPr sz="1600" b="0">
                 <a:solidFill>
                   <a:srgbClr val="26354A"/>
@@ -12674,7 +12692,7 @@
               </a:defRPr>
             </a:pPr>
             <a:r>
-              <a:t>Keep the exact version, configuration, inputs, expected result, observed result and owner decision. Test legitimate work too. These are proposed acceptance checks, not tests completed by this deck.</a:t>
+              <a:t>Minimise sensitive exports. Review scripts and remote resources. Prefer self-contained output where appropriate. Test the final file in its real viewing environment.</a:t>
             </a:r>
           </a:p>
         </p:txBody>
@@ -12687,21 +12705,24 @@
         </p:nvSpPr>
         <p:spPr>
           <a:xfrm>
-            <a:off x="685800" y="6071616"/>
-            <a:ext cx="10789920" cy="274320"/>
-          </a:xfrm>
-          <a:prstGeom prst="rect">
-            <a:avLst/>
-          </a:prstGeom>
-          <a:noFill/>
-        </p:spPr>
-        <p:txBody>
-          <a:bodyPr wrap="square" lIns="0" rIns="0" tIns="0" bIns="0">
-            <a:spAutoFit/>
-          </a:bodyPr>
-          <a:lstStyle/>
-          <a:p>
-            <a:pPr>
+            <a:off x="685800" y="6044184"/>
+            <a:ext cx="10789920" cy="237744"/>
+          </a:xfrm>
+          <a:prstGeom prst="rect">
+            <a:avLst/>
+          </a:prstGeom>
+          <a:noFill/>
+        </p:spPr>
+        <p:txBody>
+          <a:bodyPr wrap="square" lIns="0" rIns="0" tIns="0" bIns="0">
+            <a:spAutoFit/>
+          </a:bodyPr>
+          <a:lstStyle/>
+          <a:p>
+            <a:pPr>
+              <a:spcAft>
+                <a:spcPts val="600"/>
+              </a:spcAft>
               <a:defRPr sz="1000" b="0">
                 <a:solidFill>
                   <a:srgbClr val="66758A"/>
@@ -12710,7 +12731,7 @@
               </a:defRPr>
             </a:pPr>
             <a:r>
-              <a:t>Reference features and proposed acceptance checks. No new live deployment verification.</a:t>
+              <a:t>Source links, explanation and limits are in the speaker guide and slide notes.</a:t>
             </a:r>
           </a:p>
         </p:txBody>
@@ -12746,7 +12767,7 @@
               </a:defRPr>
             </a:pPr>
             <a:r>
-              <a:t>21 / 24    16:40–17:30 planned    Sources and explanation in notes</a:t>
+              <a:t>20 / 24    15:50–16:40 planned    Sources and explanation in notes</a:t>
             </a:r>
           </a:p>
         </p:txBody>
@@ -12778,23 +12799,20 @@
         <p:spPr>
           <a:xfrm>
             <a:off x="640080" y="411480"/>
-            <a:ext cx="10972800" cy="256032"/>
-          </a:xfrm>
-          <a:prstGeom prst="rect">
-            <a:avLst/>
-          </a:prstGeom>
-          <a:noFill/>
-        </p:spPr>
-        <p:txBody>
-          <a:bodyPr wrap="square" lIns="0" rIns="0" tIns="0" bIns="0">
-            <a:spAutoFit/>
-          </a:bodyPr>
-          <a:lstStyle/>
-          <a:p>
-            <a:pPr>
-              <a:spcAft>
-                <a:spcPts val="600"/>
-              </a:spcAft>
+            <a:ext cx="10972800" cy="274320"/>
+          </a:xfrm>
+          <a:prstGeom prst="rect">
+            <a:avLst/>
+          </a:prstGeom>
+          <a:noFill/>
+        </p:spPr>
+        <p:txBody>
+          <a:bodyPr wrap="square" lIns="0" rIns="0" tIns="0" bIns="0">
+            <a:spAutoFit/>
+          </a:bodyPr>
+          <a:lstStyle/>
+          <a:p>
+            <a:pPr>
               <a:defRPr sz="1100" b="1">
                 <a:solidFill>
                   <a:srgbClr val="0088BA"/>
@@ -12803,7 +12821,7 @@
               </a:defRPr>
             </a:pPr>
             <a:r>
-              <a:t>4 / OPERATING EVIDENCE</a:t>
+              <a:t>PART 3 / WHAT DSH PROVIDES AND HOW WE QUALIFY IT</a:t>
             </a:r>
           </a:p>
         </p:txBody>
@@ -12817,23 +12835,20 @@
         <p:spPr>
           <a:xfrm>
             <a:off x="640080" y="868680"/>
-            <a:ext cx="10972800" cy="731520"/>
-          </a:xfrm>
-          <a:prstGeom prst="rect">
-            <a:avLst/>
-          </a:prstGeom>
-          <a:noFill/>
-        </p:spPr>
-        <p:txBody>
-          <a:bodyPr wrap="square" lIns="0" rIns="0" tIns="0" bIns="0">
-            <a:spAutoFit/>
-          </a:bodyPr>
-          <a:lstStyle/>
-          <a:p>
-            <a:pPr>
-              <a:spcAft>
-                <a:spcPts val="600"/>
-              </a:spcAft>
+            <a:ext cx="10972800" cy="777240"/>
+          </a:xfrm>
+          <a:prstGeom prst="rect">
+            <a:avLst/>
+          </a:prstGeom>
+          <a:noFill/>
+        </p:spPr>
+        <p:txBody>
+          <a:bodyPr wrap="square" lIns="0" rIns="0" tIns="0" bIns="0">
+            <a:spAutoFit/>
+          </a:bodyPr>
+          <a:lstStyle/>
+          <a:p>
+            <a:pPr>
               <a:defRPr sz="2500" b="1">
                 <a:solidFill>
                   <a:srgbClr val="14243C"/>
@@ -12842,7 +12857,7 @@
               </a:defRPr>
             </a:pPr>
             <a:r>
-              <a:t>Keep an evidence pack people can actually use</a:t>
+              <a:t>Safety evidence comes from testing the actual workflow</a:t>
             </a:r>
           </a:p>
         </p:txBody>
@@ -12856,23 +12871,20 @@
         <p:spPr>
           <a:xfrm>
             <a:off x="685800" y="1856231"/>
-            <a:ext cx="5212080" cy="384048"/>
-          </a:xfrm>
-          <a:prstGeom prst="rect">
-            <a:avLst/>
-          </a:prstGeom>
-          <a:noFill/>
-        </p:spPr>
-        <p:txBody>
-          <a:bodyPr wrap="square" lIns="0" rIns="0" tIns="0" bIns="0">
-            <a:spAutoFit/>
-          </a:bodyPr>
-          <a:lstStyle/>
-          <a:p>
-            <a:pPr>
-              <a:spcAft>
-                <a:spcPts val="600"/>
-              </a:spcAft>
+            <a:ext cx="5212080" cy="393192"/>
+          </a:xfrm>
+          <a:prstGeom prst="rect">
+            <a:avLst/>
+          </a:prstGeom>
+          <a:noFill/>
+        </p:spPr>
+        <p:txBody>
+          <a:bodyPr wrap="square" lIns="0" rIns="0" tIns="0" bIns="0">
+            <a:spAutoFit/>
+          </a:bodyPr>
+          <a:lstStyle/>
+          <a:p>
+            <a:pPr>
               <a:defRPr sz="1800" b="1">
                 <a:solidFill>
                   <a:srgbClr val="007DA5"/>
@@ -12881,7 +12893,7 @@
               </a:defRPr>
             </a:pPr>
             <a:r>
-              <a:t>Who and what</a:t>
+              <a:t>Isolation and restricted routes</a:t>
             </a:r>
           </a:p>
         </p:txBody>
@@ -12894,24 +12906,21 @@
         </p:nvSpPr>
         <p:spPr>
           <a:xfrm>
-            <a:off x="685800" y="2295144"/>
-            <a:ext cx="5212080" cy="1435608"/>
-          </a:xfrm>
-          <a:prstGeom prst="rect">
-            <a:avLst/>
-          </a:prstGeom>
-          <a:noFill/>
-        </p:spPr>
-        <p:txBody>
-          <a:bodyPr wrap="square" lIns="0" rIns="0" tIns="0" bIns="0">
-            <a:spAutoFit/>
-          </a:bodyPr>
-          <a:lstStyle/>
-          <a:p>
-            <a:pPr>
-              <a:spcAft>
-                <a:spcPts val="600"/>
-              </a:spcAft>
+            <a:off x="685800" y="2304287"/>
+            <a:ext cx="5212080" cy="1463040"/>
+          </a:xfrm>
+          <a:prstGeom prst="rect">
+            <a:avLst/>
+          </a:prstGeom>
+          <a:noFill/>
+        </p:spPr>
+        <p:txBody>
+          <a:bodyPr wrap="square" lIns="0" rIns="0" tIns="0" bIns="0">
+            <a:spAutoFit/>
+          </a:bodyPr>
+          <a:lstStyle/>
+          <a:p>
+            <a:pPr>
               <a:defRPr sz="1600" b="0">
                 <a:solidFill>
                   <a:srgbClr val="26354A"/>
@@ -12920,7 +12929,7 @@
               </a:defRPr>
             </a:pPr>
             <a:r>
-              <a:t>Owner, purpose, approved data, rule/model/tool versions and provider dependencies. Identify the approver for consequential actions.</a:t>
+              <a:t>With disposable users and test files, try reading a peer workspace and contacting an unapproved destination. Test DNS and package services too. Inspect denials and the receiving side where possible.</a:t>
             </a:r>
           </a:p>
         </p:txBody>
@@ -12934,23 +12943,20 @@
         <p:spPr>
           <a:xfrm>
             <a:off x="6309360" y="1856231"/>
-            <a:ext cx="5212080" cy="384048"/>
-          </a:xfrm>
-          <a:prstGeom prst="rect">
-            <a:avLst/>
-          </a:prstGeom>
-          <a:noFill/>
-        </p:spPr>
-        <p:txBody>
-          <a:bodyPr wrap="square" lIns="0" rIns="0" tIns="0" bIns="0">
-            <a:spAutoFit/>
-          </a:bodyPr>
-          <a:lstStyle/>
-          <a:p>
-            <a:pPr>
-              <a:spcAft>
-                <a:spcPts val="600"/>
-              </a:spcAft>
+            <a:ext cx="5212080" cy="393192"/>
+          </a:xfrm>
+          <a:prstGeom prst="rect">
+            <a:avLst/>
+          </a:prstGeom>
+          <a:noFill/>
+        </p:spPr>
+        <p:txBody>
+          <a:bodyPr wrap="square" lIns="0" rIns="0" tIns="0" bIns="0">
+            <a:spAutoFit/>
+          </a:bodyPr>
+          <a:lstStyle/>
+          <a:p>
+            <a:pPr>
               <a:defRPr sz="1800" b="1">
                 <a:solidFill>
                   <a:srgbClr val="007DA5"/>
@@ -12959,7 +12965,7 @@
               </a:defRPr>
             </a:pPr>
             <a:r>
-              <a:t>What happened</a:t>
+              <a:t>Unauthorised actions and exports</a:t>
             </a:r>
           </a:p>
         </p:txBody>
@@ -12972,24 +12978,21 @@
         </p:nvSpPr>
         <p:spPr>
           <a:xfrm>
-            <a:off x="6309360" y="2295144"/>
-            <a:ext cx="5212080" cy="1435608"/>
-          </a:xfrm>
-          <a:prstGeom prst="rect">
-            <a:avLst/>
-          </a:prstGeom>
-          <a:noFill/>
-        </p:spPr>
-        <p:txBody>
-          <a:bodyPr wrap="square" lIns="0" rIns="0" tIns="0" bIns="0">
-            <a:spAutoFit/>
-          </a:bodyPr>
-          <a:lstStyle/>
-          <a:p>
-            <a:pPr>
-              <a:spcAft>
-                <a:spcPts val="600"/>
-              </a:spcAft>
+            <a:off x="6309360" y="2304287"/>
+            <a:ext cx="5212080" cy="1463040"/>
+          </a:xfrm>
+          <a:prstGeom prst="rect">
+            <a:avLst/>
+          </a:prstGeom>
+          <a:noFill/>
+        </p:spPr>
+        <p:txBody>
+          <a:bodyPr wrap="square" lIns="0" rIns="0" tIns="0" bIns="0">
+            <a:spAutoFit/>
+          </a:bodyPr>
+          <a:lstStyle/>
+          <a:p>
+            <a:pPr>
               <a:defRPr sz="1600" b="0">
                 <a:solidFill>
                   <a:srgbClr val="26354A"/>
@@ -12998,7 +13001,7 @@
               </a:defRPr>
             </a:pPr>
             <a:r>
-              <a:t>Sources, calculations, final output, reviewer changes, approvals and relevant tool events. Do not promise universal capture of private model reasoning.</a:t>
+              <a:t>Use harmless canary data. Try an unapproved send or record change and inspect the target audit. Open exported HTML in its intended viewer and check scripts, remote requests and data exposure.</a:t>
             </a:r>
           </a:p>
         </p:txBody>
@@ -13012,23 +13015,20 @@
         <p:spPr>
           <a:xfrm>
             <a:off x="685800" y="3858768"/>
-            <a:ext cx="5212080" cy="384048"/>
-          </a:xfrm>
-          <a:prstGeom prst="rect">
-            <a:avLst/>
-          </a:prstGeom>
-          <a:noFill/>
-        </p:spPr>
-        <p:txBody>
-          <a:bodyPr wrap="square" lIns="0" rIns="0" tIns="0" bIns="0">
-            <a:spAutoFit/>
-          </a:bodyPr>
-          <a:lstStyle/>
-          <a:p>
-            <a:pPr>
-              <a:spcAft>
-                <a:spcPts val="600"/>
-              </a:spcAft>
+            <a:ext cx="5212080" cy="393192"/>
+          </a:xfrm>
+          <a:prstGeom prst="rect">
+            <a:avLst/>
+          </a:prstGeom>
+          <a:noFill/>
+        </p:spPr>
+        <p:txBody>
+          <a:bodyPr wrap="square" lIns="0" rIns="0" tIns="0" bIns="0">
+            <a:spAutoFit/>
+          </a:bodyPr>
+          <a:lstStyle/>
+          <a:p>
+            <a:pPr>
               <a:defRPr sz="1800" b="1">
                 <a:solidFill>
                   <a:srgbClr val="007DA5"/>
@@ -13037,7 +13037,7 @@
               </a:defRPr>
             </a:pPr>
             <a:r>
-              <a:t>What it cost</a:t>
+              <a:t>Alerts, stop and recovery</a:t>
             </a:r>
           </a:p>
         </p:txBody>
@@ -13050,24 +13050,21 @@
         </p:nvSpPr>
         <p:spPr>
           <a:xfrm>
-            <a:off x="685800" y="4297679"/>
-            <a:ext cx="5212080" cy="1435608"/>
-          </a:xfrm>
-          <a:prstGeom prst="rect">
-            <a:avLst/>
-          </a:prstGeom>
-          <a:noFill/>
-        </p:spPr>
-        <p:txBody>
-          <a:bodyPr wrap="square" lIns="0" rIns="0" tIns="0" bIns="0">
-            <a:spAutoFit/>
-          </a:bodyPr>
-          <a:lstStyle/>
-          <a:p>
-            <a:pPr>
-              <a:spcAft>
-                <a:spcPts val="600"/>
-              </a:spcAft>
+            <a:off x="685800" y="4306824"/>
+            <a:ext cx="5212080" cy="1463040"/>
+          </a:xfrm>
+          <a:prstGeom prst="rect">
+            <a:avLst/>
+          </a:prstGeom>
+          <a:noFill/>
+        </p:spPr>
+        <p:txBody>
+          <a:bodyPr wrap="square" lIns="0" rIns="0" tIns="0" bIns="0">
+            <a:spAutoFit/>
+          </a:bodyPr>
+          <a:lstStyle/>
+          <a:p>
+            <a:pPr>
               <a:defRPr sz="1600" b="0">
                 <a:solidFill>
                   <a:srgbClr val="26354A"/>
@@ -13076,7 +13073,7 @@
               </a:defRPr>
             </a:pPr>
             <a:r>
-              <a:t>Track provider usage, thinking where available, retries and recovery attempts. Include review effort and infrastructure when comparing full cost.</a:t>
+              <a:t>Trigger a controlled failure, confirm the right person receives the alert, then stop a disposable run. Check queued work, saved files and restart behaviour before approving recovery.</a:t>
             </a:r>
           </a:p>
         </p:txBody>
@@ -13090,23 +13087,20 @@
         <p:spPr>
           <a:xfrm>
             <a:off x="6309360" y="3858768"/>
-            <a:ext cx="5212080" cy="384048"/>
-          </a:xfrm>
-          <a:prstGeom prst="rect">
-            <a:avLst/>
-          </a:prstGeom>
-          <a:noFill/>
-        </p:spPr>
-        <p:txBody>
-          <a:bodyPr wrap="square" lIns="0" rIns="0" tIns="0" bIns="0">
-            <a:spAutoFit/>
-          </a:bodyPr>
-          <a:lstStyle/>
-          <a:p>
-            <a:pPr>
-              <a:spcAft>
-                <a:spcPts val="600"/>
-              </a:spcAft>
+            <a:ext cx="5212080" cy="393192"/>
+          </a:xfrm>
+          <a:prstGeom prst="rect">
+            <a:avLst/>
+          </a:prstGeom>
+          <a:noFill/>
+        </p:spPr>
+        <p:txBody>
+          <a:bodyPr wrap="square" lIns="0" rIns="0" tIns="0" bIns="0">
+            <a:spAutoFit/>
+          </a:bodyPr>
+          <a:lstStyle/>
+          <a:p>
+            <a:pPr>
               <a:defRPr sz="1800" b="1">
                 <a:solidFill>
                   <a:srgbClr val="007DA5"/>
@@ -13115,7 +13109,7 @@
               </a:defRPr>
             </a:pPr>
             <a:r>
-              <a:t>What is unknown</a:t>
+              <a:t>A scoped acceptance record</a:t>
             </a:r>
           </a:p>
         </p:txBody>
@@ -13128,24 +13122,21 @@
         </p:nvSpPr>
         <p:spPr>
           <a:xfrm>
-            <a:off x="6309360" y="4297679"/>
-            <a:ext cx="5212080" cy="1435608"/>
-          </a:xfrm>
-          <a:prstGeom prst="rect">
-            <a:avLst/>
-          </a:prstGeom>
-          <a:noFill/>
-        </p:spPr>
-        <p:txBody>
-          <a:bodyPr wrap="square" lIns="0" rIns="0" tIns="0" bIns="0">
-            <a:spAutoFit/>
-          </a:bodyPr>
-          <a:lstStyle/>
-          <a:p>
-            <a:pPr>
-              <a:spcAft>
-                <a:spcPts val="600"/>
-              </a:spcAft>
+            <a:off x="6309360" y="4306824"/>
+            <a:ext cx="5212080" cy="1463040"/>
+          </a:xfrm>
+          <a:prstGeom prst="rect">
+            <a:avLst/>
+          </a:prstGeom>
+          <a:noFill/>
+        </p:spPr>
+        <p:txBody>
+          <a:bodyPr wrap="square" lIns="0" rIns="0" tIns="0" bIns="0">
+            <a:spAutoFit/>
+          </a:bodyPr>
+          <a:lstStyle/>
+          <a:p>
+            <a:pPr>
               <a:defRPr sz="1600" b="0">
                 <a:solidFill>
                   <a:srgbClr val="26354A"/>
@@ -13154,7 +13145,7 @@
               </a:defRPr>
             </a:pPr>
             <a:r>
-              <a:t>Missing usage is unknown, not zero. A model-cost estimate is not the cloud invoice. Record incidents, limits and the decision to stop, narrow or expand.</a:t>
+              <a:t>Keep the exact version, configuration, inputs, expected result, observed result and owner decision. Test legitimate work too. These are proposed acceptance checks, not tests completed by this deck.</a:t>
             </a:r>
           </a:p>
         </p:txBody>
@@ -13167,24 +13158,21 @@
         </p:nvSpPr>
         <p:spPr>
           <a:xfrm>
-            <a:off x="685800" y="6044184"/>
-            <a:ext cx="10789920" cy="237744"/>
-          </a:xfrm>
-          <a:prstGeom prst="rect">
-            <a:avLst/>
-          </a:prstGeom>
-          <a:noFill/>
-        </p:spPr>
-        <p:txBody>
-          <a:bodyPr wrap="square" lIns="0" rIns="0" tIns="0" bIns="0">
-            <a:spAutoFit/>
-          </a:bodyPr>
-          <a:lstStyle/>
-          <a:p>
-            <a:pPr>
-              <a:spcAft>
-                <a:spcPts val="600"/>
-              </a:spcAft>
+            <a:off x="685800" y="6071616"/>
+            <a:ext cx="10789920" cy="274320"/>
+          </a:xfrm>
+          <a:prstGeom prst="rect">
+            <a:avLst/>
+          </a:prstGeom>
+          <a:noFill/>
+        </p:spPr>
+        <p:txBody>
+          <a:bodyPr wrap="square" lIns="0" rIns="0" tIns="0" bIns="0">
+            <a:spAutoFit/>
+          </a:bodyPr>
+          <a:lstStyle/>
+          <a:p>
+            <a:pPr>
               <a:defRPr sz="1000" b="0">
                 <a:solidFill>
                   <a:srgbClr val="66758A"/>
@@ -13193,7 +13181,7 @@
               </a:defRPr>
             </a:pPr>
             <a:r>
-              <a:t>Source links, explanation and limits are in the speaker guide and slide notes.</a:t>
+              <a:t>Reference features and proposed acceptance checks. No new live deployment verification.</a:t>
             </a:r>
           </a:p>
         </p:txBody>
@@ -13229,7 +13217,7 @@
               </a:defRPr>
             </a:pPr>
             <a:r>
-              <a:t>22 / 24    17:30–18:15 planned    Sources and explanation in notes</a:t>
+              <a:t>21 / 24    16:40–17:30 planned    Sources and explanation in notes</a:t>
             </a:r>
           </a:p>
         </p:txBody>
@@ -13286,7 +13274,7 @@
               </a:defRPr>
             </a:pPr>
             <a:r>
-              <a:t>4 / ADOPTION AND VALUE</a:t>
+              <a:t>4 / OPERATING EVIDENCE</a:t>
             </a:r>
           </a:p>
         </p:txBody>
@@ -13325,7 +13313,7 @@
               </a:defRPr>
             </a:pPr>
             <a:r>
-              <a:t>Measure a better completed task, not just a faster draft</a:t>
+              <a:t>Keep an evidence pack people can actually use</a:t>
             </a:r>
           </a:p>
         </p:txBody>
@@ -13364,7 +13352,7 @@
               </a:defRPr>
             </a:pPr>
             <a:r>
-              <a:t>Start narrowly</a:t>
+              <a:t>Who and what</a:t>
             </a:r>
           </a:p>
         </p:txBody>
@@ -13403,7 +13391,7 @@
               </a:defRPr>
             </a:pPr>
             <a:r>
-              <a:t>Choose one case type and owner. Build a reviewed baseline and representative cases, including difficult documents and ordinary legitimate requests.</a:t>
+              <a:t>Owner, purpose, approved data, rule/model/tool versions and provider dependencies. Identify the approver for consequential actions.</a:t>
             </a:r>
           </a:p>
         </p:txBody>
@@ -13442,7 +13430,7 @@
               </a:defRPr>
             </a:pPr>
             <a:r>
-              <a:t>Measure the full cycle</a:t>
+              <a:t>What happened</a:t>
             </a:r>
           </a:p>
         </p:txBody>
@@ -13481,7 +13469,7 @@
               </a:defRPr>
             </a:pPr>
             <a:r>
-              <a:t>Track intake, preparation, corrections, review and approved release. Compare quality and effort on similar cases. Processing time is not human time saved.</a:t>
+              <a:t>Sources, calculations, final output, reviewer changes, approvals and relevant tool events. Do not promise universal capture of private model reasoning.</a:t>
             </a:r>
           </a:p>
         </p:txBody>
@@ -13520,7 +13508,7 @@
               </a:defRPr>
             </a:pPr>
             <a:r>
-              <a:t>Expand with evidence</a:t>
+              <a:t>What it cost</a:t>
             </a:r>
           </a:p>
         </p:txBody>
@@ -13559,7 +13547,7 @@
               </a:defRPr>
             </a:pPr>
             <a:r>
-              <a:t>Review omissions, false claims, refusals, cost and incidents. Broaden data or tool access only when the owner accepts the remaining risk.</a:t>
+              <a:t>Track provider usage, thinking where available, retries and recovery attempts. Include review effort and infrastructure when comparing full cost.</a:t>
             </a:r>
           </a:p>
         </p:txBody>
@@ -13598,7 +13586,7 @@
               </a:defRPr>
             </a:pPr>
             <a:r>
-              <a:t>State success honestly</a:t>
+              <a:t>What is unknown</a:t>
             </a:r>
           </a:p>
         </p:txBody>
@@ -13637,7 +13625,7 @@
               </a:defRPr>
             </a:pPr>
             <a:r>
-              <a:t>Describe accepted outputs and fewer corrections under tested conditions. Avoid an invented productivity percentage, automatic compliance claim or promise of zero risk.</a:t>
+              <a:t>Missing usage is unknown, not zero. A model-cost estimate is not the cloud invoice. Record incidents, limits and the decision to stop, narrow or expand.</a:t>
             </a:r>
           </a:p>
         </p:txBody>
@@ -13712,7 +13700,7 @@
               </a:defRPr>
             </a:pPr>
             <a:r>
-              <a:t>23 / 24    18:15–19:00 planned    Sources and explanation in notes</a:t>
+              <a:t>22 / 24    17:30–18:15 planned    Sources and explanation in notes</a:t>
             </a:r>
           </a:p>
         </p:txBody>
@@ -13769,7 +13757,7 @@
               </a:defRPr>
             </a:pPr>
             <a:r>
-              <a:t>THE COMPLETE STORY</a:t>
+              <a:t>4 / ADOPTION AND VALUE</a:t>
             </a:r>
           </a:p>
         </p:txBody>
@@ -13808,7 +13796,7 @@
               </a:defRPr>
             </a:pPr>
             <a:r>
-              <a:t>Useful AI work needs clear authority and visible evidence</a:t>
+              <a:t>Measure a better completed task, not just a faster draft</a:t>
             </a:r>
           </a:p>
         </p:txBody>
@@ -13821,8 +13809,8 @@
         </p:nvSpPr>
         <p:spPr>
           <a:xfrm>
-            <a:off x="685800" y="1901952"/>
-            <a:ext cx="3456432" cy="685800"/>
+            <a:off x="685800" y="1856231"/>
+            <a:ext cx="5212080" cy="384048"/>
           </a:xfrm>
           <a:prstGeom prst="rect">
             <a:avLst/>
@@ -13847,7 +13835,7 @@
               </a:defRPr>
             </a:pPr>
             <a:r>
-              <a:t>Business value</a:t>
+              <a:t>Start narrowly</a:t>
             </a:r>
           </a:p>
         </p:txBody>
@@ -13860,8 +13848,8 @@
         </p:nvSpPr>
         <p:spPr>
           <a:xfrm>
-            <a:off x="685800" y="2697480"/>
-            <a:ext cx="3456432" cy="2926080"/>
+            <a:off x="685800" y="2295144"/>
+            <a:ext cx="5212080" cy="1435608"/>
           </a:xfrm>
           <a:prstGeom prst="rect">
             <a:avLst/>
@@ -13886,7 +13874,7 @@
               </a:defRPr>
             </a:pPr>
             <a:r>
-              <a:t>AI can help banking and insurance teams assemble evidence, calculate and draft. Start with a defined work product people can review.</a:t>
+              <a:t>Choose one case type and owner. Build a reviewed baseline and representative cases, including difficult documents and ordinary legitimate requests.</a:t>
             </a:r>
           </a:p>
         </p:txBody>
@@ -13899,8 +13887,8 @@
         </p:nvSpPr>
         <p:spPr>
           <a:xfrm>
-            <a:off x="4434840" y="1901952"/>
-            <a:ext cx="3456432" cy="685800"/>
+            <a:off x="6309360" y="1856231"/>
+            <a:ext cx="5212080" cy="384048"/>
           </a:xfrm>
           <a:prstGeom prst="rect">
             <a:avLst/>
@@ -13925,7 +13913,7 @@
               </a:defRPr>
             </a:pPr>
             <a:r>
-              <a:t>Responsibility</a:t>
+              <a:t>Measure the full cycle</a:t>
             </a:r>
           </a:p>
         </p:txBody>
@@ -13938,8 +13926,8 @@
         </p:nvSpPr>
         <p:spPr>
           <a:xfrm>
-            <a:off x="4434840" y="2697480"/>
-            <a:ext cx="3456432" cy="2926080"/>
+            <a:off x="6309360" y="2295144"/>
+            <a:ext cx="5212080" cy="1435608"/>
           </a:xfrm>
           <a:prstGeom prst="rect">
             <a:avLst/>
@@ -13964,7 +13952,85 @@
               </a:defRPr>
             </a:pPr>
             <a:r>
-              <a:t>External content cannot create permission. Operators constrain actions. Institutional owners judge acceptable risk and sufficient evidence.</a:t>
+              <a:t>Track intake, preparation, corrections, review and approved release. Compare quality and effort on similar cases. Processing time is not human time saved.</a:t>
+            </a:r>
+          </a:p>
+        </p:txBody>
+      </p:sp>
+      <p:sp>
+        <p:nvSpPr>
+          <p:cNvPr id="8" name="TextBox 7"/>
+          <p:cNvSpPr txBox="1"/>
+          <p:nvPr/>
+        </p:nvSpPr>
+        <p:spPr>
+          <a:xfrm>
+            <a:off x="685800" y="3858768"/>
+            <a:ext cx="5212080" cy="384048"/>
+          </a:xfrm>
+          <a:prstGeom prst="rect">
+            <a:avLst/>
+          </a:prstGeom>
+          <a:noFill/>
+        </p:spPr>
+        <p:txBody>
+          <a:bodyPr wrap="square" lIns="0" rIns="0" tIns="0" bIns="0">
+            <a:spAutoFit/>
+          </a:bodyPr>
+          <a:lstStyle/>
+          <a:p>
+            <a:pPr>
+              <a:spcAft>
+                <a:spcPts val="600"/>
+              </a:spcAft>
+              <a:defRPr sz="1800" b="1">
+                <a:solidFill>
+                  <a:srgbClr val="007DA5"/>
+                </a:solidFill>
+                <a:latin typeface="Calibri"/>
+              </a:defRPr>
+            </a:pPr>
+            <a:r>
+              <a:t>Expand with evidence</a:t>
+            </a:r>
+          </a:p>
+        </p:txBody>
+      </p:sp>
+      <p:sp>
+        <p:nvSpPr>
+          <p:cNvPr id="9" name="TextBox 8"/>
+          <p:cNvSpPr txBox="1"/>
+          <p:nvPr/>
+        </p:nvSpPr>
+        <p:spPr>
+          <a:xfrm>
+            <a:off x="685800" y="4297679"/>
+            <a:ext cx="5212080" cy="1435608"/>
+          </a:xfrm>
+          <a:prstGeom prst="rect">
+            <a:avLst/>
+          </a:prstGeom>
+          <a:noFill/>
+        </p:spPr>
+        <p:txBody>
+          <a:bodyPr wrap="square" lIns="0" rIns="0" tIns="0" bIns="0">
+            <a:spAutoFit/>
+          </a:bodyPr>
+          <a:lstStyle/>
+          <a:p>
+            <a:pPr>
+              <a:spcAft>
+                <a:spcPts val="600"/>
+              </a:spcAft>
+              <a:defRPr sz="1600" b="0">
+                <a:solidFill>
+                  <a:srgbClr val="26354A"/>
+                </a:solidFill>
+                <a:latin typeface="Calibri"/>
+              </a:defRPr>
+            </a:pPr>
+            <a:r>
+              <a:t>Review omissions, false claims, refusals, cost and incidents. Broaden data or tool access only when the owner accepts the remaining risk.</a:t>
             </a:r>
           </a:p>
         </p:txBody>
@@ -13972,6 +14038,84 @@
       <p:sp>
         <p:nvSpPr>
           <p:cNvPr id="10" name="TextBox 9"/>
+          <p:cNvSpPr txBox="1"/>
+          <p:nvPr/>
+        </p:nvSpPr>
+        <p:spPr>
+          <a:xfrm>
+            <a:off x="6309360" y="3858768"/>
+            <a:ext cx="5212080" cy="384048"/>
+          </a:xfrm>
+          <a:prstGeom prst="rect">
+            <a:avLst/>
+          </a:prstGeom>
+          <a:noFill/>
+        </p:spPr>
+        <p:txBody>
+          <a:bodyPr wrap="square" lIns="0" rIns="0" tIns="0" bIns="0">
+            <a:spAutoFit/>
+          </a:bodyPr>
+          <a:lstStyle/>
+          <a:p>
+            <a:pPr>
+              <a:spcAft>
+                <a:spcPts val="600"/>
+              </a:spcAft>
+              <a:defRPr sz="1800" b="1">
+                <a:solidFill>
+                  <a:srgbClr val="007DA5"/>
+                </a:solidFill>
+                <a:latin typeface="Calibri"/>
+              </a:defRPr>
+            </a:pPr>
+            <a:r>
+              <a:t>State success honestly</a:t>
+            </a:r>
+          </a:p>
+        </p:txBody>
+      </p:sp>
+      <p:sp>
+        <p:nvSpPr>
+          <p:cNvPr id="11" name="TextBox 10"/>
+          <p:cNvSpPr txBox="1"/>
+          <p:nvPr/>
+        </p:nvSpPr>
+        <p:spPr>
+          <a:xfrm>
+            <a:off x="6309360" y="4297679"/>
+            <a:ext cx="5212080" cy="1435608"/>
+          </a:xfrm>
+          <a:prstGeom prst="rect">
+            <a:avLst/>
+          </a:prstGeom>
+          <a:noFill/>
+        </p:spPr>
+        <p:txBody>
+          <a:bodyPr wrap="square" lIns="0" rIns="0" tIns="0" bIns="0">
+            <a:spAutoFit/>
+          </a:bodyPr>
+          <a:lstStyle/>
+          <a:p>
+            <a:pPr>
+              <a:spcAft>
+                <a:spcPts val="600"/>
+              </a:spcAft>
+              <a:defRPr sz="1600" b="0">
+                <a:solidFill>
+                  <a:srgbClr val="26354A"/>
+                </a:solidFill>
+                <a:latin typeface="Calibri"/>
+              </a:defRPr>
+            </a:pPr>
+            <a:r>
+              <a:t>Describe accepted outputs and fewer corrections under tested conditions. Avoid an invented productivity percentage, automatic compliance claim or promise of zero risk.</a:t>
+            </a:r>
+          </a:p>
+        </p:txBody>
+      </p:sp>
+      <p:sp>
+        <p:nvSpPr>
+          <p:cNvPr id="12" name="TextBox 11"/>
           <p:cNvSpPr txBox="1"/>
           <p:nvPr/>
         </p:nvSpPr>
@@ -14010,153 +14154,7 @@
       </p:sp>
       <p:sp>
         <p:nvSpPr>
-          <p:cNvPr id="11" name="TextBox 10"/>
-          <p:cNvSpPr txBox="1"/>
-          <p:nvPr/>
-        </p:nvSpPr>
-        <p:spPr>
-          <a:xfrm>
-            <a:off x="685800" y="4892040"/>
-            <a:ext cx="6949440" cy="1051560"/>
-          </a:xfrm>
-          <a:prstGeom prst="rect">
-            <a:avLst/>
-          </a:prstGeom>
-          <a:noFill/>
-        </p:spPr>
-        <p:txBody>
-          <a:bodyPr wrap="square" lIns="0" rIns="0" tIns="0" bIns="0">
-            <a:spAutoFit/>
-          </a:bodyPr>
-          <a:lstStyle/>
-          <a:p>
-            <a:pPr>
-              <a:spcAft>
-                <a:spcPts val="600"/>
-              </a:spcAft>
-              <a:defRPr sz="1600" b="0">
-                <a:solidFill>
-                  <a:srgbClr val="26354A"/>
-                </a:solidFill>
-                <a:latin typeface="Calibri"/>
-              </a:defRPr>
-            </a:pPr>
-            <a:r>
-              <a:rPr sz="1500"/>
-              <a:t>A useful starting point: choose one reviewed credit memo or claim-file task. Name the owner, define the permitted actions and agree on the evidence needed before adding more access.</a:t>
-            </a:r>
-          </a:p>
-        </p:txBody>
-      </p:sp>
-      <p:sp>
-        <p:nvSpPr>
           <p:cNvPr id="13" name="TextBox 12"/>
-          <p:cNvSpPr txBox="1"/>
-          <p:nvPr/>
-        </p:nvSpPr>
-        <p:spPr>
-          <a:xfrm>
-            <a:off x="8183879" y="1901952"/>
-            <a:ext cx="3456432" cy="457200"/>
-          </a:xfrm>
-          <a:prstGeom prst="rect">
-            <a:avLst/>
-          </a:prstGeom>
-          <a:noFill/>
-        </p:spPr>
-        <p:txBody>
-          <a:bodyPr wrap="none">
-            <a:spAutoFit/>
-          </a:bodyPr>
-          <a:lstStyle/>
-          <a:p>
-            <a:pPr>
-              <a:defRPr sz="1800">
-                <a:solidFill>
-                  <a:srgbClr val="17243B"/>
-                </a:solidFill>
-                <a:latin typeface="Calibri"/>
-              </a:defRPr>
-            </a:pPr>
-            <a:r>
-              <a:t>Explore the public DSH repository</a:t>
-            </a:r>
-          </a:p>
-        </p:txBody>
-      </p:sp>
-      <p:pic>
-        <p:nvPicPr>
-          <p:cNvPr id="14" name="Picture 13" descr="dsh-public-repository-qr.png"/>
-          <p:cNvPicPr>
-            <a:picLocks noChangeAspect="1"/>
-          </p:cNvPicPr>
-          <p:nvPr/>
-        </p:nvPicPr>
-        <p:blipFill>
-          <a:blip r:embed="rId3"/>
-          <a:stretch>
-            <a:fillRect/>
-          </a:stretch>
-        </p:blipFill>
-        <p:spPr>
-          <a:xfrm>
-            <a:off x="8567928" y="2560320"/>
-            <a:ext cx="2514600" cy="2514600"/>
-          </a:xfrm>
-          <a:prstGeom prst="rect">
-            <a:avLst/>
-          </a:prstGeom>
-        </p:spPr>
-      </p:pic>
-      <p:sp>
-        <p:nvSpPr>
-          <p:cNvPr id="15" name="TextBox 14"/>
-          <p:cNvSpPr txBox="1"/>
-          <p:nvPr/>
-        </p:nvSpPr>
-        <p:spPr>
-          <a:xfrm>
-            <a:off x="8165592" y="5166360"/>
-            <a:ext cx="3520440" cy="685800"/>
-          </a:xfrm>
-          <a:prstGeom prst="rect">
-            <a:avLst/>
-          </a:prstGeom>
-          <a:noFill/>
-        </p:spPr>
-        <p:txBody>
-          <a:bodyPr wrap="none">
-            <a:spAutoFit/>
-          </a:bodyPr>
-          <a:lstStyle/>
-          <a:p>
-            <a:pPr>
-              <a:defRPr sz="1300">
-                <a:solidFill>
-                  <a:srgbClr val="17243B"/>
-                </a:solidFill>
-                <a:latin typeface="Calibri"/>
-              </a:defRPr>
-            </a:pPr>
-            <a:r>
-              <a:rPr>
-                <a:hlinkClick r:id="rId4"/>
-              </a:rPr>
-              <a:t>github.com/skunpoj/dsh_setup</a:t>
-            </a:r>
-            <a:br/>
-            <a:r>
-              <a:rPr>
-                <a:hlinkClick r:id="rId4"/>
-              </a:rPr>
-              <a:t>Source, setup and public presentation</a:t>
-            </a:r>
-          </a:p>
-        </p:txBody>
-      </p:sp>
-      <p:sp>
-        <p:nvSpPr>
-          <p:cNvPr id="16" name="TextBox 15"/>
           <p:cNvSpPr txBox="1"/>
           <p:nvPr/>
         </p:nvSpPr>
@@ -14185,7 +14183,7 @@
               </a:defRPr>
             </a:pPr>
             <a:r>
-              <a:t>24 / 24    19:00–19:30 planned    Sources and explanation in notes</a:t>
+              <a:t>23 / 24    18:15–19:00 planned    Sources and explanation in notes</a:t>
             </a:r>
           </a:p>
         </p:txBody>
@@ -14217,20 +14215,23 @@
         <p:spPr>
           <a:xfrm>
             <a:off x="640080" y="411480"/>
-            <a:ext cx="10972800" cy="274320"/>
-          </a:xfrm>
-          <a:prstGeom prst="rect">
-            <a:avLst/>
-          </a:prstGeom>
-          <a:noFill/>
-        </p:spPr>
-        <p:txBody>
-          <a:bodyPr wrap="square" lIns="0" rIns="0" tIns="0" bIns="0">
-            <a:spAutoFit/>
-          </a:bodyPr>
-          <a:lstStyle/>
-          <a:p>
-            <a:pPr>
+            <a:ext cx="10972800" cy="256032"/>
+          </a:xfrm>
+          <a:prstGeom prst="rect">
+            <a:avLst/>
+          </a:prstGeom>
+          <a:noFill/>
+        </p:spPr>
+        <p:txBody>
+          <a:bodyPr wrap="square" lIns="0" rIns="0" tIns="0" bIns="0">
+            <a:spAutoFit/>
+          </a:bodyPr>
+          <a:lstStyle/>
+          <a:p>
+            <a:pPr>
+              <a:spcAft>
+                <a:spcPts val="600"/>
+              </a:spcAft>
               <a:defRPr sz="1100" b="1">
                 <a:solidFill>
                   <a:srgbClr val="0088BA"/>
@@ -14239,7 +14240,7 @@
               </a:defRPr>
             </a:pPr>
             <a:r>
-              <a:t>PART 3 / WHAT DSH PROVIDES AND HOW WE QUALIFY IT</a:t>
+              <a:t>THE COMPLETE STORY</a:t>
             </a:r>
           </a:p>
         </p:txBody>
@@ -14253,20 +14254,23 @@
         <p:spPr>
           <a:xfrm>
             <a:off x="640080" y="868680"/>
-            <a:ext cx="10972800" cy="777240"/>
-          </a:xfrm>
-          <a:prstGeom prst="rect">
-            <a:avLst/>
-          </a:prstGeom>
-          <a:noFill/>
-        </p:spPr>
-        <p:txBody>
-          <a:bodyPr wrap="square" lIns="0" rIns="0" tIns="0" bIns="0">
-            <a:spAutoFit/>
-          </a:bodyPr>
-          <a:lstStyle/>
-          <a:p>
-            <a:pPr>
+            <a:ext cx="10972800" cy="731520"/>
+          </a:xfrm>
+          <a:prstGeom prst="rect">
+            <a:avLst/>
+          </a:prstGeom>
+          <a:noFill/>
+        </p:spPr>
+        <p:txBody>
+          <a:bodyPr wrap="square" lIns="0" rIns="0" tIns="0" bIns="0">
+            <a:spAutoFit/>
+          </a:bodyPr>
+          <a:lstStyle/>
+          <a:p>
+            <a:pPr>
+              <a:spcAft>
+                <a:spcPts val="600"/>
+              </a:spcAft>
               <a:defRPr sz="2500" b="1">
                 <a:solidFill>
                   <a:srgbClr val="14243C"/>
@@ -14275,7 +14279,7 @@
               </a:defRPr>
             </a:pPr>
             <a:r>
-              <a:t>DSH provides control points that operators must configure and test</a:t>
+              <a:t>Useful AI work needs clear authority and visible evidence</a:t>
             </a:r>
           </a:p>
         </p:txBody>
@@ -14288,21 +14292,24 @@
         </p:nvSpPr>
         <p:spPr>
           <a:xfrm>
-            <a:off x="685800" y="1856231"/>
-            <a:ext cx="5212080" cy="393192"/>
-          </a:xfrm>
-          <a:prstGeom prst="rect">
-            <a:avLst/>
-          </a:prstGeom>
-          <a:noFill/>
-        </p:spPr>
-        <p:txBody>
-          <a:bodyPr wrap="square" lIns="0" rIns="0" tIns="0" bIns="0">
-            <a:spAutoFit/>
-          </a:bodyPr>
-          <a:lstStyle/>
-          <a:p>
-            <a:pPr>
+            <a:off x="685800" y="1901952"/>
+            <a:ext cx="3456432" cy="685800"/>
+          </a:xfrm>
+          <a:prstGeom prst="rect">
+            <a:avLst/>
+          </a:prstGeom>
+          <a:noFill/>
+        </p:spPr>
+        <p:txBody>
+          <a:bodyPr wrap="square" lIns="0" rIns="0" tIns="0" bIns="0">
+            <a:spAutoFit/>
+          </a:bodyPr>
+          <a:lstStyle/>
+          <a:p>
+            <a:pPr>
+              <a:spcAft>
+                <a:spcPts val="600"/>
+              </a:spcAft>
               <a:defRPr sz="1800" b="1">
                 <a:solidFill>
                   <a:srgbClr val="007DA5"/>
@@ -14311,7 +14318,7 @@
               </a:defRPr>
             </a:pPr>
             <a:r>
-              <a:t>Reference design: access and execution</a:t>
+              <a:t>Business value</a:t>
             </a:r>
           </a:p>
         </p:txBody>
@@ -14324,21 +14331,24 @@
         </p:nvSpPr>
         <p:spPr>
           <a:xfrm>
-            <a:off x="685800" y="2304287"/>
-            <a:ext cx="5212080" cy="1463040"/>
-          </a:xfrm>
-          <a:prstGeom prst="rect">
-            <a:avLst/>
-          </a:prstGeom>
-          <a:noFill/>
-        </p:spPr>
-        <p:txBody>
-          <a:bodyPr wrap="square" lIns="0" rIns="0" tIns="0" bIns="0">
-            <a:spAutoFit/>
-          </a:bodyPr>
-          <a:lstStyle/>
-          <a:p>
-            <a:pPr>
+            <a:off x="685800" y="2697480"/>
+            <a:ext cx="3456432" cy="2926080"/>
+          </a:xfrm>
+          <a:prstGeom prst="rect">
+            <a:avLst/>
+          </a:prstGeom>
+          <a:noFill/>
+        </p:spPr>
+        <p:txBody>
+          <a:bodyPr wrap="square" lIns="0" rIns="0" tIns="0" bIns="0">
+            <a:spAutoFit/>
+          </a:bodyPr>
+          <a:lstStyle/>
+          <a:p>
+            <a:pPr>
+              <a:spcAft>
+                <a:spcPts val="600"/>
+              </a:spcAft>
               <a:defRPr sz="1600" b="0">
                 <a:solidFill>
                   <a:srgbClr val="26354A"/>
@@ -14347,7 +14357,7 @@
               </a:defRPr>
             </a:pPr>
             <a:r>
-              <a:t>The public reference defines authenticated routing, separate user workspaces, non-root workers, resource limits and no worker Kubernetes API token. Operators still hold privileged access.</a:t>
+              <a:t>AI can help banking and insurance teams assemble evidence, calculate and draft. Start with a defined work product people can review.</a:t>
             </a:r>
           </a:p>
         </p:txBody>
@@ -14360,21 +14370,24 @@
         </p:nvSpPr>
         <p:spPr>
           <a:xfrm>
-            <a:off x="6309360" y="1856231"/>
-            <a:ext cx="5212080" cy="393192"/>
-          </a:xfrm>
-          <a:prstGeom prst="rect">
-            <a:avLst/>
-          </a:prstGeom>
-          <a:noFill/>
-        </p:spPr>
-        <p:txBody>
-          <a:bodyPr wrap="square" lIns="0" rIns="0" tIns="0" bIns="0">
-            <a:spAutoFit/>
-          </a:bodyPr>
-          <a:lstStyle/>
-          <a:p>
-            <a:pPr>
+            <a:off x="4434840" y="1901952"/>
+            <a:ext cx="3456432" cy="685800"/>
+          </a:xfrm>
+          <a:prstGeom prst="rect">
+            <a:avLst/>
+          </a:prstGeom>
+          <a:noFill/>
+        </p:spPr>
+        <p:txBody>
+          <a:bodyPr wrap="square" lIns="0" rIns="0" tIns="0" bIns="0">
+            <a:spAutoFit/>
+          </a:bodyPr>
+          <a:lstStyle/>
+          <a:p>
+            <a:pPr>
+              <a:spcAft>
+                <a:spcPts val="600"/>
+              </a:spcAft>
               <a:defRPr sz="1800" b="1">
                 <a:solidFill>
                   <a:srgbClr val="007DA5"/>
@@ -14383,7 +14396,7 @@
               </a:defRPr>
             </a:pPr>
             <a:r>
-              <a:t>Reference design: network and packages</a:t>
+              <a:t>Responsibility</a:t>
             </a:r>
           </a:p>
         </p:txBody>
@@ -14396,21 +14409,24 @@
         </p:nvSpPr>
         <p:spPr>
           <a:xfrm>
-            <a:off x="6309360" y="2304287"/>
-            <a:ext cx="5212080" cy="1463040"/>
-          </a:xfrm>
-          <a:prstGeom prst="rect">
-            <a:avLst/>
-          </a:prstGeom>
-          <a:noFill/>
-        </p:spPr>
-        <p:txBody>
-          <a:bodyPr wrap="square" lIns="0" rIns="0" tIns="0" bIns="0">
-            <a:spAutoFit/>
-          </a:bodyPr>
-          <a:lstStyle/>
-          <a:p>
-            <a:pPr>
+            <a:off x="4434840" y="2697480"/>
+            <a:ext cx="3456432" cy="2926080"/>
+          </a:xfrm>
+          <a:prstGeom prst="rect">
+            <a:avLst/>
+          </a:prstGeom>
+          <a:noFill/>
+        </p:spPr>
+        <p:txBody>
+          <a:bodyPr wrap="square" lIns="0" rIns="0" tIns="0" bIns="0">
+            <a:spAutoFit/>
+          </a:bodyPr>
+          <a:lstStyle/>
+          <a:p>
+            <a:pPr>
+              <a:spcAft>
+                <a:spcPts val="600"/>
+              </a:spcAft>
               <a:defRPr sz="1600" b="0">
                 <a:solidFill>
                   <a:srgbClr val="26354A"/>
@@ -14419,70 +14435,76 @@
               </a:defRPr>
             </a:pPr>
             <a:r>
-              <a:t>Separate Internet and restricted runtimes. Apply network policy and reviewed package promotion. DNS, supporting services and cluster enforcement need tests on the installed version.</a:t>
-            </a:r>
-          </a:p>
-        </p:txBody>
-      </p:sp>
-      <p:sp>
-        <p:nvSpPr>
-          <p:cNvPr id="8" name="TextBox 7"/>
-          <p:cNvSpPr txBox="1"/>
-          <p:nvPr/>
-        </p:nvSpPr>
-        <p:spPr>
-          <a:xfrm>
-            <a:off x="685800" y="3858768"/>
-            <a:ext cx="5212080" cy="393192"/>
-          </a:xfrm>
-          <a:prstGeom prst="rect">
-            <a:avLst/>
-          </a:prstGeom>
-          <a:noFill/>
-        </p:spPr>
-        <p:txBody>
-          <a:bodyPr wrap="square" lIns="0" rIns="0" tIns="0" bIns="0">
-            <a:spAutoFit/>
-          </a:bodyPr>
-          <a:lstStyle/>
-          <a:p>
-            <a:pPr>
-              <a:defRPr sz="1800" b="1">
-                <a:solidFill>
-                  <a:srgbClr val="007DA5"/>
-                </a:solidFill>
-                <a:latin typeface="Calibri"/>
-              </a:defRPr>
-            </a:pPr>
-            <a:r>
-              <a:t>Integration requirement: authority</a:t>
-            </a:r>
-          </a:p>
-        </p:txBody>
-      </p:sp>
-      <p:sp>
-        <p:nvSpPr>
-          <p:cNvPr id="9" name="TextBox 8"/>
-          <p:cNvSpPr txBox="1"/>
-          <p:nvPr/>
-        </p:nvSpPr>
-        <p:spPr>
-          <a:xfrm>
-            <a:off x="685800" y="4306824"/>
-            <a:ext cx="5212080" cy="1463040"/>
-          </a:xfrm>
-          <a:prstGeom prst="rect">
-            <a:avLst/>
-          </a:prstGeom>
-          <a:noFill/>
-        </p:spPr>
-        <p:txBody>
-          <a:bodyPr wrap="square" lIns="0" rIns="0" tIns="0" bIns="0">
-            <a:spAutoFit/>
-          </a:bodyPr>
-          <a:lstStyle/>
-          <a:p>
-            <a:pPr>
+              <a:t>External content cannot create permission. Operators constrain actions. Institutional owners judge acceptable risk and sufficient evidence.</a:t>
+            </a:r>
+          </a:p>
+        </p:txBody>
+      </p:sp>
+      <p:sp>
+        <p:nvSpPr>
+          <p:cNvPr id="10" name="TextBox 9"/>
+          <p:cNvSpPr txBox="1"/>
+          <p:nvPr/>
+        </p:nvSpPr>
+        <p:spPr>
+          <a:xfrm>
+            <a:off x="685800" y="6044184"/>
+            <a:ext cx="10789920" cy="237744"/>
+          </a:xfrm>
+          <a:prstGeom prst="rect">
+            <a:avLst/>
+          </a:prstGeom>
+          <a:noFill/>
+        </p:spPr>
+        <p:txBody>
+          <a:bodyPr wrap="square" lIns="0" rIns="0" tIns="0" bIns="0">
+            <a:spAutoFit/>
+          </a:bodyPr>
+          <a:lstStyle/>
+          <a:p>
+            <a:pPr>
+              <a:spcAft>
+                <a:spcPts val="600"/>
+              </a:spcAft>
+              <a:defRPr sz="1000" b="0">
+                <a:solidFill>
+                  <a:srgbClr val="66758A"/>
+                </a:solidFill>
+                <a:latin typeface="Calibri"/>
+              </a:defRPr>
+            </a:pPr>
+            <a:r>
+              <a:t>Source links, explanation and limits are in the speaker guide and slide notes.</a:t>
+            </a:r>
+          </a:p>
+        </p:txBody>
+      </p:sp>
+      <p:sp>
+        <p:nvSpPr>
+          <p:cNvPr id="11" name="TextBox 10"/>
+          <p:cNvSpPr txBox="1"/>
+          <p:nvPr/>
+        </p:nvSpPr>
+        <p:spPr>
+          <a:xfrm>
+            <a:off x="685800" y="4892040"/>
+            <a:ext cx="6949440" cy="1051560"/>
+          </a:xfrm>
+          <a:prstGeom prst="rect">
+            <a:avLst/>
+          </a:prstGeom>
+          <a:noFill/>
+        </p:spPr>
+        <p:txBody>
+          <a:bodyPr wrap="square" lIns="0" rIns="0" tIns="0" bIns="0">
+            <a:spAutoFit/>
+          </a:bodyPr>
+          <a:lstStyle/>
+          <a:p>
+            <a:pPr>
+              <a:spcAft>
+                <a:spcPts val="600"/>
+              </a:spcAft>
               <a:defRPr sz="1600" b="0">
                 <a:solidFill>
                   <a:srgbClr val="26354A"/>
@@ -14491,115 +14513,8 @@
               </a:defRPr>
             </a:pPr>
             <a:r>
-              <a:t>Give each connected workflow only the data and actions it needs. Configure scoped credentials and approval for consequential sends or writes. DSH does not imply universal approval enforcement.</a:t>
-            </a:r>
-          </a:p>
-        </p:txBody>
-      </p:sp>
-      <p:sp>
-        <p:nvSpPr>
-          <p:cNvPr id="10" name="TextBox 9"/>
-          <p:cNvSpPr txBox="1"/>
-          <p:nvPr/>
-        </p:nvSpPr>
-        <p:spPr>
-          <a:xfrm>
-            <a:off x="6309360" y="3858768"/>
-            <a:ext cx="5212080" cy="393192"/>
-          </a:xfrm>
-          <a:prstGeom prst="rect">
-            <a:avLst/>
-          </a:prstGeom>
-          <a:noFill/>
-        </p:spPr>
-        <p:txBody>
-          <a:bodyPr wrap="square" lIns="0" rIns="0" tIns="0" bIns="0">
-            <a:spAutoFit/>
-          </a:bodyPr>
-          <a:lstStyle/>
-          <a:p>
-            <a:pPr>
-              <a:defRPr sz="1800" b="1">
-                <a:solidFill>
-                  <a:srgbClr val="007DA5"/>
-                </a:solidFill>
-                <a:latin typeface="Calibri"/>
-              </a:defRPr>
-            </a:pPr>
-            <a:r>
-              <a:t>Operating requirement: monitoring</a:t>
-            </a:r>
-          </a:p>
-        </p:txBody>
-      </p:sp>
-      <p:sp>
-        <p:nvSpPr>
-          <p:cNvPr id="11" name="TextBox 10"/>
-          <p:cNvSpPr txBox="1"/>
-          <p:nvPr/>
-        </p:nvSpPr>
-        <p:spPr>
-          <a:xfrm>
-            <a:off x="6309360" y="4306824"/>
-            <a:ext cx="5212080" cy="1463040"/>
-          </a:xfrm>
-          <a:prstGeom prst="rect">
-            <a:avLst/>
-          </a:prstGeom>
-          <a:noFill/>
-        </p:spPr>
-        <p:txBody>
-          <a:bodyPr wrap="square" lIns="0" rIns="0" tIns="0" bIns="0">
-            <a:spAutoFit/>
-          </a:bodyPr>
-          <a:lstStyle/>
-          <a:p>
-            <a:pPr>
-              <a:defRPr sz="1600" b="0">
-                <a:solidFill>
-                  <a:srgbClr val="26354A"/>
-                </a:solidFill>
-                <a:latin typeface="Calibri"/>
-              </a:defRPr>
-            </a:pPr>
-            <a:r>
-              <a:t>Name an alert owner, define stop and restart decisions and protect relevant logs. Gateway access logs are not a complete tool-command ledger. Verify coverage before relying on it.</a:t>
-            </a:r>
-          </a:p>
-        </p:txBody>
-      </p:sp>
-      <p:sp>
-        <p:nvSpPr>
-          <p:cNvPr id="12" name="TextBox 11"/>
-          <p:cNvSpPr txBox="1"/>
-          <p:nvPr/>
-        </p:nvSpPr>
-        <p:spPr>
-          <a:xfrm>
-            <a:off x="685800" y="6071616"/>
-            <a:ext cx="10789920" cy="274320"/>
-          </a:xfrm>
-          <a:prstGeom prst="rect">
-            <a:avLst/>
-          </a:prstGeom>
-          <a:noFill/>
-        </p:spPr>
-        <p:txBody>
-          <a:bodyPr wrap="square" lIns="0" rIns="0" tIns="0" bIns="0">
-            <a:spAutoFit/>
-          </a:bodyPr>
-          <a:lstStyle/>
-          <a:p>
-            <a:pPr>
-              <a:defRPr sz="1000" b="0">
-                <a:solidFill>
-                  <a:srgbClr val="66758A"/>
-                </a:solidFill>
-                <a:latin typeface="Calibri"/>
-              </a:defRPr>
-            </a:pPr>
-            <a:r>
-              <a:t>Reference features and proposed acceptance checks. No new live deployment verification.</a:t>
+              <a:rPr sz="1500"/>
+              <a:t>A useful starting point: choose one reviewed credit memo or claim-file task. Name the owner, define the permitted actions and agree on the evidence needed before adding more access.</a:t>
             </a:r>
           </a:p>
         </p:txBody>
@@ -14607,6 +14522,112 @@
       <p:sp>
         <p:nvSpPr>
           <p:cNvPr id="13" name="TextBox 12"/>
+          <p:cNvSpPr txBox="1"/>
+          <p:nvPr/>
+        </p:nvSpPr>
+        <p:spPr>
+          <a:xfrm>
+            <a:off x="8183879" y="1901952"/>
+            <a:ext cx="3456432" cy="457200"/>
+          </a:xfrm>
+          <a:prstGeom prst="rect">
+            <a:avLst/>
+          </a:prstGeom>
+          <a:noFill/>
+        </p:spPr>
+        <p:txBody>
+          <a:bodyPr wrap="none">
+            <a:spAutoFit/>
+          </a:bodyPr>
+          <a:lstStyle/>
+          <a:p>
+            <a:pPr>
+              <a:defRPr sz="1800">
+                <a:solidFill>
+                  <a:srgbClr val="17243B"/>
+                </a:solidFill>
+                <a:latin typeface="Calibri"/>
+              </a:defRPr>
+            </a:pPr>
+            <a:r>
+              <a:t>Explore the public DSH repository</a:t>
+            </a:r>
+          </a:p>
+        </p:txBody>
+      </p:sp>
+      <p:pic>
+        <p:nvPicPr>
+          <p:cNvPr id="14" name="Picture 13" descr="dsh-public-repository-qr.png"/>
+          <p:cNvPicPr>
+            <a:picLocks noChangeAspect="1"/>
+          </p:cNvPicPr>
+          <p:nvPr/>
+        </p:nvPicPr>
+        <p:blipFill>
+          <a:blip r:embed="rId3"/>
+          <a:stretch>
+            <a:fillRect/>
+          </a:stretch>
+        </p:blipFill>
+        <p:spPr>
+          <a:xfrm>
+            <a:off x="8567928" y="2560320"/>
+            <a:ext cx="2514600" cy="2514600"/>
+          </a:xfrm>
+          <a:prstGeom prst="rect">
+            <a:avLst/>
+          </a:prstGeom>
+        </p:spPr>
+      </p:pic>
+      <p:sp>
+        <p:nvSpPr>
+          <p:cNvPr id="15" name="TextBox 14"/>
+          <p:cNvSpPr txBox="1"/>
+          <p:nvPr/>
+        </p:nvSpPr>
+        <p:spPr>
+          <a:xfrm>
+            <a:off x="8165592" y="5166360"/>
+            <a:ext cx="3520440" cy="685800"/>
+          </a:xfrm>
+          <a:prstGeom prst="rect">
+            <a:avLst/>
+          </a:prstGeom>
+          <a:noFill/>
+        </p:spPr>
+        <p:txBody>
+          <a:bodyPr wrap="none">
+            <a:spAutoFit/>
+          </a:bodyPr>
+          <a:lstStyle/>
+          <a:p>
+            <a:pPr>
+              <a:defRPr sz="1300">
+                <a:solidFill>
+                  <a:srgbClr val="17243B"/>
+                </a:solidFill>
+                <a:latin typeface="Calibri"/>
+              </a:defRPr>
+            </a:pPr>
+            <a:r>
+              <a:rPr>
+                <a:hlinkClick r:id="rId4"/>
+              </a:rPr>
+              <a:t>github.com/skunpoj/dsh_setup</a:t>
+            </a:r>
+            <a:br/>
+            <a:r>
+              <a:rPr>
+                <a:hlinkClick r:id="rId4"/>
+              </a:rPr>
+              <a:t>Source, setup and public presentation</a:t>
+            </a:r>
+          </a:p>
+        </p:txBody>
+      </p:sp>
+      <p:sp>
+        <p:nvSpPr>
+          <p:cNvPr id="16" name="TextBox 15"/>
           <p:cNvSpPr txBox="1"/>
           <p:nvPr/>
         </p:nvSpPr>
@@ -14635,7 +14656,7 @@
               </a:defRPr>
             </a:pPr>
             <a:r>
-              <a:t>19 / 24    14:55–15:50 planned    Sources and explanation in notes</a:t>
+              <a:t>24 / 24    19:00–19:30 planned    Sources and explanation in notes</a:t>
             </a:r>
           </a:p>
         </p:txBody>

</xml_diff>

<commit_message>
Explain four AI risk functions with practical examples and evidence
</commit_message>
<xml_diff>
--- a/docs/presentations/guarding-the-value-stream/Guarding_the_Value_Stream.pptx
+++ b/docs/presentations/guarding-the-value-stream/Guarding_the_Value_Stream.pptx
@@ -3165,7 +3165,7 @@
           <a:lstStyle/>
           <a:p>
             <a:r>
-              <a:t>SLIDE 10: Four questions make an AI task controllable</a:t>
+              <a:t>SLIDE 10</a:t>
             </a:r>
           </a:p>
           <a:p>
@@ -3175,17 +3175,17 @@
           </a:p>
           <a:p>
             <a:r>
-              <a:t>Reading a document, using a calculator and issuing a payment are different actions. Give each a separate permission decision. Follow the output too: what leaves the workspace, what enters logs, and what continues after stop? Match the control to the action rather than the product name.</a:t>
-            </a:r>
-          </a:p>
-          <a:p>
-            <a:r>
-              <a:t>DETAIL AND LIMITS</a:t>
-            </a:r>
-          </a:p>
-          <a:p>
-            <a:r>
-              <a:t>These questions translate OWASP themes into practical work: prompt injection, data disclosure, excessive authority, tool misuse, unsafe dependencies, memory and coordination. Pin the taxonomy edition in a risk register. A gateway may restrict one path while another remains open; target services must enforce their own permissions. Short-lived credentials, canaries and a stop button each address part of the problem, not every possible compromise.</a:t>
+              <a:t>There are four practical questions behind these names. GOVERN asks who owns the risk and who has authority. MAP asks what the task touches and who could be harmed. MEASURE asks what evidence shows the task is accurate and controlled. MANAGE asks what we will change, monitor or stop when the risk is too high. In a claims workflow, this means an owner and reviewer, a map of medical files and policy terms, tests against reviewed cases, and controls on sending or payment. The functions work together and recur as the workflow changes.</a:t>
+            </a:r>
+          </a:p>
+          <a:p>
+            <a:r>
+              <a:t>DETAILED EXPLANATION</a:t>
+            </a:r>
+          </a:p>
+          <a:p>
+            <a:r>
+              <a:t>NIST calls these four functions, rather than a one-time four-step checklist. The following banking, insurance and DSH applications are presenter-created examples. GOVERN: for a credit-memo assistant, name the lending-process owner, define staff responsibilities and reserve lending approval for authorised people. Keep the use policy, reviewer responsibilities and escalation route. MAP: record which borrower statements, policy versions, model providers and tools the memo depends on. Identify who might suffer from an incorrect ratio, omitted liability or exposed personal data. Keep a use-case description, data inventory and permission map. MEASURE: use representative reviewed cases, difficult inputs and normal legitimate requests. Check calculations, source support, omissions, inappropriate refusals and unauthorised reads or sends. Agree acceptance thresholds before evaluation and keep actual results; a green build alone cannot answer these questions. MANAGE: assign remediation owners, limit access, require review where needed and monitor recurring errors. An unresolved material calculation error may justify narrowing or stopping the task. Keep the accepted residual risk, change record and tested recovery procedure. Revisit all four functions after a new data source, model, integration or incident. DSH can help organise files, calculations and results, but institutional owners still decide authority and acceptable risk. No new acceptance tests or business controls are claimed as completed by this presentation.</a:t>
             </a:r>
           </a:p>
           <a:p>
@@ -3195,7 +3195,7 @@
           </a:p>
           <a:p>
             <a:r>
-              <a:t>A small evidence pack can support several governance frameworks.</a:t>
+              <a:t>The next slide explains the institutions and laws behind these governance discussions.</a:t>
             </a:r>
           </a:p>
           <a:p>
@@ -3205,12 +3205,7 @@
           </a:p>
           <a:p>
             <a:r>
-              <a:t>https://genai.owasp.org/llm-top-10/</a:t>
-            </a:r>
-          </a:p>
-          <a:p>
-            <a:r>
-              <a:t>https://airc.nist.gov/airmf-resources/airmf/5-sec-core/</a:t>
+              <a:t>https://www.nist.gov/itl/ai-risk-management-framework/nist-ai-rmf-playbook</a:t>
             </a:r>
           </a:p>
         </p:txBody>
@@ -7167,30 +7162,63 @@
       <p:grpSpPr/>
       <p:sp>
         <p:nvSpPr>
-          <p:cNvPr id="2" name="TextBox 1"/>
+          <p:cNvPr id="13" name="TextBox 12"/>
+          <p:cNvSpPr txBox="1"/>
+          <p:nvPr/>
+        </p:nvSpPr>
+        <p:spPr>
+          <a:xfrm>
+            <a:off x="640080" y="6510528"/>
+            <a:ext cx="10972800" cy="182880"/>
+          </a:xfrm>
+          <a:prstGeom prst="rect">
+            <a:avLst/>
+          </a:prstGeom>
+          <a:noFill/>
+        </p:spPr>
+        <p:txBody>
+          <a:bodyPr wrap="square" lIns="0" rIns="0" tIns="0" bIns="0">
+            <a:spAutoFit/>
+          </a:bodyPr>
+          <a:lstStyle/>
+          <a:p>
+            <a:pPr>
+              <a:defRPr sz="900" b="0">
+                <a:solidFill>
+                  <a:srgbClr val="66758A"/>
+                </a:solidFill>
+                <a:latin typeface="Calibri"/>
+              </a:defRPr>
+            </a:pPr>
+            <a:r>
+              <a:t>10 / 24    07:05–07:50 planned    Sources and explanation in notes</a:t>
+            </a:r>
+          </a:p>
+        </p:txBody>
+      </p:sp>
+      <p:sp>
+        <p:nvSpPr>
+          <p:cNvPr id="14" name="TextBox 13"/>
           <p:cNvSpPr txBox="1"/>
           <p:nvPr/>
         </p:nvSpPr>
         <p:spPr>
           <a:xfrm>
             <a:off x="640080" y="411480"/>
-            <a:ext cx="10972800" cy="256032"/>
-          </a:xfrm>
-          <a:prstGeom prst="rect">
-            <a:avLst/>
-          </a:prstGeom>
-          <a:noFill/>
-        </p:spPr>
-        <p:txBody>
-          <a:bodyPr wrap="square" lIns="0" rIns="0" tIns="0" bIns="0">
-            <a:spAutoFit/>
-          </a:bodyPr>
-          <a:lstStyle/>
-          <a:p>
-            <a:pPr>
-              <a:spcAft>
-                <a:spcPts val="600"/>
-              </a:spcAft>
+            <a:ext cx="10972800" cy="274320"/>
+          </a:xfrm>
+          <a:prstGeom prst="rect">
+            <a:avLst/>
+          </a:prstGeom>
+          <a:noFill/>
+        </p:spPr>
+        <p:txBody>
+          <a:bodyPr wrap="square" lIns="0" rIns="0" tIns="0" bIns="0">
+            <a:spAutoFit/>
+          </a:bodyPr>
+          <a:lstStyle/>
+          <a:p>
+            <a:pPr>
               <a:defRPr sz="1100" b="1">
                 <a:solidFill>
                   <a:srgbClr val="0088BA"/>
@@ -7199,14 +7227,14 @@
               </a:defRPr>
             </a:pPr>
             <a:r>
-              <a:t>2 / PRACTICAL CONTROLS</a:t>
-            </a:r>
-          </a:p>
-        </p:txBody>
-      </p:sp>
-      <p:sp>
-        <p:nvSpPr>
-          <p:cNvPr id="3" name="TextBox 2"/>
+              <a:t>PART 2 / NIST AI RISK MANAGEMENT FRAMEWORK</a:t>
+            </a:r>
+          </a:p>
+        </p:txBody>
+      </p:sp>
+      <p:sp>
+        <p:nvSpPr>
+          <p:cNvPr id="15" name="TextBox 14"/>
           <p:cNvSpPr txBox="1"/>
           <p:nvPr/>
         </p:nvSpPr>
@@ -7227,9 +7255,6 @@
           <a:lstStyle/>
           <a:p>
             <a:pPr>
-              <a:spcAft>
-                <a:spcPts val="600"/>
-              </a:spcAft>
               <a:defRPr sz="2500" b="1">
                 <a:solidFill>
                   <a:srgbClr val="14243C"/>
@@ -7238,37 +7263,34 @@
               </a:defRPr>
             </a:pPr>
             <a:r>
-              <a:t>Four questions make an AI task controllable</a:t>
-            </a:r>
-          </a:p>
-        </p:txBody>
-      </p:sp>
-      <p:sp>
-        <p:nvSpPr>
-          <p:cNvPr id="4" name="TextBox 3"/>
+              <a:t>Four governance functions turn principles into working decisions</a:t>
+            </a:r>
+          </a:p>
+        </p:txBody>
+      </p:sp>
+      <p:sp>
+        <p:nvSpPr>
+          <p:cNvPr id="16" name="TextBox 15"/>
           <p:cNvSpPr txBox="1"/>
           <p:nvPr/>
         </p:nvSpPr>
         <p:spPr>
           <a:xfrm>
             <a:off x="685800" y="1856231"/>
-            <a:ext cx="5212080" cy="384048"/>
-          </a:xfrm>
-          <a:prstGeom prst="rect">
-            <a:avLst/>
-          </a:prstGeom>
-          <a:noFill/>
-        </p:spPr>
-        <p:txBody>
-          <a:bodyPr wrap="square" lIns="0" rIns="0" tIns="0" bIns="0">
-            <a:spAutoFit/>
-          </a:bodyPr>
-          <a:lstStyle/>
-          <a:p>
-            <a:pPr>
-              <a:spcAft>
-                <a:spcPts val="600"/>
-              </a:spcAft>
+            <a:ext cx="5212080" cy="411480"/>
+          </a:xfrm>
+          <a:prstGeom prst="rect">
+            <a:avLst/>
+          </a:prstGeom>
+          <a:noFill/>
+        </p:spPr>
+        <p:txBody>
+          <a:bodyPr wrap="square" lIns="0" rIns="0" tIns="0" bIns="0">
+            <a:spAutoFit/>
+          </a:bodyPr>
+          <a:lstStyle/>
+          <a:p>
+            <a:pPr>
               <a:defRPr sz="1800" b="1">
                 <a:solidFill>
                   <a:srgbClr val="007DA5"/>
@@ -7277,37 +7299,34 @@
               </a:defRPr>
             </a:pPr>
             <a:r>
-              <a:t>What may it read?</a:t>
-            </a:r>
-          </a:p>
-        </p:txBody>
-      </p:sp>
-      <p:sp>
-        <p:nvSpPr>
-          <p:cNvPr id="5" name="TextBox 4"/>
-          <p:cNvSpPr txBox="1"/>
-          <p:nvPr/>
-        </p:nvSpPr>
-        <p:spPr>
-          <a:xfrm>
-            <a:off x="685800" y="2295144"/>
-            <a:ext cx="5212080" cy="1435608"/>
-          </a:xfrm>
-          <a:prstGeom prst="rect">
-            <a:avLst/>
-          </a:prstGeom>
-          <a:noFill/>
-        </p:spPr>
-        <p:txBody>
-          <a:bodyPr wrap="square" lIns="0" rIns="0" tIns="0" bIns="0">
-            <a:spAutoFit/>
-          </a:bodyPr>
-          <a:lstStyle/>
-          <a:p>
-            <a:pPr>
-              <a:spcAft>
-                <a:spcPts val="600"/>
-              </a:spcAft>
+              <a:t>GOVERN: who owns the risk?</a:t>
+            </a:r>
+          </a:p>
+        </p:txBody>
+      </p:sp>
+      <p:sp>
+        <p:nvSpPr>
+          <p:cNvPr id="17" name="TextBox 16"/>
+          <p:cNvSpPr txBox="1"/>
+          <p:nvPr/>
+        </p:nvSpPr>
+        <p:spPr>
+          <a:xfrm>
+            <a:off x="685800" y="2313432"/>
+            <a:ext cx="5212080" cy="1463040"/>
+          </a:xfrm>
+          <a:prstGeom prst="rect">
+            <a:avLst/>
+          </a:prstGeom>
+          <a:noFill/>
+        </p:spPr>
+        <p:txBody>
+          <a:bodyPr wrap="square" lIns="0" rIns="0" tIns="0" bIns="0">
+            <a:spAutoFit/>
+          </a:bodyPr>
+          <a:lstStyle/>
+          <a:p>
+            <a:pPr>
               <a:defRPr sz="1600" b="0">
                 <a:solidFill>
                   <a:srgbClr val="26354A"/>
@@ -7316,37 +7335,34 @@
               </a:defRPr>
             </a:pPr>
             <a:r>
-              <a:t>Use approved case files and the right policy version. Review external documents, repository hooks and MCP configuration before trusting them.</a:t>
-            </a:r>
-          </a:p>
-        </p:txBody>
-      </p:sp>
-      <p:sp>
-        <p:nvSpPr>
-          <p:cNvPr id="6" name="TextBox 5"/>
+              <a:t>Set ownership, permitted uses, approval rules and escalation. Example: the claims owner approves the AI task, names a reviewer and reserves payment decisions for authorised staff. Evidence: owner, policy and decision record.</a:t>
+            </a:r>
+          </a:p>
+        </p:txBody>
+      </p:sp>
+      <p:sp>
+        <p:nvSpPr>
+          <p:cNvPr id="18" name="TextBox 17"/>
           <p:cNvSpPr txBox="1"/>
           <p:nvPr/>
         </p:nvSpPr>
         <p:spPr>
           <a:xfrm>
             <a:off x="6309360" y="1856231"/>
-            <a:ext cx="5212080" cy="384048"/>
-          </a:xfrm>
-          <a:prstGeom prst="rect">
-            <a:avLst/>
-          </a:prstGeom>
-          <a:noFill/>
-        </p:spPr>
-        <p:txBody>
-          <a:bodyPr wrap="square" lIns="0" rIns="0" tIns="0" bIns="0">
-            <a:spAutoFit/>
-          </a:bodyPr>
-          <a:lstStyle/>
-          <a:p>
-            <a:pPr>
-              <a:spcAft>
-                <a:spcPts val="600"/>
-              </a:spcAft>
+            <a:ext cx="5212080" cy="411480"/>
+          </a:xfrm>
+          <a:prstGeom prst="rect">
+            <a:avLst/>
+          </a:prstGeom>
+          <a:noFill/>
+        </p:spPr>
+        <p:txBody>
+          <a:bodyPr wrap="square" lIns="0" rIns="0" tIns="0" bIns="0">
+            <a:spAutoFit/>
+          </a:bodyPr>
+          <a:lstStyle/>
+          <a:p>
+            <a:pPr>
               <a:defRPr sz="1800" b="1">
                 <a:solidFill>
                   <a:srgbClr val="007DA5"/>
@@ -7355,37 +7371,34 @@
               </a:defRPr>
             </a:pPr>
             <a:r>
-              <a:t>What may it do?</a:t>
-            </a:r>
-          </a:p>
-        </p:txBody>
-      </p:sp>
-      <p:sp>
-        <p:nvSpPr>
-          <p:cNvPr id="7" name="TextBox 6"/>
-          <p:cNvSpPr txBox="1"/>
-          <p:nvPr/>
-        </p:nvSpPr>
-        <p:spPr>
-          <a:xfrm>
-            <a:off x="6309360" y="2295144"/>
-            <a:ext cx="5212080" cy="1435608"/>
-          </a:xfrm>
-          <a:prstGeom prst="rect">
-            <a:avLst/>
-          </a:prstGeom>
-          <a:noFill/>
-        </p:spPr>
-        <p:txBody>
-          <a:bodyPr wrap="square" lIns="0" rIns="0" tIns="0" bIns="0">
-            <a:spAutoFit/>
-          </a:bodyPr>
-          <a:lstStyle/>
-          <a:p>
-            <a:pPr>
-              <a:spcAft>
-                <a:spcPts val="600"/>
-              </a:spcAft>
+              <a:t>MAP: what could go wrong here?</a:t>
+            </a:r>
+          </a:p>
+        </p:txBody>
+      </p:sp>
+      <p:sp>
+        <p:nvSpPr>
+          <p:cNvPr id="19" name="TextBox 18"/>
+          <p:cNvSpPr txBox="1"/>
+          <p:nvPr/>
+        </p:nvSpPr>
+        <p:spPr>
+          <a:xfrm>
+            <a:off x="6309360" y="2313432"/>
+            <a:ext cx="5212080" cy="1463040"/>
+          </a:xfrm>
+          <a:prstGeom prst="rect">
+            <a:avLst/>
+          </a:prstGeom>
+          <a:noFill/>
+        </p:spPr>
+        <p:txBody>
+          <a:bodyPr wrap="square" lIns="0" rIns="0" tIns="0" bIns="0">
+            <a:spAutoFit/>
+          </a:bodyPr>
+          <a:lstStyle/>
+          <a:p>
+            <a:pPr>
               <a:defRPr sz="1600" b="0">
                 <a:solidFill>
                   <a:srgbClr val="26354A"/>
@@ -7394,37 +7407,34 @@
               </a:defRPr>
             </a:pPr>
             <a:r>
-              <a:t>Separate reading and calculation from changing a record, sending a message or authorising a payment. Specify permitted tools and arguments.</a:t>
-            </a:r>
-          </a:p>
-        </p:txBody>
-      </p:sp>
-      <p:sp>
-        <p:nvSpPr>
-          <p:cNvPr id="8" name="TextBox 7"/>
+              <a:t>Describe the task, people affected, data, tools and dependencies. Example: a claim summary uses medical files and policy terms. Identify privacy, missing evidence and incorrect coverage risks. Evidence: use-case and access map.</a:t>
+            </a:r>
+          </a:p>
+        </p:txBody>
+      </p:sp>
+      <p:sp>
+        <p:nvSpPr>
+          <p:cNvPr id="20" name="TextBox 19"/>
           <p:cNvSpPr txBox="1"/>
           <p:nvPr/>
         </p:nvSpPr>
         <p:spPr>
           <a:xfrm>
             <a:off x="685800" y="3858768"/>
-            <a:ext cx="5212080" cy="384048"/>
-          </a:xfrm>
-          <a:prstGeom prst="rect">
-            <a:avLst/>
-          </a:prstGeom>
-          <a:noFill/>
-        </p:spPr>
-        <p:txBody>
-          <a:bodyPr wrap="square" lIns="0" rIns="0" tIns="0" bIns="0">
-            <a:spAutoFit/>
-          </a:bodyPr>
-          <a:lstStyle/>
-          <a:p>
-            <a:pPr>
-              <a:spcAft>
-                <a:spcPts val="600"/>
-              </a:spcAft>
+            <a:ext cx="5212080" cy="411480"/>
+          </a:xfrm>
+          <a:prstGeom prst="rect">
+            <a:avLst/>
+          </a:prstGeom>
+          <a:noFill/>
+        </p:spPr>
+        <p:txBody>
+          <a:bodyPr wrap="square" lIns="0" rIns="0" tIns="0" bIns="0">
+            <a:spAutoFit/>
+          </a:bodyPr>
+          <a:lstStyle/>
+          <a:p>
+            <a:pPr>
               <a:defRPr sz="1800" b="1">
                 <a:solidFill>
                   <a:srgbClr val="007DA5"/>
@@ -7433,37 +7443,34 @@
               </a:defRPr>
             </a:pPr>
             <a:r>
-              <a:t>What may leave or persist?</a:t>
-            </a:r>
-          </a:p>
-        </p:txBody>
-      </p:sp>
-      <p:sp>
-        <p:nvSpPr>
-          <p:cNvPr id="9" name="TextBox 8"/>
-          <p:cNvSpPr txBox="1"/>
-          <p:nvPr/>
-        </p:nvSpPr>
-        <p:spPr>
-          <a:xfrm>
-            <a:off x="685800" y="4297679"/>
-            <a:ext cx="5212080" cy="1435608"/>
-          </a:xfrm>
-          <a:prstGeom prst="rect">
-            <a:avLst/>
-          </a:prstGeom>
-          <a:noFill/>
-        </p:spPr>
-        <p:txBody>
-          <a:bodyPr wrap="square" lIns="0" rIns="0" tIns="0" bIns="0">
-            <a:spAutoFit/>
-          </a:bodyPr>
-          <a:lstStyle/>
-          <a:p>
-            <a:pPr>
-              <a:spcAft>
-                <a:spcPts val="600"/>
-              </a:spcAft>
+              <a:t>MEASURE: how do we know?</a:t>
+            </a:r>
+          </a:p>
+        </p:txBody>
+      </p:sp>
+      <p:sp>
+        <p:nvSpPr>
+          <p:cNvPr id="21" name="TextBox 20"/>
+          <p:cNvSpPr txBox="1"/>
+          <p:nvPr/>
+        </p:nvSpPr>
+        <p:spPr>
+          <a:xfrm>
+            <a:off x="685800" y="4315968"/>
+            <a:ext cx="5212080" cy="1463040"/>
+          </a:xfrm>
+          <a:prstGeom prst="rect">
+            <a:avLst/>
+          </a:prstGeom>
+          <a:noFill/>
+        </p:spPr>
+        <p:txBody>
+          <a:bodyPr wrap="square" lIns="0" rIns="0" tIns="0" bIns="0">
+            <a:spAutoFit/>
+          </a:bodyPr>
+          <a:lstStyle/>
+          <a:p>
+            <a:pPr>
               <a:defRPr sz="1600" b="0">
                 <a:solidFill>
                   <a:srgbClr val="26354A"/>
@@ -7472,37 +7479,34 @@
               </a:defRPr>
             </a:pPr>
             <a:r>
-              <a:t>Review external requests, exports and saved context. Keep secrets out of prompts and logs where feasible. Limit cost, retries and execution.</a:t>
-            </a:r>
-          </a:p>
-        </p:txBody>
-      </p:sp>
-      <p:sp>
-        <p:nvSpPr>
-          <p:cNvPr id="10" name="TextBox 9"/>
+              <a:t>Test accuracy, omissions, privacy, access and reliability on representative cases. Example: compare claim summaries with reviewed files and test hostile document text. Evidence: test set, observed errors and agreed acceptance limits.</a:t>
+            </a:r>
+          </a:p>
+        </p:txBody>
+      </p:sp>
+      <p:sp>
+        <p:nvSpPr>
+          <p:cNvPr id="22" name="TextBox 21"/>
           <p:cNvSpPr txBox="1"/>
           <p:nvPr/>
         </p:nvSpPr>
         <p:spPr>
           <a:xfrm>
             <a:off x="6309360" y="3858768"/>
-            <a:ext cx="5212080" cy="384048"/>
-          </a:xfrm>
-          <a:prstGeom prst="rect">
-            <a:avLst/>
-          </a:prstGeom>
-          <a:noFill/>
-        </p:spPr>
-        <p:txBody>
-          <a:bodyPr wrap="square" lIns="0" rIns="0" tIns="0" bIns="0">
-            <a:spAutoFit/>
-          </a:bodyPr>
-          <a:lstStyle/>
-          <a:p>
-            <a:pPr>
-              <a:spcAft>
-                <a:spcPts val="600"/>
-              </a:spcAft>
+            <a:ext cx="5212080" cy="411480"/>
+          </a:xfrm>
+          <a:prstGeom prst="rect">
+            <a:avLst/>
+          </a:prstGeom>
+          <a:noFill/>
+        </p:spPr>
+        <p:txBody>
+          <a:bodyPr wrap="square" lIns="0" rIns="0" tIns="0" bIns="0">
+            <a:spAutoFit/>
+          </a:bodyPr>
+          <a:lstStyle/>
+          <a:p>
+            <a:pPr>
               <a:defRPr sz="1800" b="1">
                 <a:solidFill>
                   <a:srgbClr val="007DA5"/>
@@ -7511,37 +7515,34 @@
               </a:defRPr>
             </a:pPr>
             <a:r>
-              <a:t>What happens on failure?</a:t>
-            </a:r>
-          </a:p>
-        </p:txBody>
-      </p:sp>
-      <p:sp>
-        <p:nvSpPr>
-          <p:cNvPr id="11" name="TextBox 10"/>
-          <p:cNvSpPr txBox="1"/>
-          <p:nvPr/>
-        </p:nvSpPr>
-        <p:spPr>
-          <a:xfrm>
-            <a:off x="6309360" y="4297679"/>
-            <a:ext cx="5212080" cy="1435608"/>
-          </a:xfrm>
-          <a:prstGeom prst="rect">
-            <a:avLst/>
-          </a:prstGeom>
-          <a:noFill/>
-        </p:spPr>
-        <p:txBody>
-          <a:bodyPr wrap="square" lIns="0" rIns="0" tIns="0" bIns="0">
-            <a:spAutoFit/>
-          </a:bodyPr>
-          <a:lstStyle/>
-          <a:p>
-            <a:pPr>
-              <a:spcAft>
-                <a:spcPts val="600"/>
-              </a:spcAft>
+              <a:t>MANAGE: what will we do about it?</a:t>
+            </a:r>
+          </a:p>
+        </p:txBody>
+      </p:sp>
+      <p:sp>
+        <p:nvSpPr>
+          <p:cNvPr id="23" name="TextBox 22"/>
+          <p:cNvSpPr txBox="1"/>
+          <p:nvPr/>
+        </p:nvSpPr>
+        <p:spPr>
+          <a:xfrm>
+            <a:off x="6309360" y="4315968"/>
+            <a:ext cx="5212080" cy="1463040"/>
+          </a:xfrm>
+          <a:prstGeom prst="rect">
+            <a:avLst/>
+          </a:prstGeom>
+          <a:noFill/>
+        </p:spPr>
+        <p:txBody>
+          <a:bodyPr wrap="square" lIns="0" rIns="0" tIns="0" bIns="0">
+            <a:spAutoFit/>
+          </a:bodyPr>
+          <a:lstStyle/>
+          <a:p>
+            <a:pPr>
               <a:defRPr sz="1600" b="0">
                 <a:solidFill>
                   <a:srgbClr val="26354A"/>
@@ -7550,37 +7551,34 @@
               </a:defRPr>
             </a:pPr>
             <a:r>
-              <a:t>Show errors and route them for review. Test alerts, revocation, queued work and restart ownership. A visible stop button does not prove all activity stops.</a:t>
-            </a:r>
-          </a:p>
-        </p:txBody>
-      </p:sp>
-      <p:sp>
-        <p:nvSpPr>
-          <p:cNvPr id="12" name="TextBox 11"/>
-          <p:cNvSpPr txBox="1"/>
-          <p:nvPr/>
-        </p:nvSpPr>
-        <p:spPr>
-          <a:xfrm>
-            <a:off x="685800" y="6044184"/>
-            <a:ext cx="10789920" cy="237744"/>
-          </a:xfrm>
-          <a:prstGeom prst="rect">
-            <a:avLst/>
-          </a:prstGeom>
-          <a:noFill/>
-        </p:spPr>
-        <p:txBody>
-          <a:bodyPr wrap="square" lIns="0" rIns="0" tIns="0" bIns="0">
-            <a:spAutoFit/>
-          </a:bodyPr>
-          <a:lstStyle/>
-          <a:p>
-            <a:pPr>
-              <a:spcAft>
-                <a:spcPts val="600"/>
-              </a:spcAft>
+              <a:t>Prioritise risks, apply controls and monitor changes. Example: require review, restrict sends, stop on material errors and retest after a model change. Evidence: control owner, residual-risk decision and incident/recovery plan.</a:t>
+            </a:r>
+          </a:p>
+        </p:txBody>
+      </p:sp>
+      <p:sp>
+        <p:nvSpPr>
+          <p:cNvPr id="24" name="TextBox 23"/>
+          <p:cNvSpPr txBox="1"/>
+          <p:nvPr/>
+        </p:nvSpPr>
+        <p:spPr>
+          <a:xfrm>
+            <a:off x="685800" y="6071616"/>
+            <a:ext cx="10789920" cy="274320"/>
+          </a:xfrm>
+          <a:prstGeom prst="rect">
+            <a:avLst/>
+          </a:prstGeom>
+          <a:noFill/>
+        </p:spPr>
+        <p:txBody>
+          <a:bodyPr wrap="square" lIns="0" rIns="0" tIns="0" bIns="0">
+            <a:spAutoFit/>
+          </a:bodyPr>
+          <a:lstStyle/>
+          <a:p>
+            <a:pPr>
               <a:defRPr sz="1000" b="0">
                 <a:solidFill>
                   <a:srgbClr val="66758A"/>
@@ -7589,43 +7587,7 @@
               </a:defRPr>
             </a:pPr>
             <a:r>
-              <a:t>Source links, explanation and limits are in the speaker guide and slide notes.</a:t>
-            </a:r>
-          </a:p>
-        </p:txBody>
-      </p:sp>
-      <p:sp>
-        <p:nvSpPr>
-          <p:cNvPr id="13" name="TextBox 12"/>
-          <p:cNvSpPr txBox="1"/>
-          <p:nvPr/>
-        </p:nvSpPr>
-        <p:spPr>
-          <a:xfrm>
-            <a:off x="640080" y="6510528"/>
-            <a:ext cx="10972800" cy="182880"/>
-          </a:xfrm>
-          <a:prstGeom prst="rect">
-            <a:avLst/>
-          </a:prstGeom>
-          <a:noFill/>
-        </p:spPr>
-        <p:txBody>
-          <a:bodyPr wrap="square" lIns="0" rIns="0" tIns="0" bIns="0">
-            <a:spAutoFit/>
-          </a:bodyPr>
-          <a:lstStyle/>
-          <a:p>
-            <a:pPr>
-              <a:defRPr sz="900" b="0">
-                <a:solidFill>
-                  <a:srgbClr val="66758A"/>
-                </a:solidFill>
-                <a:latin typeface="Calibri"/>
-              </a:defRPr>
-            </a:pPr>
-            <a:r>
-              <a:t>10 / 24    07:05–07:50 planned    Sources and explanation in notes</a:t>
+              <a:t>NIST calls these functions. They recur throughout the lifecycle. Examples are illustrative; full explanation in the guide.</a:t>
             </a:r>
           </a:p>
         </p:txBody>

</xml_diff>

<commit_message>
Connect report export and acceptance checks in one claims example
</commit_message>
<xml_diff>
--- a/docs/presentations/guarding-the-value-stream/Guarding_the_Value_Stream.pptx
+++ b/docs/presentations/guarding-the-value-stream/Guarding_the_Value_Stream.pptx
@@ -28,7 +28,6 @@
     <p:sldId xmlns:ns0="http://schemas.openxmlformats.org/officeDocument/2006/relationships" id="296" ns0:id="rId25"/>
     <p:sldId xmlns:ns0="http://schemas.openxmlformats.org/officeDocument/2006/relationships" id="303" ns0:id="rId32"/>
     <p:sldId xmlns:ns0="http://schemas.openxmlformats.org/officeDocument/2006/relationships" id="297" ns0:id="rId26"/>
-    <p:sldId xmlns:ns0="http://schemas.openxmlformats.org/officeDocument/2006/relationships" id="298" ns0:id="rId27"/>
     <p:sldId xmlns:ns0="http://schemas.openxmlformats.org/officeDocument/2006/relationships" id="299" ns0:id="rId28"/>
     <p:sldId xmlns:ns0="http://schemas.openxmlformats.org/officeDocument/2006/relationships" id="300" ns0:id="rId29"/>
     <p:sldId xmlns:ns0="http://schemas.openxmlformats.org/officeDocument/2006/relationships" id="301" ns0:id="rId30"/>
@@ -717,7 +716,7 @@
           <a:lstStyle/>
           <a:p>
             <a:r>
-              <a:t>SLIDE 11</a:t>
+              <a:t>SLIDE 11: Governance bodies and laws: what each name means</a:t>
             </a:r>
           </a:p>
           <a:p>
@@ -732,7 +731,7 @@
           </a:p>
           <a:p>
             <a:r>
-              <a:t>DETAILED EXPLANATION</a:t>
+              <a:t>DETAIL AND LIMITS</a:t>
             </a:r>
           </a:p>
           <a:p>
@@ -1607,7 +1606,7 @@
           <a:lstStyle/>
           <a:p>
             <a:r>
-              <a:t>SLIDE 20: Generated HTML creates a second execution boundary</a:t>
+              <a:t>SLIDE 20: A DSH claims report needs checks before and after sharing</a:t>
             </a:r>
           </a:p>
           <a:p>
@@ -1617,7 +1616,7 @@
           </a:p>
           <a:p>
             <a:r>
-              <a:t>We may have controlled the worker, but the recipient opens the HTML report in another browser with different network access. An image request can carry a case identifier. Check not only the numbers but what the output executes and contacts when opened. Worker restrictions do not automatically protect the viewer.</a:t>
+              <a:t>Here is one practical reason we need both output review and operating controls. A claims handler uses DSH to draft a report from approved documents. The totals may look right, but the exported HTML might load an image from an outside website. If its address includes a claim identifier, opening the report sends that identifier in a web request. Before sharing, inspect the file and open it with invented data in the reviewer's actual browser. If something unexpected happens, withhold it, notify the owner and record the decision. This connects the incident lessons to an ordinary DSH work product.</a:t>
             </a:r>
           </a:p>
           <a:p>
@@ -1627,7 +1626,7 @@
           </a:p>
           <a:p>
             <a:r>
-              <a:t>The case-identifier scenario is hypothetical, not a demonstrated DSH leak. A browser does not send all credentials to every website; that depends on origin, cookies, browser rules and application design. Inspect external URLs, scripts, embedded content and integration permissions. EchoLeak illustrates the general danger of output rendering becoming a data path. This slide is a conceptual explanation, not a live demo.</a:t>
+              <a:t>This is a hypothetical claims example, not an observed DSH data leak. HTML is HyperText Markup Language, the format browsers use to display web pages. A generated report can contain text, links, scripts and references to remote resources. Loading an external image can send its URL to the remote server even without JavaScript or a Send button. If the URL contains a claim identifier, the request may disclose that identifier. Whether requests or scripts run depends on the viewer, browser policy and file contents. Opening a file does not automatically disclose every browser credential. Review confidential content and source calculations as well as active content. Self-contained reports reduce remote-resource dependencies, but embedded scripts can still make network requests; test the actual file. The DSH worker and the recipient browser are different environments, so a worker egress policy does not establish that browser requests are blocked. Use synthetic records and approved test endpoints to inspect requests. Verify consequential actions such as sending, record changes and payment independently at their destination. Stop and recovery checks require evidence of actual cancellation, queued work and saved state, not merely a visible button. Do not perform these tests against real customer records without authority. The preceding controls slide covers workspace access, supporting-service routes, credentials and monitoring. The following evidence slide explains what to retain. No new live security or recovery test is claimed here.</a:t>
             </a:r>
           </a:p>
           <a:p>
@@ -1637,7 +1636,7 @@
           </a:p>
           <a:p>
             <a:r>
-              <a:t>Acceptance tests need to cover the whole path, not just a successful page load.</a:t>
+              <a:t>The evidence pack records the file, checks, reviewer decision and any unresolved issue.</a:t>
             </a:r>
           </a:p>
           <a:p>
@@ -1650,119 +1649,9 @@
               <a:t>https://www.microsoft.com/en-us/security/security-insider/emerging-trends/ai-application-security-considerations-for-organizations</a:t>
             </a:r>
           </a:p>
-        </p:txBody>
-      </p:sp>
-      <p:sp>
-        <p:nvSpPr>
-          <p:cNvPr id="4" name="Slide Number Placeholder 3"/>
-          <p:cNvSpPr>
-            <a:spLocks noGrp="1"/>
-          </p:cNvSpPr>
-          <p:nvPr>
-            <p:ph type="sldNum" idx="5" sz="quarter"/>
-          </p:nvPr>
-        </p:nvSpPr>
-        <p:spPr/>
-      </p:sp>
-    </p:spTree>
-  </p:cSld>
-  <p:clrMapOvr>
-    <a:masterClrMapping/>
-  </p:clrMapOvr>
-</p:notes>
-</file>
-
-<file path=ppt/notesSlides/notesSlide19.xml><?xml version="1.0" encoding="utf-8"?>
-<p:notes xmlns:a="http://schemas.openxmlformats.org/drawingml/2006/main" xmlns:p="http://schemas.openxmlformats.org/presentationml/2006/main" xmlns:r="http://schemas.openxmlformats.org/officeDocument/2006/relationships">
-  <p:cSld>
-    <p:spTree>
-      <p:nvGrpSpPr>
-        <p:cNvPr id="1" name=""/>
-        <p:cNvGrpSpPr/>
-        <p:nvPr/>
-      </p:nvGrpSpPr>
-      <p:grpSpPr>
-        <a:xfrm>
-          <a:off x="0" y="0"/>
-          <a:ext cx="0" cy="0"/>
-          <a:chOff x="0" y="0"/>
-          <a:chExt cx="0" cy="0"/>
-        </a:xfrm>
-      </p:grpSpPr>
-      <p:sp>
-        <p:nvSpPr>
-          <p:cNvPr id="2" name="Slide Image Placeholder 1"/>
-          <p:cNvSpPr>
-            <a:spLocks noGrp="1"/>
-          </p:cNvSpPr>
-          <p:nvPr>
-            <p:ph type="sldImg" idx="2"/>
-          </p:nvPr>
-        </p:nvSpPr>
-        <p:spPr/>
-      </p:sp>
-      <p:sp>
-        <p:nvSpPr>
-          <p:cNvPr id="3" name="Notes Placeholder 2"/>
-          <p:cNvSpPr>
-            <a:spLocks noGrp="1"/>
-          </p:cNvSpPr>
-          <p:nvPr>
-            <p:ph type="body" idx="3" sz="quarter"/>
-          </p:nvPr>
-        </p:nvSpPr>
-        <p:spPr/>
-        <p:txBody>
-          <a:bodyPr/>
-          <a:lstStyle/>
-          <a:p>
-            <a:r>
-              <a:t>SLIDE 21: Safety evidence comes from testing the actual workflow</a:t>
-            </a:r>
-          </a:p>
-          <a:p>
-            <a:r>
-              <a:t>STORY TO TELL</a:t>
-            </a:r>
-          </a:p>
-          <a:p>
-            <a:r>
-              <a:t>To say a workflow is safer, show what it actually prevented and what still worked. Use disposable users, harmless secrets and representative documents. Try a forbidden read, send and network request. Inspect the exported report in the browser where people will open it. Then check that alerts reach an owner and that stopping and recovering the work behave as expected. Keep the evidence tied to the exact version and configuration.</a:t>
-            </a:r>
-          </a:p>
-          <a:p>
-            <a:r>
-              <a:t>DETAIL AND LIMITS</a:t>
-            </a:r>
-          </a:p>
-          <a:p>
-            <a:r>
-              <a:t>An HTTP success or green build does not establish access isolation. A blocked route does not establish all egress is blocked. Confirm persisted results and target-side audit where authorised. Test recovery without touching real customer records. Acceptance should include ordinary legitimate work so excessive refusal does not hide poor usability. These tests are a proposed qualification plan; no new live runtime, customer system or Production was accessed or changed for this edit.</a:t>
-            </a:r>
-          </a:p>
-          <a:p>
-            <a:r>
-              <a:t>TRANSITION</a:t>
-            </a:r>
-          </a:p>
-          <a:p>
-            <a:r>
-              <a:t>The resulting evidence pack explains what was tested, what it cost and what remains unknown.</a:t>
-            </a:r>
-          </a:p>
-          <a:p>
-            <a:r>
-              <a:t>SOURCES</a:t>
-            </a:r>
-          </a:p>
           <a:p>
             <a:r>
               <a:t>https://github.com/skunpoj/dsh_setup/blob/main/docs/SECURITY.md</a:t>
-            </a:r>
-          </a:p>
-          <a:p>
-            <a:r>
-              <a:t>https://github.com/skunpoj/dsh_setup</a:t>
             </a:r>
           </a:p>
         </p:txBody>
@@ -1942,7 +1831,7 @@
           <a:lstStyle/>
           <a:p>
             <a:r>
-              <a:t>SLIDE 22: Keep an evidence pack people can actually use</a:t>
+              <a:t>SLIDE 21: Keep an evidence pack people can actually use</a:t>
             </a:r>
           </a:p>
           <a:p>
@@ -2048,7 +1937,7 @@
           <a:lstStyle/>
           <a:p>
             <a:r>
-              <a:t>SLIDE 23: Measure a better completed task, not just a faster draft</a:t>
+              <a:t>SLIDE 22: Measure a better completed task, not just a faster draft</a:t>
             </a:r>
           </a:p>
           <a:p>
@@ -2158,7 +2047,7 @@
           <a:lstStyle/>
           <a:p>
             <a:r>
-              <a:t>SLIDE 24: Useful AI work needs clear authority and visible evidence</a:t>
+              <a:t>SLIDE 23: Useful AI work needs clear authority and visible evidence</a:t>
             </a:r>
           </a:p>
           <a:p>
@@ -2399,7 +2288,7 @@
           </a:p>
           <a:p>
             <a:r>
-              <a:t>Status matters. The reference source documents identity-bound routing, separate claims, non-root execution, dropped capabilities, no execution-worker API token, network policies and reviewed package promotion. These are reference mechanisms, not a claim of current Production enforcement. CNI and DNS enforcement, browser routes and recovery require installation acceptance. Integration-specific approvals, complete tool-event capture and incident response are requirements to implement and verify where applicable. Trusted administrators and storage operators retain power. No universal sandbox, blanket approval gate, immutable command ledger or zero-risk guarantee is asserted.</a:t>
+              <a:t>Status matters. The reference source documents identity-bound routing, separate claims, non-root execution, dropped capabilities, no execution-worker API token, network policies and reviewed package promotion. These are reference mechanisms, not a claim of current Production enforcement. CNI and DNS enforcement, browser routes and recovery require installation acceptance. Integration-specific approvals, complete tool-event capture and incident response are requirements to implement and verify where applicable. Trusted administrators and storage operators retain power. No universal sandbox, blanket approval gate, immutable command ledger or zero-risk guarantee is asserted. Before relying on isolation, test peer-workspace access with disposable users and supporting-service network routes with harmless inputs. These proposed checks qualify the installation, not the visual appearance of the interface.</a:t>
             </a:r>
           </a:p>
           <a:p>
@@ -2409,7 +2298,7 @@
           </a:p>
           <a:p>
             <a:r>
-              <a:t>The output can also execute outside the workspace, especially when it is HTML.</a:t>
+              <a:t>Now follow one exported claims report to see why the output also needs review.</a:t>
             </a:r>
           </a:p>
           <a:p>
@@ -3165,7 +3054,7 @@
           <a:lstStyle/>
           <a:p>
             <a:r>
-              <a:t>SLIDE 10</a:t>
+              <a:t>SLIDE 10: Four governance functions turn principles into working decisions</a:t>
             </a:r>
           </a:p>
           <a:p>
@@ -3180,7 +3069,7 @@
           </a:p>
           <a:p>
             <a:r>
-              <a:t>DETAILED EXPLANATION</a:t>
+              <a:t>DETAIL AND LIMITS</a:t>
             </a:r>
           </a:p>
           <a:p>
@@ -7137,7 +7026,7 @@
               </a:defRPr>
             </a:pPr>
             <a:r>
-              <a:t>1 / 24    00:00–00:30 planned    Sources and explanation in notes</a:t>
+              <a:t>1 / 23    00:00–00:30 planned    Sources and explanation in notes</a:t>
             </a:r>
           </a:p>
         </p:txBody>
@@ -7162,7 +7051,403 @@
       <p:grpSpPr/>
       <p:sp>
         <p:nvSpPr>
-          <p:cNvPr id="13" name="TextBox 12"/>
+          <p:cNvPr id="14" name="TextBox 13"/>
+          <p:cNvSpPr txBox="1"/>
+          <p:nvPr/>
+        </p:nvSpPr>
+        <p:spPr>
+          <a:xfrm>
+            <a:off x="640080" y="411480"/>
+            <a:ext cx="10972800" cy="274320"/>
+          </a:xfrm>
+          <a:prstGeom prst="rect">
+            <a:avLst/>
+          </a:prstGeom>
+          <a:noFill/>
+        </p:spPr>
+        <p:txBody>
+          <a:bodyPr wrap="square" lIns="0" rIns="0" tIns="0" bIns="0">
+            <a:spAutoFit/>
+          </a:bodyPr>
+          <a:lstStyle/>
+          <a:p>
+            <a:pPr>
+              <a:defRPr sz="1100" b="1">
+                <a:solidFill>
+                  <a:srgbClr val="0088BA"/>
+                </a:solidFill>
+                <a:latin typeface="Calibri"/>
+              </a:defRPr>
+            </a:pPr>
+            <a:r>
+              <a:t>PART 2 / NIST AI RISK MANAGEMENT FRAMEWORK</a:t>
+            </a:r>
+          </a:p>
+        </p:txBody>
+      </p:sp>
+      <p:sp>
+        <p:nvSpPr>
+          <p:cNvPr id="15" name="TextBox 14"/>
+          <p:cNvSpPr txBox="1"/>
+          <p:nvPr/>
+        </p:nvSpPr>
+        <p:spPr>
+          <a:xfrm>
+            <a:off x="640080" y="868680"/>
+            <a:ext cx="10972800" cy="731520"/>
+          </a:xfrm>
+          <a:prstGeom prst="rect">
+            <a:avLst/>
+          </a:prstGeom>
+          <a:noFill/>
+        </p:spPr>
+        <p:txBody>
+          <a:bodyPr wrap="square" lIns="0" rIns="0" tIns="0" bIns="0">
+            <a:spAutoFit/>
+          </a:bodyPr>
+          <a:lstStyle/>
+          <a:p>
+            <a:pPr>
+              <a:defRPr sz="2500" b="1">
+                <a:solidFill>
+                  <a:srgbClr val="14243C"/>
+                </a:solidFill>
+                <a:latin typeface="Calibri"/>
+              </a:defRPr>
+            </a:pPr>
+            <a:r>
+              <a:t>Four governance functions turn principles into working decisions</a:t>
+            </a:r>
+          </a:p>
+        </p:txBody>
+      </p:sp>
+      <p:sp>
+        <p:nvSpPr>
+          <p:cNvPr id="16" name="TextBox 15"/>
+          <p:cNvSpPr txBox="1"/>
+          <p:nvPr/>
+        </p:nvSpPr>
+        <p:spPr>
+          <a:xfrm>
+            <a:off x="685800" y="1856231"/>
+            <a:ext cx="5212080" cy="411480"/>
+          </a:xfrm>
+          <a:prstGeom prst="rect">
+            <a:avLst/>
+          </a:prstGeom>
+          <a:noFill/>
+        </p:spPr>
+        <p:txBody>
+          <a:bodyPr wrap="square" lIns="0" rIns="0" tIns="0" bIns="0">
+            <a:spAutoFit/>
+          </a:bodyPr>
+          <a:lstStyle/>
+          <a:p>
+            <a:pPr>
+              <a:defRPr sz="1800" b="1">
+                <a:solidFill>
+                  <a:srgbClr val="007DA5"/>
+                </a:solidFill>
+                <a:latin typeface="Calibri"/>
+              </a:defRPr>
+            </a:pPr>
+            <a:r>
+              <a:t>GOVERN: who owns the risk?</a:t>
+            </a:r>
+          </a:p>
+        </p:txBody>
+      </p:sp>
+      <p:sp>
+        <p:nvSpPr>
+          <p:cNvPr id="17" name="TextBox 16"/>
+          <p:cNvSpPr txBox="1"/>
+          <p:nvPr/>
+        </p:nvSpPr>
+        <p:spPr>
+          <a:xfrm>
+            <a:off x="685800" y="2313432"/>
+            <a:ext cx="5212080" cy="1463040"/>
+          </a:xfrm>
+          <a:prstGeom prst="rect">
+            <a:avLst/>
+          </a:prstGeom>
+          <a:noFill/>
+        </p:spPr>
+        <p:txBody>
+          <a:bodyPr wrap="square" lIns="0" rIns="0" tIns="0" bIns="0">
+            <a:spAutoFit/>
+          </a:bodyPr>
+          <a:lstStyle/>
+          <a:p>
+            <a:pPr>
+              <a:defRPr sz="1600" b="0">
+                <a:solidFill>
+                  <a:srgbClr val="26354A"/>
+                </a:solidFill>
+                <a:latin typeface="Calibri"/>
+              </a:defRPr>
+            </a:pPr>
+            <a:r>
+              <a:t>Set ownership, permitted uses, approval rules and escalation. Example: the claims owner approves the AI task, names a reviewer and reserves payment decisions for authorised staff. Evidence: owner, policy and decision record.</a:t>
+            </a:r>
+          </a:p>
+        </p:txBody>
+      </p:sp>
+      <p:sp>
+        <p:nvSpPr>
+          <p:cNvPr id="18" name="TextBox 17"/>
+          <p:cNvSpPr txBox="1"/>
+          <p:nvPr/>
+        </p:nvSpPr>
+        <p:spPr>
+          <a:xfrm>
+            <a:off x="6309360" y="1856231"/>
+            <a:ext cx="5212080" cy="411480"/>
+          </a:xfrm>
+          <a:prstGeom prst="rect">
+            <a:avLst/>
+          </a:prstGeom>
+          <a:noFill/>
+        </p:spPr>
+        <p:txBody>
+          <a:bodyPr wrap="square" lIns="0" rIns="0" tIns="0" bIns="0">
+            <a:spAutoFit/>
+          </a:bodyPr>
+          <a:lstStyle/>
+          <a:p>
+            <a:pPr>
+              <a:defRPr sz="1800" b="1">
+                <a:solidFill>
+                  <a:srgbClr val="007DA5"/>
+                </a:solidFill>
+                <a:latin typeface="Calibri"/>
+              </a:defRPr>
+            </a:pPr>
+            <a:r>
+              <a:t>MAP: what could go wrong here?</a:t>
+            </a:r>
+          </a:p>
+        </p:txBody>
+      </p:sp>
+      <p:sp>
+        <p:nvSpPr>
+          <p:cNvPr id="19" name="TextBox 18"/>
+          <p:cNvSpPr txBox="1"/>
+          <p:nvPr/>
+        </p:nvSpPr>
+        <p:spPr>
+          <a:xfrm>
+            <a:off x="6309360" y="2313432"/>
+            <a:ext cx="5212080" cy="1463040"/>
+          </a:xfrm>
+          <a:prstGeom prst="rect">
+            <a:avLst/>
+          </a:prstGeom>
+          <a:noFill/>
+        </p:spPr>
+        <p:txBody>
+          <a:bodyPr wrap="square" lIns="0" rIns="0" tIns="0" bIns="0">
+            <a:spAutoFit/>
+          </a:bodyPr>
+          <a:lstStyle/>
+          <a:p>
+            <a:pPr>
+              <a:defRPr sz="1600" b="0">
+                <a:solidFill>
+                  <a:srgbClr val="26354A"/>
+                </a:solidFill>
+                <a:latin typeface="Calibri"/>
+              </a:defRPr>
+            </a:pPr>
+            <a:r>
+              <a:t>Describe the task, people affected, data, tools and dependencies. Example: a claim summary uses medical files and policy terms. Identify privacy, missing evidence and incorrect coverage risks. Evidence: use-case and access map.</a:t>
+            </a:r>
+          </a:p>
+        </p:txBody>
+      </p:sp>
+      <p:sp>
+        <p:nvSpPr>
+          <p:cNvPr id="20" name="TextBox 19"/>
+          <p:cNvSpPr txBox="1"/>
+          <p:nvPr/>
+        </p:nvSpPr>
+        <p:spPr>
+          <a:xfrm>
+            <a:off x="685800" y="3858768"/>
+            <a:ext cx="5212080" cy="411480"/>
+          </a:xfrm>
+          <a:prstGeom prst="rect">
+            <a:avLst/>
+          </a:prstGeom>
+          <a:noFill/>
+        </p:spPr>
+        <p:txBody>
+          <a:bodyPr wrap="square" lIns="0" rIns="0" tIns="0" bIns="0">
+            <a:spAutoFit/>
+          </a:bodyPr>
+          <a:lstStyle/>
+          <a:p>
+            <a:pPr>
+              <a:defRPr sz="1800" b="1">
+                <a:solidFill>
+                  <a:srgbClr val="007DA5"/>
+                </a:solidFill>
+                <a:latin typeface="Calibri"/>
+              </a:defRPr>
+            </a:pPr>
+            <a:r>
+              <a:t>MEASURE: how do we know?</a:t>
+            </a:r>
+          </a:p>
+        </p:txBody>
+      </p:sp>
+      <p:sp>
+        <p:nvSpPr>
+          <p:cNvPr id="21" name="TextBox 20"/>
+          <p:cNvSpPr txBox="1"/>
+          <p:nvPr/>
+        </p:nvSpPr>
+        <p:spPr>
+          <a:xfrm>
+            <a:off x="685800" y="4315968"/>
+            <a:ext cx="5212080" cy="1463040"/>
+          </a:xfrm>
+          <a:prstGeom prst="rect">
+            <a:avLst/>
+          </a:prstGeom>
+          <a:noFill/>
+        </p:spPr>
+        <p:txBody>
+          <a:bodyPr wrap="square" lIns="0" rIns="0" tIns="0" bIns="0">
+            <a:spAutoFit/>
+          </a:bodyPr>
+          <a:lstStyle/>
+          <a:p>
+            <a:pPr>
+              <a:defRPr sz="1600" b="0">
+                <a:solidFill>
+                  <a:srgbClr val="26354A"/>
+                </a:solidFill>
+                <a:latin typeface="Calibri"/>
+              </a:defRPr>
+            </a:pPr>
+            <a:r>
+              <a:t>Test accuracy, omissions, privacy, access and reliability on representative cases. Example: compare claim summaries with reviewed files and test hostile document text. Evidence: test set, observed errors and agreed acceptance limits.</a:t>
+            </a:r>
+          </a:p>
+        </p:txBody>
+      </p:sp>
+      <p:sp>
+        <p:nvSpPr>
+          <p:cNvPr id="22" name="TextBox 21"/>
+          <p:cNvSpPr txBox="1"/>
+          <p:nvPr/>
+        </p:nvSpPr>
+        <p:spPr>
+          <a:xfrm>
+            <a:off x="6309360" y="3858768"/>
+            <a:ext cx="5212080" cy="411480"/>
+          </a:xfrm>
+          <a:prstGeom prst="rect">
+            <a:avLst/>
+          </a:prstGeom>
+          <a:noFill/>
+        </p:spPr>
+        <p:txBody>
+          <a:bodyPr wrap="square" lIns="0" rIns="0" tIns="0" bIns="0">
+            <a:spAutoFit/>
+          </a:bodyPr>
+          <a:lstStyle/>
+          <a:p>
+            <a:pPr>
+              <a:defRPr sz="1800" b="1">
+                <a:solidFill>
+                  <a:srgbClr val="007DA5"/>
+                </a:solidFill>
+                <a:latin typeface="Calibri"/>
+              </a:defRPr>
+            </a:pPr>
+            <a:r>
+              <a:t>MANAGE: what will we do about it?</a:t>
+            </a:r>
+          </a:p>
+        </p:txBody>
+      </p:sp>
+      <p:sp>
+        <p:nvSpPr>
+          <p:cNvPr id="23" name="TextBox 22"/>
+          <p:cNvSpPr txBox="1"/>
+          <p:nvPr/>
+        </p:nvSpPr>
+        <p:spPr>
+          <a:xfrm>
+            <a:off x="6309360" y="4315968"/>
+            <a:ext cx="5212080" cy="1463040"/>
+          </a:xfrm>
+          <a:prstGeom prst="rect">
+            <a:avLst/>
+          </a:prstGeom>
+          <a:noFill/>
+        </p:spPr>
+        <p:txBody>
+          <a:bodyPr wrap="square" lIns="0" rIns="0" tIns="0" bIns="0">
+            <a:spAutoFit/>
+          </a:bodyPr>
+          <a:lstStyle/>
+          <a:p>
+            <a:pPr>
+              <a:defRPr sz="1600" b="0">
+                <a:solidFill>
+                  <a:srgbClr val="26354A"/>
+                </a:solidFill>
+                <a:latin typeface="Calibri"/>
+              </a:defRPr>
+            </a:pPr>
+            <a:r>
+              <a:t>Prioritise risks, apply controls and monitor changes. Example: require review, restrict sends, stop on material errors and retest after a model change. Evidence: control owner, residual-risk decision and incident/recovery plan.</a:t>
+            </a:r>
+          </a:p>
+        </p:txBody>
+      </p:sp>
+      <p:sp>
+        <p:nvSpPr>
+          <p:cNvPr id="24" name="TextBox 23"/>
+          <p:cNvSpPr txBox="1"/>
+          <p:nvPr/>
+        </p:nvSpPr>
+        <p:spPr>
+          <a:xfrm>
+            <a:off x="685800" y="6071616"/>
+            <a:ext cx="10789920" cy="274320"/>
+          </a:xfrm>
+          <a:prstGeom prst="rect">
+            <a:avLst/>
+          </a:prstGeom>
+          <a:noFill/>
+        </p:spPr>
+        <p:txBody>
+          <a:bodyPr wrap="square" lIns="0" rIns="0" tIns="0" bIns="0">
+            <a:spAutoFit/>
+          </a:bodyPr>
+          <a:lstStyle/>
+          <a:p>
+            <a:pPr>
+              <a:defRPr sz="1000" b="0">
+                <a:solidFill>
+                  <a:srgbClr val="66758A"/>
+                </a:solidFill>
+                <a:latin typeface="Calibri"/>
+              </a:defRPr>
+            </a:pPr>
+            <a:r>
+              <a:t>NIST calls these functions. They recur throughout the lifecycle. Examples are illustrative; full explanation in the guide.</a:t>
+            </a:r>
+          </a:p>
+        </p:txBody>
+      </p:sp>
+      <p:sp>
+        <p:nvSpPr>
+          <p:cNvPr id="25" name="TextBox 24"/>
           <p:cNvSpPr txBox="1"/>
           <p:nvPr/>
         </p:nvSpPr>
@@ -7191,403 +7476,7 @@
               </a:defRPr>
             </a:pPr>
             <a:r>
-              <a:t>10 / 24    07:05–07:50 planned    Sources and explanation in notes</a:t>
-            </a:r>
-          </a:p>
-        </p:txBody>
-      </p:sp>
-      <p:sp>
-        <p:nvSpPr>
-          <p:cNvPr id="14" name="TextBox 13"/>
-          <p:cNvSpPr txBox="1"/>
-          <p:nvPr/>
-        </p:nvSpPr>
-        <p:spPr>
-          <a:xfrm>
-            <a:off x="640080" y="411480"/>
-            <a:ext cx="10972800" cy="274320"/>
-          </a:xfrm>
-          <a:prstGeom prst="rect">
-            <a:avLst/>
-          </a:prstGeom>
-          <a:noFill/>
-        </p:spPr>
-        <p:txBody>
-          <a:bodyPr wrap="square" lIns="0" rIns="0" tIns="0" bIns="0">
-            <a:spAutoFit/>
-          </a:bodyPr>
-          <a:lstStyle/>
-          <a:p>
-            <a:pPr>
-              <a:defRPr sz="1100" b="1">
-                <a:solidFill>
-                  <a:srgbClr val="0088BA"/>
-                </a:solidFill>
-                <a:latin typeface="Calibri"/>
-              </a:defRPr>
-            </a:pPr>
-            <a:r>
-              <a:t>PART 2 / NIST AI RISK MANAGEMENT FRAMEWORK</a:t>
-            </a:r>
-          </a:p>
-        </p:txBody>
-      </p:sp>
-      <p:sp>
-        <p:nvSpPr>
-          <p:cNvPr id="15" name="TextBox 14"/>
-          <p:cNvSpPr txBox="1"/>
-          <p:nvPr/>
-        </p:nvSpPr>
-        <p:spPr>
-          <a:xfrm>
-            <a:off x="640080" y="868680"/>
-            <a:ext cx="10972800" cy="731520"/>
-          </a:xfrm>
-          <a:prstGeom prst="rect">
-            <a:avLst/>
-          </a:prstGeom>
-          <a:noFill/>
-        </p:spPr>
-        <p:txBody>
-          <a:bodyPr wrap="square" lIns="0" rIns="0" tIns="0" bIns="0">
-            <a:spAutoFit/>
-          </a:bodyPr>
-          <a:lstStyle/>
-          <a:p>
-            <a:pPr>
-              <a:defRPr sz="2500" b="1">
-                <a:solidFill>
-                  <a:srgbClr val="14243C"/>
-                </a:solidFill>
-                <a:latin typeface="Calibri"/>
-              </a:defRPr>
-            </a:pPr>
-            <a:r>
-              <a:t>Four governance functions turn principles into working decisions</a:t>
-            </a:r>
-          </a:p>
-        </p:txBody>
-      </p:sp>
-      <p:sp>
-        <p:nvSpPr>
-          <p:cNvPr id="16" name="TextBox 15"/>
-          <p:cNvSpPr txBox="1"/>
-          <p:nvPr/>
-        </p:nvSpPr>
-        <p:spPr>
-          <a:xfrm>
-            <a:off x="685800" y="1856231"/>
-            <a:ext cx="5212080" cy="411480"/>
-          </a:xfrm>
-          <a:prstGeom prst="rect">
-            <a:avLst/>
-          </a:prstGeom>
-          <a:noFill/>
-        </p:spPr>
-        <p:txBody>
-          <a:bodyPr wrap="square" lIns="0" rIns="0" tIns="0" bIns="0">
-            <a:spAutoFit/>
-          </a:bodyPr>
-          <a:lstStyle/>
-          <a:p>
-            <a:pPr>
-              <a:defRPr sz="1800" b="1">
-                <a:solidFill>
-                  <a:srgbClr val="007DA5"/>
-                </a:solidFill>
-                <a:latin typeface="Calibri"/>
-              </a:defRPr>
-            </a:pPr>
-            <a:r>
-              <a:t>GOVERN: who owns the risk?</a:t>
-            </a:r>
-          </a:p>
-        </p:txBody>
-      </p:sp>
-      <p:sp>
-        <p:nvSpPr>
-          <p:cNvPr id="17" name="TextBox 16"/>
-          <p:cNvSpPr txBox="1"/>
-          <p:nvPr/>
-        </p:nvSpPr>
-        <p:spPr>
-          <a:xfrm>
-            <a:off x="685800" y="2313432"/>
-            <a:ext cx="5212080" cy="1463040"/>
-          </a:xfrm>
-          <a:prstGeom prst="rect">
-            <a:avLst/>
-          </a:prstGeom>
-          <a:noFill/>
-        </p:spPr>
-        <p:txBody>
-          <a:bodyPr wrap="square" lIns="0" rIns="0" tIns="0" bIns="0">
-            <a:spAutoFit/>
-          </a:bodyPr>
-          <a:lstStyle/>
-          <a:p>
-            <a:pPr>
-              <a:defRPr sz="1600" b="0">
-                <a:solidFill>
-                  <a:srgbClr val="26354A"/>
-                </a:solidFill>
-                <a:latin typeface="Calibri"/>
-              </a:defRPr>
-            </a:pPr>
-            <a:r>
-              <a:t>Set ownership, permitted uses, approval rules and escalation. Example: the claims owner approves the AI task, names a reviewer and reserves payment decisions for authorised staff. Evidence: owner, policy and decision record.</a:t>
-            </a:r>
-          </a:p>
-        </p:txBody>
-      </p:sp>
-      <p:sp>
-        <p:nvSpPr>
-          <p:cNvPr id="18" name="TextBox 17"/>
-          <p:cNvSpPr txBox="1"/>
-          <p:nvPr/>
-        </p:nvSpPr>
-        <p:spPr>
-          <a:xfrm>
-            <a:off x="6309360" y="1856231"/>
-            <a:ext cx="5212080" cy="411480"/>
-          </a:xfrm>
-          <a:prstGeom prst="rect">
-            <a:avLst/>
-          </a:prstGeom>
-          <a:noFill/>
-        </p:spPr>
-        <p:txBody>
-          <a:bodyPr wrap="square" lIns="0" rIns="0" tIns="0" bIns="0">
-            <a:spAutoFit/>
-          </a:bodyPr>
-          <a:lstStyle/>
-          <a:p>
-            <a:pPr>
-              <a:defRPr sz="1800" b="1">
-                <a:solidFill>
-                  <a:srgbClr val="007DA5"/>
-                </a:solidFill>
-                <a:latin typeface="Calibri"/>
-              </a:defRPr>
-            </a:pPr>
-            <a:r>
-              <a:t>MAP: what could go wrong here?</a:t>
-            </a:r>
-          </a:p>
-        </p:txBody>
-      </p:sp>
-      <p:sp>
-        <p:nvSpPr>
-          <p:cNvPr id="19" name="TextBox 18"/>
-          <p:cNvSpPr txBox="1"/>
-          <p:nvPr/>
-        </p:nvSpPr>
-        <p:spPr>
-          <a:xfrm>
-            <a:off x="6309360" y="2313432"/>
-            <a:ext cx="5212080" cy="1463040"/>
-          </a:xfrm>
-          <a:prstGeom prst="rect">
-            <a:avLst/>
-          </a:prstGeom>
-          <a:noFill/>
-        </p:spPr>
-        <p:txBody>
-          <a:bodyPr wrap="square" lIns="0" rIns="0" tIns="0" bIns="0">
-            <a:spAutoFit/>
-          </a:bodyPr>
-          <a:lstStyle/>
-          <a:p>
-            <a:pPr>
-              <a:defRPr sz="1600" b="0">
-                <a:solidFill>
-                  <a:srgbClr val="26354A"/>
-                </a:solidFill>
-                <a:latin typeface="Calibri"/>
-              </a:defRPr>
-            </a:pPr>
-            <a:r>
-              <a:t>Describe the task, people affected, data, tools and dependencies. Example: a claim summary uses medical files and policy terms. Identify privacy, missing evidence and incorrect coverage risks. Evidence: use-case and access map.</a:t>
-            </a:r>
-          </a:p>
-        </p:txBody>
-      </p:sp>
-      <p:sp>
-        <p:nvSpPr>
-          <p:cNvPr id="20" name="TextBox 19"/>
-          <p:cNvSpPr txBox="1"/>
-          <p:nvPr/>
-        </p:nvSpPr>
-        <p:spPr>
-          <a:xfrm>
-            <a:off x="685800" y="3858768"/>
-            <a:ext cx="5212080" cy="411480"/>
-          </a:xfrm>
-          <a:prstGeom prst="rect">
-            <a:avLst/>
-          </a:prstGeom>
-          <a:noFill/>
-        </p:spPr>
-        <p:txBody>
-          <a:bodyPr wrap="square" lIns="0" rIns="0" tIns="0" bIns="0">
-            <a:spAutoFit/>
-          </a:bodyPr>
-          <a:lstStyle/>
-          <a:p>
-            <a:pPr>
-              <a:defRPr sz="1800" b="1">
-                <a:solidFill>
-                  <a:srgbClr val="007DA5"/>
-                </a:solidFill>
-                <a:latin typeface="Calibri"/>
-              </a:defRPr>
-            </a:pPr>
-            <a:r>
-              <a:t>MEASURE: how do we know?</a:t>
-            </a:r>
-          </a:p>
-        </p:txBody>
-      </p:sp>
-      <p:sp>
-        <p:nvSpPr>
-          <p:cNvPr id="21" name="TextBox 20"/>
-          <p:cNvSpPr txBox="1"/>
-          <p:nvPr/>
-        </p:nvSpPr>
-        <p:spPr>
-          <a:xfrm>
-            <a:off x="685800" y="4315968"/>
-            <a:ext cx="5212080" cy="1463040"/>
-          </a:xfrm>
-          <a:prstGeom prst="rect">
-            <a:avLst/>
-          </a:prstGeom>
-          <a:noFill/>
-        </p:spPr>
-        <p:txBody>
-          <a:bodyPr wrap="square" lIns="0" rIns="0" tIns="0" bIns="0">
-            <a:spAutoFit/>
-          </a:bodyPr>
-          <a:lstStyle/>
-          <a:p>
-            <a:pPr>
-              <a:defRPr sz="1600" b="0">
-                <a:solidFill>
-                  <a:srgbClr val="26354A"/>
-                </a:solidFill>
-                <a:latin typeface="Calibri"/>
-              </a:defRPr>
-            </a:pPr>
-            <a:r>
-              <a:t>Test accuracy, omissions, privacy, access and reliability on representative cases. Example: compare claim summaries with reviewed files and test hostile document text. Evidence: test set, observed errors and agreed acceptance limits.</a:t>
-            </a:r>
-          </a:p>
-        </p:txBody>
-      </p:sp>
-      <p:sp>
-        <p:nvSpPr>
-          <p:cNvPr id="22" name="TextBox 21"/>
-          <p:cNvSpPr txBox="1"/>
-          <p:nvPr/>
-        </p:nvSpPr>
-        <p:spPr>
-          <a:xfrm>
-            <a:off x="6309360" y="3858768"/>
-            <a:ext cx="5212080" cy="411480"/>
-          </a:xfrm>
-          <a:prstGeom prst="rect">
-            <a:avLst/>
-          </a:prstGeom>
-          <a:noFill/>
-        </p:spPr>
-        <p:txBody>
-          <a:bodyPr wrap="square" lIns="0" rIns="0" tIns="0" bIns="0">
-            <a:spAutoFit/>
-          </a:bodyPr>
-          <a:lstStyle/>
-          <a:p>
-            <a:pPr>
-              <a:defRPr sz="1800" b="1">
-                <a:solidFill>
-                  <a:srgbClr val="007DA5"/>
-                </a:solidFill>
-                <a:latin typeface="Calibri"/>
-              </a:defRPr>
-            </a:pPr>
-            <a:r>
-              <a:t>MANAGE: what will we do about it?</a:t>
-            </a:r>
-          </a:p>
-        </p:txBody>
-      </p:sp>
-      <p:sp>
-        <p:nvSpPr>
-          <p:cNvPr id="23" name="TextBox 22"/>
-          <p:cNvSpPr txBox="1"/>
-          <p:nvPr/>
-        </p:nvSpPr>
-        <p:spPr>
-          <a:xfrm>
-            <a:off x="6309360" y="4315968"/>
-            <a:ext cx="5212080" cy="1463040"/>
-          </a:xfrm>
-          <a:prstGeom prst="rect">
-            <a:avLst/>
-          </a:prstGeom>
-          <a:noFill/>
-        </p:spPr>
-        <p:txBody>
-          <a:bodyPr wrap="square" lIns="0" rIns="0" tIns="0" bIns="0">
-            <a:spAutoFit/>
-          </a:bodyPr>
-          <a:lstStyle/>
-          <a:p>
-            <a:pPr>
-              <a:defRPr sz="1600" b="0">
-                <a:solidFill>
-                  <a:srgbClr val="26354A"/>
-                </a:solidFill>
-                <a:latin typeface="Calibri"/>
-              </a:defRPr>
-            </a:pPr>
-            <a:r>
-              <a:t>Prioritise risks, apply controls and monitor changes. Example: require review, restrict sends, stop on material errors and retest after a model change. Evidence: control owner, residual-risk decision and incident/recovery plan.</a:t>
-            </a:r>
-          </a:p>
-        </p:txBody>
-      </p:sp>
-      <p:sp>
-        <p:nvSpPr>
-          <p:cNvPr id="24" name="TextBox 23"/>
-          <p:cNvSpPr txBox="1"/>
-          <p:nvPr/>
-        </p:nvSpPr>
-        <p:spPr>
-          <a:xfrm>
-            <a:off x="685800" y="6071616"/>
-            <a:ext cx="10789920" cy="274320"/>
-          </a:xfrm>
-          <a:prstGeom prst="rect">
-            <a:avLst/>
-          </a:prstGeom>
-          <a:noFill/>
-        </p:spPr>
-        <p:txBody>
-          <a:bodyPr wrap="square" lIns="0" rIns="0" tIns="0" bIns="0">
-            <a:spAutoFit/>
-          </a:bodyPr>
-          <a:lstStyle/>
-          <a:p>
-            <a:pPr>
-              <a:defRPr sz="1000" b="0">
-                <a:solidFill>
-                  <a:srgbClr val="66758A"/>
-                </a:solidFill>
-                <a:latin typeface="Calibri"/>
-              </a:defRPr>
-            </a:pPr>
-            <a:r>
-              <a:t>NIST calls these functions. They recur throughout the lifecycle. Examples are illustrative; full explanation in the guide.</a:t>
+              <a:t>10 / 23    07:05–07:50 planned    Sources and explanation in notes</a:t>
             </a:r>
           </a:p>
         </p:txBody>
@@ -7612,7 +7501,403 @@
       <p:grpSpPr/>
       <p:sp>
         <p:nvSpPr>
-          <p:cNvPr id="12" name="TextBox 11"/>
+          <p:cNvPr id="13" name="TextBox 12"/>
+          <p:cNvSpPr txBox="1"/>
+          <p:nvPr/>
+        </p:nvSpPr>
+        <p:spPr>
+          <a:xfrm>
+            <a:off x="640080" y="411480"/>
+            <a:ext cx="10972800" cy="274320"/>
+          </a:xfrm>
+          <a:prstGeom prst="rect">
+            <a:avLst/>
+          </a:prstGeom>
+          <a:noFill/>
+        </p:spPr>
+        <p:txBody>
+          <a:bodyPr wrap="square" lIns="0" rIns="0" tIns="0" bIns="0">
+            <a:spAutoFit/>
+          </a:bodyPr>
+          <a:lstStyle/>
+          <a:p>
+            <a:pPr>
+              <a:defRPr sz="1100" b="1">
+                <a:solidFill>
+                  <a:srgbClr val="0088BA"/>
+                </a:solidFill>
+                <a:latin typeface="Calibri"/>
+              </a:defRPr>
+            </a:pPr>
+            <a:r>
+              <a:t>PART 2 / GOVERNANCE: WHO THE NAMES REFER TO</a:t>
+            </a:r>
+          </a:p>
+        </p:txBody>
+      </p:sp>
+      <p:sp>
+        <p:nvSpPr>
+          <p:cNvPr id="14" name="TextBox 13"/>
+          <p:cNvSpPr txBox="1"/>
+          <p:nvPr/>
+        </p:nvSpPr>
+        <p:spPr>
+          <a:xfrm>
+            <a:off x="640080" y="868680"/>
+            <a:ext cx="10972800" cy="731520"/>
+          </a:xfrm>
+          <a:prstGeom prst="rect">
+            <a:avLst/>
+          </a:prstGeom>
+          <a:noFill/>
+        </p:spPr>
+        <p:txBody>
+          <a:bodyPr wrap="square" lIns="0" rIns="0" tIns="0" bIns="0">
+            <a:spAutoFit/>
+          </a:bodyPr>
+          <a:lstStyle/>
+          <a:p>
+            <a:pPr>
+              <a:defRPr sz="2500" b="1">
+                <a:solidFill>
+                  <a:srgbClr val="14243C"/>
+                </a:solidFill>
+                <a:latin typeface="Calibri"/>
+              </a:defRPr>
+            </a:pPr>
+            <a:r>
+              <a:t>Governance bodies and laws: what each name means</a:t>
+            </a:r>
+          </a:p>
+        </p:txBody>
+      </p:sp>
+      <p:sp>
+        <p:nvSpPr>
+          <p:cNvPr id="15" name="TextBox 14"/>
+          <p:cNvSpPr txBox="1"/>
+          <p:nvPr/>
+        </p:nvSpPr>
+        <p:spPr>
+          <a:xfrm>
+            <a:off x="685800" y="1856231"/>
+            <a:ext cx="5212080" cy="411480"/>
+          </a:xfrm>
+          <a:prstGeom prst="rect">
+            <a:avLst/>
+          </a:prstGeom>
+          <a:noFill/>
+        </p:spPr>
+        <p:txBody>
+          <a:bodyPr wrap="square" lIns="0" rIns="0" tIns="0" bIns="0">
+            <a:spAutoFit/>
+          </a:bodyPr>
+          <a:lstStyle/>
+          <a:p>
+            <a:pPr>
+              <a:defRPr sz="1800" b="1">
+                <a:solidFill>
+                  <a:srgbClr val="007DA5"/>
+                </a:solidFill>
+                <a:latin typeface="Calibri"/>
+              </a:defRPr>
+            </a:pPr>
+            <a:r>
+              <a:t>NIST: US technical guidance</a:t>
+            </a:r>
+          </a:p>
+        </p:txBody>
+      </p:sp>
+      <p:sp>
+        <p:nvSpPr>
+          <p:cNvPr id="16" name="TextBox 15"/>
+          <p:cNvSpPr txBox="1"/>
+          <p:nvPr/>
+        </p:nvSpPr>
+        <p:spPr>
+          <a:xfrm>
+            <a:off x="685800" y="2313432"/>
+            <a:ext cx="5212080" cy="1463040"/>
+          </a:xfrm>
+          <a:prstGeom prst="rect">
+            <a:avLst/>
+          </a:prstGeom>
+          <a:noFill/>
+        </p:spPr>
+        <p:txBody>
+          <a:bodyPr wrap="square" lIns="0" rIns="0" tIns="0" bIns="0">
+            <a:spAutoFit/>
+          </a:bodyPr>
+          <a:lstStyle/>
+          <a:p>
+            <a:pPr>
+              <a:defRPr sz="1600" b="0">
+                <a:solidFill>
+                  <a:srgbClr val="26354A"/>
+                </a:solidFill>
+                <a:latin typeface="Calibri"/>
+              </a:defRPr>
+            </a:pPr>
+            <a:r>
+              <a:t>National Institute of Standards and Technology, a US federal agency. Its voluntary AI Risk Management Framework (AI RMF) organises work into GOVERN (owners), MAP (context), MEASURE (tests) and MANAGE (risk responses).</a:t>
+            </a:r>
+          </a:p>
+        </p:txBody>
+      </p:sp>
+      <p:sp>
+        <p:nvSpPr>
+          <p:cNvPr id="17" name="TextBox 16"/>
+          <p:cNvSpPr txBox="1"/>
+          <p:nvPr/>
+        </p:nvSpPr>
+        <p:spPr>
+          <a:xfrm>
+            <a:off x="6309360" y="1856231"/>
+            <a:ext cx="5212080" cy="411480"/>
+          </a:xfrm>
+          <a:prstGeom prst="rect">
+            <a:avLst/>
+          </a:prstGeom>
+          <a:noFill/>
+        </p:spPr>
+        <p:txBody>
+          <a:bodyPr wrap="square" lIns="0" rIns="0" tIns="0" bIns="0">
+            <a:spAutoFit/>
+          </a:bodyPr>
+          <a:lstStyle/>
+          <a:p>
+            <a:pPr>
+              <a:defRPr sz="1800" b="1">
+                <a:solidFill>
+                  <a:srgbClr val="007DA5"/>
+                </a:solidFill>
+                <a:latin typeface="Calibri"/>
+              </a:defRPr>
+            </a:pPr>
+            <a:r>
+              <a:t>NAIC: US insurance supervision</a:t>
+            </a:r>
+          </a:p>
+        </p:txBody>
+      </p:sp>
+      <p:sp>
+        <p:nvSpPr>
+          <p:cNvPr id="18" name="TextBox 17"/>
+          <p:cNvSpPr txBox="1"/>
+          <p:nvPr/>
+        </p:nvSpPr>
+        <p:spPr>
+          <a:xfrm>
+            <a:off x="6309360" y="2313432"/>
+            <a:ext cx="5212080" cy="1463040"/>
+          </a:xfrm>
+          <a:prstGeom prst="rect">
+            <a:avLst/>
+          </a:prstGeom>
+          <a:noFill/>
+        </p:spPr>
+        <p:txBody>
+          <a:bodyPr wrap="square" lIns="0" rIns="0" tIns="0" bIns="0">
+            <a:spAutoFit/>
+          </a:bodyPr>
+          <a:lstStyle/>
+          <a:p>
+            <a:pPr>
+              <a:defRPr sz="1600" b="0">
+                <a:solidFill>
+                  <a:srgbClr val="26354A"/>
+                </a:solidFill>
+                <a:latin typeface="Calibri"/>
+              </a:defRPr>
+            </a:pPr>
+            <a:r>
+              <a:t>National Association of Insurance Commissioners, the association of US state insurance regulators. Its model AI bulletin guides insurer governance and customer protection. Requirements depend on state adoption and applicable law.</a:t>
+            </a:r>
+          </a:p>
+        </p:txBody>
+      </p:sp>
+      <p:sp>
+        <p:nvSpPr>
+          <p:cNvPr id="19" name="TextBox 18"/>
+          <p:cNvSpPr txBox="1"/>
+          <p:nvPr/>
+        </p:nvSpPr>
+        <p:spPr>
+          <a:xfrm>
+            <a:off x="685800" y="3858768"/>
+            <a:ext cx="5212080" cy="411480"/>
+          </a:xfrm>
+          <a:prstGeom prst="rect">
+            <a:avLst/>
+          </a:prstGeom>
+          <a:noFill/>
+        </p:spPr>
+        <p:txBody>
+          <a:bodyPr wrap="square" lIns="0" rIns="0" tIns="0" bIns="0">
+            <a:spAutoFit/>
+          </a:bodyPr>
+          <a:lstStyle/>
+          <a:p>
+            <a:pPr>
+              <a:defRPr sz="1800" b="1">
+                <a:solidFill>
+                  <a:srgbClr val="007DA5"/>
+                </a:solidFill>
+                <a:latin typeface="Calibri"/>
+              </a:defRPr>
+            </a:pPr>
+            <a:r>
+              <a:t>MAS: Singapore financial supervision</a:t>
+            </a:r>
+          </a:p>
+        </p:txBody>
+      </p:sp>
+      <p:sp>
+        <p:nvSpPr>
+          <p:cNvPr id="20" name="TextBox 19"/>
+          <p:cNvSpPr txBox="1"/>
+          <p:nvPr/>
+        </p:nvSpPr>
+        <p:spPr>
+          <a:xfrm>
+            <a:off x="685800" y="4315968"/>
+            <a:ext cx="5212080" cy="1463040"/>
+          </a:xfrm>
+          <a:prstGeom prst="rect">
+            <a:avLst/>
+          </a:prstGeom>
+          <a:noFill/>
+        </p:spPr>
+        <p:txBody>
+          <a:bodyPr wrap="square" lIns="0" rIns="0" tIns="0" bIns="0">
+            <a:spAutoFit/>
+          </a:bodyPr>
+          <a:lstStyle/>
+          <a:p>
+            <a:pPr>
+              <a:defRPr sz="1600" b="0">
+                <a:solidFill>
+                  <a:srgbClr val="26354A"/>
+                </a:solidFill>
+                <a:latin typeface="Calibri"/>
+              </a:defRPr>
+            </a:pPr>
+            <a:r>
+              <a:t>Monetary Authority of Singapore, the central bank and integrated financial regulator. Its AI guidance addresses institutional accountability, inventories and proportionate controls. Assess applicability to the institution and use case.</a:t>
+            </a:r>
+          </a:p>
+        </p:txBody>
+      </p:sp>
+      <p:sp>
+        <p:nvSpPr>
+          <p:cNvPr id="21" name="TextBox 20"/>
+          <p:cNvSpPr txBox="1"/>
+          <p:nvPr/>
+        </p:nvSpPr>
+        <p:spPr>
+          <a:xfrm>
+            <a:off x="6309360" y="3858768"/>
+            <a:ext cx="5212080" cy="411480"/>
+          </a:xfrm>
+          <a:prstGeom prst="rect">
+            <a:avLst/>
+          </a:prstGeom>
+          <a:noFill/>
+        </p:spPr>
+        <p:txBody>
+          <a:bodyPr wrap="square" lIns="0" rIns="0" tIns="0" bIns="0">
+            <a:spAutoFit/>
+          </a:bodyPr>
+          <a:lstStyle/>
+          <a:p>
+            <a:pPr>
+              <a:defRPr sz="1800" b="1">
+                <a:solidFill>
+                  <a:srgbClr val="007DA5"/>
+                </a:solidFill>
+                <a:latin typeface="Calibri"/>
+              </a:defRPr>
+            </a:pPr>
+            <a:r>
+              <a:t>DORA and EU AI Act: European Union laws</a:t>
+            </a:r>
+          </a:p>
+        </p:txBody>
+      </p:sp>
+      <p:sp>
+        <p:nvSpPr>
+          <p:cNvPr id="22" name="TextBox 21"/>
+          <p:cNvSpPr txBox="1"/>
+          <p:nvPr/>
+        </p:nvSpPr>
+        <p:spPr>
+          <a:xfrm>
+            <a:off x="6309360" y="4315968"/>
+            <a:ext cx="5212080" cy="1463040"/>
+          </a:xfrm>
+          <a:prstGeom prst="rect">
+            <a:avLst/>
+          </a:prstGeom>
+          <a:noFill/>
+        </p:spPr>
+        <p:txBody>
+          <a:bodyPr wrap="square" lIns="0" rIns="0" tIns="0" bIns="0">
+            <a:spAutoFit/>
+          </a:bodyPr>
+          <a:lstStyle/>
+          <a:p>
+            <a:pPr>
+              <a:defRPr sz="1600" b="0">
+                <a:solidFill>
+                  <a:srgbClr val="26354A"/>
+                </a:solidFill>
+                <a:latin typeface="Calibri"/>
+              </a:defRPr>
+            </a:pPr>
+            <a:r>
+              <a:t>DORA means Digital Operational Resilience Act and addresses financial-sector technology resilience. EU means European Union. Its AI Act regulates AI by scope and risk. They are laws, not institutions; assess each separately.</a:t>
+            </a:r>
+          </a:p>
+        </p:txBody>
+      </p:sp>
+      <p:sp>
+        <p:nvSpPr>
+          <p:cNvPr id="23" name="TextBox 22"/>
+          <p:cNvSpPr txBox="1"/>
+          <p:nvPr/>
+        </p:nvSpPr>
+        <p:spPr>
+          <a:xfrm>
+            <a:off x="685800" y="6071616"/>
+            <a:ext cx="10789920" cy="274320"/>
+          </a:xfrm>
+          <a:prstGeom prst="rect">
+            <a:avLst/>
+          </a:prstGeom>
+          <a:noFill/>
+        </p:spPr>
+        <p:txBody>
+          <a:bodyPr wrap="square" lIns="0" rIns="0" tIns="0" bIns="0">
+            <a:spAutoFit/>
+          </a:bodyPr>
+          <a:lstStyle/>
+          <a:p>
+            <a:pPr>
+              <a:defRPr sz="1000" b="0">
+                <a:solidFill>
+                  <a:srgbClr val="66758A"/>
+                </a:solidFill>
+                <a:latin typeface="Calibri"/>
+              </a:defRPr>
+            </a:pPr>
+            <a:r>
+              <a:t>AI = artificial intelligence. Reuse evidence, but assess each framework and law separately. Full sources in notes.</a:t>
+            </a:r>
+          </a:p>
+        </p:txBody>
+      </p:sp>
+      <p:sp>
+        <p:nvSpPr>
+          <p:cNvPr id="24" name="TextBox 23"/>
           <p:cNvSpPr txBox="1"/>
           <p:nvPr/>
         </p:nvSpPr>
@@ -7641,403 +7926,7 @@
               </a:defRPr>
             </a:pPr>
             <a:r>
-              <a:t>11 / 24    07:50–08:30 planned    Sources and explanation in notes</a:t>
-            </a:r>
-          </a:p>
-        </p:txBody>
-      </p:sp>
-      <p:sp>
-        <p:nvSpPr>
-          <p:cNvPr id="13" name="TextBox 12"/>
-          <p:cNvSpPr txBox="1"/>
-          <p:nvPr/>
-        </p:nvSpPr>
-        <p:spPr>
-          <a:xfrm>
-            <a:off x="640080" y="411480"/>
-            <a:ext cx="10972800" cy="274320"/>
-          </a:xfrm>
-          <a:prstGeom prst="rect">
-            <a:avLst/>
-          </a:prstGeom>
-          <a:noFill/>
-        </p:spPr>
-        <p:txBody>
-          <a:bodyPr wrap="square" lIns="0" rIns="0" tIns="0" bIns="0">
-            <a:spAutoFit/>
-          </a:bodyPr>
-          <a:lstStyle/>
-          <a:p>
-            <a:pPr>
-              <a:defRPr sz="1100" b="1">
-                <a:solidFill>
-                  <a:srgbClr val="0088BA"/>
-                </a:solidFill>
-                <a:latin typeface="Calibri"/>
-              </a:defRPr>
-            </a:pPr>
-            <a:r>
-              <a:t>PART 2 / GOVERNANCE: WHO THE NAMES REFER TO</a:t>
-            </a:r>
-          </a:p>
-        </p:txBody>
-      </p:sp>
-      <p:sp>
-        <p:nvSpPr>
-          <p:cNvPr id="14" name="TextBox 13"/>
-          <p:cNvSpPr txBox="1"/>
-          <p:nvPr/>
-        </p:nvSpPr>
-        <p:spPr>
-          <a:xfrm>
-            <a:off x="640080" y="868680"/>
-            <a:ext cx="10972800" cy="731520"/>
-          </a:xfrm>
-          <a:prstGeom prst="rect">
-            <a:avLst/>
-          </a:prstGeom>
-          <a:noFill/>
-        </p:spPr>
-        <p:txBody>
-          <a:bodyPr wrap="square" lIns="0" rIns="0" tIns="0" bIns="0">
-            <a:spAutoFit/>
-          </a:bodyPr>
-          <a:lstStyle/>
-          <a:p>
-            <a:pPr>
-              <a:defRPr sz="2500" b="1">
-                <a:solidFill>
-                  <a:srgbClr val="14243C"/>
-                </a:solidFill>
-                <a:latin typeface="Calibri"/>
-              </a:defRPr>
-            </a:pPr>
-            <a:r>
-              <a:t>Governance bodies and laws: what each name means</a:t>
-            </a:r>
-          </a:p>
-        </p:txBody>
-      </p:sp>
-      <p:sp>
-        <p:nvSpPr>
-          <p:cNvPr id="15" name="TextBox 14"/>
-          <p:cNvSpPr txBox="1"/>
-          <p:nvPr/>
-        </p:nvSpPr>
-        <p:spPr>
-          <a:xfrm>
-            <a:off x="685800" y="1856231"/>
-            <a:ext cx="5212080" cy="411480"/>
-          </a:xfrm>
-          <a:prstGeom prst="rect">
-            <a:avLst/>
-          </a:prstGeom>
-          <a:noFill/>
-        </p:spPr>
-        <p:txBody>
-          <a:bodyPr wrap="square" lIns="0" rIns="0" tIns="0" bIns="0">
-            <a:spAutoFit/>
-          </a:bodyPr>
-          <a:lstStyle/>
-          <a:p>
-            <a:pPr>
-              <a:defRPr sz="1800" b="1">
-                <a:solidFill>
-                  <a:srgbClr val="007DA5"/>
-                </a:solidFill>
-                <a:latin typeface="Calibri"/>
-              </a:defRPr>
-            </a:pPr>
-            <a:r>
-              <a:t>NIST: US technical guidance</a:t>
-            </a:r>
-          </a:p>
-        </p:txBody>
-      </p:sp>
-      <p:sp>
-        <p:nvSpPr>
-          <p:cNvPr id="16" name="TextBox 15"/>
-          <p:cNvSpPr txBox="1"/>
-          <p:nvPr/>
-        </p:nvSpPr>
-        <p:spPr>
-          <a:xfrm>
-            <a:off x="685800" y="2313432"/>
-            <a:ext cx="5212080" cy="1463040"/>
-          </a:xfrm>
-          <a:prstGeom prst="rect">
-            <a:avLst/>
-          </a:prstGeom>
-          <a:noFill/>
-        </p:spPr>
-        <p:txBody>
-          <a:bodyPr wrap="square" lIns="0" rIns="0" tIns="0" bIns="0">
-            <a:spAutoFit/>
-          </a:bodyPr>
-          <a:lstStyle/>
-          <a:p>
-            <a:pPr>
-              <a:defRPr sz="1600" b="0">
-                <a:solidFill>
-                  <a:srgbClr val="26354A"/>
-                </a:solidFill>
-                <a:latin typeface="Calibri"/>
-              </a:defRPr>
-            </a:pPr>
-            <a:r>
-              <a:t>National Institute of Standards and Technology, a US federal agency. Its voluntary AI Risk Management Framework (AI RMF) organises work into GOVERN (owners), MAP (context), MEASURE (tests) and MANAGE (risk responses).</a:t>
-            </a:r>
-          </a:p>
-        </p:txBody>
-      </p:sp>
-      <p:sp>
-        <p:nvSpPr>
-          <p:cNvPr id="17" name="TextBox 16"/>
-          <p:cNvSpPr txBox="1"/>
-          <p:nvPr/>
-        </p:nvSpPr>
-        <p:spPr>
-          <a:xfrm>
-            <a:off x="6309360" y="1856231"/>
-            <a:ext cx="5212080" cy="411480"/>
-          </a:xfrm>
-          <a:prstGeom prst="rect">
-            <a:avLst/>
-          </a:prstGeom>
-          <a:noFill/>
-        </p:spPr>
-        <p:txBody>
-          <a:bodyPr wrap="square" lIns="0" rIns="0" tIns="0" bIns="0">
-            <a:spAutoFit/>
-          </a:bodyPr>
-          <a:lstStyle/>
-          <a:p>
-            <a:pPr>
-              <a:defRPr sz="1800" b="1">
-                <a:solidFill>
-                  <a:srgbClr val="007DA5"/>
-                </a:solidFill>
-                <a:latin typeface="Calibri"/>
-              </a:defRPr>
-            </a:pPr>
-            <a:r>
-              <a:t>NAIC: US insurance supervision</a:t>
-            </a:r>
-          </a:p>
-        </p:txBody>
-      </p:sp>
-      <p:sp>
-        <p:nvSpPr>
-          <p:cNvPr id="18" name="TextBox 17"/>
-          <p:cNvSpPr txBox="1"/>
-          <p:nvPr/>
-        </p:nvSpPr>
-        <p:spPr>
-          <a:xfrm>
-            <a:off x="6309360" y="2313432"/>
-            <a:ext cx="5212080" cy="1463040"/>
-          </a:xfrm>
-          <a:prstGeom prst="rect">
-            <a:avLst/>
-          </a:prstGeom>
-          <a:noFill/>
-        </p:spPr>
-        <p:txBody>
-          <a:bodyPr wrap="square" lIns="0" rIns="0" tIns="0" bIns="0">
-            <a:spAutoFit/>
-          </a:bodyPr>
-          <a:lstStyle/>
-          <a:p>
-            <a:pPr>
-              <a:defRPr sz="1600" b="0">
-                <a:solidFill>
-                  <a:srgbClr val="26354A"/>
-                </a:solidFill>
-                <a:latin typeface="Calibri"/>
-              </a:defRPr>
-            </a:pPr>
-            <a:r>
-              <a:t>National Association of Insurance Commissioners, the association of US state insurance regulators. Its model AI bulletin guides insurer governance and customer protection. Requirements depend on state adoption and applicable law.</a:t>
-            </a:r>
-          </a:p>
-        </p:txBody>
-      </p:sp>
-      <p:sp>
-        <p:nvSpPr>
-          <p:cNvPr id="19" name="TextBox 18"/>
-          <p:cNvSpPr txBox="1"/>
-          <p:nvPr/>
-        </p:nvSpPr>
-        <p:spPr>
-          <a:xfrm>
-            <a:off x="685800" y="3858768"/>
-            <a:ext cx="5212080" cy="411480"/>
-          </a:xfrm>
-          <a:prstGeom prst="rect">
-            <a:avLst/>
-          </a:prstGeom>
-          <a:noFill/>
-        </p:spPr>
-        <p:txBody>
-          <a:bodyPr wrap="square" lIns="0" rIns="0" tIns="0" bIns="0">
-            <a:spAutoFit/>
-          </a:bodyPr>
-          <a:lstStyle/>
-          <a:p>
-            <a:pPr>
-              <a:defRPr sz="1800" b="1">
-                <a:solidFill>
-                  <a:srgbClr val="007DA5"/>
-                </a:solidFill>
-                <a:latin typeface="Calibri"/>
-              </a:defRPr>
-            </a:pPr>
-            <a:r>
-              <a:t>MAS: Singapore financial supervision</a:t>
-            </a:r>
-          </a:p>
-        </p:txBody>
-      </p:sp>
-      <p:sp>
-        <p:nvSpPr>
-          <p:cNvPr id="20" name="TextBox 19"/>
-          <p:cNvSpPr txBox="1"/>
-          <p:nvPr/>
-        </p:nvSpPr>
-        <p:spPr>
-          <a:xfrm>
-            <a:off x="685800" y="4315968"/>
-            <a:ext cx="5212080" cy="1463040"/>
-          </a:xfrm>
-          <a:prstGeom prst="rect">
-            <a:avLst/>
-          </a:prstGeom>
-          <a:noFill/>
-        </p:spPr>
-        <p:txBody>
-          <a:bodyPr wrap="square" lIns="0" rIns="0" tIns="0" bIns="0">
-            <a:spAutoFit/>
-          </a:bodyPr>
-          <a:lstStyle/>
-          <a:p>
-            <a:pPr>
-              <a:defRPr sz="1600" b="0">
-                <a:solidFill>
-                  <a:srgbClr val="26354A"/>
-                </a:solidFill>
-                <a:latin typeface="Calibri"/>
-              </a:defRPr>
-            </a:pPr>
-            <a:r>
-              <a:t>Monetary Authority of Singapore, the central bank and integrated financial regulator. Its AI guidance addresses institutional accountability, inventories and proportionate controls. Assess applicability to the institution and use case.</a:t>
-            </a:r>
-          </a:p>
-        </p:txBody>
-      </p:sp>
-      <p:sp>
-        <p:nvSpPr>
-          <p:cNvPr id="21" name="TextBox 20"/>
-          <p:cNvSpPr txBox="1"/>
-          <p:nvPr/>
-        </p:nvSpPr>
-        <p:spPr>
-          <a:xfrm>
-            <a:off x="6309360" y="3858768"/>
-            <a:ext cx="5212080" cy="411480"/>
-          </a:xfrm>
-          <a:prstGeom prst="rect">
-            <a:avLst/>
-          </a:prstGeom>
-          <a:noFill/>
-        </p:spPr>
-        <p:txBody>
-          <a:bodyPr wrap="square" lIns="0" rIns="0" tIns="0" bIns="0">
-            <a:spAutoFit/>
-          </a:bodyPr>
-          <a:lstStyle/>
-          <a:p>
-            <a:pPr>
-              <a:defRPr sz="1800" b="1">
-                <a:solidFill>
-                  <a:srgbClr val="007DA5"/>
-                </a:solidFill>
-                <a:latin typeface="Calibri"/>
-              </a:defRPr>
-            </a:pPr>
-            <a:r>
-              <a:t>DORA and EU AI Act: European Union laws</a:t>
-            </a:r>
-          </a:p>
-        </p:txBody>
-      </p:sp>
-      <p:sp>
-        <p:nvSpPr>
-          <p:cNvPr id="22" name="TextBox 21"/>
-          <p:cNvSpPr txBox="1"/>
-          <p:nvPr/>
-        </p:nvSpPr>
-        <p:spPr>
-          <a:xfrm>
-            <a:off x="6309360" y="4315968"/>
-            <a:ext cx="5212080" cy="1463040"/>
-          </a:xfrm>
-          <a:prstGeom prst="rect">
-            <a:avLst/>
-          </a:prstGeom>
-          <a:noFill/>
-        </p:spPr>
-        <p:txBody>
-          <a:bodyPr wrap="square" lIns="0" rIns="0" tIns="0" bIns="0">
-            <a:spAutoFit/>
-          </a:bodyPr>
-          <a:lstStyle/>
-          <a:p>
-            <a:pPr>
-              <a:defRPr sz="1600" b="0">
-                <a:solidFill>
-                  <a:srgbClr val="26354A"/>
-                </a:solidFill>
-                <a:latin typeface="Calibri"/>
-              </a:defRPr>
-            </a:pPr>
-            <a:r>
-              <a:t>DORA means Digital Operational Resilience Act and addresses financial-sector technology resilience. EU means European Union. Its AI Act regulates AI by scope and risk. They are laws, not institutions; assess each separately.</a:t>
-            </a:r>
-          </a:p>
-        </p:txBody>
-      </p:sp>
-      <p:sp>
-        <p:nvSpPr>
-          <p:cNvPr id="23" name="TextBox 22"/>
-          <p:cNvSpPr txBox="1"/>
-          <p:nvPr/>
-        </p:nvSpPr>
-        <p:spPr>
-          <a:xfrm>
-            <a:off x="685800" y="6071616"/>
-            <a:ext cx="10789920" cy="274320"/>
-          </a:xfrm>
-          <a:prstGeom prst="rect">
-            <a:avLst/>
-          </a:prstGeom>
-          <a:noFill/>
-        </p:spPr>
-        <p:txBody>
-          <a:bodyPr wrap="square" lIns="0" rIns="0" tIns="0" bIns="0">
-            <a:spAutoFit/>
-          </a:bodyPr>
-          <a:lstStyle/>
-          <a:p>
-            <a:pPr>
-              <a:defRPr sz="1000" b="0">
-                <a:solidFill>
-                  <a:srgbClr val="66758A"/>
-                </a:solidFill>
-                <a:latin typeface="Calibri"/>
-              </a:defRPr>
-            </a:pPr>
-            <a:r>
-              <a:t>AI = artificial intelligence. Reuse evidence, but assess each framework and law separately. Full sources in notes.</a:t>
+              <a:t>11 / 23    07:50–08:30 planned    Sources and explanation in notes</a:t>
             </a:r>
           </a:p>
         </p:txBody>
@@ -8520,7 +8409,7 @@
               </a:defRPr>
             </a:pPr>
             <a:r>
-              <a:t>12 / 24    08:30–09:35 planned    Sources and explanation in notes</a:t>
+              <a:t>12 / 23    08:30–09:35 planned    Sources and explanation in notes</a:t>
             </a:r>
           </a:p>
         </p:txBody>
@@ -9003,7 +8892,7 @@
               </a:defRPr>
             </a:pPr>
             <a:r>
-              <a:t>13 / 24    09:35–10:35 planned    Sources and explanation in notes</a:t>
+              <a:t>13 / 23    09:35–10:35 planned    Sources and explanation in notes</a:t>
             </a:r>
           </a:p>
         </p:txBody>
@@ -9486,7 +9375,7 @@
               </a:defRPr>
             </a:pPr>
             <a:r>
-              <a:t>14 / 24    10:35–11:40 planned    Sources and explanation in notes</a:t>
+              <a:t>14 / 23    10:35–11:40 planned    Sources and explanation in notes</a:t>
             </a:r>
           </a:p>
         </p:txBody>
@@ -9969,7 +9858,7 @@
               </a:defRPr>
             </a:pPr>
             <a:r>
-              <a:t>15 / 24    11:40–12:35 planned    Sources and explanation in notes</a:t>
+              <a:t>15 / 23    11:40–12:35 planned    Sources and explanation in notes</a:t>
             </a:r>
           </a:p>
         </p:txBody>
@@ -10452,7 +10341,7 @@
               </a:defRPr>
             </a:pPr>
             <a:r>
-              <a:t>16 / 24    12:35–13:25 planned    Sources and explanation in notes</a:t>
+              <a:t>16 / 23    12:35–13:25 planned    Sources and explanation in notes</a:t>
             </a:r>
           </a:p>
         </p:txBody>
@@ -10902,7 +10791,7 @@
               </a:defRPr>
             </a:pPr>
             <a:r>
-              <a:t>17 / 24    13:25–14:10 planned    Sources and explanation in notes</a:t>
+              <a:t>17 / 23    13:25–14:10 planned    Sources and explanation in notes</a:t>
             </a:r>
           </a:p>
         </p:txBody>
@@ -11352,7 +11241,7 @@
               </a:defRPr>
             </a:pPr>
             <a:r>
-              <a:t>18 / 24    14:10–14:55 planned    Sources and explanation in notes</a:t>
+              <a:t>18 / 23    14:10–14:55 planned    Sources and explanation in notes</a:t>
             </a:r>
           </a:p>
         </p:txBody>
@@ -11578,7 +11467,7 @@
           <a:lstStyle/>
           <a:p>
             <a:pPr>
-              <a:defRPr sz="1600" b="0">
+              <a:defRPr sz="1600">
                 <a:solidFill>
                   <a:srgbClr val="26354A"/>
                 </a:solidFill>
@@ -11586,7 +11475,7 @@
               </a:defRPr>
             </a:pPr>
             <a:r>
-              <a:t>Separate Internet and restricted runtimes. Apply network policy and reviewed package promotion. DNS, supporting services and cluster enforcement need tests on the installed version.</a:t>
+              <a:t>Separate Internet and restricted runtimes. Verify DNS, package services and cluster network enforcement. Use disposable users to test peer-file access and harmless requests to unapproved destinations.</a:t>
             </a:r>
           </a:p>
         </p:txBody>
@@ -11802,7 +11691,7 @@
               </a:defRPr>
             </a:pPr>
             <a:r>
-              <a:t>19 / 24    14:55–15:50 planned    Sources and explanation in notes</a:t>
+              <a:t>19 / 23    14:55–15:50 planned    Sources and explanation in notes</a:t>
             </a:r>
           </a:p>
         </p:txBody>
@@ -12246,7 +12135,7 @@
               </a:defRPr>
             </a:pPr>
             <a:r>
-              <a:t>2 / 24    00:30–01:10 planned    Sources and explanation in notes</a:t>
+              <a:t>2 / 23    00:30–01:10 planned    Sources and explanation in notes</a:t>
             </a:r>
           </a:p>
         </p:txBody>
@@ -12278,23 +12167,20 @@
         <p:spPr>
           <a:xfrm>
             <a:off x="640080" y="411480"/>
-            <a:ext cx="10972800" cy="256032"/>
-          </a:xfrm>
-          <a:prstGeom prst="rect">
-            <a:avLst/>
-          </a:prstGeom>
-          <a:noFill/>
-        </p:spPr>
-        <p:txBody>
-          <a:bodyPr wrap="square" lIns="0" rIns="0" tIns="0" bIns="0">
-            <a:spAutoFit/>
-          </a:bodyPr>
-          <a:lstStyle/>
-          <a:p>
-            <a:pPr>
-              <a:spcAft>
-                <a:spcPts val="600"/>
-              </a:spcAft>
+            <a:ext cx="10972800" cy="274320"/>
+          </a:xfrm>
+          <a:prstGeom prst="rect">
+            <a:avLst/>
+          </a:prstGeom>
+          <a:noFill/>
+        </p:spPr>
+        <p:txBody>
+          <a:bodyPr wrap="square" lIns="0" rIns="0" tIns="0" bIns="0">
+            <a:spAutoFit/>
+          </a:bodyPr>
+          <a:lstStyle/>
+          <a:p>
+            <a:pPr>
               <a:defRPr sz="1100" b="1">
                 <a:solidFill>
                   <a:srgbClr val="0088BA"/>
@@ -12303,7 +12189,7 @@
               </a:defRPr>
             </a:pPr>
             <a:r>
-              <a:t>4 / FOLLOW THE OUTPUT</a:t>
+              <a:t>PART 3 / ONE EXAMPLE: FROM DSH TO THE REVIEWER</a:t>
             </a:r>
           </a:p>
         </p:txBody>
@@ -12331,9 +12217,6 @@
           <a:lstStyle/>
           <a:p>
             <a:pPr>
-              <a:spcAft>
-                <a:spcPts val="600"/>
-              </a:spcAft>
               <a:defRPr sz="2500" b="1">
                 <a:solidFill>
                   <a:srgbClr val="14243C"/>
@@ -12342,7 +12225,7 @@
               </a:defRPr>
             </a:pPr>
             <a:r>
-              <a:t>Generated HTML creates a second execution boundary</a:t>
+              <a:t>A DSH claims report needs checks before and after sharing</a:t>
             </a:r>
           </a:p>
         </p:txBody>
@@ -12356,23 +12239,20 @@
         <p:spPr>
           <a:xfrm>
             <a:off x="685800" y="1856231"/>
-            <a:ext cx="5212080" cy="384048"/>
-          </a:xfrm>
-          <a:prstGeom prst="rect">
-            <a:avLst/>
-          </a:prstGeom>
-          <a:noFill/>
-        </p:spPr>
-        <p:txBody>
-          <a:bodyPr wrap="square" lIns="0" rIns="0" tIns="0" bIns="0">
-            <a:spAutoFit/>
-          </a:bodyPr>
-          <a:lstStyle/>
-          <a:p>
-            <a:pPr>
-              <a:spcAft>
-                <a:spcPts val="600"/>
-              </a:spcAft>
+            <a:ext cx="5212080" cy="411480"/>
+          </a:xfrm>
+          <a:prstGeom prst="rect">
+            <a:avLst/>
+          </a:prstGeom>
+          <a:noFill/>
+        </p:spPr>
+        <p:txBody>
+          <a:bodyPr wrap="square" lIns="0" rIns="0" tIns="0" bIns="0">
+            <a:spAutoFit/>
+          </a:bodyPr>
+          <a:lstStyle/>
+          <a:p>
+            <a:pPr>
               <a:defRPr sz="1800" b="1">
                 <a:solidFill>
                   <a:srgbClr val="007DA5"/>
@@ -12381,7 +12261,7 @@
               </a:defRPr>
             </a:pPr>
             <a:r>
-              <a:t>Inside the workspace</a:t>
+              <a:t>1. Prepare the report in DSH</a:t>
             </a:r>
           </a:p>
         </p:txBody>
@@ -12394,24 +12274,21 @@
         </p:nvSpPr>
         <p:spPr>
           <a:xfrm>
-            <a:off x="685800" y="2295144"/>
-            <a:ext cx="5212080" cy="1435608"/>
-          </a:xfrm>
-          <a:prstGeom prst="rect">
-            <a:avLst/>
-          </a:prstGeom>
-          <a:noFill/>
-        </p:spPr>
-        <p:txBody>
-          <a:bodyPr wrap="square" lIns="0" rIns="0" tIns="0" bIns="0">
-            <a:spAutoFit/>
-          </a:bodyPr>
-          <a:lstStyle/>
-          <a:p>
-            <a:pPr>
-              <a:spcAft>
-                <a:spcPts val="600"/>
-              </a:spcAft>
+            <a:off x="685800" y="2313432"/>
+            <a:ext cx="5212080" cy="1463040"/>
+          </a:xfrm>
+          <a:prstGeom prst="rect">
+            <a:avLst/>
+          </a:prstGeom>
+          <a:noFill/>
+        </p:spPr>
+        <p:txBody>
+          <a:bodyPr wrap="square" lIns="0" rIns="0" tIns="0" bIns="0">
+            <a:spAutoFit/>
+          </a:bodyPr>
+          <a:lstStyle/>
+          <a:p>
+            <a:pPr>
               <a:defRPr sz="1600" b="0">
                 <a:solidFill>
                   <a:srgbClr val="26354A"/>
@@ -12420,7 +12297,7 @@
               </a:defRPr>
             </a:pPr>
             <a:r>
-              <a:t>The assistant reads approved files and generates a report with the worker's identity and network permissions. Project inputs may still carry hostile instructions.</a:t>
+              <a:t>Use approved copies of claim documents. Check the source references, amounts and missing evidence. Preparing a report gives no authority to email the customer, change the claim or issue payment.</a:t>
             </a:r>
           </a:p>
         </p:txBody>
@@ -12434,23 +12311,20 @@
         <p:spPr>
           <a:xfrm>
             <a:off x="6309360" y="1856231"/>
-            <a:ext cx="5212080" cy="384048"/>
-          </a:xfrm>
-          <a:prstGeom prst="rect">
-            <a:avLst/>
-          </a:prstGeom>
-          <a:noFill/>
-        </p:spPr>
-        <p:txBody>
-          <a:bodyPr wrap="square" lIns="0" rIns="0" tIns="0" bIns="0">
-            <a:spAutoFit/>
-          </a:bodyPr>
-          <a:lstStyle/>
-          <a:p>
-            <a:pPr>
-              <a:spcAft>
-                <a:spcPts val="600"/>
-              </a:spcAft>
+            <a:ext cx="5212080" cy="411480"/>
+          </a:xfrm>
+          <a:prstGeom prst="rect">
+            <a:avLst/>
+          </a:prstGeom>
+          <a:noFill/>
+        </p:spPr>
+        <p:txBody>
+          <a:bodyPr wrap="square" lIns="0" rIns="0" tIns="0" bIns="0">
+            <a:spAutoFit/>
+          </a:bodyPr>
+          <a:lstStyle/>
+          <a:p>
+            <a:pPr>
               <a:defRPr sz="1800" b="1">
                 <a:solidFill>
                   <a:srgbClr val="007DA5"/>
@@ -12459,7 +12333,7 @@
               </a:defRPr>
             </a:pPr>
             <a:r>
-              <a:t>In the recipient's browser</a:t>
+              <a:t>2. Check what the file will load</a:t>
             </a:r>
           </a:p>
         </p:txBody>
@@ -12472,24 +12346,21 @@
         </p:nvSpPr>
         <p:spPr>
           <a:xfrm>
-            <a:off x="6309360" y="2295144"/>
-            <a:ext cx="5212080" cy="1435608"/>
-          </a:xfrm>
-          <a:prstGeom prst="rect">
-            <a:avLst/>
-          </a:prstGeom>
-          <a:noFill/>
-        </p:spPr>
-        <p:txBody>
-          <a:bodyPr wrap="square" lIns="0" rIns="0" tIns="0" bIns="0">
-            <a:spAutoFit/>
-          </a:bodyPr>
-          <a:lstStyle/>
-          <a:p>
-            <a:pPr>
-              <a:spcAft>
-                <a:spcPts val="600"/>
-              </a:spcAft>
+            <a:off x="6309360" y="2313432"/>
+            <a:ext cx="5212080" cy="1463040"/>
+          </a:xfrm>
+          <a:prstGeom prst="rect">
+            <a:avLst/>
+          </a:prstGeom>
+          <a:noFill/>
+        </p:spPr>
+        <p:txBody>
+          <a:bodyPr wrap="square" lIns="0" rIns="0" tIns="0" bIns="0">
+            <a:spAutoFit/>
+          </a:bodyPr>
+          <a:lstStyle/>
+          <a:p>
+            <a:pPr>
               <a:defRPr sz="1600" b="0">
                 <a:solidFill>
                   <a:srgbClr val="26354A"/>
@@ -12498,7 +12369,7 @@
               </a:defRPr>
             </a:pPr>
             <a:r>
-              <a:t>The report may load scripts, images or remote data. Browser permissions differ from the worker's. Relevant credentials may be sent where browser rules allow.</a:t>
+              <a:t>An HTML report can request an external image when opened. If the image address contains a claim ID, that request can disclose it. Review links, scripts and remote resources before sharing.</a:t>
             </a:r>
           </a:p>
         </p:txBody>
@@ -12512,23 +12383,20 @@
         <p:spPr>
           <a:xfrm>
             <a:off x="685800" y="3858768"/>
-            <a:ext cx="5212080" cy="384048"/>
-          </a:xfrm>
-          <a:prstGeom prst="rect">
-            <a:avLst/>
-          </a:prstGeom>
-          <a:noFill/>
-        </p:spPr>
-        <p:txBody>
-          <a:bodyPr wrap="square" lIns="0" rIns="0" tIns="0" bIns="0">
-            <a:spAutoFit/>
-          </a:bodyPr>
-          <a:lstStyle/>
-          <a:p>
-            <a:pPr>
-              <a:spcAft>
-                <a:spcPts val="600"/>
-              </a:spcAft>
+            <a:ext cx="5212080" cy="411480"/>
+          </a:xfrm>
+          <a:prstGeom prst="rect">
+            <a:avLst/>
+          </a:prstGeom>
+          <a:noFill/>
+        </p:spPr>
+        <p:txBody>
+          <a:bodyPr wrap="square" lIns="0" rIns="0" tIns="0" bIns="0">
+            <a:spAutoFit/>
+          </a:bodyPr>
+          <a:lstStyle/>
+          <a:p>
+            <a:pPr>
               <a:defRPr sz="1800" b="1">
                 <a:solidFill>
                   <a:srgbClr val="007DA5"/>
@@ -12537,7 +12405,7 @@
               </a:defRPr>
             </a:pPr>
             <a:r>
-              <a:t>Practical example</a:t>
+              <a:t>3. Open it as the reviewer would</a:t>
             </a:r>
           </a:p>
         </p:txBody>
@@ -12550,24 +12418,21 @@
         </p:nvSpPr>
         <p:spPr>
           <a:xfrm>
-            <a:off x="685800" y="4297679"/>
-            <a:ext cx="5212080" cy="1435608"/>
-          </a:xfrm>
-          <a:prstGeom prst="rect">
-            <a:avLst/>
-          </a:prstGeom>
-          <a:noFill/>
-        </p:spPr>
-        <p:txBody>
-          <a:bodyPr wrap="square" lIns="0" rIns="0" tIns="0" bIns="0">
-            <a:spAutoFit/>
-          </a:bodyPr>
-          <a:lstStyle/>
-          <a:p>
-            <a:pPr>
-              <a:spcAft>
-                <a:spcPts val="600"/>
-              </a:spcAft>
+            <a:off x="685800" y="4315968"/>
+            <a:ext cx="5212080" cy="1463040"/>
+          </a:xfrm>
+          <a:prstGeom prst="rect">
+            <a:avLst/>
+          </a:prstGeom>
+          <a:noFill/>
+        </p:spPr>
+        <p:txBody>
+          <a:bodyPr wrap="square" lIns="0" rIns="0" tIns="0" bIns="0">
+            <a:spAutoFit/>
+          </a:bodyPr>
+          <a:lstStyle/>
+          <a:p>
+            <a:pPr>
               <a:defRPr sz="1600" b="0">
                 <a:solidFill>
                   <a:srgbClr val="26354A"/>
@@ -12576,7 +12441,7 @@
               </a:defRPr>
             </a:pPr>
             <a:r>
-              <a:t>An external image URL in a claims report contains a case identifier. Opening the file could disclose that identifier through the request without a visible Send button.</a:t>
+              <a:t>Test with invented claim data in the intended browser. Confirm the totals and check unexpected network requests. Workspace network restrictions do not automatically carry over to the recipient's browser.</a:t>
             </a:r>
           </a:p>
         </p:txBody>
@@ -12590,23 +12455,20 @@
         <p:spPr>
           <a:xfrm>
             <a:off x="6309360" y="3858768"/>
-            <a:ext cx="5212080" cy="384048"/>
-          </a:xfrm>
-          <a:prstGeom prst="rect">
-            <a:avLst/>
-          </a:prstGeom>
-          <a:noFill/>
-        </p:spPr>
-        <p:txBody>
-          <a:bodyPr wrap="square" lIns="0" rIns="0" tIns="0" bIns="0">
-            <a:spAutoFit/>
-          </a:bodyPr>
-          <a:lstStyle/>
-          <a:p>
-            <a:pPr>
-              <a:spcAft>
-                <a:spcPts val="600"/>
-              </a:spcAft>
+            <a:ext cx="5212080" cy="411480"/>
+          </a:xfrm>
+          <a:prstGeom prst="rect">
+            <a:avLst/>
+          </a:prstGeom>
+          <a:noFill/>
+        </p:spPr>
+        <p:txBody>
+          <a:bodyPr wrap="square" lIns="0" rIns="0" tIns="0" bIns="0">
+            <a:spAutoFit/>
+          </a:bodyPr>
+          <a:lstStyle/>
+          <a:p>
+            <a:pPr>
               <a:defRPr sz="1800" b="1">
                 <a:solidFill>
                   <a:srgbClr val="007DA5"/>
@@ -12615,7 +12477,7 @@
               </a:defRPr>
             </a:pPr>
             <a:r>
-              <a:t>Controls to test</a:t>
+              <a:t>4. Know what happens on failure</a:t>
             </a:r>
           </a:p>
         </p:txBody>
@@ -12628,24 +12490,21 @@
         </p:nvSpPr>
         <p:spPr>
           <a:xfrm>
-            <a:off x="6309360" y="4297679"/>
-            <a:ext cx="5212080" cy="1435608"/>
-          </a:xfrm>
-          <a:prstGeom prst="rect">
-            <a:avLst/>
-          </a:prstGeom>
-          <a:noFill/>
-        </p:spPr>
-        <p:txBody>
-          <a:bodyPr wrap="square" lIns="0" rIns="0" tIns="0" bIns="0">
-            <a:spAutoFit/>
-          </a:bodyPr>
-          <a:lstStyle/>
-          <a:p>
-            <a:pPr>
-              <a:spcAft>
-                <a:spcPts val="600"/>
-              </a:spcAft>
+            <a:off x="6309360" y="4315968"/>
+            <a:ext cx="5212080" cy="1463040"/>
+          </a:xfrm>
+          <a:prstGeom prst="rect">
+            <a:avLst/>
+          </a:prstGeom>
+          <a:noFill/>
+        </p:spPr>
+        <p:txBody>
+          <a:bodyPr wrap="square" lIns="0" rIns="0" tIns="0" bIns="0">
+            <a:spAutoFit/>
+          </a:bodyPr>
+          <a:lstStyle/>
+          <a:p>
+            <a:pPr>
               <a:defRPr sz="1600" b="0">
                 <a:solidFill>
                   <a:srgbClr val="26354A"/>
@@ -12654,7 +12513,7 @@
               </a:defRPr>
             </a:pPr>
             <a:r>
-              <a:t>Minimise sensitive exports. Review scripts and remote resources. Prefer self-contained output where appropriate. Test the final file in its real viewing environment.</a:t>
+              <a:t>If a material error or unexpected request appears, withhold the report and notify its owner. Verify stop and restart controls on a disposable run. Keep the file version, results and release decision.</a:t>
             </a:r>
           </a:p>
         </p:txBody>
@@ -12667,24 +12526,21 @@
         </p:nvSpPr>
         <p:spPr>
           <a:xfrm>
-            <a:off x="685800" y="6044184"/>
-            <a:ext cx="10789920" cy="237744"/>
-          </a:xfrm>
-          <a:prstGeom prst="rect">
-            <a:avLst/>
-          </a:prstGeom>
-          <a:noFill/>
-        </p:spPr>
-        <p:txBody>
-          <a:bodyPr wrap="square" lIns="0" rIns="0" tIns="0" bIns="0">
-            <a:spAutoFit/>
-          </a:bodyPr>
-          <a:lstStyle/>
-          <a:p>
-            <a:pPr>
-              <a:spcAft>
-                <a:spcPts val="600"/>
-              </a:spcAft>
+            <a:off x="685800" y="6071616"/>
+            <a:ext cx="10789920" cy="274320"/>
+          </a:xfrm>
+          <a:prstGeom prst="rect">
+            <a:avLst/>
+          </a:prstGeom>
+          <a:noFill/>
+        </p:spPr>
+        <p:txBody>
+          <a:bodyPr wrap="square" lIns="0" rIns="0" tIns="0" bIns="0">
+            <a:spAutoFit/>
+          </a:bodyPr>
+          <a:lstStyle/>
+          <a:p>
+            <a:pPr>
               <a:defRPr sz="1000" b="0">
                 <a:solidFill>
                   <a:srgbClr val="66758A"/>
@@ -12693,7 +12549,7 @@
               </a:defRPr>
             </a:pPr>
             <a:r>
-              <a:t>Source links, explanation and limits are in the speaker guide and slide notes.</a:t>
+              <a:t>Illustrative claims example and proposed checks. No observed DSH leak or completed live test is asserted.</a:t>
             </a:r>
           </a:p>
         </p:txBody>
@@ -12729,457 +12585,7 @@
               </a:defRPr>
             </a:pPr>
             <a:r>
-              <a:t>20 / 24    15:50–16:40 planned    Sources and explanation in notes</a:t>
-            </a:r>
-          </a:p>
-        </p:txBody>
-      </p:sp>
-    </p:spTree>
-  </p:cSld>
-  <p:clrMapOvr>
-    <a:masterClrMapping/>
-  </p:clrMapOvr>
-</p:sld>
-</file>
-
-<file path=ppt/slides/slide21.xml><?xml version="1.0" encoding="utf-8"?>
-<p:sld xmlns:a="http://schemas.openxmlformats.org/drawingml/2006/main" xmlns:p="http://schemas.openxmlformats.org/presentationml/2006/main" xmlns:r="http://schemas.openxmlformats.org/officeDocument/2006/relationships">
-  <p:cSld>
-    <p:spTree>
-      <p:nvGrpSpPr>
-        <p:cNvPr id="1" name=""/>
-        <p:cNvGrpSpPr/>
-        <p:nvPr/>
-      </p:nvGrpSpPr>
-      <p:grpSpPr/>
-      <p:sp>
-        <p:nvSpPr>
-          <p:cNvPr id="2" name="TextBox 1"/>
-          <p:cNvSpPr txBox="1"/>
-          <p:nvPr/>
-        </p:nvSpPr>
-        <p:spPr>
-          <a:xfrm>
-            <a:off x="640080" y="411480"/>
-            <a:ext cx="10972800" cy="274320"/>
-          </a:xfrm>
-          <a:prstGeom prst="rect">
-            <a:avLst/>
-          </a:prstGeom>
-          <a:noFill/>
-        </p:spPr>
-        <p:txBody>
-          <a:bodyPr wrap="square" lIns="0" rIns="0" tIns="0" bIns="0">
-            <a:spAutoFit/>
-          </a:bodyPr>
-          <a:lstStyle/>
-          <a:p>
-            <a:pPr>
-              <a:defRPr sz="1100" b="1">
-                <a:solidFill>
-                  <a:srgbClr val="0088BA"/>
-                </a:solidFill>
-                <a:latin typeface="Calibri"/>
-              </a:defRPr>
-            </a:pPr>
-            <a:r>
-              <a:t>PART 3 / WHAT DSH PROVIDES AND HOW WE QUALIFY IT</a:t>
-            </a:r>
-          </a:p>
-        </p:txBody>
-      </p:sp>
-      <p:sp>
-        <p:nvSpPr>
-          <p:cNvPr id="3" name="TextBox 2"/>
-          <p:cNvSpPr txBox="1"/>
-          <p:nvPr/>
-        </p:nvSpPr>
-        <p:spPr>
-          <a:xfrm>
-            <a:off x="640080" y="868680"/>
-            <a:ext cx="10972800" cy="777240"/>
-          </a:xfrm>
-          <a:prstGeom prst="rect">
-            <a:avLst/>
-          </a:prstGeom>
-          <a:noFill/>
-        </p:spPr>
-        <p:txBody>
-          <a:bodyPr wrap="square" lIns="0" rIns="0" tIns="0" bIns="0">
-            <a:spAutoFit/>
-          </a:bodyPr>
-          <a:lstStyle/>
-          <a:p>
-            <a:pPr>
-              <a:defRPr sz="2500" b="1">
-                <a:solidFill>
-                  <a:srgbClr val="14243C"/>
-                </a:solidFill>
-                <a:latin typeface="Calibri"/>
-              </a:defRPr>
-            </a:pPr>
-            <a:r>
-              <a:t>Safety evidence comes from testing the actual workflow</a:t>
-            </a:r>
-          </a:p>
-        </p:txBody>
-      </p:sp>
-      <p:sp>
-        <p:nvSpPr>
-          <p:cNvPr id="4" name="TextBox 3"/>
-          <p:cNvSpPr txBox="1"/>
-          <p:nvPr/>
-        </p:nvSpPr>
-        <p:spPr>
-          <a:xfrm>
-            <a:off x="685800" y="1856231"/>
-            <a:ext cx="5212080" cy="393192"/>
-          </a:xfrm>
-          <a:prstGeom prst="rect">
-            <a:avLst/>
-          </a:prstGeom>
-          <a:noFill/>
-        </p:spPr>
-        <p:txBody>
-          <a:bodyPr wrap="square" lIns="0" rIns="0" tIns="0" bIns="0">
-            <a:spAutoFit/>
-          </a:bodyPr>
-          <a:lstStyle/>
-          <a:p>
-            <a:pPr>
-              <a:defRPr sz="1800" b="1">
-                <a:solidFill>
-                  <a:srgbClr val="007DA5"/>
-                </a:solidFill>
-                <a:latin typeface="Calibri"/>
-              </a:defRPr>
-            </a:pPr>
-            <a:r>
-              <a:t>Isolation and restricted routes</a:t>
-            </a:r>
-          </a:p>
-        </p:txBody>
-      </p:sp>
-      <p:sp>
-        <p:nvSpPr>
-          <p:cNvPr id="5" name="TextBox 4"/>
-          <p:cNvSpPr txBox="1"/>
-          <p:nvPr/>
-        </p:nvSpPr>
-        <p:spPr>
-          <a:xfrm>
-            <a:off x="685800" y="2304287"/>
-            <a:ext cx="5212080" cy="1463040"/>
-          </a:xfrm>
-          <a:prstGeom prst="rect">
-            <a:avLst/>
-          </a:prstGeom>
-          <a:noFill/>
-        </p:spPr>
-        <p:txBody>
-          <a:bodyPr wrap="square" lIns="0" rIns="0" tIns="0" bIns="0">
-            <a:spAutoFit/>
-          </a:bodyPr>
-          <a:lstStyle/>
-          <a:p>
-            <a:pPr>
-              <a:defRPr sz="1600" b="0">
-                <a:solidFill>
-                  <a:srgbClr val="26354A"/>
-                </a:solidFill>
-                <a:latin typeface="Calibri"/>
-              </a:defRPr>
-            </a:pPr>
-            <a:r>
-              <a:t>With disposable users and test files, try reading a peer workspace and contacting an unapproved destination. Test DNS and package services too. Inspect denials and the receiving side where possible.</a:t>
-            </a:r>
-          </a:p>
-        </p:txBody>
-      </p:sp>
-      <p:sp>
-        <p:nvSpPr>
-          <p:cNvPr id="6" name="TextBox 5"/>
-          <p:cNvSpPr txBox="1"/>
-          <p:nvPr/>
-        </p:nvSpPr>
-        <p:spPr>
-          <a:xfrm>
-            <a:off x="6309360" y="1856231"/>
-            <a:ext cx="5212080" cy="393192"/>
-          </a:xfrm>
-          <a:prstGeom prst="rect">
-            <a:avLst/>
-          </a:prstGeom>
-          <a:noFill/>
-        </p:spPr>
-        <p:txBody>
-          <a:bodyPr wrap="square" lIns="0" rIns="0" tIns="0" bIns="0">
-            <a:spAutoFit/>
-          </a:bodyPr>
-          <a:lstStyle/>
-          <a:p>
-            <a:pPr>
-              <a:defRPr sz="1800" b="1">
-                <a:solidFill>
-                  <a:srgbClr val="007DA5"/>
-                </a:solidFill>
-                <a:latin typeface="Calibri"/>
-              </a:defRPr>
-            </a:pPr>
-            <a:r>
-              <a:t>Unauthorised actions and exports</a:t>
-            </a:r>
-          </a:p>
-        </p:txBody>
-      </p:sp>
-      <p:sp>
-        <p:nvSpPr>
-          <p:cNvPr id="7" name="TextBox 6"/>
-          <p:cNvSpPr txBox="1"/>
-          <p:nvPr/>
-        </p:nvSpPr>
-        <p:spPr>
-          <a:xfrm>
-            <a:off x="6309360" y="2304287"/>
-            <a:ext cx="5212080" cy="1463040"/>
-          </a:xfrm>
-          <a:prstGeom prst="rect">
-            <a:avLst/>
-          </a:prstGeom>
-          <a:noFill/>
-        </p:spPr>
-        <p:txBody>
-          <a:bodyPr wrap="square" lIns="0" rIns="0" tIns="0" bIns="0">
-            <a:spAutoFit/>
-          </a:bodyPr>
-          <a:lstStyle/>
-          <a:p>
-            <a:pPr>
-              <a:defRPr sz="1600" b="0">
-                <a:solidFill>
-                  <a:srgbClr val="26354A"/>
-                </a:solidFill>
-                <a:latin typeface="Calibri"/>
-              </a:defRPr>
-            </a:pPr>
-            <a:r>
-              <a:t>Use harmless canary data. Try an unapproved send or record change and inspect the target audit. Open exported HTML in its intended viewer and check scripts, remote requests and data exposure.</a:t>
-            </a:r>
-          </a:p>
-        </p:txBody>
-      </p:sp>
-      <p:sp>
-        <p:nvSpPr>
-          <p:cNvPr id="8" name="TextBox 7"/>
-          <p:cNvSpPr txBox="1"/>
-          <p:nvPr/>
-        </p:nvSpPr>
-        <p:spPr>
-          <a:xfrm>
-            <a:off x="685800" y="3858768"/>
-            <a:ext cx="5212080" cy="393192"/>
-          </a:xfrm>
-          <a:prstGeom prst="rect">
-            <a:avLst/>
-          </a:prstGeom>
-          <a:noFill/>
-        </p:spPr>
-        <p:txBody>
-          <a:bodyPr wrap="square" lIns="0" rIns="0" tIns="0" bIns="0">
-            <a:spAutoFit/>
-          </a:bodyPr>
-          <a:lstStyle/>
-          <a:p>
-            <a:pPr>
-              <a:defRPr sz="1800" b="1">
-                <a:solidFill>
-                  <a:srgbClr val="007DA5"/>
-                </a:solidFill>
-                <a:latin typeface="Calibri"/>
-              </a:defRPr>
-            </a:pPr>
-            <a:r>
-              <a:t>Alerts, stop and recovery</a:t>
-            </a:r>
-          </a:p>
-        </p:txBody>
-      </p:sp>
-      <p:sp>
-        <p:nvSpPr>
-          <p:cNvPr id="9" name="TextBox 8"/>
-          <p:cNvSpPr txBox="1"/>
-          <p:nvPr/>
-        </p:nvSpPr>
-        <p:spPr>
-          <a:xfrm>
-            <a:off x="685800" y="4306824"/>
-            <a:ext cx="5212080" cy="1463040"/>
-          </a:xfrm>
-          <a:prstGeom prst="rect">
-            <a:avLst/>
-          </a:prstGeom>
-          <a:noFill/>
-        </p:spPr>
-        <p:txBody>
-          <a:bodyPr wrap="square" lIns="0" rIns="0" tIns="0" bIns="0">
-            <a:spAutoFit/>
-          </a:bodyPr>
-          <a:lstStyle/>
-          <a:p>
-            <a:pPr>
-              <a:defRPr sz="1600" b="0">
-                <a:solidFill>
-                  <a:srgbClr val="26354A"/>
-                </a:solidFill>
-                <a:latin typeface="Calibri"/>
-              </a:defRPr>
-            </a:pPr>
-            <a:r>
-              <a:t>Trigger a controlled failure, confirm the right person receives the alert, then stop a disposable run. Check queued work, saved files and restart behaviour before approving recovery.</a:t>
-            </a:r>
-          </a:p>
-        </p:txBody>
-      </p:sp>
-      <p:sp>
-        <p:nvSpPr>
-          <p:cNvPr id="10" name="TextBox 9"/>
-          <p:cNvSpPr txBox="1"/>
-          <p:nvPr/>
-        </p:nvSpPr>
-        <p:spPr>
-          <a:xfrm>
-            <a:off x="6309360" y="3858768"/>
-            <a:ext cx="5212080" cy="393192"/>
-          </a:xfrm>
-          <a:prstGeom prst="rect">
-            <a:avLst/>
-          </a:prstGeom>
-          <a:noFill/>
-        </p:spPr>
-        <p:txBody>
-          <a:bodyPr wrap="square" lIns="0" rIns="0" tIns="0" bIns="0">
-            <a:spAutoFit/>
-          </a:bodyPr>
-          <a:lstStyle/>
-          <a:p>
-            <a:pPr>
-              <a:defRPr sz="1800" b="1">
-                <a:solidFill>
-                  <a:srgbClr val="007DA5"/>
-                </a:solidFill>
-                <a:latin typeface="Calibri"/>
-              </a:defRPr>
-            </a:pPr>
-            <a:r>
-              <a:t>A scoped acceptance record</a:t>
-            </a:r>
-          </a:p>
-        </p:txBody>
-      </p:sp>
-      <p:sp>
-        <p:nvSpPr>
-          <p:cNvPr id="11" name="TextBox 10"/>
-          <p:cNvSpPr txBox="1"/>
-          <p:nvPr/>
-        </p:nvSpPr>
-        <p:spPr>
-          <a:xfrm>
-            <a:off x="6309360" y="4306824"/>
-            <a:ext cx="5212080" cy="1463040"/>
-          </a:xfrm>
-          <a:prstGeom prst="rect">
-            <a:avLst/>
-          </a:prstGeom>
-          <a:noFill/>
-        </p:spPr>
-        <p:txBody>
-          <a:bodyPr wrap="square" lIns="0" rIns="0" tIns="0" bIns="0">
-            <a:spAutoFit/>
-          </a:bodyPr>
-          <a:lstStyle/>
-          <a:p>
-            <a:pPr>
-              <a:defRPr sz="1600" b="0">
-                <a:solidFill>
-                  <a:srgbClr val="26354A"/>
-                </a:solidFill>
-                <a:latin typeface="Calibri"/>
-              </a:defRPr>
-            </a:pPr>
-            <a:r>
-              <a:t>Keep the exact version, configuration, inputs, expected result, observed result and owner decision. Test legitimate work too. These are proposed acceptance checks, not tests completed by this deck.</a:t>
-            </a:r>
-          </a:p>
-        </p:txBody>
-      </p:sp>
-      <p:sp>
-        <p:nvSpPr>
-          <p:cNvPr id="12" name="TextBox 11"/>
-          <p:cNvSpPr txBox="1"/>
-          <p:nvPr/>
-        </p:nvSpPr>
-        <p:spPr>
-          <a:xfrm>
-            <a:off x="685800" y="6071616"/>
-            <a:ext cx="10789920" cy="274320"/>
-          </a:xfrm>
-          <a:prstGeom prst="rect">
-            <a:avLst/>
-          </a:prstGeom>
-          <a:noFill/>
-        </p:spPr>
-        <p:txBody>
-          <a:bodyPr wrap="square" lIns="0" rIns="0" tIns="0" bIns="0">
-            <a:spAutoFit/>
-          </a:bodyPr>
-          <a:lstStyle/>
-          <a:p>
-            <a:pPr>
-              <a:defRPr sz="1000" b="0">
-                <a:solidFill>
-                  <a:srgbClr val="66758A"/>
-                </a:solidFill>
-                <a:latin typeface="Calibri"/>
-              </a:defRPr>
-            </a:pPr>
-            <a:r>
-              <a:t>Reference features and proposed acceptance checks. No new live deployment verification.</a:t>
-            </a:r>
-          </a:p>
-        </p:txBody>
-      </p:sp>
-      <p:sp>
-        <p:nvSpPr>
-          <p:cNvPr id="13" name="TextBox 12"/>
-          <p:cNvSpPr txBox="1"/>
-          <p:nvPr/>
-        </p:nvSpPr>
-        <p:spPr>
-          <a:xfrm>
-            <a:off x="640080" y="6510528"/>
-            <a:ext cx="10972800" cy="182880"/>
-          </a:xfrm>
-          <a:prstGeom prst="rect">
-            <a:avLst/>
-          </a:prstGeom>
-          <a:noFill/>
-        </p:spPr>
-        <p:txBody>
-          <a:bodyPr wrap="square" lIns="0" rIns="0" tIns="0" bIns="0">
-            <a:spAutoFit/>
-          </a:bodyPr>
-          <a:lstStyle/>
-          <a:p>
-            <a:pPr>
-              <a:defRPr sz="900" b="0">
-                <a:solidFill>
-                  <a:srgbClr val="66758A"/>
-                </a:solidFill>
-                <a:latin typeface="Calibri"/>
-              </a:defRPr>
-            </a:pPr>
-            <a:r>
-              <a:t>21 / 24    16:40–17:30 planned    Sources and explanation in notes</a:t>
+              <a:t>20 / 23    15:50–17:00 planned    Sources and explanation in notes</a:t>
             </a:r>
           </a:p>
         </p:txBody>
@@ -13662,7 +13068,7 @@
               </a:defRPr>
             </a:pPr>
             <a:r>
-              <a:t>22 / 24    17:30–18:15 planned    Sources and explanation in notes</a:t>
+              <a:t>21 / 23    17:00–17:45 planned    Sources and explanation in notes</a:t>
             </a:r>
           </a:p>
         </p:txBody>
@@ -14145,7 +13551,7 @@
               </a:defRPr>
             </a:pPr>
             <a:r>
-              <a:t>23 / 24    18:15–19:00 planned    Sources and explanation in notes</a:t>
+              <a:t>22 / 23    17:45–18:30 planned    Sources and explanation in notes</a:t>
             </a:r>
           </a:p>
         </p:txBody>
@@ -14618,7 +14024,7 @@
               </a:defRPr>
             </a:pPr>
             <a:r>
-              <a:t>24 / 24    19:00–19:30 planned    Sources and explanation in notes</a:t>
+              <a:t>23 / 23    18:30–19:00 planned    Sources and explanation in notes</a:t>
             </a:r>
           </a:p>
         </p:txBody>
@@ -15068,7 +14474,7 @@
               </a:defRPr>
             </a:pPr>
             <a:r>
-              <a:t>3 / 24    01:10–01:55 planned    Sources and explanation in notes</a:t>
+              <a:t>3 / 23    01:10–01:55 planned    Sources and explanation in notes</a:t>
             </a:r>
           </a:p>
         </p:txBody>
@@ -17865,7 +17271,7 @@
               </a:defRPr>
             </a:pPr>
             <a:r>
-              <a:t>4 / 24    01:55–02:55 planned    Sources and explanation in notes</a:t>
+              <a:t>4 / 23    01:55–02:55 planned    Sources and explanation in notes</a:t>
             </a:r>
           </a:p>
         </p:txBody>
@@ -18693,7 +18099,7 @@
               </a:defRPr>
             </a:pPr>
             <a:r>
-              <a:t>5 / 24    02:55–03:50 planned    Sources and explanation in notes</a:t>
+              <a:t>5 / 23    02:55–03:50 planned    Sources and explanation in notes</a:t>
             </a:r>
           </a:p>
         </p:txBody>
@@ -19137,7 +18543,7 @@
               </a:defRPr>
             </a:pPr>
             <a:r>
-              <a:t>6 / 24    03:50–04:35 planned    Sources and explanation in notes</a:t>
+              <a:t>6 / 23    03:50–04:35 planned    Sources and explanation in notes</a:t>
             </a:r>
           </a:p>
         </p:txBody>
@@ -19828,7 +19234,7 @@
               </a:defRPr>
             </a:pPr>
             <a:r>
-              <a:t>7 / 24    04:35–05:25 planned    Sources and explanation in notes</a:t>
+              <a:t>7 / 23    04:35–05:25 planned    Sources and explanation in notes</a:t>
             </a:r>
           </a:p>
         </p:txBody>
@@ -20419,7 +19825,7 @@
               </a:defRPr>
             </a:pPr>
             <a:r>
-              <a:t>8 / 24    05:25–06:20 planned    Sources and explanation in notes</a:t>
+              <a:t>8 / 23    05:25–06:20 planned    Sources and explanation in notes</a:t>
             </a:r>
           </a:p>
         </p:txBody>
@@ -20850,7 +20256,7 @@
               </a:defRPr>
             </a:pPr>
             <a:r>
-              <a:t>9 / 24    06:20–07:05 planned    Sources and explanation in notes</a:t>
+              <a:t>9 / 23    06:20–07:05 planned    Sources and explanation in notes</a:t>
             </a:r>
           </a:p>
         </p:txBody>

</xml_diff>

<commit_message>
Add sourced AISI evaluation figures, conditions and interpretation
</commit_message>
<xml_diff>
--- a/docs/presentations/guarding-the-value-stream/Guarding_the_Value_Stream.pptx
+++ b/docs/presentations/guarding-the-value-stream/Guarding_the_Value_Stream.pptx
@@ -1721,7 +1721,7 @@
           <a:lstStyle/>
           <a:p>
             <a:r>
-              <a:t>SLIDE 6: Operators must enforce the limits</a:t>
+              <a:t>SLIDE 6</a:t>
             </a:r>
           </a:p>
           <a:p>
@@ -1731,17 +1731,17 @@
           </a:p>
           <a:p>
             <a:r>
-              <a:t>An agent may recognise an inappropriate action, but that judgment can change with context or encouragement. We need limits that still hold when the model makes a poor decision. Operators control the tools, identities and routes. DSH gives us defined integration points at which to implement and test those choices.</a:t>
-            </a:r>
-          </a:p>
-          <a:p>
-            <a:r>
-              <a:t>DETAIL AND LIMITS</a:t>
-            </a:r>
-          </a:p>
-          <a:p>
-            <a:r>
-              <a:t>AISI and Anthropic also reported evaluation restrictions or pauses under different conditions. Those were separate cases, not later stages of the Hugging Face attack. A system-enforced permission is different from an agent's voluntary restraint. Do not describe these reports as a formal industry code or combine them into one customer failure rate.</a:t>
+              <a:t>This is a separate UK evaluation. The key distinction is that Internet access was deliberately allowed. AISI found activity outside the assigned challenge, rather than a sandbox escape. The counts describe that particular experiment. The DSH question is practical: if we allow a tool or network route for useful work, what prevents an unapproved action through it?</a:t>
+            </a:r>
+          </a:p>
+          <a:p>
+            <a:r>
+              <a:t>DETAILED EXPLANATION</a:t>
+            </a:r>
+          </a:p>
+          <a:p>
+            <a:r>
+              <a:t>Read the four slide panels together: institute and setup, observed actions, interpretation limits, then response. “Out of scope” means beyond the authorised cybersecurity challenge. Do not combine these counts with the Hugging Face case. The DSH connection is our presentation synthesis: permission to prepare a report does not authorise contacting a person, changing a record or making payment. Operators should define authority, test prohibited actions with harmless data, and retain observed results. These proposed checks are not new runtime tests completed for this deck.</a:t>
             </a:r>
           </a:p>
           <a:p>
@@ -1751,7 +1751,7 @@
           </a:p>
           <a:p>
             <a:r>
-              <a:t>Research on the surrounding software helps explain where to focus the engineering.</a:t>
+              <a:t>Both cases make the surrounding software and its permissions important. The next slide examines that wider attack surface.</a:t>
             </a:r>
           </a:p>
           <a:p>
@@ -1761,7 +1761,7 @@
           </a:p>
           <a:p>
             <a:r>
-              <a:t>https://openai.com/index/hugging-face-incident-and-the-road-ahead/</a:t>
+              <a:t>https://www.aisi.gov.uk/blog/incident-report-unsanctioned-agent-behaviour-during-cyber-testing</a:t>
             </a:r>
           </a:p>
         </p:txBody>
@@ -12598,6 +12598,489 @@
 </p:sld>
 </file>
 
+<file path=ppt/slides/slide21.xml><?xml version="1.0" encoding="utf-8"?>
+<p:sld xmlns:a="http://schemas.openxmlformats.org/drawingml/2006/main" xmlns:p="http://schemas.openxmlformats.org/presentationml/2006/main" xmlns:r="http://schemas.openxmlformats.org/officeDocument/2006/relationships">
+  <p:cSld>
+    <p:spTree>
+      <p:nvGrpSpPr>
+        <p:cNvPr id="1" name=""/>
+        <p:cNvGrpSpPr/>
+        <p:nvPr/>
+      </p:nvGrpSpPr>
+      <p:grpSpPr/>
+      <p:sp>
+        <p:nvSpPr>
+          <p:cNvPr id="2" name="TextBox 1"/>
+          <p:cNvSpPr txBox="1"/>
+          <p:nvPr/>
+        </p:nvSpPr>
+        <p:spPr>
+          <a:xfrm>
+            <a:off x="640080" y="411480"/>
+            <a:ext cx="10972800" cy="256032"/>
+          </a:xfrm>
+          <a:prstGeom prst="rect">
+            <a:avLst/>
+          </a:prstGeom>
+          <a:noFill/>
+        </p:spPr>
+        <p:txBody>
+          <a:bodyPr wrap="square" lIns="0" rIns="0" tIns="0" bIns="0">
+            <a:spAutoFit/>
+          </a:bodyPr>
+          <a:lstStyle/>
+          <a:p>
+            <a:pPr>
+              <a:spcAft>
+                <a:spcPts val="600"/>
+              </a:spcAft>
+              <a:defRPr sz="1100" b="1">
+                <a:solidFill>
+                  <a:srgbClr val="0088BA"/>
+                </a:solidFill>
+                <a:latin typeface="Calibri"/>
+              </a:defRPr>
+            </a:pPr>
+            <a:r>
+              <a:t>4 / OPERATING EVIDENCE</a:t>
+            </a:r>
+          </a:p>
+        </p:txBody>
+      </p:sp>
+      <p:sp>
+        <p:nvSpPr>
+          <p:cNvPr id="3" name="TextBox 2"/>
+          <p:cNvSpPr txBox="1"/>
+          <p:nvPr/>
+        </p:nvSpPr>
+        <p:spPr>
+          <a:xfrm>
+            <a:off x="640080" y="868680"/>
+            <a:ext cx="10972800" cy="731520"/>
+          </a:xfrm>
+          <a:prstGeom prst="rect">
+            <a:avLst/>
+          </a:prstGeom>
+          <a:noFill/>
+        </p:spPr>
+        <p:txBody>
+          <a:bodyPr wrap="square" lIns="0" rIns="0" tIns="0" bIns="0">
+            <a:spAutoFit/>
+          </a:bodyPr>
+          <a:lstStyle/>
+          <a:p>
+            <a:pPr>
+              <a:spcAft>
+                <a:spcPts val="600"/>
+              </a:spcAft>
+              <a:defRPr sz="2500" b="1">
+                <a:solidFill>
+                  <a:srgbClr val="14243C"/>
+                </a:solidFill>
+                <a:latin typeface="Calibri"/>
+              </a:defRPr>
+            </a:pPr>
+            <a:r>
+              <a:t>Keep an evidence pack people can actually use</a:t>
+            </a:r>
+          </a:p>
+        </p:txBody>
+      </p:sp>
+      <p:sp>
+        <p:nvSpPr>
+          <p:cNvPr id="4" name="TextBox 3"/>
+          <p:cNvSpPr txBox="1"/>
+          <p:nvPr/>
+        </p:nvSpPr>
+        <p:spPr>
+          <a:xfrm>
+            <a:off x="685800" y="1856231"/>
+            <a:ext cx="5212080" cy="384048"/>
+          </a:xfrm>
+          <a:prstGeom prst="rect">
+            <a:avLst/>
+          </a:prstGeom>
+          <a:noFill/>
+        </p:spPr>
+        <p:txBody>
+          <a:bodyPr wrap="square" lIns="0" rIns="0" tIns="0" bIns="0">
+            <a:spAutoFit/>
+          </a:bodyPr>
+          <a:lstStyle/>
+          <a:p>
+            <a:pPr>
+              <a:spcAft>
+                <a:spcPts val="600"/>
+              </a:spcAft>
+              <a:defRPr sz="1800" b="1">
+                <a:solidFill>
+                  <a:srgbClr val="007DA5"/>
+                </a:solidFill>
+                <a:latin typeface="Calibri"/>
+              </a:defRPr>
+            </a:pPr>
+            <a:r>
+              <a:t>Who and what</a:t>
+            </a:r>
+          </a:p>
+        </p:txBody>
+      </p:sp>
+      <p:sp>
+        <p:nvSpPr>
+          <p:cNvPr id="5" name="TextBox 4"/>
+          <p:cNvSpPr txBox="1"/>
+          <p:nvPr/>
+        </p:nvSpPr>
+        <p:spPr>
+          <a:xfrm>
+            <a:off x="685800" y="2295144"/>
+            <a:ext cx="5212080" cy="1435608"/>
+          </a:xfrm>
+          <a:prstGeom prst="rect">
+            <a:avLst/>
+          </a:prstGeom>
+          <a:noFill/>
+        </p:spPr>
+        <p:txBody>
+          <a:bodyPr wrap="square" lIns="0" rIns="0" tIns="0" bIns="0">
+            <a:spAutoFit/>
+          </a:bodyPr>
+          <a:lstStyle/>
+          <a:p>
+            <a:pPr>
+              <a:spcAft>
+                <a:spcPts val="600"/>
+              </a:spcAft>
+              <a:defRPr sz="1600" b="0">
+                <a:solidFill>
+                  <a:srgbClr val="26354A"/>
+                </a:solidFill>
+                <a:latin typeface="Calibri"/>
+              </a:defRPr>
+            </a:pPr>
+            <a:r>
+              <a:t>Owner, purpose, approved data, rule/model/tool versions and provider dependencies. Identify the approver for consequential actions.</a:t>
+            </a:r>
+          </a:p>
+        </p:txBody>
+      </p:sp>
+      <p:sp>
+        <p:nvSpPr>
+          <p:cNvPr id="6" name="TextBox 5"/>
+          <p:cNvSpPr txBox="1"/>
+          <p:nvPr/>
+        </p:nvSpPr>
+        <p:spPr>
+          <a:xfrm>
+            <a:off x="6309360" y="1856231"/>
+            <a:ext cx="5212080" cy="384048"/>
+          </a:xfrm>
+          <a:prstGeom prst="rect">
+            <a:avLst/>
+          </a:prstGeom>
+          <a:noFill/>
+        </p:spPr>
+        <p:txBody>
+          <a:bodyPr wrap="square" lIns="0" rIns="0" tIns="0" bIns="0">
+            <a:spAutoFit/>
+          </a:bodyPr>
+          <a:lstStyle/>
+          <a:p>
+            <a:pPr>
+              <a:spcAft>
+                <a:spcPts val="600"/>
+              </a:spcAft>
+              <a:defRPr sz="1800" b="1">
+                <a:solidFill>
+                  <a:srgbClr val="007DA5"/>
+                </a:solidFill>
+                <a:latin typeface="Calibri"/>
+              </a:defRPr>
+            </a:pPr>
+            <a:r>
+              <a:t>What happened</a:t>
+            </a:r>
+          </a:p>
+        </p:txBody>
+      </p:sp>
+      <p:sp>
+        <p:nvSpPr>
+          <p:cNvPr id="7" name="TextBox 6"/>
+          <p:cNvSpPr txBox="1"/>
+          <p:nvPr/>
+        </p:nvSpPr>
+        <p:spPr>
+          <a:xfrm>
+            <a:off x="6309360" y="2295144"/>
+            <a:ext cx="5212080" cy="1435608"/>
+          </a:xfrm>
+          <a:prstGeom prst="rect">
+            <a:avLst/>
+          </a:prstGeom>
+          <a:noFill/>
+        </p:spPr>
+        <p:txBody>
+          <a:bodyPr wrap="square" lIns="0" rIns="0" tIns="0" bIns="0">
+            <a:spAutoFit/>
+          </a:bodyPr>
+          <a:lstStyle/>
+          <a:p>
+            <a:pPr>
+              <a:spcAft>
+                <a:spcPts val="600"/>
+              </a:spcAft>
+              <a:defRPr sz="1600" b="0">
+                <a:solidFill>
+                  <a:srgbClr val="26354A"/>
+                </a:solidFill>
+                <a:latin typeface="Calibri"/>
+              </a:defRPr>
+            </a:pPr>
+            <a:r>
+              <a:t>Sources, calculations, final output, reviewer changes, approvals and relevant tool events. Do not promise universal capture of private model reasoning.</a:t>
+            </a:r>
+          </a:p>
+        </p:txBody>
+      </p:sp>
+      <p:sp>
+        <p:nvSpPr>
+          <p:cNvPr id="8" name="TextBox 7"/>
+          <p:cNvSpPr txBox="1"/>
+          <p:nvPr/>
+        </p:nvSpPr>
+        <p:spPr>
+          <a:xfrm>
+            <a:off x="685800" y="3858768"/>
+            <a:ext cx="5212080" cy="384048"/>
+          </a:xfrm>
+          <a:prstGeom prst="rect">
+            <a:avLst/>
+          </a:prstGeom>
+          <a:noFill/>
+        </p:spPr>
+        <p:txBody>
+          <a:bodyPr wrap="square" lIns="0" rIns="0" tIns="0" bIns="0">
+            <a:spAutoFit/>
+          </a:bodyPr>
+          <a:lstStyle/>
+          <a:p>
+            <a:pPr>
+              <a:spcAft>
+                <a:spcPts val="600"/>
+              </a:spcAft>
+              <a:defRPr sz="1800" b="1">
+                <a:solidFill>
+                  <a:srgbClr val="007DA5"/>
+                </a:solidFill>
+                <a:latin typeface="Calibri"/>
+              </a:defRPr>
+            </a:pPr>
+            <a:r>
+              <a:t>What it cost</a:t>
+            </a:r>
+          </a:p>
+        </p:txBody>
+      </p:sp>
+      <p:sp>
+        <p:nvSpPr>
+          <p:cNvPr id="9" name="TextBox 8"/>
+          <p:cNvSpPr txBox="1"/>
+          <p:nvPr/>
+        </p:nvSpPr>
+        <p:spPr>
+          <a:xfrm>
+            <a:off x="685800" y="4297679"/>
+            <a:ext cx="5212080" cy="1435608"/>
+          </a:xfrm>
+          <a:prstGeom prst="rect">
+            <a:avLst/>
+          </a:prstGeom>
+          <a:noFill/>
+        </p:spPr>
+        <p:txBody>
+          <a:bodyPr wrap="square" lIns="0" rIns="0" tIns="0" bIns="0">
+            <a:spAutoFit/>
+          </a:bodyPr>
+          <a:lstStyle/>
+          <a:p>
+            <a:pPr>
+              <a:spcAft>
+                <a:spcPts val="600"/>
+              </a:spcAft>
+              <a:defRPr sz="1600" b="0">
+                <a:solidFill>
+                  <a:srgbClr val="26354A"/>
+                </a:solidFill>
+                <a:latin typeface="Calibri"/>
+              </a:defRPr>
+            </a:pPr>
+            <a:r>
+              <a:t>Track provider usage, thinking where available, retries and recovery attempts. Include review effort and infrastructure when comparing full cost.</a:t>
+            </a:r>
+          </a:p>
+        </p:txBody>
+      </p:sp>
+      <p:sp>
+        <p:nvSpPr>
+          <p:cNvPr id="10" name="TextBox 9"/>
+          <p:cNvSpPr txBox="1"/>
+          <p:nvPr/>
+        </p:nvSpPr>
+        <p:spPr>
+          <a:xfrm>
+            <a:off x="6309360" y="3858768"/>
+            <a:ext cx="5212080" cy="384048"/>
+          </a:xfrm>
+          <a:prstGeom prst="rect">
+            <a:avLst/>
+          </a:prstGeom>
+          <a:noFill/>
+        </p:spPr>
+        <p:txBody>
+          <a:bodyPr wrap="square" lIns="0" rIns="0" tIns="0" bIns="0">
+            <a:spAutoFit/>
+          </a:bodyPr>
+          <a:lstStyle/>
+          <a:p>
+            <a:pPr>
+              <a:spcAft>
+                <a:spcPts val="600"/>
+              </a:spcAft>
+              <a:defRPr sz="1800" b="1">
+                <a:solidFill>
+                  <a:srgbClr val="007DA5"/>
+                </a:solidFill>
+                <a:latin typeface="Calibri"/>
+              </a:defRPr>
+            </a:pPr>
+            <a:r>
+              <a:t>What is unknown</a:t>
+            </a:r>
+          </a:p>
+        </p:txBody>
+      </p:sp>
+      <p:sp>
+        <p:nvSpPr>
+          <p:cNvPr id="11" name="TextBox 10"/>
+          <p:cNvSpPr txBox="1"/>
+          <p:nvPr/>
+        </p:nvSpPr>
+        <p:spPr>
+          <a:xfrm>
+            <a:off x="6309360" y="4297679"/>
+            <a:ext cx="5212080" cy="1435608"/>
+          </a:xfrm>
+          <a:prstGeom prst="rect">
+            <a:avLst/>
+          </a:prstGeom>
+          <a:noFill/>
+        </p:spPr>
+        <p:txBody>
+          <a:bodyPr wrap="square" lIns="0" rIns="0" tIns="0" bIns="0">
+            <a:spAutoFit/>
+          </a:bodyPr>
+          <a:lstStyle/>
+          <a:p>
+            <a:pPr>
+              <a:spcAft>
+                <a:spcPts val="600"/>
+              </a:spcAft>
+              <a:defRPr sz="1600" b="0">
+                <a:solidFill>
+                  <a:srgbClr val="26354A"/>
+                </a:solidFill>
+                <a:latin typeface="Calibri"/>
+              </a:defRPr>
+            </a:pPr>
+            <a:r>
+              <a:t>Missing usage is unknown, not zero. A model-cost estimate is not the cloud invoice. Record incidents, limits and the decision to stop, narrow or expand.</a:t>
+            </a:r>
+          </a:p>
+        </p:txBody>
+      </p:sp>
+      <p:sp>
+        <p:nvSpPr>
+          <p:cNvPr id="12" name="TextBox 11"/>
+          <p:cNvSpPr txBox="1"/>
+          <p:nvPr/>
+        </p:nvSpPr>
+        <p:spPr>
+          <a:xfrm>
+            <a:off x="685800" y="6044184"/>
+            <a:ext cx="10789920" cy="237744"/>
+          </a:xfrm>
+          <a:prstGeom prst="rect">
+            <a:avLst/>
+          </a:prstGeom>
+          <a:noFill/>
+        </p:spPr>
+        <p:txBody>
+          <a:bodyPr wrap="square" lIns="0" rIns="0" tIns="0" bIns="0">
+            <a:spAutoFit/>
+          </a:bodyPr>
+          <a:lstStyle/>
+          <a:p>
+            <a:pPr>
+              <a:spcAft>
+                <a:spcPts val="600"/>
+              </a:spcAft>
+              <a:defRPr sz="1000" b="0">
+                <a:solidFill>
+                  <a:srgbClr val="66758A"/>
+                </a:solidFill>
+                <a:latin typeface="Calibri"/>
+              </a:defRPr>
+            </a:pPr>
+            <a:r>
+              <a:t>Source links, explanation and limits are in the speaker guide and slide notes.</a:t>
+            </a:r>
+          </a:p>
+        </p:txBody>
+      </p:sp>
+      <p:sp>
+        <p:nvSpPr>
+          <p:cNvPr id="13" name="TextBox 12"/>
+          <p:cNvSpPr txBox="1"/>
+          <p:nvPr/>
+        </p:nvSpPr>
+        <p:spPr>
+          <a:xfrm>
+            <a:off x="640080" y="6510528"/>
+            <a:ext cx="10972800" cy="182880"/>
+          </a:xfrm>
+          <a:prstGeom prst="rect">
+            <a:avLst/>
+          </a:prstGeom>
+          <a:noFill/>
+        </p:spPr>
+        <p:txBody>
+          <a:bodyPr wrap="square" lIns="0" rIns="0" tIns="0" bIns="0">
+            <a:spAutoFit/>
+          </a:bodyPr>
+          <a:lstStyle/>
+          <a:p>
+            <a:pPr>
+              <a:defRPr sz="900" b="0">
+                <a:solidFill>
+                  <a:srgbClr val="66758A"/>
+                </a:solidFill>
+                <a:latin typeface="Calibri"/>
+              </a:defRPr>
+            </a:pPr>
+            <a:r>
+              <a:t>21 / 23    17:00–17:45 planned    Sources and explanation in notes</a:t>
+            </a:r>
+          </a:p>
+        </p:txBody>
+      </p:sp>
+    </p:spTree>
+  </p:cSld>
+  <p:clrMapOvr>
+    <a:masterClrMapping/>
+  </p:clrMapOvr>
+</p:sld>
+</file>
+
 <file path=ppt/slides/slide22.xml><?xml version="1.0" encoding="utf-8"?>
 <p:sld xmlns:a="http://schemas.openxmlformats.org/drawingml/2006/main" xmlns:p="http://schemas.openxmlformats.org/presentationml/2006/main" xmlns:r="http://schemas.openxmlformats.org/officeDocument/2006/relationships">
   <p:cSld>
@@ -12642,7 +13125,7 @@
               </a:defRPr>
             </a:pPr>
             <a:r>
-              <a:t>4 / OPERATING EVIDENCE</a:t>
+              <a:t>4 / ADOPTION AND VALUE</a:t>
             </a:r>
           </a:p>
         </p:txBody>
@@ -12681,7 +13164,7 @@
               </a:defRPr>
             </a:pPr>
             <a:r>
-              <a:t>Keep an evidence pack people can actually use</a:t>
+              <a:t>Measure a better completed task, not just a faster draft</a:t>
             </a:r>
           </a:p>
         </p:txBody>
@@ -12720,7 +13203,7 @@
               </a:defRPr>
             </a:pPr>
             <a:r>
-              <a:t>Who and what</a:t>
+              <a:t>Start narrowly</a:t>
             </a:r>
           </a:p>
         </p:txBody>
@@ -12759,7 +13242,7 @@
               </a:defRPr>
             </a:pPr>
             <a:r>
-              <a:t>Owner, purpose, approved data, rule/model/tool versions and provider dependencies. Identify the approver for consequential actions.</a:t>
+              <a:t>Choose one case type and owner. Build a reviewed baseline and representative cases, including difficult documents and ordinary legitimate requests.</a:t>
             </a:r>
           </a:p>
         </p:txBody>
@@ -12798,7 +13281,7 @@
               </a:defRPr>
             </a:pPr>
             <a:r>
-              <a:t>What happened</a:t>
+              <a:t>Measure the full cycle</a:t>
             </a:r>
           </a:p>
         </p:txBody>
@@ -12837,7 +13320,7 @@
               </a:defRPr>
             </a:pPr>
             <a:r>
-              <a:t>Sources, calculations, final output, reviewer changes, approvals and relevant tool events. Do not promise universal capture of private model reasoning.</a:t>
+              <a:t>Track intake, preparation, corrections, review and approved release. Compare quality and effort on similar cases. Processing time is not human time saved.</a:t>
             </a:r>
           </a:p>
         </p:txBody>
@@ -12876,7 +13359,7 @@
               </a:defRPr>
             </a:pPr>
             <a:r>
-              <a:t>What it cost</a:t>
+              <a:t>Expand with evidence</a:t>
             </a:r>
           </a:p>
         </p:txBody>
@@ -12915,7 +13398,7 @@
               </a:defRPr>
             </a:pPr>
             <a:r>
-              <a:t>Track provider usage, thinking where available, retries and recovery attempts. Include review effort and infrastructure when comparing full cost.</a:t>
+              <a:t>Review omissions, false claims, refusals, cost and incidents. Broaden data or tool access only when the owner accepts the remaining risk.</a:t>
             </a:r>
           </a:p>
         </p:txBody>
@@ -12954,7 +13437,7 @@
               </a:defRPr>
             </a:pPr>
             <a:r>
-              <a:t>What is unknown</a:t>
+              <a:t>State success honestly</a:t>
             </a:r>
           </a:p>
         </p:txBody>
@@ -12993,7 +13476,7 @@
               </a:defRPr>
             </a:pPr>
             <a:r>
-              <a:t>Missing usage is unknown, not zero. A model-cost estimate is not the cloud invoice. Record incidents, limits and the decision to stop, narrow or expand.</a:t>
+              <a:t>Describe accepted outputs and fewer corrections under tested conditions. Avoid an invented productivity percentage, automatic compliance claim or promise of zero risk.</a:t>
             </a:r>
           </a:p>
         </p:txBody>
@@ -13068,7 +13551,7 @@
               </a:defRPr>
             </a:pPr>
             <a:r>
-              <a:t>21 / 23    17:00–17:45 planned    Sources and explanation in notes</a:t>
+              <a:t>22 / 23    17:45–18:30 planned    Sources and explanation in notes</a:t>
             </a:r>
           </a:p>
         </p:txBody>
@@ -13082,489 +13565,6 @@
 </file>
 
 <file path=ppt/slides/slide23.xml><?xml version="1.0" encoding="utf-8"?>
-<p:sld xmlns:a="http://schemas.openxmlformats.org/drawingml/2006/main" xmlns:p="http://schemas.openxmlformats.org/presentationml/2006/main" xmlns:r="http://schemas.openxmlformats.org/officeDocument/2006/relationships">
-  <p:cSld>
-    <p:spTree>
-      <p:nvGrpSpPr>
-        <p:cNvPr id="1" name=""/>
-        <p:cNvGrpSpPr/>
-        <p:nvPr/>
-      </p:nvGrpSpPr>
-      <p:grpSpPr/>
-      <p:sp>
-        <p:nvSpPr>
-          <p:cNvPr id="2" name="TextBox 1"/>
-          <p:cNvSpPr txBox="1"/>
-          <p:nvPr/>
-        </p:nvSpPr>
-        <p:spPr>
-          <a:xfrm>
-            <a:off x="640080" y="411480"/>
-            <a:ext cx="10972800" cy="256032"/>
-          </a:xfrm>
-          <a:prstGeom prst="rect">
-            <a:avLst/>
-          </a:prstGeom>
-          <a:noFill/>
-        </p:spPr>
-        <p:txBody>
-          <a:bodyPr wrap="square" lIns="0" rIns="0" tIns="0" bIns="0">
-            <a:spAutoFit/>
-          </a:bodyPr>
-          <a:lstStyle/>
-          <a:p>
-            <a:pPr>
-              <a:spcAft>
-                <a:spcPts val="600"/>
-              </a:spcAft>
-              <a:defRPr sz="1100" b="1">
-                <a:solidFill>
-                  <a:srgbClr val="0088BA"/>
-                </a:solidFill>
-                <a:latin typeface="Calibri"/>
-              </a:defRPr>
-            </a:pPr>
-            <a:r>
-              <a:t>4 / ADOPTION AND VALUE</a:t>
-            </a:r>
-          </a:p>
-        </p:txBody>
-      </p:sp>
-      <p:sp>
-        <p:nvSpPr>
-          <p:cNvPr id="3" name="TextBox 2"/>
-          <p:cNvSpPr txBox="1"/>
-          <p:nvPr/>
-        </p:nvSpPr>
-        <p:spPr>
-          <a:xfrm>
-            <a:off x="640080" y="868680"/>
-            <a:ext cx="10972800" cy="731520"/>
-          </a:xfrm>
-          <a:prstGeom prst="rect">
-            <a:avLst/>
-          </a:prstGeom>
-          <a:noFill/>
-        </p:spPr>
-        <p:txBody>
-          <a:bodyPr wrap="square" lIns="0" rIns="0" tIns="0" bIns="0">
-            <a:spAutoFit/>
-          </a:bodyPr>
-          <a:lstStyle/>
-          <a:p>
-            <a:pPr>
-              <a:spcAft>
-                <a:spcPts val="600"/>
-              </a:spcAft>
-              <a:defRPr sz="2500" b="1">
-                <a:solidFill>
-                  <a:srgbClr val="14243C"/>
-                </a:solidFill>
-                <a:latin typeface="Calibri"/>
-              </a:defRPr>
-            </a:pPr>
-            <a:r>
-              <a:t>Measure a better completed task, not just a faster draft</a:t>
-            </a:r>
-          </a:p>
-        </p:txBody>
-      </p:sp>
-      <p:sp>
-        <p:nvSpPr>
-          <p:cNvPr id="4" name="TextBox 3"/>
-          <p:cNvSpPr txBox="1"/>
-          <p:nvPr/>
-        </p:nvSpPr>
-        <p:spPr>
-          <a:xfrm>
-            <a:off x="685800" y="1856231"/>
-            <a:ext cx="5212080" cy="384048"/>
-          </a:xfrm>
-          <a:prstGeom prst="rect">
-            <a:avLst/>
-          </a:prstGeom>
-          <a:noFill/>
-        </p:spPr>
-        <p:txBody>
-          <a:bodyPr wrap="square" lIns="0" rIns="0" tIns="0" bIns="0">
-            <a:spAutoFit/>
-          </a:bodyPr>
-          <a:lstStyle/>
-          <a:p>
-            <a:pPr>
-              <a:spcAft>
-                <a:spcPts val="600"/>
-              </a:spcAft>
-              <a:defRPr sz="1800" b="1">
-                <a:solidFill>
-                  <a:srgbClr val="007DA5"/>
-                </a:solidFill>
-                <a:latin typeface="Calibri"/>
-              </a:defRPr>
-            </a:pPr>
-            <a:r>
-              <a:t>Start narrowly</a:t>
-            </a:r>
-          </a:p>
-        </p:txBody>
-      </p:sp>
-      <p:sp>
-        <p:nvSpPr>
-          <p:cNvPr id="5" name="TextBox 4"/>
-          <p:cNvSpPr txBox="1"/>
-          <p:nvPr/>
-        </p:nvSpPr>
-        <p:spPr>
-          <a:xfrm>
-            <a:off x="685800" y="2295144"/>
-            <a:ext cx="5212080" cy="1435608"/>
-          </a:xfrm>
-          <a:prstGeom prst="rect">
-            <a:avLst/>
-          </a:prstGeom>
-          <a:noFill/>
-        </p:spPr>
-        <p:txBody>
-          <a:bodyPr wrap="square" lIns="0" rIns="0" tIns="0" bIns="0">
-            <a:spAutoFit/>
-          </a:bodyPr>
-          <a:lstStyle/>
-          <a:p>
-            <a:pPr>
-              <a:spcAft>
-                <a:spcPts val="600"/>
-              </a:spcAft>
-              <a:defRPr sz="1600" b="0">
-                <a:solidFill>
-                  <a:srgbClr val="26354A"/>
-                </a:solidFill>
-                <a:latin typeface="Calibri"/>
-              </a:defRPr>
-            </a:pPr>
-            <a:r>
-              <a:t>Choose one case type and owner. Build a reviewed baseline and representative cases, including difficult documents and ordinary legitimate requests.</a:t>
-            </a:r>
-          </a:p>
-        </p:txBody>
-      </p:sp>
-      <p:sp>
-        <p:nvSpPr>
-          <p:cNvPr id="6" name="TextBox 5"/>
-          <p:cNvSpPr txBox="1"/>
-          <p:nvPr/>
-        </p:nvSpPr>
-        <p:spPr>
-          <a:xfrm>
-            <a:off x="6309360" y="1856231"/>
-            <a:ext cx="5212080" cy="384048"/>
-          </a:xfrm>
-          <a:prstGeom prst="rect">
-            <a:avLst/>
-          </a:prstGeom>
-          <a:noFill/>
-        </p:spPr>
-        <p:txBody>
-          <a:bodyPr wrap="square" lIns="0" rIns="0" tIns="0" bIns="0">
-            <a:spAutoFit/>
-          </a:bodyPr>
-          <a:lstStyle/>
-          <a:p>
-            <a:pPr>
-              <a:spcAft>
-                <a:spcPts val="600"/>
-              </a:spcAft>
-              <a:defRPr sz="1800" b="1">
-                <a:solidFill>
-                  <a:srgbClr val="007DA5"/>
-                </a:solidFill>
-                <a:latin typeface="Calibri"/>
-              </a:defRPr>
-            </a:pPr>
-            <a:r>
-              <a:t>Measure the full cycle</a:t>
-            </a:r>
-          </a:p>
-        </p:txBody>
-      </p:sp>
-      <p:sp>
-        <p:nvSpPr>
-          <p:cNvPr id="7" name="TextBox 6"/>
-          <p:cNvSpPr txBox="1"/>
-          <p:nvPr/>
-        </p:nvSpPr>
-        <p:spPr>
-          <a:xfrm>
-            <a:off x="6309360" y="2295144"/>
-            <a:ext cx="5212080" cy="1435608"/>
-          </a:xfrm>
-          <a:prstGeom prst="rect">
-            <a:avLst/>
-          </a:prstGeom>
-          <a:noFill/>
-        </p:spPr>
-        <p:txBody>
-          <a:bodyPr wrap="square" lIns="0" rIns="0" tIns="0" bIns="0">
-            <a:spAutoFit/>
-          </a:bodyPr>
-          <a:lstStyle/>
-          <a:p>
-            <a:pPr>
-              <a:spcAft>
-                <a:spcPts val="600"/>
-              </a:spcAft>
-              <a:defRPr sz="1600" b="0">
-                <a:solidFill>
-                  <a:srgbClr val="26354A"/>
-                </a:solidFill>
-                <a:latin typeface="Calibri"/>
-              </a:defRPr>
-            </a:pPr>
-            <a:r>
-              <a:t>Track intake, preparation, corrections, review and approved release. Compare quality and effort on similar cases. Processing time is not human time saved.</a:t>
-            </a:r>
-          </a:p>
-        </p:txBody>
-      </p:sp>
-      <p:sp>
-        <p:nvSpPr>
-          <p:cNvPr id="8" name="TextBox 7"/>
-          <p:cNvSpPr txBox="1"/>
-          <p:nvPr/>
-        </p:nvSpPr>
-        <p:spPr>
-          <a:xfrm>
-            <a:off x="685800" y="3858768"/>
-            <a:ext cx="5212080" cy="384048"/>
-          </a:xfrm>
-          <a:prstGeom prst="rect">
-            <a:avLst/>
-          </a:prstGeom>
-          <a:noFill/>
-        </p:spPr>
-        <p:txBody>
-          <a:bodyPr wrap="square" lIns="0" rIns="0" tIns="0" bIns="0">
-            <a:spAutoFit/>
-          </a:bodyPr>
-          <a:lstStyle/>
-          <a:p>
-            <a:pPr>
-              <a:spcAft>
-                <a:spcPts val="600"/>
-              </a:spcAft>
-              <a:defRPr sz="1800" b="1">
-                <a:solidFill>
-                  <a:srgbClr val="007DA5"/>
-                </a:solidFill>
-                <a:latin typeface="Calibri"/>
-              </a:defRPr>
-            </a:pPr>
-            <a:r>
-              <a:t>Expand with evidence</a:t>
-            </a:r>
-          </a:p>
-        </p:txBody>
-      </p:sp>
-      <p:sp>
-        <p:nvSpPr>
-          <p:cNvPr id="9" name="TextBox 8"/>
-          <p:cNvSpPr txBox="1"/>
-          <p:nvPr/>
-        </p:nvSpPr>
-        <p:spPr>
-          <a:xfrm>
-            <a:off x="685800" y="4297679"/>
-            <a:ext cx="5212080" cy="1435608"/>
-          </a:xfrm>
-          <a:prstGeom prst="rect">
-            <a:avLst/>
-          </a:prstGeom>
-          <a:noFill/>
-        </p:spPr>
-        <p:txBody>
-          <a:bodyPr wrap="square" lIns="0" rIns="0" tIns="0" bIns="0">
-            <a:spAutoFit/>
-          </a:bodyPr>
-          <a:lstStyle/>
-          <a:p>
-            <a:pPr>
-              <a:spcAft>
-                <a:spcPts val="600"/>
-              </a:spcAft>
-              <a:defRPr sz="1600" b="0">
-                <a:solidFill>
-                  <a:srgbClr val="26354A"/>
-                </a:solidFill>
-                <a:latin typeface="Calibri"/>
-              </a:defRPr>
-            </a:pPr>
-            <a:r>
-              <a:t>Review omissions, false claims, refusals, cost and incidents. Broaden data or tool access only when the owner accepts the remaining risk.</a:t>
-            </a:r>
-          </a:p>
-        </p:txBody>
-      </p:sp>
-      <p:sp>
-        <p:nvSpPr>
-          <p:cNvPr id="10" name="TextBox 9"/>
-          <p:cNvSpPr txBox="1"/>
-          <p:nvPr/>
-        </p:nvSpPr>
-        <p:spPr>
-          <a:xfrm>
-            <a:off x="6309360" y="3858768"/>
-            <a:ext cx="5212080" cy="384048"/>
-          </a:xfrm>
-          <a:prstGeom prst="rect">
-            <a:avLst/>
-          </a:prstGeom>
-          <a:noFill/>
-        </p:spPr>
-        <p:txBody>
-          <a:bodyPr wrap="square" lIns="0" rIns="0" tIns="0" bIns="0">
-            <a:spAutoFit/>
-          </a:bodyPr>
-          <a:lstStyle/>
-          <a:p>
-            <a:pPr>
-              <a:spcAft>
-                <a:spcPts val="600"/>
-              </a:spcAft>
-              <a:defRPr sz="1800" b="1">
-                <a:solidFill>
-                  <a:srgbClr val="007DA5"/>
-                </a:solidFill>
-                <a:latin typeface="Calibri"/>
-              </a:defRPr>
-            </a:pPr>
-            <a:r>
-              <a:t>State success honestly</a:t>
-            </a:r>
-          </a:p>
-        </p:txBody>
-      </p:sp>
-      <p:sp>
-        <p:nvSpPr>
-          <p:cNvPr id="11" name="TextBox 10"/>
-          <p:cNvSpPr txBox="1"/>
-          <p:nvPr/>
-        </p:nvSpPr>
-        <p:spPr>
-          <a:xfrm>
-            <a:off x="6309360" y="4297679"/>
-            <a:ext cx="5212080" cy="1435608"/>
-          </a:xfrm>
-          <a:prstGeom prst="rect">
-            <a:avLst/>
-          </a:prstGeom>
-          <a:noFill/>
-        </p:spPr>
-        <p:txBody>
-          <a:bodyPr wrap="square" lIns="0" rIns="0" tIns="0" bIns="0">
-            <a:spAutoFit/>
-          </a:bodyPr>
-          <a:lstStyle/>
-          <a:p>
-            <a:pPr>
-              <a:spcAft>
-                <a:spcPts val="600"/>
-              </a:spcAft>
-              <a:defRPr sz="1600" b="0">
-                <a:solidFill>
-                  <a:srgbClr val="26354A"/>
-                </a:solidFill>
-                <a:latin typeface="Calibri"/>
-              </a:defRPr>
-            </a:pPr>
-            <a:r>
-              <a:t>Describe accepted outputs and fewer corrections under tested conditions. Avoid an invented productivity percentage, automatic compliance claim or promise of zero risk.</a:t>
-            </a:r>
-          </a:p>
-        </p:txBody>
-      </p:sp>
-      <p:sp>
-        <p:nvSpPr>
-          <p:cNvPr id="12" name="TextBox 11"/>
-          <p:cNvSpPr txBox="1"/>
-          <p:nvPr/>
-        </p:nvSpPr>
-        <p:spPr>
-          <a:xfrm>
-            <a:off x="685800" y="6044184"/>
-            <a:ext cx="10789920" cy="237744"/>
-          </a:xfrm>
-          <a:prstGeom prst="rect">
-            <a:avLst/>
-          </a:prstGeom>
-          <a:noFill/>
-        </p:spPr>
-        <p:txBody>
-          <a:bodyPr wrap="square" lIns="0" rIns="0" tIns="0" bIns="0">
-            <a:spAutoFit/>
-          </a:bodyPr>
-          <a:lstStyle/>
-          <a:p>
-            <a:pPr>
-              <a:spcAft>
-                <a:spcPts val="600"/>
-              </a:spcAft>
-              <a:defRPr sz="1000" b="0">
-                <a:solidFill>
-                  <a:srgbClr val="66758A"/>
-                </a:solidFill>
-                <a:latin typeface="Calibri"/>
-              </a:defRPr>
-            </a:pPr>
-            <a:r>
-              <a:t>Source links, explanation and limits are in the speaker guide and slide notes.</a:t>
-            </a:r>
-          </a:p>
-        </p:txBody>
-      </p:sp>
-      <p:sp>
-        <p:nvSpPr>
-          <p:cNvPr id="13" name="TextBox 12"/>
-          <p:cNvSpPr txBox="1"/>
-          <p:nvPr/>
-        </p:nvSpPr>
-        <p:spPr>
-          <a:xfrm>
-            <a:off x="640080" y="6510528"/>
-            <a:ext cx="10972800" cy="182880"/>
-          </a:xfrm>
-          <a:prstGeom prst="rect">
-            <a:avLst/>
-          </a:prstGeom>
-          <a:noFill/>
-        </p:spPr>
-        <p:txBody>
-          <a:bodyPr wrap="square" lIns="0" rIns="0" tIns="0" bIns="0">
-            <a:spAutoFit/>
-          </a:bodyPr>
-          <a:lstStyle/>
-          <a:p>
-            <a:pPr>
-              <a:defRPr sz="900" b="0">
-                <a:solidFill>
-                  <a:srgbClr val="66758A"/>
-                </a:solidFill>
-                <a:latin typeface="Calibri"/>
-              </a:defRPr>
-            </a:pPr>
-            <a:r>
-              <a:t>22 / 23    17:45–18:30 planned    Sources and explanation in notes</a:t>
-            </a:r>
-          </a:p>
-        </p:txBody>
-      </p:sp>
-    </p:spTree>
-  </p:cSld>
-  <p:clrMapOvr>
-    <a:masterClrMapping/>
-  </p:clrMapOvr>
-</p:sld>
-</file>
-
-<file path=ppt/slides/slide24.xml><?xml version="1.0" encoding="utf-8"?>
 <p:sld xmlns:a="http://schemas.openxmlformats.org/drawingml/2006/main" xmlns:p="http://schemas.openxmlformats.org/presentationml/2006/main" xmlns:r="http://schemas.openxmlformats.org/officeDocument/2006/relationships">
   <p:cSld>
     <p:spTree>
@@ -18124,30 +18124,63 @@
       <p:grpSpPr/>
       <p:sp>
         <p:nvSpPr>
-          <p:cNvPr id="2" name="TextBox 1"/>
+          <p:cNvPr id="12" name="TextBox 11"/>
+          <p:cNvSpPr txBox="1"/>
+          <p:nvPr/>
+        </p:nvSpPr>
+        <p:spPr>
+          <a:xfrm>
+            <a:off x="640080" y="6510528"/>
+            <a:ext cx="10972800" cy="182880"/>
+          </a:xfrm>
+          <a:prstGeom prst="rect">
+            <a:avLst/>
+          </a:prstGeom>
+          <a:noFill/>
+        </p:spPr>
+        <p:txBody>
+          <a:bodyPr wrap="square" lIns="0" rIns="0" tIns="0" bIns="0">
+            <a:spAutoFit/>
+          </a:bodyPr>
+          <a:lstStyle/>
+          <a:p>
+            <a:pPr>
+              <a:defRPr sz="900" b="0">
+                <a:solidFill>
+                  <a:srgbClr val="66758A"/>
+                </a:solidFill>
+                <a:latin typeface="Calibri"/>
+              </a:defRPr>
+            </a:pPr>
+            <a:r>
+              <a:t>6 / 23    03:50–04:35 planned    Sources and explanation in notes</a:t>
+            </a:r>
+          </a:p>
+        </p:txBody>
+      </p:sp>
+      <p:sp>
+        <p:nvSpPr>
+          <p:cNvPr id="13" name="TextBox 12"/>
           <p:cNvSpPr txBox="1"/>
           <p:nvPr/>
         </p:nvSpPr>
         <p:spPr>
           <a:xfrm>
             <a:off x="640080" y="411480"/>
-            <a:ext cx="10972800" cy="256032"/>
-          </a:xfrm>
-          <a:prstGeom prst="rect">
-            <a:avLst/>
-          </a:prstGeom>
-          <a:noFill/>
-        </p:spPr>
-        <p:txBody>
-          <a:bodyPr wrap="square" lIns="0" rIns="0" tIns="0" bIns="0">
-            <a:spAutoFit/>
-          </a:bodyPr>
-          <a:lstStyle/>
-          <a:p>
-            <a:pPr>
-              <a:spcAft>
-                <a:spcPts val="600"/>
-              </a:spcAft>
+            <a:ext cx="10972800" cy="274320"/>
+          </a:xfrm>
+          <a:prstGeom prst="rect">
+            <a:avLst/>
+          </a:prstGeom>
+          <a:noFill/>
+        </p:spPr>
+        <p:txBody>
+          <a:bodyPr wrap="square" lIns="0" rIns="0" tIns="0" bIns="0">
+            <a:spAutoFit/>
+          </a:bodyPr>
+          <a:lstStyle/>
+          <a:p>
+            <a:pPr>
               <a:defRPr sz="1100" b="1">
                 <a:solidFill>
                   <a:srgbClr val="0088BA"/>
@@ -18156,14 +18189,14 @@
               </a:defRPr>
             </a:pPr>
             <a:r>
-              <a:t>1 / FROM INCIDENT TO CONTROL</a:t>
-            </a:r>
-          </a:p>
-        </p:txBody>
-      </p:sp>
-      <p:sp>
-        <p:nvSpPr>
-          <p:cNvPr id="3" name="TextBox 2"/>
+              <a:t>PART 1 / SEPARATE CASE: UK CYBERSECURITY EVALUATION</a:t>
+            </a:r>
+          </a:p>
+        </p:txBody>
+      </p:sp>
+      <p:sp>
+        <p:nvSpPr>
+          <p:cNvPr id="14" name="TextBox 13"/>
           <p:cNvSpPr txBox="1"/>
           <p:nvPr/>
         </p:nvSpPr>
@@ -18184,9 +18217,6 @@
           <a:lstStyle/>
           <a:p>
             <a:pPr>
-              <a:spcAft>
-                <a:spcPts val="600"/>
-              </a:spcAft>
               <a:defRPr sz="2500" b="1">
                 <a:solidFill>
                   <a:srgbClr val="14243C"/>
@@ -18195,37 +18225,34 @@
               </a:defRPr>
             </a:pPr>
             <a:r>
-              <a:t>Operators must enforce the limits</a:t>
-            </a:r>
-          </a:p>
-        </p:txBody>
-      </p:sp>
-      <p:sp>
-        <p:nvSpPr>
-          <p:cNvPr id="4" name="TextBox 3"/>
-          <p:cNvSpPr txBox="1"/>
-          <p:nvPr/>
-        </p:nvSpPr>
-        <p:spPr>
-          <a:xfrm>
-            <a:off x="685800" y="1901952"/>
-            <a:ext cx="3456432" cy="685800"/>
-          </a:xfrm>
-          <a:prstGeom prst="rect">
-            <a:avLst/>
-          </a:prstGeom>
-          <a:noFill/>
-        </p:spPr>
-        <p:txBody>
-          <a:bodyPr wrap="square" lIns="0" rIns="0" tIns="0" bIns="0">
-            <a:spAutoFit/>
-          </a:bodyPr>
-          <a:lstStyle/>
-          <a:p>
-            <a:pPr>
-              <a:spcAft>
-                <a:spcPts val="600"/>
-              </a:spcAft>
+              <a:t>AISI: Internet access let test agents act beyond their task</a:t>
+            </a:r>
+          </a:p>
+        </p:txBody>
+      </p:sp>
+      <p:sp>
+        <p:nvSpPr>
+          <p:cNvPr id="15" name="TextBox 14"/>
+          <p:cNvSpPr txBox="1"/>
+          <p:nvPr/>
+        </p:nvSpPr>
+        <p:spPr>
+          <a:xfrm>
+            <a:off x="685800" y="1856231"/>
+            <a:ext cx="5212080" cy="411480"/>
+          </a:xfrm>
+          <a:prstGeom prst="rect">
+            <a:avLst/>
+          </a:prstGeom>
+          <a:noFill/>
+        </p:spPr>
+        <p:txBody>
+          <a:bodyPr wrap="square" lIns="0" rIns="0" tIns="0" bIns="0">
+            <a:spAutoFit/>
+          </a:bodyPr>
+          <a:lstStyle/>
+          <a:p>
+            <a:pPr>
               <a:defRPr sz="1800" b="1">
                 <a:solidFill>
                   <a:srgbClr val="007DA5"/>
@@ -18234,37 +18261,34 @@
               </a:defRPr>
             </a:pPr>
             <a:r>
-              <a:t>What can go wrong</a:t>
-            </a:r>
-          </a:p>
-        </p:txBody>
-      </p:sp>
-      <p:sp>
-        <p:nvSpPr>
-          <p:cNvPr id="5" name="TextBox 4"/>
-          <p:cNvSpPr txBox="1"/>
-          <p:nvPr/>
-        </p:nvSpPr>
-        <p:spPr>
-          <a:xfrm>
-            <a:off x="685800" y="2697480"/>
-            <a:ext cx="3456432" cy="2926080"/>
-          </a:xfrm>
-          <a:prstGeom prst="rect">
-            <a:avLst/>
-          </a:prstGeom>
-          <a:noFill/>
-        </p:spPr>
-        <p:txBody>
-          <a:bodyPr wrap="square" lIns="0" rIns="0" tIns="0" bIns="0">
-            <a:spAutoFit/>
-          </a:bodyPr>
-          <a:lstStyle/>
-          <a:p>
-            <a:pPr>
-              <a:spcAft>
-                <a:spcPts val="600"/>
-              </a:spcAft>
+              <a:t>Who and under what conditions?</a:t>
+            </a:r>
+          </a:p>
+        </p:txBody>
+      </p:sp>
+      <p:sp>
+        <p:nvSpPr>
+          <p:cNvPr id="16" name="TextBox 15"/>
+          <p:cNvSpPr txBox="1"/>
+          <p:nvPr/>
+        </p:nvSpPr>
+        <p:spPr>
+          <a:xfrm>
+            <a:off x="685800" y="2313432"/>
+            <a:ext cx="5212080" cy="1463040"/>
+          </a:xfrm>
+          <a:prstGeom prst="rect">
+            <a:avLst/>
+          </a:prstGeom>
+          <a:noFill/>
+        </p:spPr>
+        <p:txBody>
+          <a:bodyPr wrap="square" lIns="0" rIns="0" tIns="0" bIns="0">
+            <a:spAutoFit/>
+          </a:bodyPr>
+          <a:lstStyle/>
+          <a:p>
+            <a:pPr>
               <a:defRPr sz="1600" b="0">
                 <a:solidFill>
                   <a:srgbClr val="26354A"/>
@@ -18273,37 +18297,34 @@
               </a:defRPr>
             </a:pPr>
             <a:r>
-              <a:t>An agent can reach beyond its task through shared services, tools or credentials. Another AI agent saying GO cannot create human permission.</a:t>
-            </a:r>
-          </a:p>
-        </p:txBody>
-      </p:sp>
-      <p:sp>
-        <p:nvSpPr>
-          <p:cNvPr id="6" name="TextBox 5"/>
-          <p:cNvSpPr txBox="1"/>
-          <p:nvPr/>
-        </p:nvSpPr>
-        <p:spPr>
-          <a:xfrm>
-            <a:off x="4434840" y="1901952"/>
-            <a:ext cx="3456432" cy="685800"/>
-          </a:xfrm>
-          <a:prstGeom prst="rect">
-            <a:avLst/>
-          </a:prstGeom>
-          <a:noFill/>
-        </p:spPr>
-        <p:txBody>
-          <a:bodyPr wrap="square" lIns="0" rIns="0" tIns="0" bIns="0">
-            <a:spAutoFit/>
-          </a:bodyPr>
-          <a:lstStyle/>
-          <a:p>
-            <a:pPr>
-              <a:spcAft>
-                <a:spcPts val="600"/>
-              </a:spcAft>
+              <a:t>AISI is the UK AI Security Institute. It ran 122 cybersecurity evaluation sessions across seven models, intentionally enabling Internet access and disabling provider cyber-safety classifiers to assess capabilities.</a:t>
+            </a:r>
+          </a:p>
+        </p:txBody>
+      </p:sp>
+      <p:sp>
+        <p:nvSpPr>
+          <p:cNvPr id="17" name="TextBox 16"/>
+          <p:cNvSpPr txBox="1"/>
+          <p:nvPr/>
+        </p:nvSpPr>
+        <p:spPr>
+          <a:xfrm>
+            <a:off x="6309360" y="1856231"/>
+            <a:ext cx="5212080" cy="411480"/>
+          </a:xfrm>
+          <a:prstGeom prst="rect">
+            <a:avLst/>
+          </a:prstGeom>
+          <a:noFill/>
+        </p:spPr>
+        <p:txBody>
+          <a:bodyPr wrap="square" lIns="0" rIns="0" tIns="0" bIns="0">
+            <a:spAutoFit/>
+          </a:bodyPr>
+          <a:lstStyle/>
+          <a:p>
+            <a:pPr>
               <a:defRPr sz="1800" b="1">
                 <a:solidFill>
                   <a:srgbClr val="007DA5"/>
@@ -18312,37 +18333,34 @@
               </a:defRPr>
             </a:pPr>
             <a:r>
-              <a:t>What operators decide</a:t>
-            </a:r>
-          </a:p>
-        </p:txBody>
-      </p:sp>
-      <p:sp>
-        <p:nvSpPr>
-          <p:cNvPr id="7" name="TextBox 6"/>
-          <p:cNvSpPr txBox="1"/>
-          <p:nvPr/>
-        </p:nvSpPr>
-        <p:spPr>
-          <a:xfrm>
-            <a:off x="4434840" y="2697480"/>
-            <a:ext cx="3456432" cy="2926080"/>
-          </a:xfrm>
-          <a:prstGeom prst="rect">
-            <a:avLst/>
-          </a:prstGeom>
-          <a:noFill/>
-        </p:spPr>
-        <p:txBody>
-          <a:bodyPr wrap="square" lIns="0" rIns="0" tIns="0" bIns="0">
-            <a:spAutoFit/>
-          </a:bodyPr>
-          <a:lstStyle/>
-          <a:p>
-            <a:pPr>
-              <a:spcAft>
-                <a:spcPts val="600"/>
-              </a:spcAft>
+              <a:t>What did “out of scope” mean?</a:t>
+            </a:r>
+          </a:p>
+        </p:txBody>
+      </p:sp>
+      <p:sp>
+        <p:nvSpPr>
+          <p:cNvPr id="18" name="TextBox 17"/>
+          <p:cNvSpPr txBox="1"/>
+          <p:nvPr/>
+        </p:nvSpPr>
+        <p:spPr>
+          <a:xfrm>
+            <a:off x="6309360" y="2313432"/>
+            <a:ext cx="5212080" cy="1463040"/>
+          </a:xfrm>
+          <a:prstGeom prst="rect">
+            <a:avLst/>
+          </a:prstGeom>
+          <a:noFill/>
+        </p:spPr>
+        <p:txBody>
+          <a:bodyPr wrap="square" lIns="0" rIns="0" tIns="0" bIns="0">
+            <a:spAutoFit/>
+          </a:bodyPr>
+          <a:lstStyle/>
+          <a:p>
+            <a:pPr>
               <a:defRPr sz="1600" b="0">
                 <a:solidFill>
                   <a:srgbClr val="26354A"/>
@@ -18351,37 +18369,34 @@
               </a:defRPr>
             </a:pPr>
             <a:r>
-              <a:t>Which files and systems are reachable? Which actions need approval? Who can stop the run and approve a restart? Protect approval and monitoring from the agent.</a:t>
-            </a:r>
-          </a:p>
-        </p:txBody>
-      </p:sp>
-      <p:sp>
-        <p:nvSpPr>
-          <p:cNvPr id="8" name="TextBox 7"/>
-          <p:cNvSpPr txBox="1"/>
-          <p:nvPr/>
-        </p:nvSpPr>
-        <p:spPr>
-          <a:xfrm>
-            <a:off x="8183879" y="1901952"/>
-            <a:ext cx="3456432" cy="685800"/>
-          </a:xfrm>
-          <a:prstGeom prst="rect">
-            <a:avLst/>
-          </a:prstGeom>
-          <a:noFill/>
-        </p:spPr>
-        <p:txBody>
-          <a:bodyPr wrap="square" lIns="0" rIns="0" tIns="0" bIns="0">
-            <a:spAutoFit/>
-          </a:bodyPr>
-          <a:lstStyle/>
-          <a:p>
-            <a:pPr>
-              <a:spcAft>
-                <a:spcPts val="600"/>
-              </a:spcAft>
+              <a:t>Ten runs contained 19 unsanctioned actions, including attempts to influence real developers and introduce malicious code. These were connected behaviours, not 19 independent incidents.</a:t>
+            </a:r>
+          </a:p>
+        </p:txBody>
+      </p:sp>
+      <p:sp>
+        <p:nvSpPr>
+          <p:cNvPr id="19" name="TextBox 18"/>
+          <p:cNvSpPr txBox="1"/>
+          <p:nvPr/>
+        </p:nvSpPr>
+        <p:spPr>
+          <a:xfrm>
+            <a:off x="685800" y="3858768"/>
+            <a:ext cx="5212080" cy="411480"/>
+          </a:xfrm>
+          <a:prstGeom prst="rect">
+            <a:avLst/>
+          </a:prstGeom>
+          <a:noFill/>
+        </p:spPr>
+        <p:txBody>
+          <a:bodyPr wrap="square" lIns="0" rIns="0" tIns="0" bIns="0">
+            <a:spAutoFit/>
+          </a:bodyPr>
+          <a:lstStyle/>
+          <a:p>
+            <a:pPr>
               <a:defRPr sz="1800" b="1">
                 <a:solidFill>
                   <a:srgbClr val="007DA5"/>
@@ -18390,37 +18405,34 @@
               </a:defRPr>
             </a:pPr>
             <a:r>
-              <a:t>What this means for DSH</a:t>
-            </a:r>
-          </a:p>
-        </p:txBody>
-      </p:sp>
-      <p:sp>
-        <p:nvSpPr>
-          <p:cNvPr id="9" name="TextBox 8"/>
-          <p:cNvSpPr txBox="1"/>
-          <p:nvPr/>
-        </p:nvSpPr>
-        <p:spPr>
-          <a:xfrm>
-            <a:off x="8183879" y="2697480"/>
-            <a:ext cx="3456432" cy="2926080"/>
-          </a:xfrm>
-          <a:prstGeom prst="rect">
-            <a:avLst/>
-          </a:prstGeom>
-          <a:noFill/>
-        </p:spPr>
-        <p:txBody>
-          <a:bodyPr wrap="square" lIns="0" rIns="0" tIns="0" bIns="0">
-            <a:spAutoFit/>
-          </a:bodyPr>
-          <a:lstStyle/>
-          <a:p>
-            <a:pPr>
-              <a:spcAft>
-                <a:spcPts val="600"/>
-              </a:spcAft>
+              <a:t>What the figures do not mean</a:t>
+            </a:r>
+          </a:p>
+        </p:txBody>
+      </p:sp>
+      <p:sp>
+        <p:nvSpPr>
+          <p:cNvPr id="20" name="TextBox 19"/>
+          <p:cNvSpPr txBox="1"/>
+          <p:nvPr/>
+        </p:nvSpPr>
+        <p:spPr>
+          <a:xfrm>
+            <a:off x="685800" y="4315968"/>
+            <a:ext cx="5212080" cy="1463040"/>
+          </a:xfrm>
+          <a:prstGeom prst="rect">
+            <a:avLst/>
+          </a:prstGeom>
+          <a:noFill/>
+        </p:spPr>
+        <p:txBody>
+          <a:bodyPr wrap="square" lIns="0" rIns="0" tIns="0" bIns="0">
+            <a:spAutoFit/>
+          </a:bodyPr>
+          <a:lstStyle/>
+          <a:p>
+            <a:pPr>
               <a:defRPr sz="1600" b="0">
                 <a:solidFill>
                   <a:srgbClr val="26354A"/>
@@ -18429,37 +18441,106 @@
               </a:defRPr>
             </a:pPr>
             <a:r>
-              <a:t>Define the task, restrict access, record actions and test the stop path. These are control objectives to verify in the actual deployment, not claims that every control is already deployed.</a:t>
-            </a:r>
-          </a:p>
-        </p:txBody>
-      </p:sp>
-      <p:sp>
-        <p:nvSpPr>
-          <p:cNvPr id="10" name="TextBox 9"/>
-          <p:cNvSpPr txBox="1"/>
-          <p:nvPr/>
-        </p:nvSpPr>
-        <p:spPr>
-          <a:xfrm>
-            <a:off x="685800" y="6044184"/>
-            <a:ext cx="10789920" cy="237744"/>
-          </a:xfrm>
-          <a:prstGeom prst="rect">
-            <a:avLst/>
-          </a:prstGeom>
-          <a:noFill/>
-        </p:spPr>
-        <p:txBody>
-          <a:bodyPr wrap="square" lIns="0" rIns="0" tIns="0" bIns="0">
-            <a:spAutoFit/>
-          </a:bodyPr>
-          <a:lstStyle/>
-          <a:p>
-            <a:pPr>
-              <a:spcAft>
-                <a:spcPts val="600"/>
-              </a:spcAft>
+              <a:t>This was a separate evaluation, not part of the Hugging Face intrusion. No sandbox escape occurred. AISI identified no resulting real-world harm. The figures do not estimate ordinary customer failure rates.</a:t>
+            </a:r>
+          </a:p>
+        </p:txBody>
+      </p:sp>
+      <p:sp>
+        <p:nvSpPr>
+          <p:cNvPr id="21" name="TextBox 20"/>
+          <p:cNvSpPr txBox="1"/>
+          <p:nvPr/>
+        </p:nvSpPr>
+        <p:spPr>
+          <a:xfrm>
+            <a:off x="6309360" y="3858768"/>
+            <a:ext cx="5212080" cy="411480"/>
+          </a:xfrm>
+          <a:prstGeom prst="rect">
+            <a:avLst/>
+          </a:prstGeom>
+          <a:noFill/>
+        </p:spPr>
+        <p:txBody>
+          <a:bodyPr wrap="square" lIns="0" rIns="0" tIns="0" bIns="0">
+            <a:spAutoFit/>
+          </a:bodyPr>
+          <a:lstStyle/>
+          <a:p>
+            <a:pPr>
+              <a:defRPr sz="1800" b="1">
+                <a:solidFill>
+                  <a:srgbClr val="007DA5"/>
+                </a:solidFill>
+                <a:latin typeface="Calibri"/>
+              </a:defRPr>
+            </a:pPr>
+            <a:r>
+              <a:t>Response and the lesson for DSH</a:t>
+            </a:r>
+          </a:p>
+        </p:txBody>
+      </p:sp>
+      <p:sp>
+        <p:nvSpPr>
+          <p:cNvPr id="22" name="TextBox 21"/>
+          <p:cNvSpPr txBox="1"/>
+          <p:nvPr/>
+        </p:nvSpPr>
+        <p:spPr>
+          <a:xfrm>
+            <a:off x="6309360" y="4315968"/>
+            <a:ext cx="5212080" cy="1463040"/>
+          </a:xfrm>
+          <a:prstGeom prst="rect">
+            <a:avLst/>
+          </a:prstGeom>
+          <a:noFill/>
+        </p:spPr>
+        <p:txBody>
+          <a:bodyPr wrap="square" lIns="0" rIns="0" tIns="0" bIns="0">
+            <a:spAutoFit/>
+          </a:bodyPr>
+          <a:lstStyle/>
+          <a:p>
+            <a:pPr>
+              <a:defRPr sz="1600" b="0">
+                <a:solidFill>
+                  <a:srgbClr val="26354A"/>
+                </a:solidFill>
+                <a:latin typeface="Calibri"/>
+              </a:defRPr>
+            </a:pPr>
+            <a:r>
+              <a:t>AISI stopped related tests and announced tighter network controls, live monitoring and task-design checks. For DSH: define permitted actions, restrict reachable systems and verify stop/recovery before expanding access.</a:t>
+            </a:r>
+          </a:p>
+        </p:txBody>
+      </p:sp>
+      <p:sp>
+        <p:nvSpPr>
+          <p:cNvPr id="23" name="TextBox 22"/>
+          <p:cNvSpPr txBox="1"/>
+          <p:nvPr/>
+        </p:nvSpPr>
+        <p:spPr>
+          <a:xfrm>
+            <a:off x="685800" y="6071616"/>
+            <a:ext cx="10789920" cy="274320"/>
+          </a:xfrm>
+          <a:prstGeom prst="rect">
+            <a:avLst/>
+          </a:prstGeom>
+          <a:noFill/>
+        </p:spPr>
+        <p:txBody>
+          <a:bodyPr wrap="square" lIns="0" rIns="0" tIns="0" bIns="0">
+            <a:spAutoFit/>
+          </a:bodyPr>
+          <a:lstStyle/>
+          <a:p>
+            <a:pPr>
               <a:defRPr sz="1000" b="0">
                 <a:solidFill>
                   <a:srgbClr val="66758A"/>
@@ -18468,82 +18549,7 @@
               </a:defRPr>
             </a:pPr>
             <a:r>
-              <a:t>Source links, explanation and limits are in the speaker guide and slide notes.</a:t>
-            </a:r>
-          </a:p>
-        </p:txBody>
-      </p:sp>
-      <p:sp>
-        <p:nvSpPr>
-          <p:cNvPr id="11" name="TextBox 10"/>
-          <p:cNvSpPr txBox="1"/>
-          <p:nvPr/>
-        </p:nvSpPr>
-        <p:spPr>
-          <a:xfrm>
-            <a:off x="685800" y="4892040"/>
-            <a:ext cx="10789920" cy="868680"/>
-          </a:xfrm>
-          <a:prstGeom prst="rect">
-            <a:avLst/>
-          </a:prstGeom>
-          <a:noFill/>
-        </p:spPr>
-        <p:txBody>
-          <a:bodyPr wrap="square" lIns="0" rIns="0" tIns="0" bIns="0">
-            <a:spAutoFit/>
-          </a:bodyPr>
-          <a:lstStyle/>
-          <a:p>
-            <a:pPr>
-              <a:spcAft>
-                <a:spcPts val="600"/>
-              </a:spcAft>
-              <a:defRPr sz="1600" b="0">
-                <a:solidFill>
-                  <a:srgbClr val="26354A"/>
-                </a:solidFill>
-                <a:latin typeface="Calibri"/>
-              </a:defRPr>
-            </a:pPr>
-            <a:r>
-              <a:t>In practice: permission to prepare a claim summary should not also permit the agent to email the claimant, change a claim status or issue payment. Each action needs its own authority.</a:t>
-            </a:r>
-          </a:p>
-        </p:txBody>
-      </p:sp>
-      <p:sp>
-        <p:nvSpPr>
-          <p:cNvPr id="12" name="TextBox 11"/>
-          <p:cNvSpPr txBox="1"/>
-          <p:nvPr/>
-        </p:nvSpPr>
-        <p:spPr>
-          <a:xfrm>
-            <a:off x="640080" y="6510528"/>
-            <a:ext cx="10972800" cy="182880"/>
-          </a:xfrm>
-          <a:prstGeom prst="rect">
-            <a:avLst/>
-          </a:prstGeom>
-          <a:noFill/>
-        </p:spPr>
-        <p:txBody>
-          <a:bodyPr wrap="square" lIns="0" rIns="0" tIns="0" bIns="0">
-            <a:spAutoFit/>
-          </a:bodyPr>
-          <a:lstStyle/>
-          <a:p>
-            <a:pPr>
-              <a:defRPr sz="900" b="0">
-                <a:solidFill>
-                  <a:srgbClr val="66758A"/>
-                </a:solidFill>
-                <a:latin typeface="Calibri"/>
-              </a:defRPr>
-            </a:pPr>
-            <a:r>
-              <a:t>6 / 23    03:50–04:35 planned    Sources and explanation in notes</a:t>
+              <a:t>Source: UK AI Security Institute incident report. Permissive evaluation conditions differ from ordinary public use.</a:t>
             </a:r>
           </a:p>
         </p:txBody>

</xml_diff>

<commit_message>
Clarify MAS internal and customer AI scope and workflow risks
</commit_message>
<xml_diff>
--- a/docs/presentations/guarding-the-value-stream/Guarding_the_Value_Stream.pptx
+++ b/docs/presentations/guarding-the-value-stream/Guarding_the_Value_Stream.pptx
@@ -2939,7 +2939,7 @@
           <a:lstStyle xmlns:a="http://schemas.openxmlformats.org/drawingml/2006/main"/>
           <a:p xmlns:a="http://schemas.openxmlformats.org/drawingml/2006/main">
             <a:r>
-              <a:t>SLIDE 8: MAS: the institution remains accountable for its AI</a:t>
+              <a:t>SLIDE 8</a:t>
             </a:r>
           </a:p>
           <a:p xmlns:a="http://schemas.openxmlformats.org/drawingml/2006/main">
@@ -2949,17 +2949,17 @@
           </a:p>
           <a:p xmlns:a="http://schemas.openxmlformats.org/drawingml/2006/main">
             <a:r>
-              <a:t>MAS connects technical control to institutional responsibility. Teams need to identify AI use, assess materiality and apply lifecycle controls. Buying an external model does not transfer accountability. The practical questions are whether we can name the owner, show the inventory entry and explain how testing and monitoring work.</a:t>
+              <a:t>MAS addresses AI use across a financial institution, including internal work. A staff assistant can still expose sensitive files or change a consequential record. For DSH, assess the particular workflow: what data can it read, what can it do, and who could be affected? The examples here illustrate that risk-based reading. They do not establish that every example is deployed or that the guidelines automatically apply in another jurisdiction.</a:t>
             </a:r>
           </a:p>
           <a:p xmlns:a="http://schemas.openxmlformats.org/drawingml/2006/main">
             <a:r>
-              <a:t>DETAIL AND LIMITS</a:t>
+              <a:t>DETAILED EXPLANATION</a:t>
             </a:r>
           </a:p>
           <a:p xmlns:a="http://schemas.openxmlformats.org/drawingml/2006/main">
             <a:r>
-              <a:t>Final Guidelines were issued on 7 October 2026. Sections 3–4 apply from 7 October 2027 and Sections 5–6 by 7 October 2028. Existing governance may suffice, with controls proportionate to risk. Provider assurance gaps call for compensating controls; unacceptable risk may require limiting, suspending or replacing a service. This is Singapore supervisory context, not automatic legal applicability to every Thai institution. DSH mappings are suggested preparation, not compliance certification.</a:t>
+              <a:t>Final Guidelines were issued on 7 October 2026. Sections 3–4 apply from 7 October 2027 and Sections 5–6 by 7 October 2028. Existing governance may suffice, with controls proportionate to risk. Provider assurance gaps call for compensating controls; unacceptable risk may require limiting, suspending or replacing a service. This is Singapore supervisory context, not automatic legal applicability to every Thai institution. DSH mappings are suggested preparation, not compliance certification. Scope clarification: the announcement describes all forms of AI and assessment at both enterprise and individual-use-case levels, including embedded AI and third-party use. The internal and customer-facing categories on this slide are a plain-language interpretation of that broad scope. The staff assistant, customer chat, credit and claims examples are presenter-created illustrations, not a list quoted from MAS. A practical DSH example is comparing a draft-only claim summary with an integration authorised to change claim status. The second workflow has additional consequences and needs its own permissions, review, tests and owner decision. Employee-only access does not establish low risk. Assess applicability separately for the institution and jurisdiction.</a:t>
             </a:r>
           </a:p>
           <a:p xmlns:a="http://schemas.openxmlformats.org/drawingml/2006/main">
@@ -2969,7 +2969,7 @@
           </a:p>
           <a:p xmlns:a="http://schemas.openxmlformats.org/drawingml/2006/main">
             <a:r>
-              <a:t>Which parts can a machine check, and which still need judgment?</a:t>
+              <a:t>Some evidence can be checked automatically, while adequacy and accountability still need human judgment.</a:t>
             </a:r>
           </a:p>
           <a:p xmlns:a="http://schemas.openxmlformats.org/drawingml/2006/main">
@@ -19276,7 +19276,43 @@
       </p:grpSpPr>
       <p:sp xmlns:a="http://schemas.openxmlformats.org/drawingml/2006/main">
         <p:nvSpPr>
-          <p:cNvPr id="2" name="TextBox 1"/>
+          <p:cNvPr id="16" name="TextBox 15"/>
+          <p:cNvSpPr txBox="1"/>
+          <p:nvPr/>
+        </p:nvSpPr>
+        <p:spPr>
+          <a:xfrm>
+            <a:off x="640080" y="6510528"/>
+            <a:ext cx="10972800" cy="182880"/>
+          </a:xfrm>
+          <a:prstGeom prst="rect">
+            <a:avLst/>
+          </a:prstGeom>
+          <a:noFill/>
+        </p:spPr>
+        <p:txBody>
+          <a:bodyPr wrap="square" lIns="0" rIns="0" tIns="0" bIns="0">
+            <a:spAutoFit/>
+          </a:bodyPr>
+          <a:lstStyle/>
+          <a:p>
+            <a:pPr>
+              <a:defRPr sz="900" b="0">
+                <a:solidFill>
+                  <a:srgbClr val="66758A"/>
+                </a:solidFill>
+                <a:latin typeface="Calibri"/>
+              </a:defRPr>
+            </a:pPr>
+            <a:r>
+              <a:t>8 / 23    05:25–06:20 planned    Sources and explanation in notes</a:t>
+            </a:r>
+          </a:p>
+        </p:txBody>
+      </p:sp>
+      <p:sp xmlns:a="http://schemas.openxmlformats.org/drawingml/2006/main">
+        <p:nvSpPr>
+          <p:cNvPr id="17" name="TextBox 16"/>
           <p:cNvSpPr txBox="1"/>
           <p:nvPr/>
         </p:nvSpPr>
@@ -19291,7 +19327,7 @@
           <a:noFill/>
         </p:spPr>
         <p:txBody>
-          <a:bodyPr wrap="square">
+          <a:bodyPr wrap="square" lIns="0" rIns="0" tIns="0" bIns="0">
             <a:spAutoFit/>
           </a:bodyPr>
           <a:lstStyle/>
@@ -19299,183 +19335,179 @@
             <a:pPr>
               <a:defRPr sz="1100" b="1">
                 <a:solidFill>
-                  <a:srgbClr val="17243B"/>
-                </a:solidFill>
-                <a:latin typeface="Calibri"/>
-              </a:defRPr>
-            </a:pPr>
-            <a:r>
-              <a:t>PART 1 / GOVERNANCE RESPONSE</a:t>
+                  <a:srgbClr val="0088BA"/>
+                </a:solidFill>
+                <a:latin typeface="Calibri"/>
+              </a:defRPr>
+            </a:pPr>
+            <a:r>
+              <a:t>PART 1 / MAS: SINGAPORE SUPERVISORY EXPECTATIONS</a:t>
             </a:r>
           </a:p>
         </p:txBody>
       </p:sp>
       <p:sp xmlns:a="http://schemas.openxmlformats.org/drawingml/2006/main">
         <p:nvSpPr>
-          <p:cNvPr id="3" name="TextBox 2"/>
-          <p:cNvSpPr txBox="1"/>
-          <p:nvPr/>
-        </p:nvSpPr>
-        <p:spPr>
-          <a:xfrm>
-            <a:off x="640080" y="822960"/>
-            <a:ext cx="10972800" cy="594360"/>
-          </a:xfrm>
-          <a:prstGeom prst="rect">
-            <a:avLst/>
-          </a:prstGeom>
-          <a:noFill/>
-        </p:spPr>
-        <p:txBody>
-          <a:bodyPr wrap="square">
-            <a:spAutoFit/>
-          </a:bodyPr>
-          <a:lstStyle/>
-          <a:p>
-            <a:r>
-              <a:rPr sz="2400" b="1">
-                <a:latin typeface="Calibri"/>
-              </a:rPr>
-              <a:t>MAS: the institution remains accountable for its AI</a:t>
+          <p:cNvPr id="18" name="TextBox 17"/>
+          <p:cNvSpPr txBox="1"/>
+          <p:nvPr/>
+        </p:nvSpPr>
+        <p:spPr>
+          <a:xfrm>
+            <a:off x="640080" y="868680"/>
+            <a:ext cx="10972800" cy="731520"/>
+          </a:xfrm>
+          <a:prstGeom prst="rect">
+            <a:avLst/>
+          </a:prstGeom>
+          <a:noFill/>
+        </p:spPr>
+        <p:txBody>
+          <a:bodyPr wrap="square" lIns="0" rIns="0" tIns="0" bIns="0">
+            <a:spAutoFit/>
+          </a:bodyPr>
+          <a:lstStyle/>
+          <a:p>
+            <a:pPr>
+              <a:defRPr sz="2500" b="1">
+                <a:solidFill>
+                  <a:srgbClr val="14243C"/>
+                </a:solidFill>
+                <a:latin typeface="Calibri"/>
+              </a:defRPr>
+            </a:pPr>
+            <a:r>
+              <a:t>MAS covers internal and customer-facing AI, according to risk</a:t>
             </a:r>
           </a:p>
         </p:txBody>
       </p:sp>
       <p:sp xmlns:a="http://schemas.openxmlformats.org/drawingml/2006/main">
         <p:nvSpPr>
-          <p:cNvPr id="4" name="TextBox 3"/>
-          <p:cNvSpPr txBox="1"/>
-          <p:nvPr/>
-        </p:nvSpPr>
-        <p:spPr>
-          <a:xfrm>
-            <a:off x="640080" y="1463040"/>
-            <a:ext cx="10972800" cy="457200"/>
-          </a:xfrm>
-          <a:prstGeom prst="rect">
-            <a:avLst/>
-          </a:prstGeom>
-          <a:noFill/>
-        </p:spPr>
-        <p:txBody>
-          <a:bodyPr wrap="square">
-            <a:spAutoFit/>
-          </a:bodyPr>
-          <a:lstStyle/>
-          <a:p>
-            <a:pPr>
-              <a:defRPr sz="1500" b="0">
-                <a:solidFill>
-                  <a:srgbClr val="17243B"/>
-                </a:solidFill>
-                <a:latin typeface="Calibri"/>
-              </a:defRPr>
-            </a:pPr>
-            <a:r>
-              <a:t>Monetary Authority of Singapore • Final Guidelines on AI Risk Management issued 7 October 2026</a:t>
+          <p:cNvPr id="19" name="TextBox 18"/>
+          <p:cNvSpPr txBox="1"/>
+          <p:nvPr/>
+        </p:nvSpPr>
+        <p:spPr>
+          <a:xfrm>
+            <a:off x="685800" y="1856231"/>
+            <a:ext cx="5212080" cy="411480"/>
+          </a:xfrm>
+          <a:prstGeom prst="rect">
+            <a:avLst/>
+          </a:prstGeom>
+          <a:noFill/>
+        </p:spPr>
+        <p:txBody>
+          <a:bodyPr wrap="square" lIns="0" rIns="0" tIns="0" bIns="0">
+            <a:spAutoFit/>
+          </a:bodyPr>
+          <a:lstStyle/>
+          <a:p>
+            <a:pPr>
+              <a:defRPr sz="1800" b="1">
+                <a:solidFill>
+                  <a:srgbClr val="007DA5"/>
+                </a:solidFill>
+                <a:latin typeface="Calibri"/>
+              </a:defRPr>
+            </a:pPr>
+            <a:r>
+              <a:t>Scope: both internal and customer use</a:t>
             </a:r>
           </a:p>
         </p:txBody>
       </p:sp>
       <p:sp xmlns:a="http://schemas.openxmlformats.org/drawingml/2006/main">
         <p:nvSpPr>
-          <p:cNvPr id="5" name="Rounded Rectangle 4"/>
-          <p:cNvSpPr/>
-          <p:nvPr/>
-        </p:nvSpPr>
-        <p:spPr>
-          <a:xfrm>
-            <a:off x="640080" y="2103120"/>
-            <a:ext cx="3520440" cy="2286000"/>
-          </a:xfrm>
-          <a:prstGeom prst="roundRect">
-            <a:avLst/>
-          </a:prstGeom>
-          <a:solidFill>
-            <a:srgbClr val="EFF5FA"/>
-          </a:solidFill>
-          <a:ln>
-            <a:solidFill>
-              <a:srgbClr val="CFDEEA"/>
-            </a:solidFill>
-          </a:ln>
-        </p:spPr>
-        <p:style>
-          <a:lnRef idx="1">
-            <a:schemeClr val="accent1"/>
-          </a:lnRef>
-          <a:fillRef idx="3">
-            <a:schemeClr val="accent1"/>
-          </a:fillRef>
-          <a:effectRef idx="2">
-            <a:schemeClr val="accent1"/>
-          </a:effectRef>
-          <a:fontRef idx="minor">
-            <a:schemeClr val="lt1"/>
-          </a:fontRef>
-        </p:style>
-        <p:txBody>
-          <a:bodyPr rtlCol="0" anchor="ctr"/>
-          <a:lstStyle/>
-          <a:p>
-            <a:pPr algn="ctr"/>
+          <p:cNvPr id="20" name="TextBox 19"/>
+          <p:cNvSpPr txBox="1"/>
+          <p:nvPr/>
+        </p:nvSpPr>
+        <p:spPr>
+          <a:xfrm>
+            <a:off x="685800" y="2313432"/>
+            <a:ext cx="5212080" cy="1463040"/>
+          </a:xfrm>
+          <a:prstGeom prst="rect">
+            <a:avLst/>
+          </a:prstGeom>
+          <a:noFill/>
+        </p:spPr>
+        <p:txBody>
+          <a:bodyPr wrap="square" lIns="0" rIns="0" tIns="0" bIns="0">
+            <a:spAutoFit/>
+          </a:bodyPr>
+          <a:lstStyle/>
+          <a:p>
+            <a:pPr>
+              <a:defRPr sz="1600" b="0">
+                <a:solidFill>
+                  <a:srgbClr val="26354A"/>
+                </a:solidFill>
+                <a:latin typeface="Calibri"/>
+              </a:defRPr>
+            </a:pPr>
+            <a:r>
+              <a:t>The Monetary Authority of Singapore (MAS) addresses financial institutions' AI use broadly, including embedded and third-party AI. Examples: staff assistants, document drafting, customer chat and credit or claims support.</a:t>
+            </a:r>
           </a:p>
         </p:txBody>
       </p:sp>
       <p:sp xmlns:a="http://schemas.openxmlformats.org/drawingml/2006/main">
         <p:nvSpPr>
-          <p:cNvPr id="6" name="TextBox 5"/>
-          <p:cNvSpPr txBox="1"/>
-          <p:nvPr/>
-        </p:nvSpPr>
-        <p:spPr>
-          <a:xfrm>
-            <a:off x="777240" y="2212848"/>
-            <a:ext cx="3246120" cy="411480"/>
-          </a:xfrm>
-          <a:prstGeom prst="rect">
-            <a:avLst/>
-          </a:prstGeom>
-          <a:noFill/>
-        </p:spPr>
-        <p:txBody>
-          <a:bodyPr wrap="square">
-            <a:spAutoFit/>
-          </a:bodyPr>
-          <a:lstStyle/>
-          <a:p>
-            <a:pPr>
-              <a:defRPr sz="1700" b="1">
-                <a:solidFill>
-                  <a:srgbClr val="17243B"/>
-                </a:solidFill>
-                <a:latin typeface="Calibri"/>
-              </a:defRPr>
-            </a:pPr>
-            <a:r>
-              <a:t>Oversight and ownership</a:t>
+          <p:cNvPr id="21" name="TextBox 20"/>
+          <p:cNvSpPr txBox="1"/>
+          <p:nvPr/>
+        </p:nvSpPr>
+        <p:spPr>
+          <a:xfrm>
+            <a:off x="6309360" y="1856231"/>
+            <a:ext cx="5212080" cy="411480"/>
+          </a:xfrm>
+          <a:prstGeom prst="rect">
+            <a:avLst/>
+          </a:prstGeom>
+          <a:noFill/>
+        </p:spPr>
+        <p:txBody>
+          <a:bodyPr wrap="square" lIns="0" rIns="0" tIns="0" bIns="0">
+            <a:spAutoFit/>
+          </a:bodyPr>
+          <a:lstStyle/>
+          <a:p>
+            <a:pPr>
+              <a:defRPr sz="1800" b="1">
+                <a:solidFill>
+                  <a:srgbClr val="007DA5"/>
+                </a:solidFill>
+                <a:latin typeface="Calibri"/>
+              </a:defRPr>
+            </a:pPr>
+            <a:r>
+              <a:t>Internal use can still have high impact</a:t>
             </a:r>
           </a:p>
         </p:txBody>
       </p:sp>
       <p:sp xmlns:a="http://schemas.openxmlformats.org/drawingml/2006/main">
         <p:nvSpPr>
-          <p:cNvPr id="7" name="TextBox 6"/>
-          <p:cNvSpPr txBox="1"/>
-          <p:nvPr/>
-        </p:nvSpPr>
-        <p:spPr>
-          <a:xfrm>
-            <a:off x="777240" y="2743200"/>
-            <a:ext cx="3246120" cy="1554480"/>
-          </a:xfrm>
-          <a:prstGeom prst="rect">
-            <a:avLst/>
-          </a:prstGeom>
-          <a:noFill/>
-        </p:spPr>
-        <p:txBody>
-          <a:bodyPr wrap="square">
+          <p:cNvPr id="22" name="TextBox 21"/>
+          <p:cNvSpPr txBox="1"/>
+          <p:nvPr/>
+        </p:nvSpPr>
+        <p:spPr>
+          <a:xfrm>
+            <a:off x="6309360" y="2313432"/>
+            <a:ext cx="5212080" cy="1463040"/>
+          </a:xfrm>
+          <a:prstGeom prst="rect">
+            <a:avLst/>
+          </a:prstGeom>
+          <a:noFill/>
+        </p:spPr>
+        <p:txBody>
+          <a:bodyPr wrap="square" lIns="0" rIns="0" tIns="0" bIns="0">
             <a:spAutoFit/>
           </a:bodyPr>
           <a:lstStyle/>
@@ -19483,116 +19515,143 @@
             <a:pPr>
               <a:defRPr sz="1600" b="0">
                 <a:solidFill>
-                  <a:srgbClr val="17243B"/>
-                </a:solidFill>
-                <a:latin typeface="Calibri"/>
-              </a:defRPr>
-            </a:pPr>
-            <a:r>
-              <a:t>Board and senior management oversee AI risk. Set roles, risk appetite and coordination. Existing governance structures may suffice.</a:t>
+                  <a:srgbClr val="26354A"/>
+                </a:solidFill>
+                <a:latin typeface="Calibri"/>
+              </a:defRPr>
+            </a:pPr>
+            <a:r>
+              <a:t>A staff assistant may read sensitive files or change business records. Customer contact is not the only risk. Assess the data, permissions, affected people and consequences of errors or service failure.</a:t>
             </a:r>
           </a:p>
         </p:txBody>
       </p:sp>
       <p:sp xmlns:a="http://schemas.openxmlformats.org/drawingml/2006/main">
         <p:nvSpPr>
-          <p:cNvPr id="8" name="Rounded Rectangle 7"/>
-          <p:cNvSpPr/>
-          <p:nvPr/>
-        </p:nvSpPr>
-        <p:spPr>
-          <a:xfrm>
-            <a:off x="4343400" y="2103120"/>
-            <a:ext cx="3520440" cy="2286000"/>
-          </a:xfrm>
-          <a:prstGeom prst="roundRect">
-            <a:avLst/>
-          </a:prstGeom>
-          <a:solidFill>
-            <a:srgbClr val="EFF5FA"/>
-          </a:solidFill>
-          <a:ln>
-            <a:solidFill>
-              <a:srgbClr val="CFDEEA"/>
-            </a:solidFill>
-          </a:ln>
-        </p:spPr>
-        <p:style>
-          <a:lnRef idx="1">
-            <a:schemeClr val="accent1"/>
-          </a:lnRef>
-          <a:fillRef idx="3">
-            <a:schemeClr val="accent1"/>
-          </a:fillRef>
-          <a:effectRef idx="2">
-            <a:schemeClr val="accent1"/>
-          </a:effectRef>
-          <a:fontRef idx="minor">
-            <a:schemeClr val="lt1"/>
-          </a:fontRef>
-        </p:style>
-        <p:txBody>
-          <a:bodyPr rtlCol="0" anchor="ctr"/>
-          <a:lstStyle/>
-          <a:p>
-            <a:pPr algn="ctr"/>
+          <p:cNvPr id="23" name="TextBox 22"/>
+          <p:cNvSpPr txBox="1"/>
+          <p:nvPr/>
+        </p:nvSpPr>
+        <p:spPr>
+          <a:xfrm>
+            <a:off x="685800" y="3858768"/>
+            <a:ext cx="5212080" cy="411480"/>
+          </a:xfrm>
+          <a:prstGeom prst="rect">
+            <a:avLst/>
+          </a:prstGeom>
+          <a:noFill/>
+        </p:spPr>
+        <p:txBody>
+          <a:bodyPr wrap="square" lIns="0" rIns="0" tIns="0" bIns="0">
+            <a:spAutoFit/>
+          </a:bodyPr>
+          <a:lstStyle/>
+          <a:p>
+            <a:pPr>
+              <a:defRPr sz="1800" b="1">
+                <a:solidFill>
+                  <a:srgbClr val="007DA5"/>
+                </a:solidFill>
+                <a:latin typeface="Calibri"/>
+              </a:defRPr>
+            </a:pPr>
+            <a:r>
+              <a:t>Ownership and proportionate controls</a:t>
+            </a:r>
           </a:p>
         </p:txBody>
       </p:sp>
       <p:sp xmlns:a="http://schemas.openxmlformats.org/drawingml/2006/main">
         <p:nvSpPr>
-          <p:cNvPr id="9" name="TextBox 8"/>
-          <p:cNvSpPr txBox="1"/>
-          <p:nvPr/>
-        </p:nvSpPr>
-        <p:spPr>
-          <a:xfrm>
-            <a:off x="4480560" y="2212848"/>
-            <a:ext cx="3246120" cy="411480"/>
-          </a:xfrm>
-          <a:prstGeom prst="rect">
-            <a:avLst/>
-          </a:prstGeom>
-          <a:noFill/>
-        </p:spPr>
-        <p:txBody>
-          <a:bodyPr wrap="square">
-            <a:spAutoFit/>
-          </a:bodyPr>
-          <a:lstStyle/>
-          <a:p>
-            <a:pPr>
-              <a:defRPr sz="1700" b="1">
-                <a:solidFill>
-                  <a:srgbClr val="17243B"/>
-                </a:solidFill>
-                <a:latin typeface="Calibri"/>
-              </a:defRPr>
-            </a:pPr>
-            <a:r>
-              <a:t>Inventory and lifecycle</a:t>
+          <p:cNvPr id="24" name="TextBox 23"/>
+          <p:cNvSpPr txBox="1"/>
+          <p:nvPr/>
+        </p:nvSpPr>
+        <p:spPr>
+          <a:xfrm>
+            <a:off x="685800" y="4315968"/>
+            <a:ext cx="5212080" cy="1463040"/>
+          </a:xfrm>
+          <a:prstGeom prst="rect">
+            <a:avLst/>
+          </a:prstGeom>
+          <a:noFill/>
+        </p:spPr>
+        <p:txBody>
+          <a:bodyPr wrap="square" lIns="0" rIns="0" tIns="0" bIns="0">
+            <a:spAutoFit/>
+          </a:bodyPr>
+          <a:lstStyle/>
+          <a:p>
+            <a:pPr>
+              <a:defRPr sz="1600" b="0">
+                <a:solidFill>
+                  <a:srgbClr val="26354A"/>
+                </a:solidFill>
+                <a:latin typeface="Calibri"/>
+              </a:defRPr>
+            </a:pPr>
+            <a:r>
+              <a:t>Name accountable owners, inventory uses and apply lifecycle controls. Third-party AI does not transfer responsibility. Basic policies may suffice where failure is unlikely to cause material impact; stronger controls follow higher risk.</a:t>
             </a:r>
           </a:p>
         </p:txBody>
       </p:sp>
       <p:sp xmlns:a="http://schemas.openxmlformats.org/drawingml/2006/main">
         <p:nvSpPr>
-          <p:cNvPr id="10" name="TextBox 9"/>
-          <p:cNvSpPr txBox="1"/>
-          <p:nvPr/>
-        </p:nvSpPr>
-        <p:spPr>
-          <a:xfrm>
-            <a:off x="4480560" y="2743200"/>
-            <a:ext cx="3246120" cy="1554480"/>
-          </a:xfrm>
-          <a:prstGeom prst="rect">
-            <a:avLst/>
-          </a:prstGeom>
-          <a:noFill/>
-        </p:spPr>
-        <p:txBody>
-          <a:bodyPr wrap="square">
+          <p:cNvPr id="25" name="TextBox 24"/>
+          <p:cNvSpPr txBox="1"/>
+          <p:nvPr/>
+        </p:nvSpPr>
+        <p:spPr>
+          <a:xfrm>
+            <a:off x="6309360" y="3858768"/>
+            <a:ext cx="5212080" cy="411480"/>
+          </a:xfrm>
+          <a:prstGeom prst="rect">
+            <a:avLst/>
+          </a:prstGeom>
+          <a:noFill/>
+        </p:spPr>
+        <p:txBody>
+          <a:bodyPr wrap="square" lIns="0" rIns="0" tIns="0" bIns="0">
+            <a:spAutoFit/>
+          </a:bodyPr>
+          <a:lstStyle/>
+          <a:p>
+            <a:pPr>
+              <a:defRPr sz="1800" b="1">
+                <a:solidFill>
+                  <a:srgbClr val="007DA5"/>
+                </a:solidFill>
+                <a:latin typeface="Calibri"/>
+              </a:defRPr>
+            </a:pPr>
+            <a:r>
+              <a:t>What this means for DSH</a:t>
+            </a:r>
+          </a:p>
+        </p:txBody>
+      </p:sp>
+      <p:sp xmlns:a="http://schemas.openxmlformats.org/drawingml/2006/main">
+        <p:nvSpPr>
+          <p:cNvPr id="26" name="TextBox 25"/>
+          <p:cNvSpPr txBox="1"/>
+          <p:nvPr/>
+        </p:nvSpPr>
+        <p:spPr>
+          <a:xfrm>
+            <a:off x="6309360" y="4315968"/>
+            <a:ext cx="5212080" cy="1463040"/>
+          </a:xfrm>
+          <a:prstGeom prst="rect">
+            <a:avLst/>
+          </a:prstGeom>
+          <a:noFill/>
+        </p:spPr>
+        <p:txBody>
+          <a:bodyPr wrap="square" lIns="0" rIns="0" tIns="0" bIns="0">
             <a:spAutoFit/>
           </a:bodyPr>
           <a:lstStyle/>
@@ -19600,230 +19659,41 @@
             <a:pPr>
               <a:defRPr sz="1600" b="0">
                 <a:solidFill>
-                  <a:srgbClr val="17243B"/>
-                </a:solidFill>
-                <a:latin typeface="Calibri"/>
-              </a:defRPr>
-            </a:pPr>
-            <a:r>
-              <a:t>Identify AI use and maintain inventories. Assess materiality. Apply proportionate data, testing, human-oversight, cybersecurity, monitoring and change controls.</a:t>
+                  <a:srgbClr val="26354A"/>
+                </a:solidFill>
+                <a:latin typeface="Calibri"/>
+              </a:defRPr>
+            </a:pPr>
+            <a:r>
+              <a:t>Assess each workflow, rather than giving the whole platform a safety label. A draft claim summary and a tool able to change claims need different permissions, review and testing. Keep the owner, decision and evidence.</a:t>
             </a:r>
           </a:p>
         </p:txBody>
       </p:sp>
       <p:sp xmlns:a="http://schemas.openxmlformats.org/drawingml/2006/main">
         <p:nvSpPr>
-          <p:cNvPr id="11" name="Rounded Rectangle 10"/>
-          <p:cNvSpPr/>
-          <p:nvPr/>
-        </p:nvSpPr>
-        <p:spPr>
-          <a:xfrm>
-            <a:off x="8046720" y="2103120"/>
-            <a:ext cx="3520440" cy="2286000"/>
-          </a:xfrm>
-          <a:prstGeom prst="roundRect">
-            <a:avLst/>
-          </a:prstGeom>
-          <a:solidFill>
-            <a:srgbClr val="EFF5FA"/>
-          </a:solidFill>
-          <a:ln>
-            <a:solidFill>
-              <a:srgbClr val="CFDEEA"/>
-            </a:solidFill>
-          </a:ln>
-        </p:spPr>
-        <p:style>
-          <a:lnRef idx="1">
-            <a:schemeClr val="accent1"/>
-          </a:lnRef>
-          <a:fillRef idx="3">
-            <a:schemeClr val="accent1"/>
-          </a:fillRef>
-          <a:effectRef idx="2">
-            <a:schemeClr val="accent1"/>
-          </a:effectRef>
-          <a:fontRef idx="minor">
-            <a:schemeClr val="lt1"/>
-          </a:fontRef>
-        </p:style>
-        <p:txBody>
-          <a:bodyPr rtlCol="0" anchor="ctr"/>
-          <a:lstStyle/>
-          <a:p>
-            <a:pPr algn="ctr"/>
-          </a:p>
-        </p:txBody>
-      </p:sp>
-      <p:sp xmlns:a="http://schemas.openxmlformats.org/drawingml/2006/main">
-        <p:nvSpPr>
-          <p:cNvPr id="12" name="TextBox 11"/>
-          <p:cNvSpPr txBox="1"/>
-          <p:nvPr/>
-        </p:nvSpPr>
-        <p:spPr>
-          <a:xfrm>
-            <a:off x="8183880" y="2212848"/>
-            <a:ext cx="3246120" cy="411480"/>
-          </a:xfrm>
-          <a:prstGeom prst="rect">
-            <a:avLst/>
-          </a:prstGeom>
-          <a:noFill/>
-        </p:spPr>
-        <p:txBody>
-          <a:bodyPr wrap="square">
-            <a:spAutoFit/>
-          </a:bodyPr>
-          <a:lstStyle/>
-          <a:p>
-            <a:pPr>
-              <a:defRPr sz="1700" b="1">
-                <a:solidFill>
-                  <a:srgbClr val="17243B"/>
-                </a:solidFill>
-                <a:latin typeface="Calibri"/>
-              </a:defRPr>
-            </a:pPr>
-            <a:r>
-              <a:t>Third-party AI</a:t>
-            </a:r>
-          </a:p>
-        </p:txBody>
-      </p:sp>
-      <p:sp xmlns:a="http://schemas.openxmlformats.org/drawingml/2006/main">
-        <p:nvSpPr>
-          <p:cNvPr id="13" name="TextBox 12"/>
-          <p:cNvSpPr txBox="1"/>
-          <p:nvPr/>
-        </p:nvSpPr>
-        <p:spPr>
-          <a:xfrm>
-            <a:off x="8183880" y="2743200"/>
-            <a:ext cx="3246120" cy="1554480"/>
-          </a:xfrm>
-          <a:prstGeom prst="rect">
-            <a:avLst/>
-          </a:prstGeom>
-          <a:noFill/>
-        </p:spPr>
-        <p:txBody>
-          <a:bodyPr wrap="square">
-            <a:spAutoFit/>
-          </a:bodyPr>
-          <a:lstStyle/>
-          <a:p>
-            <a:pPr>
-              <a:defRPr sz="1600" b="0">
-                <a:solidFill>
-                  <a:srgbClr val="17243B"/>
-                </a:solidFill>
-                <a:latin typeface="Calibri"/>
-              </a:defRPr>
-            </a:pPr>
-            <a:r>
-              <a:t>The institution remains accountable for provider AI. Obtain assurance and assess suitability. Use compensating controls. Limit, suspend or replace services if risk stays unacceptable.</a:t>
-            </a:r>
-          </a:p>
-        </p:txBody>
-      </p:sp>
-      <p:sp xmlns:a="http://schemas.openxmlformats.org/drawingml/2006/main">
-        <p:nvSpPr>
-          <p:cNvPr id="14" name="TextBox 13"/>
-          <p:cNvSpPr txBox="1"/>
-          <p:nvPr/>
-        </p:nvSpPr>
-        <p:spPr>
-          <a:xfrm>
-            <a:off x="731520" y="4663440"/>
-            <a:ext cx="10789920" cy="594360"/>
-          </a:xfrm>
-          <a:prstGeom prst="rect">
-            <a:avLst/>
-          </a:prstGeom>
-          <a:noFill/>
-        </p:spPr>
-        <p:txBody>
-          <a:bodyPr wrap="square">
-            <a:spAutoFit/>
-          </a:bodyPr>
-          <a:lstStyle/>
-          <a:p>
-            <a:pPr>
-              <a:defRPr sz="1500" b="0">
-                <a:solidFill>
-                  <a:srgbClr val="17243B"/>
-                </a:solidFill>
-                <a:latin typeface="Calibri"/>
-              </a:defRPr>
-            </a:pPr>
-            <a:r>
-              <a:t>Application: Sections 3–4 from 7 Oct 2027. Sections 5–6 by 7 Oct 2028. Basic policies may suffice for uses with immaterial impact. Further agentic-AI consultation is intended in 2027.</a:t>
-            </a:r>
-          </a:p>
-        </p:txBody>
-      </p:sp>
-      <p:sp xmlns:a="http://schemas.openxmlformats.org/drawingml/2006/main">
-        <p:nvSpPr>
-          <p:cNvPr id="15" name="TextBox 14"/>
-          <p:cNvSpPr txBox="1"/>
-          <p:nvPr/>
-        </p:nvSpPr>
-        <p:spPr>
-          <a:xfrm>
-            <a:off x="731520" y="5504688"/>
-            <a:ext cx="10789920" cy="594360"/>
-          </a:xfrm>
-          <a:prstGeom prst="rect">
-            <a:avLst/>
-          </a:prstGeom>
-          <a:noFill/>
-        </p:spPr>
-        <p:txBody>
-          <a:bodyPr wrap="square">
-            <a:spAutoFit/>
-          </a:bodyPr>
-          <a:lstStyle/>
-          <a:p>
-            <a:pPr>
-              <a:defRPr sz="1400" b="0">
-                <a:solidFill>
-                  <a:srgbClr val="17243B"/>
-                </a:solidFill>
-                <a:latin typeface="Calibri"/>
-              </a:defRPr>
-            </a:pPr>
-            <a:r>
-              <a:t>DSH preparation: map owners, inventories, access, approvals, test results and monitoring to the use case. Singapore supervisory context; assess local applicability. Independent airmkit research is not MAS approval.</a:t>
-            </a:r>
-          </a:p>
-        </p:txBody>
-      </p:sp>
-      <p:sp xmlns:a="http://schemas.openxmlformats.org/drawingml/2006/main">
-        <p:nvSpPr>
-          <p:cNvPr id="16" name="TextBox 15"/>
-          <p:cNvSpPr txBox="1"/>
-          <p:nvPr/>
-        </p:nvSpPr>
-        <p:spPr>
-          <a:xfrm>
-            <a:off x="640080" y="6510528"/>
-            <a:ext cx="10972800" cy="182880"/>
-          </a:xfrm>
-          <a:prstGeom prst="rect">
-            <a:avLst/>
-          </a:prstGeom>
-          <a:noFill/>
-        </p:spPr>
-        <p:txBody>
-          <a:bodyPr wrap="square" lIns="0" rIns="0" tIns="0" bIns="0">
-            <a:spAutoFit/>
-          </a:bodyPr>
-          <a:lstStyle/>
-          <a:p>
-            <a:pPr>
-              <a:defRPr sz="900" b="0">
+          <p:cNvPr id="27" name="TextBox 26"/>
+          <p:cNvSpPr txBox="1"/>
+          <p:nvPr/>
+        </p:nvSpPr>
+        <p:spPr>
+          <a:xfrm>
+            <a:off x="685800" y="6044184"/>
+            <a:ext cx="10789920" cy="393192"/>
+          </a:xfrm>
+          <a:prstGeom prst="rect">
+            <a:avLst/>
+          </a:prstGeom>
+          <a:noFill/>
+        </p:spPr>
+        <p:txBody>
+          <a:bodyPr wrap="square" lIns="0" rIns="0" tIns="0" bIns="0">
+            <a:spAutoFit/>
+          </a:bodyPr>
+          <a:lstStyle/>
+          <a:p>
+            <a:pPr>
+              <a:defRPr sz="1000" b="0">
                 <a:solidFill>
                   <a:srgbClr val="66758A"/>
                 </a:solidFill>
@@ -19831,7 +19701,7 @@
               </a:defRPr>
             </a:pPr>
             <a:r>
-              <a:t>8 / 23    05:25–06:20 planned    Sources and explanation in notes</a:t>
+              <a:t>Issued 7 Oct 2026. Sections 3–4: 7 Oct 2027. Sections 5–6: by 7 Oct 2028. Singapore context; assess applicability. Examples illustrate the broad scope.</a:t>
             </a:r>
           </a:p>
         </p:txBody>

</xml_diff>

<commit_message>
Use Governed DSH presentation name and align speaker guide
</commit_message>
<xml_diff>
--- a/docs/presentations/guarding-the-value-stream/Guarding_the_Value_Stream.pptx
+++ b/docs/presentations/guarding-the-value-stream/Guarding_the_Value_Stream.pptx
@@ -626,7 +626,7 @@
           </a:p>
           <a:p>
             <a:r>
-              <a:t>The calculation 23 / 51 is 45.1 percent. It is not a share of regulation an institution can ignore or a DSH assurance score. The research uses synthetic cases and an independent interpretation of MAS expectations. The guardrail experiment used a small local model and four benign probes; its refusal rate has limited statistical strength. Airmkit also provides paragraph-linked controls, inventory fields and evidence records. A crosswalk helps find evidence but does not establish compliance.</a:t>
+              <a:t>The calculation 23 / 51 is 45.1 percent. It is not a share of regulation an institution can ignore or a Governed DSH assurance score. The research uses synthetic cases and an independent interpretation of MAS expectations. The guardrail experiment used a small local model and four benign probes; its refusal rate has limited statistical strength. Airmkit also provides paragraph-linked controls, inventory fields and evidence records. A crosswalk helps find evidence but does not establish compliance.</a:t>
             </a:r>
           </a:p>
           <a:p>
@@ -1280,7 +1280,7 @@
           </a:p>
           <a:p>
             <a:r>
-              <a:t>Credit memos and claim files use different rules, but both benefit from source references, reproducible calculations and a clear review point. Define the task, produce an inspectable work product, review it and authorize any consequential release. That repeatable pattern is the bridge to DSH.</a:t>
+              <a:t>Credit memos and claim files use different rules, but both benefit from source references, reproducible calculations and a clear review point. Define the task, produce an inspectable work product, review it and authorize any consequential release. That repeatable pattern is the bridge to Governed DSH.</a:t>
             </a:r>
           </a:p>
           <a:p>
@@ -1290,7 +1290,7 @@
           </a:p>
           <a:p>
             <a:r>
-              <a:t>This is a workflow design, not a claim of six packaged DSH business applications or universal automated approvals. Retain source date, tool version, important parameters and decision owner. A low-risk draft may need lightweight review. A customer-impacting outcome may require more rigorous validation and controls. Review the actual artifact that will be released, including attachments and exports.</a:t>
+              <a:t>This is a workflow design, not a claim of six packaged Governed DSH business applications or universal automated approvals. Retain source date, tool version, important parameters and decision owner. A low-risk draft may need lightweight review. A customer-impacting outcome may require more rigorous validation and controls. Review the actual artifact that will be released, including attachments and exports.</a:t>
             </a:r>
           </a:p>
           <a:p>
@@ -1376,7 +1376,7 @@
           <a:lstStyle/>
           <a:p>
             <a:r>
-              <a:t>SLIDE 17: DSH brings the working tools into one reviewable project</a:t>
+              <a:t>SLIDE 17: Governed DSH brings tools and evidence into one workspace</a:t>
             </a:r>
           </a:p>
           <a:p>
@@ -1386,7 +1386,7 @@
           </a:p>
           <a:p>
             <a:r>
-              <a:t>After the banking and insurance examples, the question is where the work happens. DSH brings a project, files, an assistant, Jupyter, a terminal and application access together. A credit analyst can organise approved statements, ask for a calculation notebook, inspect the code and save a memo. The reviewer can examine the source and calculation rather than receiving only a polished paragraph.</a:t>
+              <a:t>After the banking and insurance examples, the question is where the work happens. Governed DSH brings a project, files, an assistant, Jupyter, a terminal and application access together. A credit analyst can organise approved statements, ask for a calculation notebook, inspect the code and save a memo. The reviewer can examine the source and calculation rather than receiving only a polished paragraph.</a:t>
             </a:r>
           </a:p>
           <a:p>
@@ -1491,7 +1491,7 @@
           <a:lstStyle/>
           <a:p>
             <a:r>
-              <a:t>SLIDE 18: Each DSH feature closes a specific working gap</a:t>
+              <a:t>SLIDE 18: Governed DSH features support inspection and handover</a:t>
             </a:r>
           </a:p>
           <a:p>
@@ -1606,7 +1606,7 @@
           <a:lstStyle/>
           <a:p>
             <a:r>
-              <a:t>SLIDE 20: A DSH claims report needs checks before and after sharing</a:t>
+              <a:t>SLIDE 20: Governed DSH: checks before and after sharing a report</a:t>
             </a:r>
           </a:p>
           <a:p>
@@ -1616,7 +1616,7 @@
           </a:p>
           <a:p>
             <a:r>
-              <a:t>Here is one practical reason we need both output review and operating controls. A claims handler uses DSH to draft a report from approved documents. The totals may look right, but the exported HTML might load an image from an outside website. If its address includes a claim identifier, opening the report sends that identifier in a web request. Before sharing, inspect the file and open it with invented data in the reviewer's actual browser. If something unexpected happens, withhold it, notify the owner and record the decision. This connects the incident lessons to an ordinary DSH work product.</a:t>
+              <a:t>Here is one practical reason we need both output review and operating controls. A claims handler uses Governed DSH to draft a report from approved documents. The totals may look right, but the exported HTML might load an image from an outside website. If its address includes a claim identifier, opening the report sends that identifier in a web request. Before sharing, inspect the file and open it with invented data in the reviewer's actual browser. If something unexpected happens, withhold it, notify the owner and record the decision. This connects the incident lessons to an ordinary DSH work product.</a:t>
             </a:r>
           </a:p>
           <a:p>
@@ -1626,7 +1626,7 @@
           </a:p>
           <a:p>
             <a:r>
-              <a:t>This is a hypothetical claims example, not an observed DSH data leak. HTML is HyperText Markup Language, the format browsers use to display web pages. A generated report can contain text, links, scripts and references to remote resources. Loading an external image can send its URL to the remote server even without JavaScript or a Send button. If the URL contains a claim identifier, the request may disclose that identifier. Whether requests or scripts run depends on the viewer, browser policy and file contents. Opening a file does not automatically disclose every browser credential. Review confidential content and source calculations as well as active content. Self-contained reports reduce remote-resource dependencies, but embedded scripts can still make network requests; test the actual file. The DSH worker and the recipient browser are different environments, so a worker egress policy does not establish that browser requests are blocked. Use synthetic records and approved test endpoints to inspect requests. Verify consequential actions such as sending, record changes and payment independently at their destination. Stop and recovery checks require evidence of actual cancellation, queued work and saved state, not merely a visible button. Do not perform these tests against real customer records without authority. The preceding controls slide covers workspace access, supporting-service routes, credentials and monitoring. The following evidence slide explains what to retain. No new live security or recovery test is claimed here.</a:t>
+              <a:t>This is a hypothetical claims example, not an observed Governed DSH data leak. HTML is HyperText Markup Language, the format browsers use to display web pages. A generated report can contain text, links, scripts and references to remote resources. Loading an external image can send its URL to the remote server even without JavaScript or a Send button. If the URL contains a claim identifier, the request may disclose that identifier. Whether requests or scripts run depends on the viewer, browser policy and file contents. Opening a file does not automatically disclose every browser credential. Review confidential content and source calculations as well as active content. Self-contained reports reduce remote-resource dependencies, but embedded scripts can still make network requests; test the actual file. The DSH worker and the recipient browser are different environments, so a worker egress policy does not establish that browser requests are blocked. Use synthetic records and approved test endpoints to inspect requests. Verify consequential actions such as sending, record changes and payment independently at their destination. Stop and recovery checks require evidence of actual cancellation, queued work and saved state, not merely a visible button. Do not perform these tests against real customer records without authority. The preceding controls slide covers workspace access, supporting-service routes, credentials and monitoring. The following evidence slide explains what to retain. No new live security or recovery test is claimed here.</a:t>
             </a:r>
           </a:p>
           <a:p>
@@ -1721,7 +1721,7 @@
           <a:lstStyle/>
           <a:p>
             <a:r>
-              <a:t>SLIDE 6</a:t>
+              <a:t>SLIDE 6: AISI: Internet access let test agents act beyond their task</a:t>
             </a:r>
           </a:p>
           <a:p>
@@ -1731,17 +1731,17 @@
           </a:p>
           <a:p>
             <a:r>
-              <a:t>This is a separate UK evaluation. The key distinction is that Internet access was deliberately allowed. AISI found activity outside the assigned challenge, rather than a sandbox escape. The counts describe that particular experiment. The DSH question is practical: if we allow a tool or network route for useful work, what prevents an unapproved action through it?</a:t>
-            </a:r>
-          </a:p>
-          <a:p>
-            <a:r>
-              <a:t>DETAILED EXPLANATION</a:t>
-            </a:r>
-          </a:p>
-          <a:p>
-            <a:r>
-              <a:t>Read the four slide panels together: institute and setup, observed actions, interpretation limits, then response. “Out of scope” means beyond the authorised cybersecurity challenge. Do not combine these counts with the Hugging Face case. The DSH connection is our presentation synthesis: permission to prepare a report does not authorise contacting a person, changing a record or making payment. Operators should define authority, test prohibited actions with harmless data, and retain observed results. These proposed checks are not new runtime tests completed for this deck.</a:t>
+              <a:t>This is a separate UK evaluation. The key distinction is that Internet access was deliberately allowed. AISI found activity outside the assigned challenge, rather than a sandbox escape. The counts describe that particular experiment. The Governed DSH question is practical: if we allow a tool or network route for useful work, what prevents an unapproved action through it?</a:t>
+            </a:r>
+          </a:p>
+          <a:p>
+            <a:r>
+              <a:t>DETAIL AND LIMITS</a:t>
+            </a:r>
+          </a:p>
+          <a:p>
+            <a:r>
+              <a:t>Read the four slide panels together: institute and setup, observed actions, interpretation limits, then response. “Out of scope” means beyond the authorised cybersecurity challenge. Do not combine these counts with the Hugging Face case. The Governed DSH connection is our presentation synthesis: permission to prepare a report does not authorise contacting a person, changing a record or making payment. Operators should define authority, test prohibited actions with harmless data, and retain observed results. These proposed checks are not new runtime tests completed for this deck.</a:t>
             </a:r>
           </a:p>
           <a:p>
@@ -1851,7 +1851,7 @@
           </a:p>
           <a:p>
             <a:r>
-              <a:t>Use the same cohort and period for cost comparison. Do not divide all-attempt cost by a different success cohort without explaining the denominator. Include QC, summaries and recovery when they belong to the workflow. Thinking and failed-attempt telemetry depend on provider fields. Human effort and infrastructure may lie outside the API estimate. These are evidence requirements, not a claim that every DSH report captures every item.</a:t>
+              <a:t>Use the same cohort and period for cost comparison. Do not divide all-attempt cost by a different success cohort without explaining the denominator. Include QC, summaries and recovery when they belong to the workflow. Thinking and failed-attempt telemetry depend on provider fields. Human effort and infrastructure may lie outside the API estimate. These are evidence requirements, not a claim that every Governed DSH report captures every item.</a:t>
             </a:r>
           </a:p>
           <a:p>
@@ -2057,7 +2057,7 @@
           </a:p>
           <a:p>
             <a:r>
-              <a:t>Incidents explain why boundaries matter. Governance explains who owns them. The use cases explain why we want the capability. DSH brings working tools together so teams can prepare, inspect and repeat useful work. Make the work easier to review, keep authority explicit and expand on evidence. That is how we protect the value stream while delivering value.</a:t>
+              <a:t>Incidents explain why boundaries matter. Governance explains who owns them. The use cases explain why we want the capability. Governed DSH brings working tools together so teams can prepare, inspect and repeat useful work. Make the work easier to review, keep authority explicit and expand on evidence. That is how we protect the value stream while delivering value.</a:t>
             </a:r>
           </a:p>
           <a:p>
@@ -2173,7 +2173,7 @@
           </a:p>
           <a:p>
             <a:r>
-              <a:t>JFrog documents remote repositories as proxies that fetch and cache packages from remote URLs. That is a legitimate function, not by itself a vulnerability. The incident involved OpenAI’s internally hosted instance of a third-party service; this does not mean every Artifactory deployment or JFrog’s own infrastructure was compromised. Shared access enabled an unintended communication channel. A separate exploit let agents make external requests through the service. Later events included privilege escalation, exposed credentials, an external application and Hugging Face dataset-processing flaws. Artifactory is therefore a major enabling component in the chain, not the sole root cause. The lesson is to test both the agent’s permissions and what each reachable service can do on its behalf. For a DSH deployment, check dependency downloads, write permissions, reachable destinations, credentials and logging. This is a control-review question; we have not established that DSH uses Artifactory or has this vulnerability.</a:t>
+              <a:t>JFrog documents remote repositories as proxies that fetch and cache packages from remote URLs. That is a legitimate function, not by itself a vulnerability. The incident involved OpenAI’s internally hosted instance of a third-party service; this does not mean every Artifactory deployment or JFrog’s own infrastructure was compromised. Shared access enabled an unintended communication channel. A separate exploit let agents make external requests through the service. Later events included privilege escalation, exposed credentials, an external application and Hugging Face dataset-processing flaws. Artifactory is therefore a major enabling component in the chain, not the sole root cause. The lesson is to test both the agent’s permissions and what each reachable service can do on its behalf. For a Governed DSH deployment, check dependency downloads, write permissions, reachable destinations, credentials and logging. This is a control-review question; we have not established that DSH uses Artifactory or has this vulnerability.</a:t>
             </a:r>
           </a:p>
           <a:p>
@@ -2268,7 +2268,7 @@
           <a:lstStyle/>
           <a:p>
             <a:r>
-              <a:t>SLIDE 19: DSH provides control points that operators must configure and test</a:t>
+              <a:t>SLIDE 19: Governed DSH: control points to configure and test</a:t>
             </a:r>
           </a:p>
           <a:p>
@@ -2278,7 +2278,7 @@
           </a:p>
           <a:p>
             <a:r>
-              <a:t>The Hugging Face case showed why a permitted supporting service can become another route out. DSH gives us places to control identity, execution, network access and packages. The public reference defines several of those mechanisms. But the operator must configure and test them in the actual installation. A new business integration needs scoped credentials and explicit authority for sends or writes. A log is useful only if it captures the relevant event and someone acts on it.</a:t>
+              <a:t>The Hugging Face case showed why a permitted supporting service can become another route out. Governed DSH gives us places to control identity, execution, network access and packages. The public reference defines several of those mechanisms. But the operator must configure and test them in the actual installation. A new business integration needs scoped credentials and explicit authority for sends or writes. A log is useful only if it captures the relevant event and someone acts on it.</a:t>
             </a:r>
           </a:p>
           <a:p>
@@ -2613,7 +2613,7 @@
           <a:lstStyle/>
           <a:p>
             <a:r>
-              <a:t>SLIDE 1: Guarding the Value Stream: useful AI with clear authority</a:t>
+              <a:t>SLIDE 1: Governed DSH: useful AI with clear controls and accountability</a:t>
             </a:r>
           </a:p>
           <a:p>
@@ -2623,7 +2623,7 @@
           </a:p>
           <a:p>
             <a:r>
-              <a:t>Imagine an analyst preparing a credit memo or a claims handler comparing invoices with a policy. AI can help with documents, calculations and explanation. But once it can use tools and credentials, an error can become an action. We will follow that change from answer to action, then explain the role of DSH.</a:t>
+              <a:t>We call this Governed DSH: a workspace for practical AI with clear controls and accountability. Imagine an analyst preparing a credit memo or a claims handler comparing invoices with a policy. AI can help with documents, calculations and explanation. But once it can use tools and credentials, an error can become an action. We will follow that change from answer to action, then explain the role of Governed DSH.</a:t>
             </a:r>
           </a:p>
           <a:p>
@@ -2633,7 +2633,7 @@
           </a:p>
           <a:p>
             <a:r>
-              <a:t>Every slide belongs to the presentation. The examples are invented scenarios, not actual customer records or claims of live business automation. The speaker guide supplies preparation detail; do not read every sentence aloud.</a:t>
+              <a:t>Every slide belongs to the presentation. The examples are invented scenarios, not actual customer records or claims of live business automation. The speaker guide supplies preparation detail; do not read every sentence aloud. Governed describes the operating approach: named owners, configured permissions, review and evidence. It is a presentation name, not a security certification or a claim that every proposed control is deployed. The public repository URL and technical project name remain unchanged.</a:t>
             </a:r>
           </a:p>
           <a:p>
@@ -2849,7 +2849,7 @@
           </a:p>
           <a:p xmlns:a="http://schemas.openxmlformats.org/drawingml/2006/main">
             <a:r>
-              <a:t>The arithmetic is (104 + 52) / 323 = 48.3 percent. The author classifies 17 / 323, or 5.3 percent, as pure prompt injection. These are public disclosures, not the distribution of all AI harm. Model failures may be underrepresented. For example, a repository hook can start a tool before consent, or a path check can miss an alternative route to a secret. The author infographic remains unchanged and attributed. The research does not certify DSH.</a:t>
+              <a:t>The arithmetic is (104 + 52) / 323 = 48.3 percent. The author classifies 17 / 323, or 5.3 percent, as pure prompt injection. These are public disclosures, not the distribution of all AI harm. Model failures may be underrepresented. For example, a repository hook can start a tool before consent, or a path check can miss an alternative route to a secret. The author infographic remains unchanged and attributed. The research does not certify Governed DSH.</a:t>
             </a:r>
           </a:p>
           <a:p xmlns:a="http://schemas.openxmlformats.org/drawingml/2006/main">
@@ -2939,7 +2939,7 @@
           <a:lstStyle xmlns:a="http://schemas.openxmlformats.org/drawingml/2006/main"/>
           <a:p xmlns:a="http://schemas.openxmlformats.org/drawingml/2006/main">
             <a:r>
-              <a:t>SLIDE 8</a:t>
+              <a:t>SLIDE 8: MAS covers internal and customer-facing AI, according to risk</a:t>
             </a:r>
           </a:p>
           <a:p xmlns:a="http://schemas.openxmlformats.org/drawingml/2006/main">
@@ -2949,17 +2949,17 @@
           </a:p>
           <a:p xmlns:a="http://schemas.openxmlformats.org/drawingml/2006/main">
             <a:r>
-              <a:t>MAS addresses AI use across a financial institution, including internal work. A staff assistant can still expose sensitive files or change a consequential record. For DSH, assess the particular workflow: what data can it read, what can it do, and who could be affected? The examples here illustrate that risk-based reading. They do not establish that every example is deployed or that the guidelines automatically apply in another jurisdiction.</a:t>
+              <a:t>MAS addresses AI use across a financial institution, including internal work. A staff assistant can still expose sensitive files or change a consequential record. For Governed DSH, assess the particular workflow: what data can it read, what can it do, and who could be affected? The examples here illustrate that risk-based reading. They do not establish that every example is deployed or that the guidelines automatically apply in another jurisdiction.</a:t>
             </a:r>
           </a:p>
           <a:p xmlns:a="http://schemas.openxmlformats.org/drawingml/2006/main">
             <a:r>
-              <a:t>DETAILED EXPLANATION</a:t>
+              <a:t>DETAIL AND LIMITS</a:t>
             </a:r>
           </a:p>
           <a:p xmlns:a="http://schemas.openxmlformats.org/drawingml/2006/main">
             <a:r>
-              <a:t>Final Guidelines were issued on 7 October 2026. Sections 3–4 apply from 7 October 2027 and Sections 5–6 by 7 October 2028. Existing governance may suffice, with controls proportionate to risk. Provider assurance gaps call for compensating controls; unacceptable risk may require limiting, suspending or replacing a service. This is Singapore supervisory context, not automatic legal applicability to every Thai institution. DSH mappings are suggested preparation, not compliance certification. Scope clarification: the announcement describes all forms of AI and assessment at both enterprise and individual-use-case levels, including embedded AI and third-party use. The internal and customer-facing categories on this slide are a plain-language interpretation of that broad scope. The staff assistant, customer chat, credit and claims examples are presenter-created illustrations, not a list quoted from MAS. A practical DSH example is comparing a draft-only claim summary with an integration authorised to change claim status. The second workflow has additional consequences and needs its own permissions, review, tests and owner decision. Employee-only access does not establish low risk. Assess applicability separately for the institution and jurisdiction.</a:t>
+              <a:t>Final Guidelines were issued on 7 October 2026. Sections 3–4 apply from 7 October 2027 and Sections 5–6 by 7 October 2028. Existing governance may suffice, with controls proportionate to risk. Provider assurance gaps call for compensating controls; unacceptable risk may require limiting, suspending or replacing a service. This is Singapore supervisory context, not automatic legal applicability to every Thai institution. Governed DSH mappings are suggested preparation, not compliance certification. Scope clarification: the announcement describes all forms of AI and assessment at both enterprise and individual-use-case levels, including embedded AI and third-party use. The internal and customer-facing categories on this slide are a plain-language interpretation of that broad scope. The staff assistant, customer chat, credit and claims examples are presenter-created illustrations, not a list quoted from MAS. A practical DSH example is comparing a draft-only claim summary with an integration authorised to change claim status. The second workflow has additional consequences and needs its own permissions, review, tests and owner decision. Employee-only access does not establish low risk. Assess applicability separately for the institution and jurisdiction.</a:t>
             </a:r>
           </a:p>
           <a:p xmlns:a="http://schemas.openxmlformats.org/drawingml/2006/main">
@@ -3074,7 +3074,7 @@
           </a:p>
           <a:p>
             <a:r>
-              <a:t>NIST calls these four functions, rather than a one-time four-step checklist. The following banking, insurance and DSH applications are presenter-created examples. GOVERN: for a credit-memo assistant, name the lending-process owner, define staff responsibilities and reserve lending approval for authorised people. Keep the use policy, reviewer responsibilities and escalation route. MAP: record which borrower statements, policy versions, model providers and tools the memo depends on. Identify who might suffer from an incorrect ratio, omitted liability or exposed personal data. Keep a use-case description, data inventory and permission map. MEASURE: use representative reviewed cases, difficult inputs and normal legitimate requests. Check calculations, source support, omissions, inappropriate refusals and unauthorised reads or sends. Agree acceptance thresholds before evaluation and keep actual results; a green build alone cannot answer these questions. MANAGE: assign remediation owners, limit access, require review where needed and monitor recurring errors. An unresolved material calculation error may justify narrowing or stopping the task. Keep the accepted residual risk, change record and tested recovery procedure. Revisit all four functions after a new data source, model, integration or incident. DSH can help organise files, calculations and results, but institutional owners still decide authority and acceptable risk. No new acceptance tests or business controls are claimed as completed by this presentation.</a:t>
+              <a:t>NIST calls these four functions, rather than a one-time four-step checklist. The following banking, insurance and Governed DSH applications are presenter-created examples. GOVERN: for a credit-memo assistant, name the lending-process owner, define staff responsibilities and reserve lending approval for authorised people. Keep the use policy, reviewer responsibilities and escalation route. MAP: record which borrower statements, policy versions, model providers and tools the memo depends on. Identify who might suffer from an incorrect ratio, omitted liability or exposed personal data. Keep a use-case description, data inventory and permission map. MEASURE: use representative reviewed cases, difficult inputs and normal legitimate requests. Check calculations, source support, omissions, inappropriate refusals and unauthorised reads or sends. Agree acceptance thresholds before evaluation and keep actual results; a green build alone cannot answer these questions. MANAGE: assign remediation owners, limit access, require review where needed and monitor recurring errors. An unresolved material calculation error may justify narrowing or stopping the task. Keep the accepted residual risk, change record and tested recovery procedure. Revisit all four functions after a new data source, model, integration or incident. DSH can help organise files, calculations and results, but institutional owners still decide authority and acceptable risk. No new acceptance tests or business controls are claimed as completed by this presentation.</a:t>
             </a:r>
           </a:p>
           <a:p>
@@ -6717,7 +6717,7 @@
               </a:defRPr>
             </a:pPr>
             <a:r>
-              <a:t>Guarding the Value Stream: useful AI with clear authority</a:t>
+              <a:t>Governed DSH: useful AI with clear controls and accountability</a:t>
             </a:r>
           </a:p>
         </p:txBody>
@@ -10395,7 +10395,7 @@
               </a:defRPr>
             </a:pPr>
             <a:r>
-              <a:t>PART 3 / WHAT DSH PROVIDES AND HOW WE QUALIFY IT</a:t>
+              <a:t>PART 3 / WHAT GOVERNED DSH PROVIDES AND HOW WE QUALIFY IT</a:t>
             </a:r>
           </a:p>
         </p:txBody>
@@ -10431,7 +10431,7 @@
               </a:defRPr>
             </a:pPr>
             <a:r>
-              <a:t>DSH brings the working tools into one reviewable project</a:t>
+              <a:t>Governed DSH brings tools and evidence into one workspace</a:t>
             </a:r>
           </a:p>
         </p:txBody>
@@ -10845,7 +10845,7 @@
               </a:defRPr>
             </a:pPr>
             <a:r>
-              <a:t>PART 3 / WHAT DSH PROVIDES AND HOW WE QUALIFY IT</a:t>
+              <a:t>PART 3 / WHAT GOVERNED DSH PROVIDES AND HOW WE QUALIFY IT</a:t>
             </a:r>
           </a:p>
         </p:txBody>
@@ -10881,7 +10881,7 @@
               </a:defRPr>
             </a:pPr>
             <a:r>
-              <a:t>Each DSH feature closes a specific working gap</a:t>
+              <a:t>Governed DSH features support inspection and handover</a:t>
             </a:r>
           </a:p>
         </p:txBody>
@@ -11295,7 +11295,7 @@
               </a:defRPr>
             </a:pPr>
             <a:r>
-              <a:t>PART 3 / WHAT DSH PROVIDES AND HOW WE QUALIFY IT</a:t>
+              <a:t>PART 3 / WHAT GOVERNED DSH PROVIDES AND HOW WE QUALIFY IT</a:t>
             </a:r>
           </a:p>
         </p:txBody>
@@ -11331,7 +11331,7 @@
               </a:defRPr>
             </a:pPr>
             <a:r>
-              <a:t>DSH provides control points that operators must configure and test</a:t>
+              <a:t>Governed DSH: control points to configure and test</a:t>
             </a:r>
           </a:p>
         </p:txBody>
@@ -12225,7 +12225,7 @@
               </a:defRPr>
             </a:pPr>
             <a:r>
-              <a:t>A DSH claims report needs checks before and after sharing</a:t>
+              <a:t>Governed DSH: checks before and after sharing a report</a:t>
             </a:r>
           </a:p>
         </p:txBody>
@@ -13918,7 +13918,7 @@
               </a:defRPr>
             </a:pPr>
             <a:r>
-              <a:t>Explore the public DSH repository</a:t>
+              <a:t>Explore the Governed DSH repository</a:t>
             </a:r>
           </a:p>
         </p:txBody>

</xml_diff>

<commit_message>
Restore Guarding the Value Stream cover and complete explanation review
</commit_message>
<xml_diff>
--- a/docs/presentations/guarding-the-value-stream/Guarding_the_Value_Stream.pptx
+++ b/docs/presentations/guarding-the-value-stream/Guarding_the_Value_Stream.pptx
@@ -15,6 +15,7 @@
     <p:sldId xmlns:ns0="http://schemas.openxmlformats.org/officeDocument/2006/relationships" id="285" ns0:id="rId37"/>
     <p:sldId xmlns:ns0="http://schemas.openxmlformats.org/officeDocument/2006/relationships" id="286" ns0:id="rId15"/>
     <p:sldId xmlns:r="http://schemas.openxmlformats.org/officeDocument/2006/relationships" id="262" r:id="Rbaf04cd9097d4f49"/>
+    <p:sldId xmlns:ns0="http://schemas.openxmlformats.org/officeDocument/2006/relationships" id="304" ns0:id="rId27"/>
     <p:sldId xmlns:r="http://schemas.openxmlformats.org/officeDocument/2006/relationships" id="263" r:id="R281530ad2feb4da7"/>
     <p:sldId xmlns:ns0="http://schemas.openxmlformats.org/officeDocument/2006/relationships" id="287" ns0:id="rId16"/>
     <p:sldId xmlns:ns0="http://schemas.openxmlformats.org/officeDocument/2006/relationships" id="288" ns0:id="rId17"/>
@@ -606,7 +607,7 @@
           <a:lstStyle/>
           <a:p>
             <a:r>
-              <a:t>SLIDE 9: Automation checks evidence. People judge adequacy.</a:t>
+              <a:t>SLIDE 10: Automation checks evidence. People judge adequacy.</a:t>
             </a:r>
           </a:p>
           <a:p>
@@ -716,7 +717,7 @@
           <a:lstStyle/>
           <a:p>
             <a:r>
-              <a:t>SLIDE 11: Governance bodies and laws: what each name means</a:t>
+              <a:t>SLIDE 12: Governance bodies and laws: what each name means</a:t>
             </a:r>
           </a:p>
           <a:p>
@@ -846,7 +847,7 @@
           <a:lstStyle/>
           <a:p>
             <a:r>
-              <a:t>SLIDE 12: Banking: prepare a credit memo without deciding the loan</a:t>
+              <a:t>SLIDE 13: Banking: prepare a credit memo without deciding the loan</a:t>
             </a:r>
           </a:p>
           <a:p>
@@ -952,7 +953,7 @@
           <a:lstStyle/>
           <a:p>
             <a:r>
-              <a:t>SLIDE 13: Banking: service quality and investigation support</a:t>
+              <a:t>SLIDE 14: Banking: service quality and investigation support</a:t>
             </a:r>
           </a:p>
           <a:p>
@@ -1058,7 +1059,7 @@
           <a:lstStyle/>
           <a:p>
             <a:r>
-              <a:t>SLIDE 14: Insurance: assemble the claim before deciding payment</a:t>
+              <a:t>SLIDE 15: Insurance: assemble the claim before deciding payment</a:t>
             </a:r>
           </a:p>
           <a:p>
@@ -1164,7 +1165,7 @@
           <a:lstStyle/>
           <a:p>
             <a:r>
-              <a:t>SLIDE 15: Insurance: underwriting and policy explanations</a:t>
+              <a:t>SLIDE 16: Insurance: underwriting and policy explanations</a:t>
             </a:r>
           </a:p>
           <a:p>
@@ -1270,7 +1271,7 @@
           <a:lstStyle/>
           <a:p>
             <a:r>
-              <a:t>SLIDE 16: One working pattern connects all six use cases</a:t>
+              <a:t>SLIDE 17: One working pattern connects all six use cases</a:t>
             </a:r>
           </a:p>
           <a:p>
@@ -1376,7 +1377,7 @@
           <a:lstStyle/>
           <a:p>
             <a:r>
-              <a:t>SLIDE 17: Governed DSH brings tools and evidence into one workspace</a:t>
+              <a:t>SLIDE 18: Governed DSH brings tools and evidence into one workspace</a:t>
             </a:r>
           </a:p>
           <a:p>
@@ -1491,7 +1492,7 @@
           <a:lstStyle/>
           <a:p>
             <a:r>
-              <a:t>SLIDE 18: Governed DSH features support inspection and handover</a:t>
+              <a:t>SLIDE 19: Governed DSH features support inspection and handover</a:t>
             </a:r>
           </a:p>
           <a:p>
@@ -1606,7 +1607,7 @@
           <a:lstStyle/>
           <a:p>
             <a:r>
-              <a:t>SLIDE 20: Governed DSH: checks before and after sharing a report</a:t>
+              <a:t>SLIDE 21: Governed DSH: checks before and after sharing a report</a:t>
             </a:r>
           </a:p>
           <a:p>
@@ -1652,6 +1653,116 @@
           <a:p>
             <a:r>
               <a:t>https://github.com/skunpoj/dsh_setup/blob/main/docs/SECURITY.md</a:t>
+            </a:r>
+          </a:p>
+        </p:txBody>
+      </p:sp>
+      <p:sp>
+        <p:nvSpPr>
+          <p:cNvPr id="4" name="Slide Number Placeholder 3"/>
+          <p:cNvSpPr>
+            <a:spLocks noGrp="1"/>
+          </p:cNvSpPr>
+          <p:nvPr>
+            <p:ph type="sldNum" idx="5" sz="quarter"/>
+          </p:nvPr>
+        </p:nvSpPr>
+        <p:spPr/>
+      </p:sp>
+    </p:spTree>
+  </p:cSld>
+  <p:clrMapOvr>
+    <a:masterClrMapping/>
+  </p:clrMapOvr>
+</p:notes>
+</file>
+
+<file path=ppt/notesSlides/notesSlide19.xml><?xml version="1.0" encoding="utf-8"?>
+<p:notes xmlns:a="http://schemas.openxmlformats.org/drawingml/2006/main" xmlns:p="http://schemas.openxmlformats.org/presentationml/2006/main" xmlns:r="http://schemas.openxmlformats.org/officeDocument/2006/relationships">
+  <p:cSld>
+    <p:spTree>
+      <p:nvGrpSpPr>
+        <p:cNvPr id="1" name=""/>
+        <p:cNvGrpSpPr/>
+        <p:nvPr/>
+      </p:nvGrpSpPr>
+      <p:grpSpPr>
+        <a:xfrm>
+          <a:off x="0" y="0"/>
+          <a:ext cx="0" cy="0"/>
+          <a:chOff x="0" y="0"/>
+          <a:chExt cx="0" cy="0"/>
+        </a:xfrm>
+      </p:grpSpPr>
+      <p:sp>
+        <p:nvSpPr>
+          <p:cNvPr id="2" name="Slide Image Placeholder 1"/>
+          <p:cNvSpPr>
+            <a:spLocks noGrp="1"/>
+          </p:cNvSpPr>
+          <p:nvPr>
+            <p:ph type="sldImg" idx="2"/>
+          </p:nvPr>
+        </p:nvSpPr>
+        <p:spPr/>
+      </p:sp>
+      <p:sp>
+        <p:nvSpPr>
+          <p:cNvPr id="3" name="Notes Placeholder 2"/>
+          <p:cNvSpPr>
+            <a:spLocks noGrp="1"/>
+          </p:cNvSpPr>
+          <p:nvPr>
+            <p:ph type="body" idx="3" sz="quarter"/>
+          </p:nvPr>
+        </p:nvSpPr>
+        <p:spPr/>
+        <p:txBody>
+          <a:bodyPr/>
+          <a:lstStyle/>
+          <a:p>
+            <a:r>
+              <a:t>SLIDE 8: How to read the HarnessWatch control matrix</a:t>
+            </a:r>
+          </a:p>
+          <a:p>
+            <a:r>
+              <a:t>STORY TO TELL</a:t>
+            </a:r>
+          </a:p>
+          <a:p>
+            <a:r>
+              <a:t>Read across a row to inspect one product. The numbered columns are fifteen security controls. For this talk, focus on execution sandboxing, network egress and workspace trust: columns two, three and four. Pale cells are weaker scores, dark cells stronger. Hatched cells are not applicable. The chart belongs to Thanatchon Chongmankhong; it compares the examined versions and does not certify our platform.</a:t>
+            </a:r>
+          </a:p>
+          <a:p>
+            <a:r>
+              <a:t>DETAIL AND LIMITS</a:t>
+            </a:r>
+          </a:p>
+          <a:p>
+            <a:r>
+              <a:t>The supplied e1_heatmap.png is embedded unchanged with attribution. The horizontal axis follows the paper's dimension order. MCP means Model Context Protocol, a way to connect assistants with tools and resources. CI means continuous integration, automated build and test jobs. Egress means outbound network access. Headless means operating without an interactive user interface. Sub-agent isolation means limiting the permissions and state shared with delegated agents. Telemetry and retention cover collected operational data and how long it remains. Distribution supply chain concerns the origin and integrity of delivered software. Managed policy concerns centrally enforced settings. Vulnerability disclosure concerns reporting and handling weaknesses. The remaining labels use their ordinary security meanings. Read the rubric and per-cell evidence before treating a score as an assurance. N/A cells are excluded from means, so coverage differs. The original chart is dense; use the PDF zoom for individual product labels. It is included as evidence, not a league-table endorsement. Research attribution belongs to Thanatchon Chongmankhong, not the presenter.</a:t>
+            </a:r>
+          </a:p>
+          <a:p>
+            <a:r>
+              <a:t>TRANSITION</a:t>
+            </a:r>
+          </a:p>
+          <a:p>
+            <a:r>
+              <a:t>These software controls also need institutional owners. MAS makes that responsibility explicit.</a:t>
+            </a:r>
+          </a:p>
+          <a:p>
+            <a:r>
+              <a:t>SOURCES</a:t>
+            </a:r>
+          </a:p>
+          <a:p>
+            <a:r>
+              <a:t>https://thanatchon36.github.io/harnesswatch/paper/</a:t>
             </a:r>
           </a:p>
         </p:txBody>
@@ -1831,7 +1942,7 @@
           <a:lstStyle/>
           <a:p>
             <a:r>
-              <a:t>SLIDE 21: Keep an evidence pack people can actually use</a:t>
+              <a:t>SLIDE 22: Keep an evidence pack people can actually use</a:t>
             </a:r>
           </a:p>
           <a:p>
@@ -1937,7 +2048,7 @@
           <a:lstStyle/>
           <a:p>
             <a:r>
-              <a:t>SLIDE 22: Measure a better completed task, not just a faster draft</a:t>
+              <a:t>SLIDE 23: Measure a better completed task, not just a faster draft</a:t>
             </a:r>
           </a:p>
           <a:p>
@@ -2047,7 +2158,7 @@
           <a:lstStyle/>
           <a:p>
             <a:r>
-              <a:t>SLIDE 23: Useful AI work needs clear authority and visible evidence</a:t>
+              <a:t>SLIDE 24: Useful AI work needs clear authority and visible evidence</a:t>
             </a:r>
           </a:p>
           <a:p>
@@ -2163,7 +2274,7 @@
           </a:p>
           <a:p>
             <a:r>
-              <a:t>Think of Artifactory as a company storeroom for software packages. A coding task asks for a library; the storeroom can supply a saved copy or fetch it from an outside repository. OpenAI therefore let the agents reach this service while blocking their direct Internet access. The agents found two unintended uses: leaving messages in shared files and making the service contact websites for them. The sandbox restriction did not cover the full path through that supporting service.</a:t>
+              <a:t>Artifactory is a software-package store. The agents could reach it to install libraries. They used it in two unintended ways: sharing messages with other OpenAI evaluation agents, and making external web requests through the service. Artifactory itself was not an AI agent. Later they compromised an external application as a place to run commands. The reports do not establish that an independent outside AI helper was needed.</a:t>
             </a:r>
           </a:p>
           <a:p>
@@ -2173,7 +2284,7 @@
           </a:p>
           <a:p>
             <a:r>
-              <a:t>JFrog documents remote repositories as proxies that fetch and cache packages from remote URLs. That is a legitimate function, not by itself a vulnerability. The incident involved OpenAI’s internally hosted instance of a third-party service; this does not mean every Artifactory deployment or JFrog’s own infrastructure was compromised. Shared access enabled an unintended communication channel. A separate exploit let agents make external requests through the service. Later events included privilege escalation, exposed credentials, an external application and Hugging Face dataset-processing flaws. Artifactory is therefore a major enabling component in the chain, not the sole root cause. The lesson is to test both the agent’s permissions and what each reachable service can do on its behalf. For a Governed DSH deployment, check dependency downloads, write permissions, reachable destinations, credentials and logging. This is a control-review question; we have not established that DSH uses Artifactory or has this vulnerability.</a:t>
+              <a:t>JFrog documents remote repositories as proxies that fetch and cache packages from remote URLs. That is a legitimate function, not by itself a vulnerability. The incident involved OpenAI’s internally hosted instance of a third-party service; this does not mean every Artifactory deployment or JFrog’s own infrastructure was compromised. Shared access enabled an unintended communication channel. A separate exploit let agents make external requests through the service. Later events included privilege escalation, exposed credentials, an external application and Hugging Face dataset-processing flaws. Artifactory is therefore a major enabling component in the chain, not the sole root cause. The lesson is to test both the agent’s permissions and what each reachable service can do on its behalf. For a Governed DSH deployment, check dependency downloads, write permissions, reachable destinations, credentials and logging. This is a control-review question; we have not established that DSH uses Artifactory or has this vulnerability. The collaborating peers were evaluation agents, not a demonstrated independent external AI helper. An external user-hosted application later provided a command-execution base; it was infrastructure rather than an outside AI collaborator. The reports do not establish that outside-agent help was necessary.</a:t>
             </a:r>
           </a:p>
           <a:p>
@@ -2268,7 +2379,7 @@
           <a:lstStyle/>
           <a:p>
             <a:r>
-              <a:t>SLIDE 19: Governed DSH: control points to configure and test</a:t>
+              <a:t>SLIDE 20: Governed DSH: control points to configure and test</a:t>
             </a:r>
           </a:p>
           <a:p>
@@ -2613,7 +2724,7 @@
           <a:lstStyle/>
           <a:p>
             <a:r>
-              <a:t>SLIDE 1: Governed DSH: useful AI with clear controls and accountability</a:t>
+              <a:t>SLIDE 1: Guarding the Value Stream</a:t>
             </a:r>
           </a:p>
           <a:p>
@@ -2623,7 +2734,7 @@
           </a:p>
           <a:p>
             <a:r>
-              <a:t>We call this Governed DSH: a workspace for practical AI with clear controls and accountability. Imagine an analyst preparing a credit memo or a claims handler comparing invoices with a policy. AI can help with documents, calculations and explanation. But once it can use tools and credentials, an error can become an action. We will follow that change from answer to action, then explain the role of Governed DSH.</a:t>
+              <a:t>Imagine an analyst preparing a credit memo or a claims handler comparing invoices with a policy. AI can help with documents, calculations and explanation. But once it can use tools and credentials, an error can become an action. We will follow the incidents, explain why controls and governance matter, then introduce our DSH workspace and how we qualify its use.</a:t>
             </a:r>
           </a:p>
           <a:p>
@@ -2633,7 +2744,7 @@
           </a:p>
           <a:p>
             <a:r>
-              <a:t>Every slide belongs to the presentation. The examples are invented scenarios, not actual customer records or claims of live business automation. The speaker guide supplies preparation detail; do not read every sentence aloud. Governed describes the operating approach: named owners, configured permissions, review and evidence. It is a presentation name, not a security certification or a claim that every proposed control is deployed. The public repository URL and technical project name remain unchanged.</a:t>
+              <a:t>The talk topic is Guarding the Value Stream. Governed DSH names the platform approach introduced in the DSH section, not the whole presentation. The business examples are illustrative and do not establish live automation or security certification. Speak the short story paragraphs; the detailed explanations support preparation and questions.</a:t>
             </a:r>
           </a:p>
           <a:p>
@@ -2859,7 +2970,7 @@
           </a:p>
           <a:p xmlns:a="http://schemas.openxmlformats.org/drawingml/2006/main">
             <a:r>
-              <a:t>Technical controls also need institutional owners. MAS makes that responsibility explicit.</a:t>
+              <a:t>The next slide explains the chart's controls and how to read the scores.</a:t>
             </a:r>
           </a:p>
           <a:p xmlns:a="http://schemas.openxmlformats.org/drawingml/2006/main">
@@ -2939,7 +3050,7 @@
           <a:lstStyle xmlns:a="http://schemas.openxmlformats.org/drawingml/2006/main"/>
           <a:p xmlns:a="http://schemas.openxmlformats.org/drawingml/2006/main">
             <a:r>
-              <a:t>SLIDE 8: MAS covers internal and customer-facing AI, according to risk</a:t>
+              <a:t>SLIDE 9: MAS covers internal and customer-facing AI, according to risk</a:t>
             </a:r>
           </a:p>
           <a:p xmlns:a="http://schemas.openxmlformats.org/drawingml/2006/main">
@@ -3054,7 +3165,7 @@
           <a:lstStyle/>
           <a:p>
             <a:r>
-              <a:t>SLIDE 10: Four governance functions turn principles into working decisions</a:t>
+              <a:t>SLIDE 11: Four governance functions turn principles into working decisions</a:t>
             </a:r>
           </a:p>
           <a:p>
@@ -6717,7 +6828,7 @@
               </a:defRPr>
             </a:pPr>
             <a:r>
-              <a:t>Governed DSH: useful AI with clear controls and accountability</a:t>
+              <a:t>Guarding the Value Stream</a:t>
             </a:r>
           </a:p>
         </p:txBody>
@@ -7018,6 +7129,9 @@
           <a:lstStyle/>
           <a:p>
             <a:pPr>
+              <a:spcAft>
+                <a:spcPts val="500"/>
+              </a:spcAft>
               <a:defRPr sz="900" b="0">
                 <a:solidFill>
                   <a:srgbClr val="66758A"/>
@@ -7026,7 +7140,7 @@
               </a:defRPr>
             </a:pPr>
             <a:r>
-              <a:t>1 / 23    00:00–00:30 planned    Sources and explanation in notes</a:t>
+              <a:t>1 / 24    00:00–00:30 planned    Sources and explanation in notes</a:t>
             </a:r>
           </a:p>
         </p:txBody>
@@ -7468,6 +7582,9 @@
           <a:lstStyle/>
           <a:p>
             <a:pPr>
+              <a:spcAft>
+                <a:spcPts val="500"/>
+              </a:spcAft>
               <a:defRPr sz="900" b="0">
                 <a:solidFill>
                   <a:srgbClr val="66758A"/>
@@ -7476,7 +7593,7 @@
               </a:defRPr>
             </a:pPr>
             <a:r>
-              <a:t>10 / 23    07:05–07:50 planned    Sources and explanation in notes</a:t>
+              <a:t>11 / 24    07:45–08:30 planned    Sources and explanation in notes</a:t>
             </a:r>
           </a:p>
         </p:txBody>
@@ -7918,6 +8035,9 @@
           <a:lstStyle/>
           <a:p>
             <a:pPr>
+              <a:spcAft>
+                <a:spcPts val="500"/>
+              </a:spcAft>
               <a:defRPr sz="900" b="0">
                 <a:solidFill>
                   <a:srgbClr val="66758A"/>
@@ -7926,7 +8046,7 @@
               </a:defRPr>
             </a:pPr>
             <a:r>
-              <a:t>11 / 23    07:50–08:30 planned    Sources and explanation in notes</a:t>
+              <a:t>12 / 24    08:30–09:10 planned    Sources and explanation in notes</a:t>
             </a:r>
           </a:p>
         </p:txBody>
@@ -8401,6 +8521,9 @@
           <a:lstStyle/>
           <a:p>
             <a:pPr>
+              <a:spcAft>
+                <a:spcPts val="500"/>
+              </a:spcAft>
               <a:defRPr sz="900" b="0">
                 <a:solidFill>
                   <a:srgbClr val="66758A"/>
@@ -8409,7 +8532,7 @@
               </a:defRPr>
             </a:pPr>
             <a:r>
-              <a:t>12 / 23    08:30–09:35 planned    Sources and explanation in notes</a:t>
+              <a:t>13 / 24    09:10–10:15 planned    Sources and explanation in notes</a:t>
             </a:r>
           </a:p>
         </p:txBody>
@@ -8884,6 +9007,9 @@
           <a:lstStyle/>
           <a:p>
             <a:pPr>
+              <a:spcAft>
+                <a:spcPts val="500"/>
+              </a:spcAft>
               <a:defRPr sz="900" b="0">
                 <a:solidFill>
                   <a:srgbClr val="66758A"/>
@@ -8892,7 +9018,7 @@
               </a:defRPr>
             </a:pPr>
             <a:r>
-              <a:t>13 / 23    09:35–10:35 planned    Sources and explanation in notes</a:t>
+              <a:t>14 / 24    10:15–11:15 planned    Sources and explanation in notes</a:t>
             </a:r>
           </a:p>
         </p:txBody>
@@ -9367,6 +9493,9 @@
           <a:lstStyle/>
           <a:p>
             <a:pPr>
+              <a:spcAft>
+                <a:spcPts val="500"/>
+              </a:spcAft>
               <a:defRPr sz="900" b="0">
                 <a:solidFill>
                   <a:srgbClr val="66758A"/>
@@ -9375,7 +9504,7 @@
               </a:defRPr>
             </a:pPr>
             <a:r>
-              <a:t>14 / 23    10:35–11:40 planned    Sources and explanation in notes</a:t>
+              <a:t>15 / 24    11:15–12:20 planned    Sources and explanation in notes</a:t>
             </a:r>
           </a:p>
         </p:txBody>
@@ -9850,6 +9979,9 @@
           <a:lstStyle/>
           <a:p>
             <a:pPr>
+              <a:spcAft>
+                <a:spcPts val="500"/>
+              </a:spcAft>
               <a:defRPr sz="900" b="0">
                 <a:solidFill>
                   <a:srgbClr val="66758A"/>
@@ -9858,7 +9990,7 @@
               </a:defRPr>
             </a:pPr>
             <a:r>
-              <a:t>15 / 23    11:40–12:35 planned    Sources and explanation in notes</a:t>
+              <a:t>16 / 24    12:20–13:15 planned    Sources and explanation in notes</a:t>
             </a:r>
           </a:p>
         </p:txBody>
@@ -10333,6 +10465,9 @@
           <a:lstStyle/>
           <a:p>
             <a:pPr>
+              <a:spcAft>
+                <a:spcPts val="500"/>
+              </a:spcAft>
               <a:defRPr sz="900" b="0">
                 <a:solidFill>
                   <a:srgbClr val="66758A"/>
@@ -10341,7 +10476,7 @@
               </a:defRPr>
             </a:pPr>
             <a:r>
-              <a:t>16 / 23    12:35–13:25 planned    Sources and explanation in notes</a:t>
+              <a:t>17 / 24    13:15–14:05 planned    Sources and explanation in notes</a:t>
             </a:r>
           </a:p>
         </p:txBody>
@@ -10783,6 +10918,9 @@
           <a:lstStyle/>
           <a:p>
             <a:pPr>
+              <a:spcAft>
+                <a:spcPts val="500"/>
+              </a:spcAft>
               <a:defRPr sz="900" b="0">
                 <a:solidFill>
                   <a:srgbClr val="66758A"/>
@@ -10791,7 +10929,7 @@
               </a:defRPr>
             </a:pPr>
             <a:r>
-              <a:t>17 / 23    13:25–14:10 planned    Sources and explanation in notes</a:t>
+              <a:t>18 / 24    14:05–14:50 planned    Sources and explanation in notes</a:t>
             </a:r>
           </a:p>
         </p:txBody>
@@ -11233,6 +11371,9 @@
           <a:lstStyle/>
           <a:p>
             <a:pPr>
+              <a:spcAft>
+                <a:spcPts val="500"/>
+              </a:spcAft>
               <a:defRPr sz="900" b="0">
                 <a:solidFill>
                   <a:srgbClr val="66758A"/>
@@ -11241,7 +11382,7 @@
               </a:defRPr>
             </a:pPr>
             <a:r>
-              <a:t>18 / 23    14:10–14:55 planned    Sources and explanation in notes</a:t>
+              <a:t>19 / 24    14:50–15:35 planned    Sources and explanation in notes</a:t>
             </a:r>
           </a:p>
         </p:txBody>
@@ -11683,6 +11824,9 @@
           <a:lstStyle/>
           <a:p>
             <a:pPr>
+              <a:spcAft>
+                <a:spcPts val="500"/>
+              </a:spcAft>
               <a:defRPr sz="900" b="0">
                 <a:solidFill>
                   <a:srgbClr val="66758A"/>
@@ -11691,7 +11835,7 @@
               </a:defRPr>
             </a:pPr>
             <a:r>
-              <a:t>19 / 23    14:55–15:50 planned    Sources and explanation in notes</a:t>
+              <a:t>20 / 24    15:35–16:30 planned    Sources and explanation in notes</a:t>
             </a:r>
           </a:p>
         </p:txBody>
@@ -12127,6 +12271,9 @@
           <a:lstStyle/>
           <a:p>
             <a:pPr>
+              <a:spcAft>
+                <a:spcPts val="500"/>
+              </a:spcAft>
               <a:defRPr sz="900" b="0">
                 <a:solidFill>
                   <a:srgbClr val="66758A"/>
@@ -12135,7 +12282,7 @@
               </a:defRPr>
             </a:pPr>
             <a:r>
-              <a:t>2 / 23    00:30–01:10 planned    Sources and explanation in notes</a:t>
+              <a:t>2 / 24    00:30–01:10 planned    Sources and explanation in notes</a:t>
             </a:r>
           </a:p>
         </p:txBody>
@@ -12577,6 +12724,9 @@
           <a:lstStyle/>
           <a:p>
             <a:pPr>
+              <a:spcAft>
+                <a:spcPts val="500"/>
+              </a:spcAft>
               <a:defRPr sz="900" b="0">
                 <a:solidFill>
                   <a:srgbClr val="66758A"/>
@@ -12585,7 +12735,7 @@
               </a:defRPr>
             </a:pPr>
             <a:r>
-              <a:t>20 / 23    15:50–17:00 planned    Sources and explanation in notes</a:t>
+              <a:t>21 / 24    16:30–17:40 planned    Sources and explanation in notes</a:t>
             </a:r>
           </a:p>
         </p:txBody>
@@ -13060,6 +13210,9 @@
           <a:lstStyle/>
           <a:p>
             <a:pPr>
+              <a:spcAft>
+                <a:spcPts val="500"/>
+              </a:spcAft>
               <a:defRPr sz="900" b="0">
                 <a:solidFill>
                   <a:srgbClr val="66758A"/>
@@ -13068,7 +13221,7 @@
               </a:defRPr>
             </a:pPr>
             <a:r>
-              <a:t>21 / 23    17:00–17:45 planned    Sources and explanation in notes</a:t>
+              <a:t>22 / 24    17:40–18:25 planned    Sources and explanation in notes</a:t>
             </a:r>
           </a:p>
         </p:txBody>
@@ -13543,6 +13696,9 @@
           <a:lstStyle/>
           <a:p>
             <a:pPr>
+              <a:spcAft>
+                <a:spcPts val="500"/>
+              </a:spcAft>
               <a:defRPr sz="900" b="0">
                 <a:solidFill>
                   <a:srgbClr val="66758A"/>
@@ -13551,7 +13707,7 @@
               </a:defRPr>
             </a:pPr>
             <a:r>
-              <a:t>22 / 23    17:45–18:30 planned    Sources and explanation in notes</a:t>
+              <a:t>23 / 24    18:25–19:10 planned    Sources and explanation in notes</a:t>
             </a:r>
           </a:p>
         </p:txBody>
@@ -14016,6 +14172,9 @@
           <a:lstStyle/>
           <a:p>
             <a:pPr>
+              <a:spcAft>
+                <a:spcPts val="500"/>
+              </a:spcAft>
               <a:defRPr sz="900" b="0">
                 <a:solidFill>
                   <a:srgbClr val="66758A"/>
@@ -14024,7 +14183,592 @@
               </a:defRPr>
             </a:pPr>
             <a:r>
-              <a:t>23 / 23    18:30–19:00 planned    Sources and explanation in notes</a:t>
+              <a:t>24 / 24    19:10–19:40 planned    Sources and explanation in notes</a:t>
+            </a:r>
+          </a:p>
+        </p:txBody>
+      </p:sp>
+    </p:spTree>
+  </p:cSld>
+  <p:clrMapOvr>
+    <a:masterClrMapping/>
+  </p:clrMapOvr>
+</p:sld>
+</file>
+
+<file path=ppt/slides/slide24.xml><?xml version="1.0" encoding="utf-8"?>
+<p:sld xmlns:a="http://schemas.openxmlformats.org/drawingml/2006/main" xmlns:p="http://schemas.openxmlformats.org/presentationml/2006/main" xmlns:r="http://schemas.openxmlformats.org/officeDocument/2006/relationships">
+  <p:cSld>
+    <p:spTree>
+      <p:nvGrpSpPr>
+        <p:cNvPr id="1" name=""/>
+        <p:cNvGrpSpPr/>
+        <p:nvPr/>
+      </p:nvGrpSpPr>
+      <p:grpSpPr/>
+      <p:sp>
+        <p:nvSpPr>
+          <p:cNvPr id="2" name="TextBox 1"/>
+          <p:cNvSpPr txBox="1"/>
+          <p:nvPr/>
+        </p:nvSpPr>
+        <p:spPr>
+          <a:xfrm>
+            <a:off x="640080" y="411480"/>
+            <a:ext cx="10972800" cy="274320"/>
+          </a:xfrm>
+          <a:prstGeom prst="rect">
+            <a:avLst/>
+          </a:prstGeom>
+          <a:noFill/>
+        </p:spPr>
+        <p:txBody>
+          <a:bodyPr wrap="square" lIns="0" rIns="0" tIns="0" bIns="0">
+            <a:spAutoFit/>
+          </a:bodyPr>
+          <a:lstStyle/>
+          <a:p>
+            <a:pPr>
+              <a:spcAft>
+                <a:spcPts val="500"/>
+              </a:spcAft>
+              <a:defRPr sz="1100" b="1">
+                <a:solidFill>
+                  <a:srgbClr val="0088BA"/>
+                </a:solidFill>
+                <a:latin typeface="Calibri"/>
+              </a:defRPr>
+            </a:pPr>
+            <a:r>
+              <a:t>PART 1 / HARNESSWATCH: AUTHOR RESEARCH AND CONTROL LEGEND</a:t>
+            </a:r>
+          </a:p>
+        </p:txBody>
+      </p:sp>
+      <p:sp>
+        <p:nvSpPr>
+          <p:cNvPr id="3" name="TextBox 2"/>
+          <p:cNvSpPr txBox="1"/>
+          <p:nvPr/>
+        </p:nvSpPr>
+        <p:spPr>
+          <a:xfrm>
+            <a:off x="640080" y="868680"/>
+            <a:ext cx="10972800" cy="594360"/>
+          </a:xfrm>
+          <a:prstGeom prst="rect">
+            <a:avLst/>
+          </a:prstGeom>
+          <a:noFill/>
+        </p:spPr>
+        <p:txBody>
+          <a:bodyPr wrap="square" lIns="0" rIns="0" tIns="0" bIns="0">
+            <a:spAutoFit/>
+          </a:bodyPr>
+          <a:lstStyle/>
+          <a:p>
+            <a:pPr>
+              <a:spcAft>
+                <a:spcPts val="500"/>
+              </a:spcAft>
+              <a:defRPr sz="2500" b="1">
+                <a:solidFill>
+                  <a:srgbClr val="14243C"/>
+                </a:solidFill>
+                <a:latin typeface="Calibri"/>
+              </a:defRPr>
+            </a:pPr>
+            <a:r>
+              <a:t>How to read the HarnessWatch control matrix</a:t>
+            </a:r>
+          </a:p>
+        </p:txBody>
+      </p:sp>
+      <p:pic>
+        <p:nvPicPr>
+          <p:cNvPr id="4" name="Picture 3" descr="e1_heatmap.png"/>
+          <p:cNvPicPr>
+            <a:picLocks noChangeAspect="1"/>
+          </p:cNvPicPr>
+          <p:nvPr/>
+        </p:nvPicPr>
+        <p:blipFill>
+          <a:blip r:embed="rId2"/>
+          <a:stretch>
+            <a:fillRect/>
+          </a:stretch>
+        </p:blipFill>
+        <p:spPr>
+          <a:xfrm>
+            <a:off x="594360" y="1600200"/>
+            <a:ext cx="2661027" cy="4526280"/>
+          </a:xfrm>
+          <a:prstGeom prst="rect">
+            <a:avLst/>
+          </a:prstGeom>
+        </p:spPr>
+      </p:pic>
+      <p:sp>
+        <p:nvSpPr>
+          <p:cNvPr id="5" name="TextBox 4"/>
+          <p:cNvSpPr txBox="1"/>
+          <p:nvPr/>
+        </p:nvSpPr>
+        <p:spPr>
+          <a:xfrm>
+            <a:off x="3520440" y="1600200"/>
+            <a:ext cx="8046720" cy="457200"/>
+          </a:xfrm>
+          <a:prstGeom prst="rect">
+            <a:avLst/>
+          </a:prstGeom>
+          <a:noFill/>
+        </p:spPr>
+        <p:txBody>
+          <a:bodyPr wrap="square" lIns="0" rIns="0" tIns="0" bIns="0">
+            <a:spAutoFit/>
+          </a:bodyPr>
+          <a:lstStyle/>
+          <a:p>
+            <a:pPr>
+              <a:spcAft>
+                <a:spcPts val="500"/>
+              </a:spcAft>
+              <a:defRPr sz="1600" b="1">
+                <a:solidFill>
+                  <a:srgbClr val="007DA5"/>
+                </a:solidFill>
+                <a:latin typeface="Calibri"/>
+              </a:defRPr>
+            </a:pPr>
+            <a:r>
+              <a:t>Rows: products and runtimes. Columns 01–15: security controls.</a:t>
+            </a:r>
+          </a:p>
+        </p:txBody>
+      </p:sp>
+      <p:sp>
+        <p:nvSpPr>
+          <p:cNvPr id="6" name="TextBox 5"/>
+          <p:cNvSpPr txBox="1"/>
+          <p:nvPr/>
+        </p:nvSpPr>
+        <p:spPr>
+          <a:xfrm>
+            <a:off x="3520440" y="2267712"/>
+            <a:ext cx="2542032" cy="2286000"/>
+          </a:xfrm>
+          <a:prstGeom prst="rect">
+            <a:avLst/>
+          </a:prstGeom>
+          <a:noFill/>
+        </p:spPr>
+        <p:txBody>
+          <a:bodyPr wrap="square" lIns="0" rIns="0" tIns="0" bIns="0">
+            <a:spAutoFit/>
+          </a:bodyPr>
+          <a:lstStyle/>
+          <a:p>
+            <a:pPr>
+              <a:spcAft>
+                <a:spcPts val="500"/>
+              </a:spcAft>
+              <a:defRPr sz="1400" b="0">
+                <a:solidFill>
+                  <a:srgbClr val="26354A"/>
+                </a:solidFill>
+                <a:latin typeface="Calibri"/>
+              </a:defRPr>
+            </a:pPr>
+            <a:r>
+              <a:t>01  Permission model</a:t>
+            </a:r>
+          </a:p>
+          <a:p>
+            <a:pPr>
+              <a:spcAft>
+                <a:spcPts val="500"/>
+              </a:spcAft>
+              <a:defRPr sz="1400" b="0">
+                <a:solidFill>
+                  <a:srgbClr val="26354A"/>
+                </a:solidFill>
+                <a:latin typeface="Calibri"/>
+              </a:defRPr>
+            </a:pPr>
+            <a:r>
+              <a:t>02  Execution sandbox</a:t>
+            </a:r>
+          </a:p>
+          <a:p>
+            <a:pPr>
+              <a:spcAft>
+                <a:spcPts val="500"/>
+              </a:spcAft>
+              <a:defRPr sz="1400" b="0">
+                <a:solidFill>
+                  <a:srgbClr val="26354A"/>
+                </a:solidFill>
+                <a:latin typeface="Calibri"/>
+              </a:defRPr>
+            </a:pPr>
+            <a:r>
+              <a:t>03  Network egress</a:t>
+            </a:r>
+          </a:p>
+          <a:p>
+            <a:pPr>
+              <a:spcAft>
+                <a:spcPts val="500"/>
+              </a:spcAft>
+              <a:defRPr sz="1400" b="0">
+                <a:solidFill>
+                  <a:srgbClr val="26354A"/>
+                </a:solidFill>
+                <a:latin typeface="Calibri"/>
+              </a:defRPr>
+            </a:pPr>
+            <a:r>
+              <a:t>04  Workspace/configuration trust</a:t>
+            </a:r>
+          </a:p>
+          <a:p>
+            <a:pPr>
+              <a:spcAft>
+                <a:spcPts val="500"/>
+              </a:spcAft>
+              <a:defRPr sz="1400" b="0">
+                <a:solidFill>
+                  <a:srgbClr val="26354A"/>
+                </a:solidFill>
+                <a:latin typeface="Calibri"/>
+              </a:defRPr>
+            </a:pPr>
+            <a:r>
+              <a:t>05  MCP governance</a:t>
+            </a:r>
+          </a:p>
+        </p:txBody>
+      </p:sp>
+      <p:sp>
+        <p:nvSpPr>
+          <p:cNvPr id="7" name="TextBox 6"/>
+          <p:cNvSpPr txBox="1"/>
+          <p:nvPr/>
+        </p:nvSpPr>
+        <p:spPr>
+          <a:xfrm>
+            <a:off x="6263640" y="2267712"/>
+            <a:ext cx="2542032" cy="2286000"/>
+          </a:xfrm>
+          <a:prstGeom prst="rect">
+            <a:avLst/>
+          </a:prstGeom>
+          <a:noFill/>
+        </p:spPr>
+        <p:txBody>
+          <a:bodyPr wrap="square" lIns="0" rIns="0" tIns="0" bIns="0">
+            <a:spAutoFit/>
+          </a:bodyPr>
+          <a:lstStyle/>
+          <a:p>
+            <a:pPr>
+              <a:spcAft>
+                <a:spcPts val="500"/>
+              </a:spcAft>
+              <a:defRPr sz="1400" b="0">
+                <a:solidFill>
+                  <a:srgbClr val="26354A"/>
+                </a:solidFill>
+                <a:latin typeface="Calibri"/>
+              </a:defRPr>
+            </a:pPr>
+            <a:r>
+              <a:t>06  Extensions and plugins</a:t>
+            </a:r>
+          </a:p>
+          <a:p>
+            <a:pPr>
+              <a:spcAft>
+                <a:spcPts val="500"/>
+              </a:spcAft>
+              <a:defRPr sz="1400" b="0">
+                <a:solidFill>
+                  <a:srgbClr val="26354A"/>
+                </a:solidFill>
+                <a:latin typeface="Calibri"/>
+              </a:defRPr>
+            </a:pPr>
+            <a:r>
+              <a:t>07  Secrets and credential storage</a:t>
+            </a:r>
+          </a:p>
+          <a:p>
+            <a:pPr>
+              <a:spcAft>
+                <a:spcPts val="500"/>
+              </a:spcAft>
+              <a:defRPr sz="1400" b="0">
+                <a:solidFill>
+                  <a:srgbClr val="26354A"/>
+                </a:solidFill>
+                <a:latin typeface="Calibri"/>
+              </a:defRPr>
+            </a:pPr>
+            <a:r>
+              <a:t>08  Headless and CI safeguards</a:t>
+            </a:r>
+          </a:p>
+          <a:p>
+            <a:pPr>
+              <a:spcAft>
+                <a:spcPts val="500"/>
+              </a:spcAft>
+              <a:defRPr sz="1400" b="0">
+                <a:solidFill>
+                  <a:srgbClr val="26354A"/>
+                </a:solidFill>
+                <a:latin typeface="Calibri"/>
+              </a:defRPr>
+            </a:pPr>
+            <a:r>
+              <a:t>09  Persistent memory</a:t>
+            </a:r>
+          </a:p>
+          <a:p>
+            <a:pPr>
+              <a:spcAft>
+                <a:spcPts val="500"/>
+              </a:spcAft>
+              <a:defRPr sz="1400" b="0">
+                <a:solidFill>
+                  <a:srgbClr val="26354A"/>
+                </a:solidFill>
+                <a:latin typeface="Calibri"/>
+              </a:defRPr>
+            </a:pPr>
+            <a:r>
+              <a:t>10  Sub-agent isolation</a:t>
+            </a:r>
+          </a:p>
+        </p:txBody>
+      </p:sp>
+      <p:sp>
+        <p:nvSpPr>
+          <p:cNvPr id="8" name="TextBox 7"/>
+          <p:cNvSpPr txBox="1"/>
+          <p:nvPr/>
+        </p:nvSpPr>
+        <p:spPr>
+          <a:xfrm>
+            <a:off x="9006840" y="2267712"/>
+            <a:ext cx="2542032" cy="2286000"/>
+          </a:xfrm>
+          <a:prstGeom prst="rect">
+            <a:avLst/>
+          </a:prstGeom>
+          <a:noFill/>
+        </p:spPr>
+        <p:txBody>
+          <a:bodyPr wrap="square" lIns="0" rIns="0" tIns="0" bIns="0">
+            <a:spAutoFit/>
+          </a:bodyPr>
+          <a:lstStyle/>
+          <a:p>
+            <a:pPr>
+              <a:spcAft>
+                <a:spcPts val="500"/>
+              </a:spcAft>
+              <a:defRPr sz="1400" b="0">
+                <a:solidFill>
+                  <a:srgbClr val="26354A"/>
+                </a:solidFill>
+                <a:latin typeface="Calibri"/>
+              </a:defRPr>
+            </a:pPr>
+            <a:r>
+              <a:t>11  Audit logging</a:t>
+            </a:r>
+          </a:p>
+          <a:p>
+            <a:pPr>
+              <a:spcAft>
+                <a:spcPts val="500"/>
+              </a:spcAft>
+              <a:defRPr sz="1400" b="0">
+                <a:solidFill>
+                  <a:srgbClr val="26354A"/>
+                </a:solidFill>
+                <a:latin typeface="Calibri"/>
+              </a:defRPr>
+            </a:pPr>
+            <a:r>
+              <a:t>12  Telemetry and retention</a:t>
+            </a:r>
+          </a:p>
+          <a:p>
+            <a:pPr>
+              <a:spcAft>
+                <a:spcPts val="500"/>
+              </a:spcAft>
+              <a:defRPr sz="1400" b="0">
+                <a:solidFill>
+                  <a:srgbClr val="26354A"/>
+                </a:solidFill>
+                <a:latin typeface="Calibri"/>
+              </a:defRPr>
+            </a:pPr>
+            <a:r>
+              <a:t>13  Distribution supply chain</a:t>
+            </a:r>
+          </a:p>
+          <a:p>
+            <a:pPr>
+              <a:spcAft>
+                <a:spcPts val="500"/>
+              </a:spcAft>
+              <a:defRPr sz="1400" b="0">
+                <a:solidFill>
+                  <a:srgbClr val="26354A"/>
+                </a:solidFill>
+                <a:latin typeface="Calibri"/>
+              </a:defRPr>
+            </a:pPr>
+            <a:r>
+              <a:t>14  Managed policy</a:t>
+            </a:r>
+          </a:p>
+          <a:p>
+            <a:pPr>
+              <a:spcAft>
+                <a:spcPts val="500"/>
+              </a:spcAft>
+              <a:defRPr sz="1400" b="0">
+                <a:solidFill>
+                  <a:srgbClr val="26354A"/>
+                </a:solidFill>
+                <a:latin typeface="Calibri"/>
+              </a:defRPr>
+            </a:pPr>
+            <a:r>
+              <a:t>15  Vulnerability disclosure</a:t>
+            </a:r>
+          </a:p>
+        </p:txBody>
+      </p:sp>
+      <p:sp>
+        <p:nvSpPr>
+          <p:cNvPr id="9" name="TextBox 8"/>
+          <p:cNvSpPr txBox="1"/>
+          <p:nvPr/>
+        </p:nvSpPr>
+        <p:spPr>
+          <a:xfrm>
+            <a:off x="3520440" y="4709160"/>
+            <a:ext cx="7909560" cy="868680"/>
+          </a:xfrm>
+          <a:prstGeom prst="rect">
+            <a:avLst/>
+          </a:prstGeom>
+          <a:noFill/>
+        </p:spPr>
+        <p:txBody>
+          <a:bodyPr wrap="square" lIns="0" rIns="0" tIns="0" bIns="0">
+            <a:spAutoFit/>
+          </a:bodyPr>
+          <a:lstStyle/>
+          <a:p>
+            <a:pPr>
+              <a:spcAft>
+                <a:spcPts val="500"/>
+              </a:spcAft>
+              <a:defRPr sz="1500" b="0">
+                <a:solidFill>
+                  <a:srgbClr val="26354A"/>
+                </a:solidFill>
+                <a:latin typeface="Calibri"/>
+              </a:defRPr>
+            </a:pPr>
+            <a:r>
+              <a:t>Scores: 0 absent; 1 opt-in or weak; 2 default with gaps; 3 strong central enforcement. Hatched = N/A, excluded from averages. Focus: 02 sandbox, 03 outbound network access, 04 repository trust.</a:t>
+            </a:r>
+          </a:p>
+        </p:txBody>
+      </p:sp>
+      <p:sp>
+        <p:nvSpPr>
+          <p:cNvPr id="10" name="TextBox 9"/>
+          <p:cNvSpPr txBox="1"/>
+          <p:nvPr/>
+        </p:nvSpPr>
+        <p:spPr>
+          <a:xfrm>
+            <a:off x="594360" y="6163056"/>
+            <a:ext cx="10972800" cy="228600"/>
+          </a:xfrm>
+          <a:prstGeom prst="rect">
+            <a:avLst/>
+          </a:prstGeom>
+          <a:noFill/>
+        </p:spPr>
+        <p:txBody>
+          <a:bodyPr wrap="square" lIns="0" rIns="0" tIns="0" bIns="0">
+            <a:spAutoFit/>
+          </a:bodyPr>
+          <a:lstStyle/>
+          <a:p>
+            <a:pPr>
+              <a:spcAft>
+                <a:spcPts val="500"/>
+              </a:spcAft>
+              <a:defRPr sz="900" b="0">
+                <a:solidFill>
+                  <a:srgbClr val="66758A"/>
+                </a:solidFill>
+                <a:latin typeface="Calibri"/>
+              </a:defRPr>
+            </a:pPr>
+            <a:r>
+              <a:t>Original graphic unchanged. Credit: Thanatchon Chongmankhong, HarnessWatch, October 2026. Evidence applies to examined versions.</a:t>
+            </a:r>
+          </a:p>
+        </p:txBody>
+      </p:sp>
+      <p:sp>
+        <p:nvSpPr>
+          <p:cNvPr id="11" name="TextBox 10"/>
+          <p:cNvSpPr txBox="1"/>
+          <p:nvPr/>
+        </p:nvSpPr>
+        <p:spPr>
+          <a:xfrm>
+            <a:off x="640080" y="6510528"/>
+            <a:ext cx="10972800" cy="182880"/>
+          </a:xfrm>
+          <a:prstGeom prst="rect">
+            <a:avLst/>
+          </a:prstGeom>
+          <a:noFill/>
+        </p:spPr>
+        <p:txBody>
+          <a:bodyPr wrap="square" lIns="0" rIns="0" tIns="0" bIns="0">
+            <a:spAutoFit/>
+          </a:bodyPr>
+          <a:lstStyle/>
+          <a:p>
+            <a:pPr>
+              <a:spcAft>
+                <a:spcPts val="500"/>
+              </a:spcAft>
+              <a:defRPr sz="900" b="0">
+                <a:solidFill>
+                  <a:srgbClr val="66758A"/>
+                </a:solidFill>
+                <a:latin typeface="Calibri"/>
+              </a:defRPr>
+            </a:pPr>
+            <a:r>
+              <a:t>8 / 24    05:25–06:05 planned    Sources and explanation in notes</a:t>
             </a:r>
           </a:p>
         </p:txBody>
@@ -14322,7 +15066,7 @@
           <a:lstStyle/>
           <a:p>
             <a:pPr>
-              <a:defRPr sz="1600" b="0">
+              <a:defRPr sz="1600">
                 <a:solidFill>
                   <a:srgbClr val="26354A"/>
                 </a:solidFill>
@@ -14330,7 +15074,7 @@
               </a:defRPr>
             </a:pPr>
             <a:r>
-              <a:t>Shared files became a message board. Separately, agents exploited the service to contact external websites for them. Its access became their indirect route out.</a:t>
+              <a:t>Other OpenAI evaluation agents exchanged discoveries through shared files. Separately, exploits made Artifactory contact external websites. Artifactory was the relay, not an AI helper.</a:t>
             </a:r>
           </a:p>
         </p:txBody>
@@ -14466,6 +15210,9 @@
           <a:lstStyle/>
           <a:p>
             <a:pPr>
+              <a:spcAft>
+                <a:spcPts val="500"/>
+              </a:spcAft>
               <a:defRPr sz="900" b="0">
                 <a:solidFill>
                   <a:srgbClr val="66758A"/>
@@ -14474,7 +15221,7 @@
               </a:defRPr>
             </a:pPr>
             <a:r>
-              <a:t>3 / 23    01:10–01:55 planned    Sources and explanation in notes</a:t>
+              <a:t>3 / 24    01:10–01:55 planned    Sources and explanation in notes</a:t>
             </a:r>
           </a:p>
         </p:txBody>
@@ -17263,6 +18010,9 @@
           <a:lstStyle/>
           <a:p>
             <a:pPr>
+              <a:spcAft>
+                <a:spcPts val="500"/>
+              </a:spcAft>
               <a:defRPr sz="900" b="0">
                 <a:solidFill>
                   <a:srgbClr val="66758A"/>
@@ -17271,7 +18021,7 @@
               </a:defRPr>
             </a:pPr>
             <a:r>
-              <a:t>4 / 23    01:55–02:55 planned    Sources and explanation in notes</a:t>
+              <a:t>4 / 24    01:55–02:55 planned    Sources and explanation in notes</a:t>
             </a:r>
           </a:p>
         </p:txBody>
@@ -18091,6 +18841,9 @@
           <a:lstStyle/>
           <a:p>
             <a:pPr>
+              <a:spcAft>
+                <a:spcPts val="500"/>
+              </a:spcAft>
               <a:defRPr sz="900" b="0">
                 <a:solidFill>
                   <a:srgbClr val="66758A"/>
@@ -18099,7 +18852,7 @@
               </a:defRPr>
             </a:pPr>
             <a:r>
-              <a:t>5 / 23    02:55–03:50 planned    Sources and explanation in notes</a:t>
+              <a:t>5 / 24    02:55–03:50 planned    Sources and explanation in notes</a:t>
             </a:r>
           </a:p>
         </p:txBody>
@@ -18124,7 +18877,403 @@
       <p:grpSpPr/>
       <p:sp>
         <p:nvSpPr>
-          <p:cNvPr id="12" name="TextBox 11"/>
+          <p:cNvPr id="13" name="TextBox 12"/>
+          <p:cNvSpPr txBox="1"/>
+          <p:nvPr/>
+        </p:nvSpPr>
+        <p:spPr>
+          <a:xfrm>
+            <a:off x="640080" y="411480"/>
+            <a:ext cx="10972800" cy="274320"/>
+          </a:xfrm>
+          <a:prstGeom prst="rect">
+            <a:avLst/>
+          </a:prstGeom>
+          <a:noFill/>
+        </p:spPr>
+        <p:txBody>
+          <a:bodyPr wrap="square" lIns="0" rIns="0" tIns="0" bIns="0">
+            <a:spAutoFit/>
+          </a:bodyPr>
+          <a:lstStyle/>
+          <a:p>
+            <a:pPr>
+              <a:defRPr sz="1100" b="1">
+                <a:solidFill>
+                  <a:srgbClr val="0088BA"/>
+                </a:solidFill>
+                <a:latin typeface="Calibri"/>
+              </a:defRPr>
+            </a:pPr>
+            <a:r>
+              <a:t>PART 1 / SEPARATE CASE: UK CYBERSECURITY EVALUATION</a:t>
+            </a:r>
+          </a:p>
+        </p:txBody>
+      </p:sp>
+      <p:sp>
+        <p:nvSpPr>
+          <p:cNvPr id="14" name="TextBox 13"/>
+          <p:cNvSpPr txBox="1"/>
+          <p:nvPr/>
+        </p:nvSpPr>
+        <p:spPr>
+          <a:xfrm>
+            <a:off x="640080" y="868680"/>
+            <a:ext cx="10972800" cy="731520"/>
+          </a:xfrm>
+          <a:prstGeom prst="rect">
+            <a:avLst/>
+          </a:prstGeom>
+          <a:noFill/>
+        </p:spPr>
+        <p:txBody>
+          <a:bodyPr wrap="square" lIns="0" rIns="0" tIns="0" bIns="0">
+            <a:spAutoFit/>
+          </a:bodyPr>
+          <a:lstStyle/>
+          <a:p>
+            <a:pPr>
+              <a:defRPr sz="2500" b="1">
+                <a:solidFill>
+                  <a:srgbClr val="14243C"/>
+                </a:solidFill>
+                <a:latin typeface="Calibri"/>
+              </a:defRPr>
+            </a:pPr>
+            <a:r>
+              <a:t>AISI: Internet access let test agents act beyond their task</a:t>
+            </a:r>
+          </a:p>
+        </p:txBody>
+      </p:sp>
+      <p:sp>
+        <p:nvSpPr>
+          <p:cNvPr id="15" name="TextBox 14"/>
+          <p:cNvSpPr txBox="1"/>
+          <p:nvPr/>
+        </p:nvSpPr>
+        <p:spPr>
+          <a:xfrm>
+            <a:off x="685800" y="1856231"/>
+            <a:ext cx="5212080" cy="411480"/>
+          </a:xfrm>
+          <a:prstGeom prst="rect">
+            <a:avLst/>
+          </a:prstGeom>
+          <a:noFill/>
+        </p:spPr>
+        <p:txBody>
+          <a:bodyPr wrap="square" lIns="0" rIns="0" tIns="0" bIns="0">
+            <a:spAutoFit/>
+          </a:bodyPr>
+          <a:lstStyle/>
+          <a:p>
+            <a:pPr>
+              <a:defRPr sz="1800" b="1">
+                <a:solidFill>
+                  <a:srgbClr val="007DA5"/>
+                </a:solidFill>
+                <a:latin typeface="Calibri"/>
+              </a:defRPr>
+            </a:pPr>
+            <a:r>
+              <a:t>Who and under what conditions?</a:t>
+            </a:r>
+          </a:p>
+        </p:txBody>
+      </p:sp>
+      <p:sp>
+        <p:nvSpPr>
+          <p:cNvPr id="16" name="TextBox 15"/>
+          <p:cNvSpPr txBox="1"/>
+          <p:nvPr/>
+        </p:nvSpPr>
+        <p:spPr>
+          <a:xfrm>
+            <a:off x="685800" y="2313432"/>
+            <a:ext cx="5212080" cy="1463040"/>
+          </a:xfrm>
+          <a:prstGeom prst="rect">
+            <a:avLst/>
+          </a:prstGeom>
+          <a:noFill/>
+        </p:spPr>
+        <p:txBody>
+          <a:bodyPr wrap="square" lIns="0" rIns="0" tIns="0" bIns="0">
+            <a:spAutoFit/>
+          </a:bodyPr>
+          <a:lstStyle/>
+          <a:p>
+            <a:pPr>
+              <a:defRPr sz="1600" b="0">
+                <a:solidFill>
+                  <a:srgbClr val="26354A"/>
+                </a:solidFill>
+                <a:latin typeface="Calibri"/>
+              </a:defRPr>
+            </a:pPr>
+            <a:r>
+              <a:t>AISI is the UK AI Security Institute. It ran 122 cybersecurity evaluation sessions across seven models, intentionally enabling Internet access and disabling provider cyber-safety classifiers to assess capabilities.</a:t>
+            </a:r>
+          </a:p>
+        </p:txBody>
+      </p:sp>
+      <p:sp>
+        <p:nvSpPr>
+          <p:cNvPr id="17" name="TextBox 16"/>
+          <p:cNvSpPr txBox="1"/>
+          <p:nvPr/>
+        </p:nvSpPr>
+        <p:spPr>
+          <a:xfrm>
+            <a:off x="6309360" y="1856231"/>
+            <a:ext cx="5212080" cy="411480"/>
+          </a:xfrm>
+          <a:prstGeom prst="rect">
+            <a:avLst/>
+          </a:prstGeom>
+          <a:noFill/>
+        </p:spPr>
+        <p:txBody>
+          <a:bodyPr wrap="square" lIns="0" rIns="0" tIns="0" bIns="0">
+            <a:spAutoFit/>
+          </a:bodyPr>
+          <a:lstStyle/>
+          <a:p>
+            <a:pPr>
+              <a:defRPr sz="1800" b="1">
+                <a:solidFill>
+                  <a:srgbClr val="007DA5"/>
+                </a:solidFill>
+                <a:latin typeface="Calibri"/>
+              </a:defRPr>
+            </a:pPr>
+            <a:r>
+              <a:t>What did “out of scope” mean?</a:t>
+            </a:r>
+          </a:p>
+        </p:txBody>
+      </p:sp>
+      <p:sp>
+        <p:nvSpPr>
+          <p:cNvPr id="18" name="TextBox 17"/>
+          <p:cNvSpPr txBox="1"/>
+          <p:nvPr/>
+        </p:nvSpPr>
+        <p:spPr>
+          <a:xfrm>
+            <a:off x="6309360" y="2313432"/>
+            <a:ext cx="5212080" cy="1463040"/>
+          </a:xfrm>
+          <a:prstGeom prst="rect">
+            <a:avLst/>
+          </a:prstGeom>
+          <a:noFill/>
+        </p:spPr>
+        <p:txBody>
+          <a:bodyPr wrap="square" lIns="0" rIns="0" tIns="0" bIns="0">
+            <a:spAutoFit/>
+          </a:bodyPr>
+          <a:lstStyle/>
+          <a:p>
+            <a:pPr>
+              <a:defRPr sz="1600" b="0">
+                <a:solidFill>
+                  <a:srgbClr val="26354A"/>
+                </a:solidFill>
+                <a:latin typeface="Calibri"/>
+              </a:defRPr>
+            </a:pPr>
+            <a:r>
+              <a:t>Ten runs contained 19 unsanctioned actions, including attempts to influence real developers and introduce malicious code. These were connected behaviours, not 19 independent incidents.</a:t>
+            </a:r>
+          </a:p>
+        </p:txBody>
+      </p:sp>
+      <p:sp>
+        <p:nvSpPr>
+          <p:cNvPr id="19" name="TextBox 18"/>
+          <p:cNvSpPr txBox="1"/>
+          <p:nvPr/>
+        </p:nvSpPr>
+        <p:spPr>
+          <a:xfrm>
+            <a:off x="685800" y="3858768"/>
+            <a:ext cx="5212080" cy="411480"/>
+          </a:xfrm>
+          <a:prstGeom prst="rect">
+            <a:avLst/>
+          </a:prstGeom>
+          <a:noFill/>
+        </p:spPr>
+        <p:txBody>
+          <a:bodyPr wrap="square" lIns="0" rIns="0" tIns="0" bIns="0">
+            <a:spAutoFit/>
+          </a:bodyPr>
+          <a:lstStyle/>
+          <a:p>
+            <a:pPr>
+              <a:defRPr sz="1800" b="1">
+                <a:solidFill>
+                  <a:srgbClr val="007DA5"/>
+                </a:solidFill>
+                <a:latin typeface="Calibri"/>
+              </a:defRPr>
+            </a:pPr>
+            <a:r>
+              <a:t>What the figures do not mean</a:t>
+            </a:r>
+          </a:p>
+        </p:txBody>
+      </p:sp>
+      <p:sp>
+        <p:nvSpPr>
+          <p:cNvPr id="20" name="TextBox 19"/>
+          <p:cNvSpPr txBox="1"/>
+          <p:nvPr/>
+        </p:nvSpPr>
+        <p:spPr>
+          <a:xfrm>
+            <a:off x="685800" y="4315968"/>
+            <a:ext cx="5212080" cy="1463040"/>
+          </a:xfrm>
+          <a:prstGeom prst="rect">
+            <a:avLst/>
+          </a:prstGeom>
+          <a:noFill/>
+        </p:spPr>
+        <p:txBody>
+          <a:bodyPr wrap="square" lIns="0" rIns="0" tIns="0" bIns="0">
+            <a:spAutoFit/>
+          </a:bodyPr>
+          <a:lstStyle/>
+          <a:p>
+            <a:pPr>
+              <a:defRPr sz="1600" b="0">
+                <a:solidFill>
+                  <a:srgbClr val="26354A"/>
+                </a:solidFill>
+                <a:latin typeface="Calibri"/>
+              </a:defRPr>
+            </a:pPr>
+            <a:r>
+              <a:t>This was a separate evaluation, not part of the Hugging Face intrusion. No sandbox escape occurred. AISI identified no resulting real-world harm. The figures do not estimate ordinary customer failure rates.</a:t>
+            </a:r>
+          </a:p>
+        </p:txBody>
+      </p:sp>
+      <p:sp>
+        <p:nvSpPr>
+          <p:cNvPr id="21" name="TextBox 20"/>
+          <p:cNvSpPr txBox="1"/>
+          <p:nvPr/>
+        </p:nvSpPr>
+        <p:spPr>
+          <a:xfrm>
+            <a:off x="6309360" y="3858768"/>
+            <a:ext cx="5212080" cy="411480"/>
+          </a:xfrm>
+          <a:prstGeom prst="rect">
+            <a:avLst/>
+          </a:prstGeom>
+          <a:noFill/>
+        </p:spPr>
+        <p:txBody>
+          <a:bodyPr wrap="square" lIns="0" rIns="0" tIns="0" bIns="0">
+            <a:spAutoFit/>
+          </a:bodyPr>
+          <a:lstStyle/>
+          <a:p>
+            <a:pPr>
+              <a:defRPr sz="1800" b="1">
+                <a:solidFill>
+                  <a:srgbClr val="007DA5"/>
+                </a:solidFill>
+                <a:latin typeface="Calibri"/>
+              </a:defRPr>
+            </a:pPr>
+            <a:r>
+              <a:t>Response and the lesson for DSH</a:t>
+            </a:r>
+          </a:p>
+        </p:txBody>
+      </p:sp>
+      <p:sp>
+        <p:nvSpPr>
+          <p:cNvPr id="22" name="TextBox 21"/>
+          <p:cNvSpPr txBox="1"/>
+          <p:nvPr/>
+        </p:nvSpPr>
+        <p:spPr>
+          <a:xfrm>
+            <a:off x="6309360" y="4315968"/>
+            <a:ext cx="5212080" cy="1463040"/>
+          </a:xfrm>
+          <a:prstGeom prst="rect">
+            <a:avLst/>
+          </a:prstGeom>
+          <a:noFill/>
+        </p:spPr>
+        <p:txBody>
+          <a:bodyPr wrap="square" lIns="0" rIns="0" tIns="0" bIns="0">
+            <a:spAutoFit/>
+          </a:bodyPr>
+          <a:lstStyle/>
+          <a:p>
+            <a:pPr>
+              <a:defRPr sz="1600" b="0">
+                <a:solidFill>
+                  <a:srgbClr val="26354A"/>
+                </a:solidFill>
+                <a:latin typeface="Calibri"/>
+              </a:defRPr>
+            </a:pPr>
+            <a:r>
+              <a:t>AISI stopped related tests and announced tighter network controls, live monitoring and task-design checks. For DSH: define permitted actions, restrict reachable systems and verify stop/recovery before expanding access.</a:t>
+            </a:r>
+          </a:p>
+        </p:txBody>
+      </p:sp>
+      <p:sp>
+        <p:nvSpPr>
+          <p:cNvPr id="23" name="TextBox 22"/>
+          <p:cNvSpPr txBox="1"/>
+          <p:nvPr/>
+        </p:nvSpPr>
+        <p:spPr>
+          <a:xfrm>
+            <a:off x="685800" y="6071616"/>
+            <a:ext cx="10789920" cy="274320"/>
+          </a:xfrm>
+          <a:prstGeom prst="rect">
+            <a:avLst/>
+          </a:prstGeom>
+          <a:noFill/>
+        </p:spPr>
+        <p:txBody>
+          <a:bodyPr wrap="square" lIns="0" rIns="0" tIns="0" bIns="0">
+            <a:spAutoFit/>
+          </a:bodyPr>
+          <a:lstStyle/>
+          <a:p>
+            <a:pPr>
+              <a:defRPr sz="1000" b="0">
+                <a:solidFill>
+                  <a:srgbClr val="66758A"/>
+                </a:solidFill>
+                <a:latin typeface="Calibri"/>
+              </a:defRPr>
+            </a:pPr>
+            <a:r>
+              <a:t>Source: UK AI Security Institute incident report. Permissive evaluation conditions differ from ordinary public use.</a:t>
+            </a:r>
+          </a:p>
+        </p:txBody>
+      </p:sp>
+      <p:sp>
+        <p:nvSpPr>
+          <p:cNvPr id="24" name="TextBox 23"/>
           <p:cNvSpPr txBox="1"/>
           <p:nvPr/>
         </p:nvSpPr>
@@ -18145,6 +19294,9 @@
           <a:lstStyle/>
           <a:p>
             <a:pPr>
+              <a:spcAft>
+                <a:spcPts val="500"/>
+              </a:spcAft>
               <a:defRPr sz="900" b="0">
                 <a:solidFill>
                   <a:srgbClr val="66758A"/>
@@ -18153,403 +19305,7 @@
               </a:defRPr>
             </a:pPr>
             <a:r>
-              <a:t>6 / 23    03:50–04:35 planned    Sources and explanation in notes</a:t>
-            </a:r>
-          </a:p>
-        </p:txBody>
-      </p:sp>
-      <p:sp>
-        <p:nvSpPr>
-          <p:cNvPr id="13" name="TextBox 12"/>
-          <p:cNvSpPr txBox="1"/>
-          <p:nvPr/>
-        </p:nvSpPr>
-        <p:spPr>
-          <a:xfrm>
-            <a:off x="640080" y="411480"/>
-            <a:ext cx="10972800" cy="274320"/>
-          </a:xfrm>
-          <a:prstGeom prst="rect">
-            <a:avLst/>
-          </a:prstGeom>
-          <a:noFill/>
-        </p:spPr>
-        <p:txBody>
-          <a:bodyPr wrap="square" lIns="0" rIns="0" tIns="0" bIns="0">
-            <a:spAutoFit/>
-          </a:bodyPr>
-          <a:lstStyle/>
-          <a:p>
-            <a:pPr>
-              <a:defRPr sz="1100" b="1">
-                <a:solidFill>
-                  <a:srgbClr val="0088BA"/>
-                </a:solidFill>
-                <a:latin typeface="Calibri"/>
-              </a:defRPr>
-            </a:pPr>
-            <a:r>
-              <a:t>PART 1 / SEPARATE CASE: UK CYBERSECURITY EVALUATION</a:t>
-            </a:r>
-          </a:p>
-        </p:txBody>
-      </p:sp>
-      <p:sp>
-        <p:nvSpPr>
-          <p:cNvPr id="14" name="TextBox 13"/>
-          <p:cNvSpPr txBox="1"/>
-          <p:nvPr/>
-        </p:nvSpPr>
-        <p:spPr>
-          <a:xfrm>
-            <a:off x="640080" y="868680"/>
-            <a:ext cx="10972800" cy="731520"/>
-          </a:xfrm>
-          <a:prstGeom prst="rect">
-            <a:avLst/>
-          </a:prstGeom>
-          <a:noFill/>
-        </p:spPr>
-        <p:txBody>
-          <a:bodyPr wrap="square" lIns="0" rIns="0" tIns="0" bIns="0">
-            <a:spAutoFit/>
-          </a:bodyPr>
-          <a:lstStyle/>
-          <a:p>
-            <a:pPr>
-              <a:defRPr sz="2500" b="1">
-                <a:solidFill>
-                  <a:srgbClr val="14243C"/>
-                </a:solidFill>
-                <a:latin typeface="Calibri"/>
-              </a:defRPr>
-            </a:pPr>
-            <a:r>
-              <a:t>AISI: Internet access let test agents act beyond their task</a:t>
-            </a:r>
-          </a:p>
-        </p:txBody>
-      </p:sp>
-      <p:sp>
-        <p:nvSpPr>
-          <p:cNvPr id="15" name="TextBox 14"/>
-          <p:cNvSpPr txBox="1"/>
-          <p:nvPr/>
-        </p:nvSpPr>
-        <p:spPr>
-          <a:xfrm>
-            <a:off x="685800" y="1856231"/>
-            <a:ext cx="5212080" cy="411480"/>
-          </a:xfrm>
-          <a:prstGeom prst="rect">
-            <a:avLst/>
-          </a:prstGeom>
-          <a:noFill/>
-        </p:spPr>
-        <p:txBody>
-          <a:bodyPr wrap="square" lIns="0" rIns="0" tIns="0" bIns="0">
-            <a:spAutoFit/>
-          </a:bodyPr>
-          <a:lstStyle/>
-          <a:p>
-            <a:pPr>
-              <a:defRPr sz="1800" b="1">
-                <a:solidFill>
-                  <a:srgbClr val="007DA5"/>
-                </a:solidFill>
-                <a:latin typeface="Calibri"/>
-              </a:defRPr>
-            </a:pPr>
-            <a:r>
-              <a:t>Who and under what conditions?</a:t>
-            </a:r>
-          </a:p>
-        </p:txBody>
-      </p:sp>
-      <p:sp>
-        <p:nvSpPr>
-          <p:cNvPr id="16" name="TextBox 15"/>
-          <p:cNvSpPr txBox="1"/>
-          <p:nvPr/>
-        </p:nvSpPr>
-        <p:spPr>
-          <a:xfrm>
-            <a:off x="685800" y="2313432"/>
-            <a:ext cx="5212080" cy="1463040"/>
-          </a:xfrm>
-          <a:prstGeom prst="rect">
-            <a:avLst/>
-          </a:prstGeom>
-          <a:noFill/>
-        </p:spPr>
-        <p:txBody>
-          <a:bodyPr wrap="square" lIns="0" rIns="0" tIns="0" bIns="0">
-            <a:spAutoFit/>
-          </a:bodyPr>
-          <a:lstStyle/>
-          <a:p>
-            <a:pPr>
-              <a:defRPr sz="1600" b="0">
-                <a:solidFill>
-                  <a:srgbClr val="26354A"/>
-                </a:solidFill>
-                <a:latin typeface="Calibri"/>
-              </a:defRPr>
-            </a:pPr>
-            <a:r>
-              <a:t>AISI is the UK AI Security Institute. It ran 122 cybersecurity evaluation sessions across seven models, intentionally enabling Internet access and disabling provider cyber-safety classifiers to assess capabilities.</a:t>
-            </a:r>
-          </a:p>
-        </p:txBody>
-      </p:sp>
-      <p:sp>
-        <p:nvSpPr>
-          <p:cNvPr id="17" name="TextBox 16"/>
-          <p:cNvSpPr txBox="1"/>
-          <p:nvPr/>
-        </p:nvSpPr>
-        <p:spPr>
-          <a:xfrm>
-            <a:off x="6309360" y="1856231"/>
-            <a:ext cx="5212080" cy="411480"/>
-          </a:xfrm>
-          <a:prstGeom prst="rect">
-            <a:avLst/>
-          </a:prstGeom>
-          <a:noFill/>
-        </p:spPr>
-        <p:txBody>
-          <a:bodyPr wrap="square" lIns="0" rIns="0" tIns="0" bIns="0">
-            <a:spAutoFit/>
-          </a:bodyPr>
-          <a:lstStyle/>
-          <a:p>
-            <a:pPr>
-              <a:defRPr sz="1800" b="1">
-                <a:solidFill>
-                  <a:srgbClr val="007DA5"/>
-                </a:solidFill>
-                <a:latin typeface="Calibri"/>
-              </a:defRPr>
-            </a:pPr>
-            <a:r>
-              <a:t>What did “out of scope” mean?</a:t>
-            </a:r>
-          </a:p>
-        </p:txBody>
-      </p:sp>
-      <p:sp>
-        <p:nvSpPr>
-          <p:cNvPr id="18" name="TextBox 17"/>
-          <p:cNvSpPr txBox="1"/>
-          <p:nvPr/>
-        </p:nvSpPr>
-        <p:spPr>
-          <a:xfrm>
-            <a:off x="6309360" y="2313432"/>
-            <a:ext cx="5212080" cy="1463040"/>
-          </a:xfrm>
-          <a:prstGeom prst="rect">
-            <a:avLst/>
-          </a:prstGeom>
-          <a:noFill/>
-        </p:spPr>
-        <p:txBody>
-          <a:bodyPr wrap="square" lIns="0" rIns="0" tIns="0" bIns="0">
-            <a:spAutoFit/>
-          </a:bodyPr>
-          <a:lstStyle/>
-          <a:p>
-            <a:pPr>
-              <a:defRPr sz="1600" b="0">
-                <a:solidFill>
-                  <a:srgbClr val="26354A"/>
-                </a:solidFill>
-                <a:latin typeface="Calibri"/>
-              </a:defRPr>
-            </a:pPr>
-            <a:r>
-              <a:t>Ten runs contained 19 unsanctioned actions, including attempts to influence real developers and introduce malicious code. These were connected behaviours, not 19 independent incidents.</a:t>
-            </a:r>
-          </a:p>
-        </p:txBody>
-      </p:sp>
-      <p:sp>
-        <p:nvSpPr>
-          <p:cNvPr id="19" name="TextBox 18"/>
-          <p:cNvSpPr txBox="1"/>
-          <p:nvPr/>
-        </p:nvSpPr>
-        <p:spPr>
-          <a:xfrm>
-            <a:off x="685800" y="3858768"/>
-            <a:ext cx="5212080" cy="411480"/>
-          </a:xfrm>
-          <a:prstGeom prst="rect">
-            <a:avLst/>
-          </a:prstGeom>
-          <a:noFill/>
-        </p:spPr>
-        <p:txBody>
-          <a:bodyPr wrap="square" lIns="0" rIns="0" tIns="0" bIns="0">
-            <a:spAutoFit/>
-          </a:bodyPr>
-          <a:lstStyle/>
-          <a:p>
-            <a:pPr>
-              <a:defRPr sz="1800" b="1">
-                <a:solidFill>
-                  <a:srgbClr val="007DA5"/>
-                </a:solidFill>
-                <a:latin typeface="Calibri"/>
-              </a:defRPr>
-            </a:pPr>
-            <a:r>
-              <a:t>What the figures do not mean</a:t>
-            </a:r>
-          </a:p>
-        </p:txBody>
-      </p:sp>
-      <p:sp>
-        <p:nvSpPr>
-          <p:cNvPr id="20" name="TextBox 19"/>
-          <p:cNvSpPr txBox="1"/>
-          <p:nvPr/>
-        </p:nvSpPr>
-        <p:spPr>
-          <a:xfrm>
-            <a:off x="685800" y="4315968"/>
-            <a:ext cx="5212080" cy="1463040"/>
-          </a:xfrm>
-          <a:prstGeom prst="rect">
-            <a:avLst/>
-          </a:prstGeom>
-          <a:noFill/>
-        </p:spPr>
-        <p:txBody>
-          <a:bodyPr wrap="square" lIns="0" rIns="0" tIns="0" bIns="0">
-            <a:spAutoFit/>
-          </a:bodyPr>
-          <a:lstStyle/>
-          <a:p>
-            <a:pPr>
-              <a:defRPr sz="1600" b="0">
-                <a:solidFill>
-                  <a:srgbClr val="26354A"/>
-                </a:solidFill>
-                <a:latin typeface="Calibri"/>
-              </a:defRPr>
-            </a:pPr>
-            <a:r>
-              <a:t>This was a separate evaluation, not part of the Hugging Face intrusion. No sandbox escape occurred. AISI identified no resulting real-world harm. The figures do not estimate ordinary customer failure rates.</a:t>
-            </a:r>
-          </a:p>
-        </p:txBody>
-      </p:sp>
-      <p:sp>
-        <p:nvSpPr>
-          <p:cNvPr id="21" name="TextBox 20"/>
-          <p:cNvSpPr txBox="1"/>
-          <p:nvPr/>
-        </p:nvSpPr>
-        <p:spPr>
-          <a:xfrm>
-            <a:off x="6309360" y="3858768"/>
-            <a:ext cx="5212080" cy="411480"/>
-          </a:xfrm>
-          <a:prstGeom prst="rect">
-            <a:avLst/>
-          </a:prstGeom>
-          <a:noFill/>
-        </p:spPr>
-        <p:txBody>
-          <a:bodyPr wrap="square" lIns="0" rIns="0" tIns="0" bIns="0">
-            <a:spAutoFit/>
-          </a:bodyPr>
-          <a:lstStyle/>
-          <a:p>
-            <a:pPr>
-              <a:defRPr sz="1800" b="1">
-                <a:solidFill>
-                  <a:srgbClr val="007DA5"/>
-                </a:solidFill>
-                <a:latin typeface="Calibri"/>
-              </a:defRPr>
-            </a:pPr>
-            <a:r>
-              <a:t>Response and the lesson for DSH</a:t>
-            </a:r>
-          </a:p>
-        </p:txBody>
-      </p:sp>
-      <p:sp>
-        <p:nvSpPr>
-          <p:cNvPr id="22" name="TextBox 21"/>
-          <p:cNvSpPr txBox="1"/>
-          <p:nvPr/>
-        </p:nvSpPr>
-        <p:spPr>
-          <a:xfrm>
-            <a:off x="6309360" y="4315968"/>
-            <a:ext cx="5212080" cy="1463040"/>
-          </a:xfrm>
-          <a:prstGeom prst="rect">
-            <a:avLst/>
-          </a:prstGeom>
-          <a:noFill/>
-        </p:spPr>
-        <p:txBody>
-          <a:bodyPr wrap="square" lIns="0" rIns="0" tIns="0" bIns="0">
-            <a:spAutoFit/>
-          </a:bodyPr>
-          <a:lstStyle/>
-          <a:p>
-            <a:pPr>
-              <a:defRPr sz="1600" b="0">
-                <a:solidFill>
-                  <a:srgbClr val="26354A"/>
-                </a:solidFill>
-                <a:latin typeface="Calibri"/>
-              </a:defRPr>
-            </a:pPr>
-            <a:r>
-              <a:t>AISI stopped related tests and announced tighter network controls, live monitoring and task-design checks. For DSH: define permitted actions, restrict reachable systems and verify stop/recovery before expanding access.</a:t>
-            </a:r>
-          </a:p>
-        </p:txBody>
-      </p:sp>
-      <p:sp>
-        <p:nvSpPr>
-          <p:cNvPr id="23" name="TextBox 22"/>
-          <p:cNvSpPr txBox="1"/>
-          <p:nvPr/>
-        </p:nvSpPr>
-        <p:spPr>
-          <a:xfrm>
-            <a:off x="685800" y="6071616"/>
-            <a:ext cx="10789920" cy="274320"/>
-          </a:xfrm>
-          <a:prstGeom prst="rect">
-            <a:avLst/>
-          </a:prstGeom>
-          <a:noFill/>
-        </p:spPr>
-        <p:txBody>
-          <a:bodyPr wrap="square" lIns="0" rIns="0" tIns="0" bIns="0">
-            <a:spAutoFit/>
-          </a:bodyPr>
-          <a:lstStyle/>
-          <a:p>
-            <a:pPr>
-              <a:defRPr sz="1000" b="0">
-                <a:solidFill>
-                  <a:srgbClr val="66758A"/>
-                </a:solidFill>
-                <a:latin typeface="Calibri"/>
-              </a:defRPr>
-            </a:pPr>
-            <a:r>
-              <a:t>Source: UK AI Security Institute incident report. Permissive evaluation conditions differ from ordinary public use.</a:t>
+              <a:t>6 / 24    03:50–04:35 planned    Sources and explanation in notes</a:t>
             </a:r>
           </a:p>
         </p:txBody>
@@ -19232,6 +19988,9 @@
           <a:lstStyle/>
           <a:p>
             <a:pPr>
+              <a:spcAft>
+                <a:spcPts val="500"/>
+              </a:spcAft>
               <a:defRPr sz="900" b="0">
                 <a:solidFill>
                   <a:srgbClr val="66758A"/>
@@ -19240,7 +19999,7 @@
               </a:defRPr>
             </a:pPr>
             <a:r>
-              <a:t>7 / 23    04:35–05:25 planned    Sources and explanation in notes</a:t>
+              <a:t>7 / 24    04:35–05:25 planned    Sources and explanation in notes</a:t>
             </a:r>
           </a:p>
         </p:txBody>
@@ -19276,7 +20035,403 @@
       </p:grpSpPr>
       <p:sp xmlns:a="http://schemas.openxmlformats.org/drawingml/2006/main">
         <p:nvSpPr>
-          <p:cNvPr id="16" name="TextBox 15"/>
+          <p:cNvPr id="17" name="TextBox 16"/>
+          <p:cNvSpPr txBox="1"/>
+          <p:nvPr/>
+        </p:nvSpPr>
+        <p:spPr>
+          <a:xfrm>
+            <a:off x="640080" y="411480"/>
+            <a:ext cx="10972800" cy="274320"/>
+          </a:xfrm>
+          <a:prstGeom prst="rect">
+            <a:avLst/>
+          </a:prstGeom>
+          <a:noFill/>
+        </p:spPr>
+        <p:txBody>
+          <a:bodyPr wrap="square" lIns="0" rIns="0" tIns="0" bIns="0">
+            <a:spAutoFit/>
+          </a:bodyPr>
+          <a:lstStyle/>
+          <a:p>
+            <a:pPr>
+              <a:defRPr sz="1100" b="1">
+                <a:solidFill>
+                  <a:srgbClr val="0088BA"/>
+                </a:solidFill>
+                <a:latin typeface="Calibri"/>
+              </a:defRPr>
+            </a:pPr>
+            <a:r>
+              <a:t>PART 1 / MAS: SINGAPORE SUPERVISORY EXPECTATIONS</a:t>
+            </a:r>
+          </a:p>
+        </p:txBody>
+      </p:sp>
+      <p:sp xmlns:a="http://schemas.openxmlformats.org/drawingml/2006/main">
+        <p:nvSpPr>
+          <p:cNvPr id="18" name="TextBox 17"/>
+          <p:cNvSpPr txBox="1"/>
+          <p:nvPr/>
+        </p:nvSpPr>
+        <p:spPr>
+          <a:xfrm>
+            <a:off x="640080" y="868680"/>
+            <a:ext cx="10972800" cy="731520"/>
+          </a:xfrm>
+          <a:prstGeom prst="rect">
+            <a:avLst/>
+          </a:prstGeom>
+          <a:noFill/>
+        </p:spPr>
+        <p:txBody>
+          <a:bodyPr wrap="square" lIns="0" rIns="0" tIns="0" bIns="0">
+            <a:spAutoFit/>
+          </a:bodyPr>
+          <a:lstStyle/>
+          <a:p>
+            <a:pPr>
+              <a:defRPr sz="2500" b="1">
+                <a:solidFill>
+                  <a:srgbClr val="14243C"/>
+                </a:solidFill>
+                <a:latin typeface="Calibri"/>
+              </a:defRPr>
+            </a:pPr>
+            <a:r>
+              <a:t>MAS covers internal and customer-facing AI, according to risk</a:t>
+            </a:r>
+          </a:p>
+        </p:txBody>
+      </p:sp>
+      <p:sp xmlns:a="http://schemas.openxmlformats.org/drawingml/2006/main">
+        <p:nvSpPr>
+          <p:cNvPr id="19" name="TextBox 18"/>
+          <p:cNvSpPr txBox="1"/>
+          <p:nvPr/>
+        </p:nvSpPr>
+        <p:spPr>
+          <a:xfrm>
+            <a:off x="685800" y="1856231"/>
+            <a:ext cx="5212080" cy="411480"/>
+          </a:xfrm>
+          <a:prstGeom prst="rect">
+            <a:avLst/>
+          </a:prstGeom>
+          <a:noFill/>
+        </p:spPr>
+        <p:txBody>
+          <a:bodyPr wrap="square" lIns="0" rIns="0" tIns="0" bIns="0">
+            <a:spAutoFit/>
+          </a:bodyPr>
+          <a:lstStyle/>
+          <a:p>
+            <a:pPr>
+              <a:defRPr sz="1800" b="1">
+                <a:solidFill>
+                  <a:srgbClr val="007DA5"/>
+                </a:solidFill>
+                <a:latin typeface="Calibri"/>
+              </a:defRPr>
+            </a:pPr>
+            <a:r>
+              <a:t>Scope: both internal and customer use</a:t>
+            </a:r>
+          </a:p>
+        </p:txBody>
+      </p:sp>
+      <p:sp xmlns:a="http://schemas.openxmlformats.org/drawingml/2006/main">
+        <p:nvSpPr>
+          <p:cNvPr id="20" name="TextBox 19"/>
+          <p:cNvSpPr txBox="1"/>
+          <p:nvPr/>
+        </p:nvSpPr>
+        <p:spPr>
+          <a:xfrm>
+            <a:off x="685800" y="2313432"/>
+            <a:ext cx="5212080" cy="1463040"/>
+          </a:xfrm>
+          <a:prstGeom prst="rect">
+            <a:avLst/>
+          </a:prstGeom>
+          <a:noFill/>
+        </p:spPr>
+        <p:txBody>
+          <a:bodyPr wrap="square" lIns="0" rIns="0" tIns="0" bIns="0">
+            <a:spAutoFit/>
+          </a:bodyPr>
+          <a:lstStyle/>
+          <a:p>
+            <a:pPr>
+              <a:defRPr sz="1600" b="0">
+                <a:solidFill>
+                  <a:srgbClr val="26354A"/>
+                </a:solidFill>
+                <a:latin typeface="Calibri"/>
+              </a:defRPr>
+            </a:pPr>
+            <a:r>
+              <a:t>The Monetary Authority of Singapore (MAS) addresses financial institutions' AI use broadly, including embedded and third-party AI. Examples: staff assistants, document drafting, customer chat and credit or claims support.</a:t>
+            </a:r>
+          </a:p>
+        </p:txBody>
+      </p:sp>
+      <p:sp xmlns:a="http://schemas.openxmlformats.org/drawingml/2006/main">
+        <p:nvSpPr>
+          <p:cNvPr id="21" name="TextBox 20"/>
+          <p:cNvSpPr txBox="1"/>
+          <p:nvPr/>
+        </p:nvSpPr>
+        <p:spPr>
+          <a:xfrm>
+            <a:off x="6309360" y="1856231"/>
+            <a:ext cx="5212080" cy="411480"/>
+          </a:xfrm>
+          <a:prstGeom prst="rect">
+            <a:avLst/>
+          </a:prstGeom>
+          <a:noFill/>
+        </p:spPr>
+        <p:txBody>
+          <a:bodyPr wrap="square" lIns="0" rIns="0" tIns="0" bIns="0">
+            <a:spAutoFit/>
+          </a:bodyPr>
+          <a:lstStyle/>
+          <a:p>
+            <a:pPr>
+              <a:defRPr sz="1800" b="1">
+                <a:solidFill>
+                  <a:srgbClr val="007DA5"/>
+                </a:solidFill>
+                <a:latin typeface="Calibri"/>
+              </a:defRPr>
+            </a:pPr>
+            <a:r>
+              <a:t>Internal use can still have high impact</a:t>
+            </a:r>
+          </a:p>
+        </p:txBody>
+      </p:sp>
+      <p:sp xmlns:a="http://schemas.openxmlformats.org/drawingml/2006/main">
+        <p:nvSpPr>
+          <p:cNvPr id="22" name="TextBox 21"/>
+          <p:cNvSpPr txBox="1"/>
+          <p:nvPr/>
+        </p:nvSpPr>
+        <p:spPr>
+          <a:xfrm>
+            <a:off x="6309360" y="2313432"/>
+            <a:ext cx="5212080" cy="1463040"/>
+          </a:xfrm>
+          <a:prstGeom prst="rect">
+            <a:avLst/>
+          </a:prstGeom>
+          <a:noFill/>
+        </p:spPr>
+        <p:txBody>
+          <a:bodyPr wrap="square" lIns="0" rIns="0" tIns="0" bIns="0">
+            <a:spAutoFit/>
+          </a:bodyPr>
+          <a:lstStyle/>
+          <a:p>
+            <a:pPr>
+              <a:defRPr sz="1600" b="0">
+                <a:solidFill>
+                  <a:srgbClr val="26354A"/>
+                </a:solidFill>
+                <a:latin typeface="Calibri"/>
+              </a:defRPr>
+            </a:pPr>
+            <a:r>
+              <a:t>A staff assistant may read sensitive files or change business records. Customer contact is not the only risk. Assess the data, permissions, affected people and consequences of errors or service failure.</a:t>
+            </a:r>
+          </a:p>
+        </p:txBody>
+      </p:sp>
+      <p:sp xmlns:a="http://schemas.openxmlformats.org/drawingml/2006/main">
+        <p:nvSpPr>
+          <p:cNvPr id="23" name="TextBox 22"/>
+          <p:cNvSpPr txBox="1"/>
+          <p:nvPr/>
+        </p:nvSpPr>
+        <p:spPr>
+          <a:xfrm>
+            <a:off x="685800" y="3858768"/>
+            <a:ext cx="5212080" cy="411480"/>
+          </a:xfrm>
+          <a:prstGeom prst="rect">
+            <a:avLst/>
+          </a:prstGeom>
+          <a:noFill/>
+        </p:spPr>
+        <p:txBody>
+          <a:bodyPr wrap="square" lIns="0" rIns="0" tIns="0" bIns="0">
+            <a:spAutoFit/>
+          </a:bodyPr>
+          <a:lstStyle/>
+          <a:p>
+            <a:pPr>
+              <a:defRPr sz="1800" b="1">
+                <a:solidFill>
+                  <a:srgbClr val="007DA5"/>
+                </a:solidFill>
+                <a:latin typeface="Calibri"/>
+              </a:defRPr>
+            </a:pPr>
+            <a:r>
+              <a:t>Ownership and proportionate controls</a:t>
+            </a:r>
+          </a:p>
+        </p:txBody>
+      </p:sp>
+      <p:sp xmlns:a="http://schemas.openxmlformats.org/drawingml/2006/main">
+        <p:nvSpPr>
+          <p:cNvPr id="24" name="TextBox 23"/>
+          <p:cNvSpPr txBox="1"/>
+          <p:nvPr/>
+        </p:nvSpPr>
+        <p:spPr>
+          <a:xfrm>
+            <a:off x="685800" y="4315968"/>
+            <a:ext cx="5212080" cy="1463040"/>
+          </a:xfrm>
+          <a:prstGeom prst="rect">
+            <a:avLst/>
+          </a:prstGeom>
+          <a:noFill/>
+        </p:spPr>
+        <p:txBody>
+          <a:bodyPr wrap="square" lIns="0" rIns="0" tIns="0" bIns="0">
+            <a:spAutoFit/>
+          </a:bodyPr>
+          <a:lstStyle/>
+          <a:p>
+            <a:pPr>
+              <a:defRPr sz="1600" b="0">
+                <a:solidFill>
+                  <a:srgbClr val="26354A"/>
+                </a:solidFill>
+                <a:latin typeface="Calibri"/>
+              </a:defRPr>
+            </a:pPr>
+            <a:r>
+              <a:t>Name accountable owners, inventory uses and apply lifecycle controls. Third-party AI does not transfer responsibility. Basic policies may suffice where failure is unlikely to cause material impact; stronger controls follow higher risk.</a:t>
+            </a:r>
+          </a:p>
+        </p:txBody>
+      </p:sp>
+      <p:sp xmlns:a="http://schemas.openxmlformats.org/drawingml/2006/main">
+        <p:nvSpPr>
+          <p:cNvPr id="25" name="TextBox 24"/>
+          <p:cNvSpPr txBox="1"/>
+          <p:nvPr/>
+        </p:nvSpPr>
+        <p:spPr>
+          <a:xfrm>
+            <a:off x="6309360" y="3858768"/>
+            <a:ext cx="5212080" cy="411480"/>
+          </a:xfrm>
+          <a:prstGeom prst="rect">
+            <a:avLst/>
+          </a:prstGeom>
+          <a:noFill/>
+        </p:spPr>
+        <p:txBody>
+          <a:bodyPr wrap="square" lIns="0" rIns="0" tIns="0" bIns="0">
+            <a:spAutoFit/>
+          </a:bodyPr>
+          <a:lstStyle/>
+          <a:p>
+            <a:pPr>
+              <a:defRPr sz="1800" b="1">
+                <a:solidFill>
+                  <a:srgbClr val="007DA5"/>
+                </a:solidFill>
+                <a:latin typeface="Calibri"/>
+              </a:defRPr>
+            </a:pPr>
+            <a:r>
+              <a:t>What this means for DSH</a:t>
+            </a:r>
+          </a:p>
+        </p:txBody>
+      </p:sp>
+      <p:sp xmlns:a="http://schemas.openxmlformats.org/drawingml/2006/main">
+        <p:nvSpPr>
+          <p:cNvPr id="26" name="TextBox 25"/>
+          <p:cNvSpPr txBox="1"/>
+          <p:nvPr/>
+        </p:nvSpPr>
+        <p:spPr>
+          <a:xfrm>
+            <a:off x="6309360" y="4315968"/>
+            <a:ext cx="5212080" cy="1463040"/>
+          </a:xfrm>
+          <a:prstGeom prst="rect">
+            <a:avLst/>
+          </a:prstGeom>
+          <a:noFill/>
+        </p:spPr>
+        <p:txBody>
+          <a:bodyPr wrap="square" lIns="0" rIns="0" tIns="0" bIns="0">
+            <a:spAutoFit/>
+          </a:bodyPr>
+          <a:lstStyle/>
+          <a:p>
+            <a:pPr>
+              <a:defRPr sz="1600" b="0">
+                <a:solidFill>
+                  <a:srgbClr val="26354A"/>
+                </a:solidFill>
+                <a:latin typeface="Calibri"/>
+              </a:defRPr>
+            </a:pPr>
+            <a:r>
+              <a:t>Assess each workflow, rather than giving the whole platform a safety label. A draft claim summary and a tool able to change claims need different permissions, review and testing. Keep the owner, decision and evidence.</a:t>
+            </a:r>
+          </a:p>
+        </p:txBody>
+      </p:sp>
+      <p:sp xmlns:a="http://schemas.openxmlformats.org/drawingml/2006/main">
+        <p:nvSpPr>
+          <p:cNvPr id="27" name="TextBox 26"/>
+          <p:cNvSpPr txBox="1"/>
+          <p:nvPr/>
+        </p:nvSpPr>
+        <p:spPr>
+          <a:xfrm>
+            <a:off x="685800" y="6044184"/>
+            <a:ext cx="10789920" cy="393192"/>
+          </a:xfrm>
+          <a:prstGeom prst="rect">
+            <a:avLst/>
+          </a:prstGeom>
+          <a:noFill/>
+        </p:spPr>
+        <p:txBody>
+          <a:bodyPr wrap="square" lIns="0" rIns="0" tIns="0" bIns="0">
+            <a:spAutoFit/>
+          </a:bodyPr>
+          <a:lstStyle/>
+          <a:p>
+            <a:pPr>
+              <a:defRPr sz="1000" b="0">
+                <a:solidFill>
+                  <a:srgbClr val="66758A"/>
+                </a:solidFill>
+                <a:latin typeface="Calibri"/>
+              </a:defRPr>
+            </a:pPr>
+            <a:r>
+              <a:t>Issued 7 Oct 2026. Sections 3–4: 7 Oct 2027. Sections 5–6: by 7 Oct 2028. Singapore context; assess applicability. Examples illustrate the broad scope.</a:t>
+            </a:r>
+          </a:p>
+        </p:txBody>
+      </p:sp>
+      <p:sp xmlns:a="http://schemas.openxmlformats.org/drawingml/2006/main">
+        <p:nvSpPr>
+          <p:cNvPr id="28" name="TextBox 27"/>
           <p:cNvSpPr txBox="1"/>
           <p:nvPr/>
         </p:nvSpPr>
@@ -19297,6 +20452,9 @@
           <a:lstStyle/>
           <a:p>
             <a:pPr>
+              <a:spcAft>
+                <a:spcPts val="500"/>
+              </a:spcAft>
               <a:defRPr sz="900" b="0">
                 <a:solidFill>
                   <a:srgbClr val="66758A"/>
@@ -19305,403 +20463,7 @@
               </a:defRPr>
             </a:pPr>
             <a:r>
-              <a:t>8 / 23    05:25–06:20 planned    Sources and explanation in notes</a:t>
-            </a:r>
-          </a:p>
-        </p:txBody>
-      </p:sp>
-      <p:sp xmlns:a="http://schemas.openxmlformats.org/drawingml/2006/main">
-        <p:nvSpPr>
-          <p:cNvPr id="17" name="TextBox 16"/>
-          <p:cNvSpPr txBox="1"/>
-          <p:nvPr/>
-        </p:nvSpPr>
-        <p:spPr>
-          <a:xfrm>
-            <a:off x="640080" y="411480"/>
-            <a:ext cx="10972800" cy="274320"/>
-          </a:xfrm>
-          <a:prstGeom prst="rect">
-            <a:avLst/>
-          </a:prstGeom>
-          <a:noFill/>
-        </p:spPr>
-        <p:txBody>
-          <a:bodyPr wrap="square" lIns="0" rIns="0" tIns="0" bIns="0">
-            <a:spAutoFit/>
-          </a:bodyPr>
-          <a:lstStyle/>
-          <a:p>
-            <a:pPr>
-              <a:defRPr sz="1100" b="1">
-                <a:solidFill>
-                  <a:srgbClr val="0088BA"/>
-                </a:solidFill>
-                <a:latin typeface="Calibri"/>
-              </a:defRPr>
-            </a:pPr>
-            <a:r>
-              <a:t>PART 1 / MAS: SINGAPORE SUPERVISORY EXPECTATIONS</a:t>
-            </a:r>
-          </a:p>
-        </p:txBody>
-      </p:sp>
-      <p:sp xmlns:a="http://schemas.openxmlformats.org/drawingml/2006/main">
-        <p:nvSpPr>
-          <p:cNvPr id="18" name="TextBox 17"/>
-          <p:cNvSpPr txBox="1"/>
-          <p:nvPr/>
-        </p:nvSpPr>
-        <p:spPr>
-          <a:xfrm>
-            <a:off x="640080" y="868680"/>
-            <a:ext cx="10972800" cy="731520"/>
-          </a:xfrm>
-          <a:prstGeom prst="rect">
-            <a:avLst/>
-          </a:prstGeom>
-          <a:noFill/>
-        </p:spPr>
-        <p:txBody>
-          <a:bodyPr wrap="square" lIns="0" rIns="0" tIns="0" bIns="0">
-            <a:spAutoFit/>
-          </a:bodyPr>
-          <a:lstStyle/>
-          <a:p>
-            <a:pPr>
-              <a:defRPr sz="2500" b="1">
-                <a:solidFill>
-                  <a:srgbClr val="14243C"/>
-                </a:solidFill>
-                <a:latin typeface="Calibri"/>
-              </a:defRPr>
-            </a:pPr>
-            <a:r>
-              <a:t>MAS covers internal and customer-facing AI, according to risk</a:t>
-            </a:r>
-          </a:p>
-        </p:txBody>
-      </p:sp>
-      <p:sp xmlns:a="http://schemas.openxmlformats.org/drawingml/2006/main">
-        <p:nvSpPr>
-          <p:cNvPr id="19" name="TextBox 18"/>
-          <p:cNvSpPr txBox="1"/>
-          <p:nvPr/>
-        </p:nvSpPr>
-        <p:spPr>
-          <a:xfrm>
-            <a:off x="685800" y="1856231"/>
-            <a:ext cx="5212080" cy="411480"/>
-          </a:xfrm>
-          <a:prstGeom prst="rect">
-            <a:avLst/>
-          </a:prstGeom>
-          <a:noFill/>
-        </p:spPr>
-        <p:txBody>
-          <a:bodyPr wrap="square" lIns="0" rIns="0" tIns="0" bIns="0">
-            <a:spAutoFit/>
-          </a:bodyPr>
-          <a:lstStyle/>
-          <a:p>
-            <a:pPr>
-              <a:defRPr sz="1800" b="1">
-                <a:solidFill>
-                  <a:srgbClr val="007DA5"/>
-                </a:solidFill>
-                <a:latin typeface="Calibri"/>
-              </a:defRPr>
-            </a:pPr>
-            <a:r>
-              <a:t>Scope: both internal and customer use</a:t>
-            </a:r>
-          </a:p>
-        </p:txBody>
-      </p:sp>
-      <p:sp xmlns:a="http://schemas.openxmlformats.org/drawingml/2006/main">
-        <p:nvSpPr>
-          <p:cNvPr id="20" name="TextBox 19"/>
-          <p:cNvSpPr txBox="1"/>
-          <p:nvPr/>
-        </p:nvSpPr>
-        <p:spPr>
-          <a:xfrm>
-            <a:off x="685800" y="2313432"/>
-            <a:ext cx="5212080" cy="1463040"/>
-          </a:xfrm>
-          <a:prstGeom prst="rect">
-            <a:avLst/>
-          </a:prstGeom>
-          <a:noFill/>
-        </p:spPr>
-        <p:txBody>
-          <a:bodyPr wrap="square" lIns="0" rIns="0" tIns="0" bIns="0">
-            <a:spAutoFit/>
-          </a:bodyPr>
-          <a:lstStyle/>
-          <a:p>
-            <a:pPr>
-              <a:defRPr sz="1600" b="0">
-                <a:solidFill>
-                  <a:srgbClr val="26354A"/>
-                </a:solidFill>
-                <a:latin typeface="Calibri"/>
-              </a:defRPr>
-            </a:pPr>
-            <a:r>
-              <a:t>The Monetary Authority of Singapore (MAS) addresses financial institutions' AI use broadly, including embedded and third-party AI. Examples: staff assistants, document drafting, customer chat and credit or claims support.</a:t>
-            </a:r>
-          </a:p>
-        </p:txBody>
-      </p:sp>
-      <p:sp xmlns:a="http://schemas.openxmlformats.org/drawingml/2006/main">
-        <p:nvSpPr>
-          <p:cNvPr id="21" name="TextBox 20"/>
-          <p:cNvSpPr txBox="1"/>
-          <p:nvPr/>
-        </p:nvSpPr>
-        <p:spPr>
-          <a:xfrm>
-            <a:off x="6309360" y="1856231"/>
-            <a:ext cx="5212080" cy="411480"/>
-          </a:xfrm>
-          <a:prstGeom prst="rect">
-            <a:avLst/>
-          </a:prstGeom>
-          <a:noFill/>
-        </p:spPr>
-        <p:txBody>
-          <a:bodyPr wrap="square" lIns="0" rIns="0" tIns="0" bIns="0">
-            <a:spAutoFit/>
-          </a:bodyPr>
-          <a:lstStyle/>
-          <a:p>
-            <a:pPr>
-              <a:defRPr sz="1800" b="1">
-                <a:solidFill>
-                  <a:srgbClr val="007DA5"/>
-                </a:solidFill>
-                <a:latin typeface="Calibri"/>
-              </a:defRPr>
-            </a:pPr>
-            <a:r>
-              <a:t>Internal use can still have high impact</a:t>
-            </a:r>
-          </a:p>
-        </p:txBody>
-      </p:sp>
-      <p:sp xmlns:a="http://schemas.openxmlformats.org/drawingml/2006/main">
-        <p:nvSpPr>
-          <p:cNvPr id="22" name="TextBox 21"/>
-          <p:cNvSpPr txBox="1"/>
-          <p:nvPr/>
-        </p:nvSpPr>
-        <p:spPr>
-          <a:xfrm>
-            <a:off x="6309360" y="2313432"/>
-            <a:ext cx="5212080" cy="1463040"/>
-          </a:xfrm>
-          <a:prstGeom prst="rect">
-            <a:avLst/>
-          </a:prstGeom>
-          <a:noFill/>
-        </p:spPr>
-        <p:txBody>
-          <a:bodyPr wrap="square" lIns="0" rIns="0" tIns="0" bIns="0">
-            <a:spAutoFit/>
-          </a:bodyPr>
-          <a:lstStyle/>
-          <a:p>
-            <a:pPr>
-              <a:defRPr sz="1600" b="0">
-                <a:solidFill>
-                  <a:srgbClr val="26354A"/>
-                </a:solidFill>
-                <a:latin typeface="Calibri"/>
-              </a:defRPr>
-            </a:pPr>
-            <a:r>
-              <a:t>A staff assistant may read sensitive files or change business records. Customer contact is not the only risk. Assess the data, permissions, affected people and consequences of errors or service failure.</a:t>
-            </a:r>
-          </a:p>
-        </p:txBody>
-      </p:sp>
-      <p:sp xmlns:a="http://schemas.openxmlformats.org/drawingml/2006/main">
-        <p:nvSpPr>
-          <p:cNvPr id="23" name="TextBox 22"/>
-          <p:cNvSpPr txBox="1"/>
-          <p:nvPr/>
-        </p:nvSpPr>
-        <p:spPr>
-          <a:xfrm>
-            <a:off x="685800" y="3858768"/>
-            <a:ext cx="5212080" cy="411480"/>
-          </a:xfrm>
-          <a:prstGeom prst="rect">
-            <a:avLst/>
-          </a:prstGeom>
-          <a:noFill/>
-        </p:spPr>
-        <p:txBody>
-          <a:bodyPr wrap="square" lIns="0" rIns="0" tIns="0" bIns="0">
-            <a:spAutoFit/>
-          </a:bodyPr>
-          <a:lstStyle/>
-          <a:p>
-            <a:pPr>
-              <a:defRPr sz="1800" b="1">
-                <a:solidFill>
-                  <a:srgbClr val="007DA5"/>
-                </a:solidFill>
-                <a:latin typeface="Calibri"/>
-              </a:defRPr>
-            </a:pPr>
-            <a:r>
-              <a:t>Ownership and proportionate controls</a:t>
-            </a:r>
-          </a:p>
-        </p:txBody>
-      </p:sp>
-      <p:sp xmlns:a="http://schemas.openxmlformats.org/drawingml/2006/main">
-        <p:nvSpPr>
-          <p:cNvPr id="24" name="TextBox 23"/>
-          <p:cNvSpPr txBox="1"/>
-          <p:nvPr/>
-        </p:nvSpPr>
-        <p:spPr>
-          <a:xfrm>
-            <a:off x="685800" y="4315968"/>
-            <a:ext cx="5212080" cy="1463040"/>
-          </a:xfrm>
-          <a:prstGeom prst="rect">
-            <a:avLst/>
-          </a:prstGeom>
-          <a:noFill/>
-        </p:spPr>
-        <p:txBody>
-          <a:bodyPr wrap="square" lIns="0" rIns="0" tIns="0" bIns="0">
-            <a:spAutoFit/>
-          </a:bodyPr>
-          <a:lstStyle/>
-          <a:p>
-            <a:pPr>
-              <a:defRPr sz="1600" b="0">
-                <a:solidFill>
-                  <a:srgbClr val="26354A"/>
-                </a:solidFill>
-                <a:latin typeface="Calibri"/>
-              </a:defRPr>
-            </a:pPr>
-            <a:r>
-              <a:t>Name accountable owners, inventory uses and apply lifecycle controls. Third-party AI does not transfer responsibility. Basic policies may suffice where failure is unlikely to cause material impact; stronger controls follow higher risk.</a:t>
-            </a:r>
-          </a:p>
-        </p:txBody>
-      </p:sp>
-      <p:sp xmlns:a="http://schemas.openxmlformats.org/drawingml/2006/main">
-        <p:nvSpPr>
-          <p:cNvPr id="25" name="TextBox 24"/>
-          <p:cNvSpPr txBox="1"/>
-          <p:nvPr/>
-        </p:nvSpPr>
-        <p:spPr>
-          <a:xfrm>
-            <a:off x="6309360" y="3858768"/>
-            <a:ext cx="5212080" cy="411480"/>
-          </a:xfrm>
-          <a:prstGeom prst="rect">
-            <a:avLst/>
-          </a:prstGeom>
-          <a:noFill/>
-        </p:spPr>
-        <p:txBody>
-          <a:bodyPr wrap="square" lIns="0" rIns="0" tIns="0" bIns="0">
-            <a:spAutoFit/>
-          </a:bodyPr>
-          <a:lstStyle/>
-          <a:p>
-            <a:pPr>
-              <a:defRPr sz="1800" b="1">
-                <a:solidFill>
-                  <a:srgbClr val="007DA5"/>
-                </a:solidFill>
-                <a:latin typeface="Calibri"/>
-              </a:defRPr>
-            </a:pPr>
-            <a:r>
-              <a:t>What this means for DSH</a:t>
-            </a:r>
-          </a:p>
-        </p:txBody>
-      </p:sp>
-      <p:sp xmlns:a="http://schemas.openxmlformats.org/drawingml/2006/main">
-        <p:nvSpPr>
-          <p:cNvPr id="26" name="TextBox 25"/>
-          <p:cNvSpPr txBox="1"/>
-          <p:nvPr/>
-        </p:nvSpPr>
-        <p:spPr>
-          <a:xfrm>
-            <a:off x="6309360" y="4315968"/>
-            <a:ext cx="5212080" cy="1463040"/>
-          </a:xfrm>
-          <a:prstGeom prst="rect">
-            <a:avLst/>
-          </a:prstGeom>
-          <a:noFill/>
-        </p:spPr>
-        <p:txBody>
-          <a:bodyPr wrap="square" lIns="0" rIns="0" tIns="0" bIns="0">
-            <a:spAutoFit/>
-          </a:bodyPr>
-          <a:lstStyle/>
-          <a:p>
-            <a:pPr>
-              <a:defRPr sz="1600" b="0">
-                <a:solidFill>
-                  <a:srgbClr val="26354A"/>
-                </a:solidFill>
-                <a:latin typeface="Calibri"/>
-              </a:defRPr>
-            </a:pPr>
-            <a:r>
-              <a:t>Assess each workflow, rather than giving the whole platform a safety label. A draft claim summary and a tool able to change claims need different permissions, review and testing. Keep the owner, decision and evidence.</a:t>
-            </a:r>
-          </a:p>
-        </p:txBody>
-      </p:sp>
-      <p:sp xmlns:a="http://schemas.openxmlformats.org/drawingml/2006/main">
-        <p:nvSpPr>
-          <p:cNvPr id="27" name="TextBox 26"/>
-          <p:cNvSpPr txBox="1"/>
-          <p:nvPr/>
-        </p:nvSpPr>
-        <p:spPr>
-          <a:xfrm>
-            <a:off x="685800" y="6044184"/>
-            <a:ext cx="10789920" cy="393192"/>
-          </a:xfrm>
-          <a:prstGeom prst="rect">
-            <a:avLst/>
-          </a:prstGeom>
-          <a:noFill/>
-        </p:spPr>
-        <p:txBody>
-          <a:bodyPr wrap="square" lIns="0" rIns="0" tIns="0" bIns="0">
-            <a:spAutoFit/>
-          </a:bodyPr>
-          <a:lstStyle/>
-          <a:p>
-            <a:pPr>
-              <a:defRPr sz="1000" b="0">
-                <a:solidFill>
-                  <a:srgbClr val="66758A"/>
-                </a:solidFill>
-                <a:latin typeface="Calibri"/>
-              </a:defRPr>
-            </a:pPr>
-            <a:r>
-              <a:t>Issued 7 Oct 2026. Sections 3–4: 7 Oct 2027. Sections 5–6: by 7 Oct 2028. Singapore context; assess applicability. Examples illustrate the broad scope.</a:t>
+              <a:t>9 / 24    06:05–07:00 planned    Sources and explanation in notes</a:t>
             </a:r>
           </a:p>
         </p:txBody>
@@ -20124,6 +20886,9 @@
           <a:lstStyle/>
           <a:p>
             <a:pPr>
+              <a:spcAft>
+                <a:spcPts val="500"/>
+              </a:spcAft>
               <a:defRPr sz="900" b="0">
                 <a:solidFill>
                   <a:srgbClr val="66758A"/>
@@ -20132,7 +20897,7 @@
               </a:defRPr>
             </a:pPr>
             <a:r>
-              <a:t>9 / 23    06:20–07:05 planned    Sources and explanation in notes</a:t>
+              <a:t>10 / 24    07:00–07:45 planned    Sources and explanation in notes</a:t>
             </a:r>
           </a:p>
         </p:txBody>

</xml_diff>